<commit_message>
Align V10 deck theme with V9
Co-authored-by: Shyam <shyam.nexus@gmail.com>
</commit_message>
<xml_diff>
--- a/AI-Driven Embedded Product Lifecycle OrchestratorV10.pptx
+++ b/AI-Driven Embedded Product Lifecycle OrchestratorV10.pptx
@@ -3135,7 +3135,7 @@
             <a:avLst/>
           </a:prstGeom>
           <a:solidFill>
-            <a:srgbClr val="1F1F1F"/>
+            <a:srgbClr val="020A1A"/>
           </a:solidFill>
           <a:ln>
             <a:noFill/>
@@ -3178,7 +3178,7 @@
             <a:avLst/>
           </a:prstGeom>
           <a:solidFill>
-            <a:srgbClr val="D71920"/>
+            <a:srgbClr val="00C8F0"/>
           </a:solidFill>
           <a:ln>
             <a:noFill/>
@@ -3337,7 +3337,7 @@
             <a:r>
               <a:rPr sz="3100" b="1" i="0">
                 <a:solidFill>
-                  <a:srgbClr val="D71920"/>
+                  <a:srgbClr val="00C8F0"/>
                 </a:solidFill>
                 <a:latin typeface="Arial"/>
               </a:rPr>
@@ -3361,7 +3361,7 @@
             <a:avLst/>
           </a:prstGeom>
           <a:solidFill>
-            <a:srgbClr val="D71920"/>
+            <a:srgbClr val="0066A4"/>
           </a:solidFill>
           <a:ln>
             <a:noFill/>
@@ -3509,7 +3509,7 @@
             <a:avLst/>
           </a:prstGeom>
           <a:solidFill>
-            <a:srgbClr val="1F1F1F"/>
+            <a:srgbClr val="0E2A4A"/>
           </a:solidFill>
           <a:ln>
             <a:noFill/>
@@ -3563,7 +3563,7 @@
             <a:r>
               <a:rPr sz="850" b="0" i="0">
                 <a:solidFill>
-                  <a:srgbClr val="FFFFFF"/>
+                  <a:srgbClr val="B8D0EC"/>
                 </a:solidFill>
                 <a:latin typeface="Arial"/>
               </a:rPr>
@@ -3598,7 +3598,7 @@
             <a:r>
               <a:rPr sz="850" b="0" i="0">
                 <a:solidFill>
-                  <a:srgbClr val="FFFFFF"/>
+                  <a:srgbClr val="B8D0EC"/>
                 </a:solidFill>
                 <a:latin typeface="Arial"/>
               </a:rPr>
@@ -3664,7 +3664,7 @@
             <a:avLst/>
           </a:prstGeom>
           <a:solidFill>
-            <a:srgbClr val="FFFFFF"/>
+            <a:srgbClr val="020A1A"/>
           </a:solidFill>
           <a:ln>
             <a:noFill/>
@@ -3701,13 +3701,13 @@
         <p:spPr>
           <a:xfrm>
             <a:off x="0" y="0"/>
-            <a:ext cx="9144000" cy="512064"/>
-          </a:xfrm>
-          <a:prstGeom prst="rect">
-            <a:avLst/>
-          </a:prstGeom>
-          <a:solidFill>
-            <a:srgbClr val="FFFFFF"/>
+            <a:ext cx="9144000" cy="54864"/>
+          </a:xfrm>
+          <a:prstGeom prst="rect">
+            <a:avLst/>
+          </a:prstGeom>
+          <a:solidFill>
+            <a:srgbClr val="00C8F0"/>
           </a:solidFill>
           <a:ln>
             <a:noFill/>
@@ -3737,20 +3737,20 @@
       </p:sp>
       <p:sp>
         <p:nvSpPr>
-          <p:cNvPr id="5" name="Rectangle 4"/>
+          <p:cNvPr id="5" name="Rounded Rectangle 4"/>
           <p:cNvSpPr/>
           <p:nvPr/>
         </p:nvSpPr>
         <p:spPr>
           <a:xfrm>
-            <a:off x="0" y="512064"/>
-            <a:ext cx="9144000" cy="45720"/>
-          </a:xfrm>
-          <a:prstGeom prst="rect">
-            <a:avLst/>
-          </a:prstGeom>
-          <a:solidFill>
-            <a:srgbClr val="D71920"/>
+            <a:off x="320040" y="411480"/>
+            <a:ext cx="2148840" cy="274320"/>
+          </a:xfrm>
+          <a:prstGeom prst="roundRect">
+            <a:avLst/>
+          </a:prstGeom>
+          <a:solidFill>
+            <a:srgbClr val="0066A4"/>
           </a:solidFill>
           <a:ln>
             <a:noFill/>
@@ -3786,8 +3786,8 @@
         </p:nvSpPr>
         <p:spPr>
           <a:xfrm>
-            <a:off x="320040" y="118872"/>
-            <a:ext cx="1737360" cy="256032"/>
+            <a:off x="320040" y="457200"/>
+            <a:ext cx="2148840" cy="109728"/>
           </a:xfrm>
           <a:prstGeom prst="rect">
             <a:avLst/>
@@ -3800,9 +3800,44 @@
           </a:bodyPr>
           <a:lstStyle/>
           <a:p>
-            <a:pPr algn="l"/>
-            <a:r>
-              <a:rPr sz="1400" b="1" i="0">
+            <a:pPr algn="ctr"/>
+            <a:r>
+              <a:rPr sz="800" b="1" i="0">
+                <a:solidFill>
+                  <a:srgbClr val="FFFFFF"/>
+                </a:solidFill>
+                <a:latin typeface="Arial"/>
+              </a:rPr>
+              <a:t>PROBLEM STATEMENT</a:t>
+            </a:r>
+          </a:p>
+        </p:txBody>
+      </p:sp>
+      <p:sp>
+        <p:nvSpPr>
+          <p:cNvPr id="7" name="TextBox 6"/>
+          <p:cNvSpPr txBox="1"/>
+          <p:nvPr/>
+        </p:nvSpPr>
+        <p:spPr>
+          <a:xfrm>
+            <a:off x="7498079" y="411480"/>
+            <a:ext cx="1325880" cy="201168"/>
+          </a:xfrm>
+          <a:prstGeom prst="rect">
+            <a:avLst/>
+          </a:prstGeom>
+          <a:noFill/>
+        </p:spPr>
+        <p:txBody>
+          <a:bodyPr wrap="square" lIns="36576" rIns="36576" tIns="18288" bIns="18288">
+            <a:spAutoFit/>
+          </a:bodyPr>
+          <a:lstStyle/>
+          <a:p>
+            <a:pPr algn="r"/>
+            <a:r>
+              <a:rPr sz="1050" b="1" i="0">
                 <a:solidFill>
                   <a:srgbClr val="D71920"/>
                 </a:solidFill>
@@ -3815,14 +3850,14 @@
       </p:sp>
       <p:sp>
         <p:nvSpPr>
-          <p:cNvPr id="7" name="TextBox 6"/>
+          <p:cNvPr id="8" name="TextBox 7"/>
           <p:cNvSpPr txBox="1"/>
           <p:nvPr/>
         </p:nvSpPr>
         <p:spPr>
           <a:xfrm>
-            <a:off x="6400800" y="146304"/>
-            <a:ext cx="2423160" cy="219456"/>
+            <a:off x="320040" y="749808"/>
+            <a:ext cx="8183879" cy="493776"/>
           </a:xfrm>
           <a:prstGeom prst="rect">
             <a:avLst/>
@@ -3835,46 +3870,11 @@
           </a:bodyPr>
           <a:lstStyle/>
           <a:p>
-            <a:pPr algn="r"/>
-            <a:r>
-              <a:rPr sz="850" b="1" i="0">
-                <a:solidFill>
-                  <a:srgbClr val="686868"/>
-                </a:solidFill>
-                <a:latin typeface="Arial"/>
-              </a:rPr>
-              <a:t>PROBLEM STATEMENT</a:t>
-            </a:r>
-          </a:p>
-        </p:txBody>
-      </p:sp>
-      <p:sp>
-        <p:nvSpPr>
-          <p:cNvPr id="8" name="TextBox 7"/>
-          <p:cNvSpPr txBox="1"/>
-          <p:nvPr/>
-        </p:nvSpPr>
-        <p:spPr>
-          <a:xfrm>
-            <a:off x="320040" y="749808"/>
-            <a:ext cx="8183879" cy="493776"/>
-          </a:xfrm>
-          <a:prstGeom prst="rect">
-            <a:avLst/>
-          </a:prstGeom>
-          <a:noFill/>
-        </p:spPr>
-        <p:txBody>
-          <a:bodyPr wrap="square" lIns="36576" rIns="36576" tIns="18288" bIns="18288">
-            <a:spAutoFit/>
-          </a:bodyPr>
-          <a:lstStyle/>
-          <a:p>
             <a:pPr algn="l"/>
             <a:r>
               <a:rPr sz="2500" b="1" i="0">
                 <a:solidFill>
-                  <a:srgbClr val="242424"/>
+                  <a:srgbClr val="FFFFFF"/>
                 </a:solidFill>
                 <a:latin typeface="Arial"/>
               </a:rPr>
@@ -3898,7 +3898,7 @@
             <a:avLst/>
           </a:prstGeom>
           <a:solidFill>
-            <a:srgbClr val="D71920"/>
+            <a:srgbClr val="00C8F0"/>
           </a:solidFill>
           <a:ln>
             <a:noFill/>
@@ -3952,7 +3952,7 @@
             <a:r>
               <a:rPr sz="1230" b="0" i="1">
                 <a:solidFill>
-                  <a:srgbClr val="242424"/>
+                  <a:srgbClr val="E8F0FC"/>
                 </a:solidFill>
                 <a:latin typeface="Arial"/>
               </a:rPr>
@@ -3976,11 +3976,11 @@
             <a:avLst/>
           </a:prstGeom>
           <a:solidFill>
-            <a:srgbClr val="FFFFFF"/>
+            <a:srgbClr val="0F2845"/>
           </a:solidFill>
           <a:ln>
             <a:solidFill>
-              <a:srgbClr val="D9DDE3"/>
+              <a:srgbClr val="244A70"/>
             </a:solidFill>
           </a:ln>
         </p:spPr>
@@ -4153,7 +4153,7 @@
             <a:r>
               <a:rPr sz="1170" b="1" i="0">
                 <a:solidFill>
-                  <a:srgbClr val="242424"/>
+                  <a:srgbClr val="E8F0FC"/>
                 </a:solidFill>
                 <a:latin typeface="Arial"/>
               </a:rPr>
@@ -4189,7 +4189,7 @@
             <a:r>
               <a:rPr sz="969" b="0" i="0">
                 <a:solidFill>
-                  <a:srgbClr val="686868"/>
+                  <a:srgbClr val="B8D0EC"/>
                 </a:solidFill>
                 <a:latin typeface="Arial"/>
               </a:rPr>
@@ -4213,11 +4213,11 @@
             <a:avLst/>
           </a:prstGeom>
           <a:solidFill>
-            <a:srgbClr val="FFFFFF"/>
+            <a:srgbClr val="0F2845"/>
           </a:solidFill>
           <a:ln>
             <a:solidFill>
-              <a:srgbClr val="D9DDE3"/>
+              <a:srgbClr val="244A70"/>
             </a:solidFill>
           </a:ln>
         </p:spPr>
@@ -4390,7 +4390,7 @@
             <a:r>
               <a:rPr sz="1170" b="1" i="0">
                 <a:solidFill>
-                  <a:srgbClr val="242424"/>
+                  <a:srgbClr val="E8F0FC"/>
                 </a:solidFill>
                 <a:latin typeface="Arial"/>
               </a:rPr>
@@ -4426,7 +4426,7 @@
             <a:r>
               <a:rPr sz="969" b="0" i="0">
                 <a:solidFill>
-                  <a:srgbClr val="686868"/>
+                  <a:srgbClr val="B8D0EC"/>
                 </a:solidFill>
                 <a:latin typeface="Arial"/>
               </a:rPr>
@@ -4450,11 +4450,11 @@
             <a:avLst/>
           </a:prstGeom>
           <a:solidFill>
-            <a:srgbClr val="FFFFFF"/>
+            <a:srgbClr val="0F2845"/>
           </a:solidFill>
           <a:ln>
             <a:solidFill>
-              <a:srgbClr val="D9DDE3"/>
+              <a:srgbClr val="244A70"/>
             </a:solidFill>
           </a:ln>
         </p:spPr>
@@ -4627,7 +4627,7 @@
             <a:r>
               <a:rPr sz="1170" b="1" i="0">
                 <a:solidFill>
-                  <a:srgbClr val="242424"/>
+                  <a:srgbClr val="E8F0FC"/>
                 </a:solidFill>
                 <a:latin typeface="Arial"/>
               </a:rPr>
@@ -4663,7 +4663,7 @@
             <a:r>
               <a:rPr sz="969" b="0" i="0">
                 <a:solidFill>
-                  <a:srgbClr val="686868"/>
+                  <a:srgbClr val="B8D0EC"/>
                 </a:solidFill>
                 <a:latin typeface="Arial"/>
               </a:rPr>
@@ -4687,11 +4687,11 @@
             <a:avLst/>
           </a:prstGeom>
           <a:solidFill>
-            <a:srgbClr val="FFFFFF"/>
+            <a:srgbClr val="0F2845"/>
           </a:solidFill>
           <a:ln>
             <a:solidFill>
-              <a:srgbClr val="D9DDE3"/>
+              <a:srgbClr val="244A70"/>
             </a:solidFill>
           </a:ln>
         </p:spPr>
@@ -4864,7 +4864,7 @@
             <a:r>
               <a:rPr sz="1170" b="1" i="0">
                 <a:solidFill>
-                  <a:srgbClr val="242424"/>
+                  <a:srgbClr val="E8F0FC"/>
                 </a:solidFill>
                 <a:latin typeface="Arial"/>
               </a:rPr>
@@ -4900,7 +4900,7 @@
             <a:r>
               <a:rPr sz="969" b="0" i="0">
                 <a:solidFill>
-                  <a:srgbClr val="686868"/>
+                  <a:srgbClr val="B8D0EC"/>
                 </a:solidFill>
                 <a:latin typeface="Arial"/>
               </a:rPr>
@@ -4924,11 +4924,11 @@
             <a:avLst/>
           </a:prstGeom>
           <a:solidFill>
-            <a:srgbClr val="FFFFFF"/>
+            <a:srgbClr val="0F2845"/>
           </a:solidFill>
           <a:ln>
             <a:solidFill>
-              <a:srgbClr val="D9DDE3"/>
+              <a:srgbClr val="244A70"/>
             </a:solidFill>
           </a:ln>
         </p:spPr>
@@ -5101,7 +5101,7 @@
             <a:r>
               <a:rPr sz="1170" b="1" i="0">
                 <a:solidFill>
-                  <a:srgbClr val="242424"/>
+                  <a:srgbClr val="E8F0FC"/>
                 </a:solidFill>
                 <a:latin typeface="Arial"/>
               </a:rPr>
@@ -5137,7 +5137,7 @@
             <a:r>
               <a:rPr sz="969" b="0" i="0">
                 <a:solidFill>
-                  <a:srgbClr val="686868"/>
+                  <a:srgbClr val="B8D0EC"/>
                 </a:solidFill>
                 <a:latin typeface="Arial"/>
               </a:rPr>
@@ -5161,11 +5161,11 @@
             <a:avLst/>
           </a:prstGeom>
           <a:solidFill>
-            <a:srgbClr val="FFFFFF"/>
+            <a:srgbClr val="0F2845"/>
           </a:solidFill>
           <a:ln>
             <a:solidFill>
-              <a:srgbClr val="D9DDE3"/>
+              <a:srgbClr val="244A70"/>
             </a:solidFill>
           </a:ln>
         </p:spPr>
@@ -5338,7 +5338,7 @@
             <a:r>
               <a:rPr sz="1170" b="1" i="0">
                 <a:solidFill>
-                  <a:srgbClr val="242424"/>
+                  <a:srgbClr val="E8F0FC"/>
                 </a:solidFill>
                 <a:latin typeface="Arial"/>
               </a:rPr>
@@ -5374,7 +5374,7 @@
             <a:r>
               <a:rPr sz="969" b="0" i="0">
                 <a:solidFill>
-                  <a:srgbClr val="686868"/>
+                  <a:srgbClr val="B8D0EC"/>
                 </a:solidFill>
                 <a:latin typeface="Arial"/>
               </a:rPr>
@@ -5398,7 +5398,7 @@
             <a:avLst/>
           </a:prstGeom>
           <a:solidFill>
-            <a:srgbClr val="1F1F1F"/>
+            <a:srgbClr val="0E2A4A"/>
           </a:solidFill>
           <a:ln>
             <a:noFill/>
@@ -5452,7 +5452,7 @@
             <a:r>
               <a:rPr sz="850" b="0" i="0">
                 <a:solidFill>
-                  <a:srgbClr val="FFFFFF"/>
+                  <a:srgbClr val="B8D0EC"/>
                 </a:solidFill>
                 <a:latin typeface="Arial"/>
               </a:rPr>
@@ -5487,7 +5487,7 @@
             <a:r>
               <a:rPr sz="850" b="0" i="0">
                 <a:solidFill>
-                  <a:srgbClr val="FFFFFF"/>
+                  <a:srgbClr val="B8D0EC"/>
                 </a:solidFill>
                 <a:latin typeface="Arial"/>
               </a:rPr>
@@ -5553,7 +5553,7 @@
             <a:avLst/>
           </a:prstGeom>
           <a:solidFill>
-            <a:srgbClr val="FFFFFF"/>
+            <a:srgbClr val="020A1A"/>
           </a:solidFill>
           <a:ln>
             <a:noFill/>
@@ -5590,13 +5590,13 @@
         <p:spPr>
           <a:xfrm>
             <a:off x="0" y="0"/>
-            <a:ext cx="9144000" cy="512064"/>
-          </a:xfrm>
-          <a:prstGeom prst="rect">
-            <a:avLst/>
-          </a:prstGeom>
-          <a:solidFill>
-            <a:srgbClr val="FFFFFF"/>
+            <a:ext cx="9144000" cy="54864"/>
+          </a:xfrm>
+          <a:prstGeom prst="rect">
+            <a:avLst/>
+          </a:prstGeom>
+          <a:solidFill>
+            <a:srgbClr val="00C8F0"/>
           </a:solidFill>
           <a:ln>
             <a:noFill/>
@@ -5626,20 +5626,20 @@
       </p:sp>
       <p:sp>
         <p:nvSpPr>
-          <p:cNvPr id="5" name="Rectangle 4"/>
+          <p:cNvPr id="5" name="Rounded Rectangle 4"/>
           <p:cNvSpPr/>
           <p:nvPr/>
         </p:nvSpPr>
         <p:spPr>
           <a:xfrm>
-            <a:off x="0" y="512064"/>
-            <a:ext cx="9144000" cy="45720"/>
-          </a:xfrm>
-          <a:prstGeom prst="rect">
-            <a:avLst/>
-          </a:prstGeom>
-          <a:solidFill>
-            <a:srgbClr val="D71920"/>
+            <a:off x="320040" y="411480"/>
+            <a:ext cx="2148840" cy="274320"/>
+          </a:xfrm>
+          <a:prstGeom prst="roundRect">
+            <a:avLst/>
+          </a:prstGeom>
+          <a:solidFill>
+            <a:srgbClr val="0066A4"/>
           </a:solidFill>
           <a:ln>
             <a:noFill/>
@@ -5675,8 +5675,8 @@
         </p:nvSpPr>
         <p:spPr>
           <a:xfrm>
-            <a:off x="320040" y="118872"/>
-            <a:ext cx="1737360" cy="256032"/>
+            <a:off x="320040" y="457200"/>
+            <a:ext cx="2148840" cy="109728"/>
           </a:xfrm>
           <a:prstGeom prst="rect">
             <a:avLst/>
@@ -5689,9 +5689,44 @@
           </a:bodyPr>
           <a:lstStyle/>
           <a:p>
-            <a:pPr algn="l"/>
-            <a:r>
-              <a:rPr sz="1400" b="1" i="0">
+            <a:pPr algn="ctr"/>
+            <a:r>
+              <a:rPr sz="800" b="1" i="0">
+                <a:solidFill>
+                  <a:srgbClr val="FFFFFF"/>
+                </a:solidFill>
+                <a:latin typeface="Arial"/>
+              </a:rPr>
+              <a:t>ARCHITECTURE</a:t>
+            </a:r>
+          </a:p>
+        </p:txBody>
+      </p:sp>
+      <p:sp>
+        <p:nvSpPr>
+          <p:cNvPr id="7" name="TextBox 6"/>
+          <p:cNvSpPr txBox="1"/>
+          <p:nvPr/>
+        </p:nvSpPr>
+        <p:spPr>
+          <a:xfrm>
+            <a:off x="7498079" y="411480"/>
+            <a:ext cx="1325880" cy="201168"/>
+          </a:xfrm>
+          <a:prstGeom prst="rect">
+            <a:avLst/>
+          </a:prstGeom>
+          <a:noFill/>
+        </p:spPr>
+        <p:txBody>
+          <a:bodyPr wrap="square" lIns="36576" rIns="36576" tIns="18288" bIns="18288">
+            <a:spAutoFit/>
+          </a:bodyPr>
+          <a:lstStyle/>
+          <a:p>
+            <a:pPr algn="r"/>
+            <a:r>
+              <a:rPr sz="1050" b="1" i="0">
                 <a:solidFill>
                   <a:srgbClr val="D71920"/>
                 </a:solidFill>
@@ -5704,14 +5739,14 @@
       </p:sp>
       <p:sp>
         <p:nvSpPr>
-          <p:cNvPr id="7" name="TextBox 6"/>
+          <p:cNvPr id="8" name="TextBox 7"/>
           <p:cNvSpPr txBox="1"/>
           <p:nvPr/>
         </p:nvSpPr>
         <p:spPr>
           <a:xfrm>
-            <a:off x="6400800" y="146304"/>
-            <a:ext cx="2423160" cy="219456"/>
+            <a:off x="320040" y="749808"/>
+            <a:ext cx="8183879" cy="493776"/>
           </a:xfrm>
           <a:prstGeom prst="rect">
             <a:avLst/>
@@ -5724,46 +5759,11 @@
           </a:bodyPr>
           <a:lstStyle/>
           <a:p>
-            <a:pPr algn="r"/>
-            <a:r>
-              <a:rPr sz="850" b="1" i="0">
-                <a:solidFill>
-                  <a:srgbClr val="686868"/>
-                </a:solidFill>
-                <a:latin typeface="Arial"/>
-              </a:rPr>
-              <a:t>ARCHITECTURE</a:t>
-            </a:r>
-          </a:p>
-        </p:txBody>
-      </p:sp>
-      <p:sp>
-        <p:nvSpPr>
-          <p:cNvPr id="8" name="TextBox 7"/>
-          <p:cNvSpPr txBox="1"/>
-          <p:nvPr/>
-        </p:nvSpPr>
-        <p:spPr>
-          <a:xfrm>
-            <a:off x="320040" y="749808"/>
-            <a:ext cx="8183879" cy="493776"/>
-          </a:xfrm>
-          <a:prstGeom prst="rect">
-            <a:avLst/>
-          </a:prstGeom>
-          <a:noFill/>
-        </p:spPr>
-        <p:txBody>
-          <a:bodyPr wrap="square" lIns="36576" rIns="36576" tIns="18288" bIns="18288">
-            <a:spAutoFit/>
-          </a:bodyPr>
-          <a:lstStyle/>
-          <a:p>
             <a:pPr algn="l"/>
             <a:r>
               <a:rPr sz="2500" b="1" i="0">
                 <a:solidFill>
-                  <a:srgbClr val="242424"/>
+                  <a:srgbClr val="FFFFFF"/>
                 </a:solidFill>
                 <a:latin typeface="Arial"/>
               </a:rPr>
@@ -5787,7 +5787,7 @@
             <a:avLst/>
           </a:prstGeom>
           <a:solidFill>
-            <a:srgbClr val="D71920"/>
+            <a:srgbClr val="00C8F0"/>
           </a:solidFill>
           <a:ln>
             <a:noFill/>
@@ -5841,7 +5841,7 @@
             <a:r>
               <a:rPr sz="1180" b="0" i="1">
                 <a:solidFill>
-                  <a:srgbClr val="242424"/>
+                  <a:srgbClr val="E8F0FC"/>
                 </a:solidFill>
                 <a:latin typeface="Arial"/>
               </a:rPr>
@@ -5943,11 +5943,11 @@
             <a:avLst/>
           </a:prstGeom>
           <a:solidFill>
-            <a:srgbClr val="FFFFFF"/>
+            <a:srgbClr val="0F2845"/>
           </a:solidFill>
           <a:ln>
             <a:solidFill>
-              <a:srgbClr val="D9DDE3"/>
+              <a:srgbClr val="244A70"/>
             </a:solidFill>
           </a:ln>
         </p:spPr>
@@ -6042,7 +6042,7 @@
             <a:r>
               <a:rPr sz="1019" b="0" i="0">
                 <a:solidFill>
-                  <a:srgbClr val="242424"/>
+                  <a:srgbClr val="E8F0FC"/>
                 </a:solidFill>
                 <a:latin typeface="Arial"/>
               </a:rPr>
@@ -6144,11 +6144,11 @@
             <a:avLst/>
           </a:prstGeom>
           <a:solidFill>
-            <a:srgbClr val="FFFFFF"/>
+            <a:srgbClr val="0F2845"/>
           </a:solidFill>
           <a:ln>
             <a:solidFill>
-              <a:srgbClr val="D9DDE3"/>
+              <a:srgbClr val="244A70"/>
             </a:solidFill>
           </a:ln>
         </p:spPr>
@@ -6243,7 +6243,7 @@
             <a:r>
               <a:rPr sz="1019" b="0" i="0">
                 <a:solidFill>
-                  <a:srgbClr val="242424"/>
+                  <a:srgbClr val="E8F0FC"/>
                 </a:solidFill>
                 <a:latin typeface="Arial"/>
               </a:rPr>
@@ -6345,11 +6345,11 @@
             <a:avLst/>
           </a:prstGeom>
           <a:solidFill>
-            <a:srgbClr val="FFFFFF"/>
+            <a:srgbClr val="0F2845"/>
           </a:solidFill>
           <a:ln>
             <a:solidFill>
-              <a:srgbClr val="D9DDE3"/>
+              <a:srgbClr val="244A70"/>
             </a:solidFill>
           </a:ln>
         </p:spPr>
@@ -6444,7 +6444,7 @@
             <a:r>
               <a:rPr sz="1019" b="0" i="0">
                 <a:solidFill>
-                  <a:srgbClr val="242424"/>
+                  <a:srgbClr val="E8F0FC"/>
                 </a:solidFill>
                 <a:latin typeface="Arial"/>
               </a:rPr>
@@ -6546,11 +6546,11 @@
             <a:avLst/>
           </a:prstGeom>
           <a:solidFill>
-            <a:srgbClr val="FFFFFF"/>
+            <a:srgbClr val="0F2845"/>
           </a:solidFill>
           <a:ln>
             <a:solidFill>
-              <a:srgbClr val="D9DDE3"/>
+              <a:srgbClr val="244A70"/>
             </a:solidFill>
           </a:ln>
         </p:spPr>
@@ -6645,7 +6645,7 @@
             <a:r>
               <a:rPr sz="1019" b="0" i="0">
                 <a:solidFill>
-                  <a:srgbClr val="242424"/>
+                  <a:srgbClr val="E8F0FC"/>
                 </a:solidFill>
                 <a:latin typeface="Arial"/>
               </a:rPr>
@@ -6747,11 +6747,11 @@
             <a:avLst/>
           </a:prstGeom>
           <a:solidFill>
-            <a:srgbClr val="FFFFFF"/>
+            <a:srgbClr val="0F2845"/>
           </a:solidFill>
           <a:ln>
             <a:solidFill>
-              <a:srgbClr val="D9DDE3"/>
+              <a:srgbClr val="244A70"/>
             </a:solidFill>
           </a:ln>
         </p:spPr>
@@ -6846,7 +6846,7 @@
             <a:r>
               <a:rPr sz="1019" b="0" i="0">
                 <a:solidFill>
-                  <a:srgbClr val="242424"/>
+                  <a:srgbClr val="E8F0FC"/>
                 </a:solidFill>
                 <a:latin typeface="Arial"/>
               </a:rPr>
@@ -6870,7 +6870,7 @@
             <a:avLst/>
           </a:prstGeom>
           <a:solidFill>
-            <a:srgbClr val="1F1F1F"/>
+            <a:srgbClr val="0E2A4A"/>
           </a:solidFill>
           <a:ln>
             <a:noFill/>
@@ -6924,7 +6924,7 @@
             <a:r>
               <a:rPr sz="850" b="0" i="0">
                 <a:solidFill>
-                  <a:srgbClr val="FFFFFF"/>
+                  <a:srgbClr val="B8D0EC"/>
                 </a:solidFill>
                 <a:latin typeface="Arial"/>
               </a:rPr>
@@ -6959,7 +6959,7 @@
             <a:r>
               <a:rPr sz="850" b="0" i="0">
                 <a:solidFill>
-                  <a:srgbClr val="FFFFFF"/>
+                  <a:srgbClr val="B8D0EC"/>
                 </a:solidFill>
                 <a:latin typeface="Arial"/>
               </a:rPr>
@@ -7025,7 +7025,7 @@
             <a:avLst/>
           </a:prstGeom>
           <a:solidFill>
-            <a:srgbClr val="FFFFFF"/>
+            <a:srgbClr val="020A1A"/>
           </a:solidFill>
           <a:ln>
             <a:noFill/>
@@ -7062,13 +7062,13 @@
         <p:spPr>
           <a:xfrm>
             <a:off x="0" y="0"/>
-            <a:ext cx="9144000" cy="512064"/>
-          </a:xfrm>
-          <a:prstGeom prst="rect">
-            <a:avLst/>
-          </a:prstGeom>
-          <a:solidFill>
-            <a:srgbClr val="FFFFFF"/>
+            <a:ext cx="9144000" cy="54864"/>
+          </a:xfrm>
+          <a:prstGeom prst="rect">
+            <a:avLst/>
+          </a:prstGeom>
+          <a:solidFill>
+            <a:srgbClr val="00C8F0"/>
           </a:solidFill>
           <a:ln>
             <a:noFill/>
@@ -7098,20 +7098,20 @@
       </p:sp>
       <p:sp>
         <p:nvSpPr>
-          <p:cNvPr id="5" name="Rectangle 4"/>
+          <p:cNvPr id="5" name="Rounded Rectangle 4"/>
           <p:cNvSpPr/>
           <p:nvPr/>
         </p:nvSpPr>
         <p:spPr>
           <a:xfrm>
-            <a:off x="0" y="512064"/>
-            <a:ext cx="9144000" cy="45720"/>
-          </a:xfrm>
-          <a:prstGeom prst="rect">
-            <a:avLst/>
-          </a:prstGeom>
-          <a:solidFill>
-            <a:srgbClr val="D71920"/>
+            <a:off x="320040" y="411480"/>
+            <a:ext cx="2148840" cy="274320"/>
+          </a:xfrm>
+          <a:prstGeom prst="roundRect">
+            <a:avLst/>
+          </a:prstGeom>
+          <a:solidFill>
+            <a:srgbClr val="0066A4"/>
           </a:solidFill>
           <a:ln>
             <a:noFill/>
@@ -7147,8 +7147,8 @@
         </p:nvSpPr>
         <p:spPr>
           <a:xfrm>
-            <a:off x="320040" y="118872"/>
-            <a:ext cx="1737360" cy="256032"/>
+            <a:off x="320040" y="457200"/>
+            <a:ext cx="2148840" cy="109728"/>
           </a:xfrm>
           <a:prstGeom prst="rect">
             <a:avLst/>
@@ -7161,9 +7161,44 @@
           </a:bodyPr>
           <a:lstStyle/>
           <a:p>
-            <a:pPr algn="l"/>
-            <a:r>
-              <a:rPr sz="1400" b="1" i="0">
+            <a:pPr algn="ctr"/>
+            <a:r>
+              <a:rPr sz="800" b="1" i="0">
+                <a:solidFill>
+                  <a:srgbClr val="FFFFFF"/>
+                </a:solidFill>
+                <a:latin typeface="Arial"/>
+              </a:rPr>
+              <a:t>PRD TO BACKLOG</a:t>
+            </a:r>
+          </a:p>
+        </p:txBody>
+      </p:sp>
+      <p:sp>
+        <p:nvSpPr>
+          <p:cNvPr id="7" name="TextBox 6"/>
+          <p:cNvSpPr txBox="1"/>
+          <p:nvPr/>
+        </p:nvSpPr>
+        <p:spPr>
+          <a:xfrm>
+            <a:off x="7498079" y="411480"/>
+            <a:ext cx="1325880" cy="201168"/>
+          </a:xfrm>
+          <a:prstGeom prst="rect">
+            <a:avLst/>
+          </a:prstGeom>
+          <a:noFill/>
+        </p:spPr>
+        <p:txBody>
+          <a:bodyPr wrap="square" lIns="36576" rIns="36576" tIns="18288" bIns="18288">
+            <a:spAutoFit/>
+          </a:bodyPr>
+          <a:lstStyle/>
+          <a:p>
+            <a:pPr algn="r"/>
+            <a:r>
+              <a:rPr sz="1050" b="1" i="0">
                 <a:solidFill>
                   <a:srgbClr val="D71920"/>
                 </a:solidFill>
@@ -7176,14 +7211,14 @@
       </p:sp>
       <p:sp>
         <p:nvSpPr>
-          <p:cNvPr id="7" name="TextBox 6"/>
+          <p:cNvPr id="8" name="TextBox 7"/>
           <p:cNvSpPr txBox="1"/>
           <p:nvPr/>
         </p:nvSpPr>
         <p:spPr>
           <a:xfrm>
-            <a:off x="6400800" y="146304"/>
-            <a:ext cx="2423160" cy="219456"/>
+            <a:off x="320040" y="749808"/>
+            <a:ext cx="8183879" cy="493776"/>
           </a:xfrm>
           <a:prstGeom prst="rect">
             <a:avLst/>
@@ -7196,46 +7231,11 @@
           </a:bodyPr>
           <a:lstStyle/>
           <a:p>
-            <a:pPr algn="r"/>
-            <a:r>
-              <a:rPr sz="850" b="1" i="0">
-                <a:solidFill>
-                  <a:srgbClr val="686868"/>
-                </a:solidFill>
-                <a:latin typeface="Arial"/>
-              </a:rPr>
-              <a:t>PRD TO BACKLOG</a:t>
-            </a:r>
-          </a:p>
-        </p:txBody>
-      </p:sp>
-      <p:sp>
-        <p:nvSpPr>
-          <p:cNvPr id="8" name="TextBox 7"/>
-          <p:cNvSpPr txBox="1"/>
-          <p:nvPr/>
-        </p:nvSpPr>
-        <p:spPr>
-          <a:xfrm>
-            <a:off x="320040" y="749808"/>
-            <a:ext cx="8183879" cy="493776"/>
-          </a:xfrm>
-          <a:prstGeom prst="rect">
-            <a:avLst/>
-          </a:prstGeom>
-          <a:noFill/>
-        </p:spPr>
-        <p:txBody>
-          <a:bodyPr wrap="square" lIns="36576" rIns="36576" tIns="18288" bIns="18288">
-            <a:spAutoFit/>
-          </a:bodyPr>
-          <a:lstStyle/>
-          <a:p>
             <a:pPr algn="l"/>
             <a:r>
               <a:rPr sz="2500" b="1" i="0">
                 <a:solidFill>
-                  <a:srgbClr val="242424"/>
+                  <a:srgbClr val="FFFFFF"/>
                 </a:solidFill>
                 <a:latin typeface="Arial"/>
               </a:rPr>
@@ -7259,7 +7259,7 @@
             <a:avLst/>
           </a:prstGeom>
           <a:solidFill>
-            <a:srgbClr val="D71920"/>
+            <a:srgbClr val="00C8F0"/>
           </a:solidFill>
           <a:ln>
             <a:noFill/>
@@ -7313,7 +7313,7 @@
             <a:r>
               <a:rPr sz="1180" b="0" i="1">
                 <a:solidFill>
-                  <a:srgbClr val="242424"/>
+                  <a:srgbClr val="E8F0FC"/>
                 </a:solidFill>
                 <a:latin typeface="Arial"/>
               </a:rPr>
@@ -7337,11 +7337,11 @@
             <a:avLst/>
           </a:prstGeom>
           <a:solidFill>
-            <a:srgbClr val="FFFFFF"/>
+            <a:srgbClr val="0F2845"/>
           </a:solidFill>
           <a:ln>
             <a:solidFill>
-              <a:srgbClr val="D9DDE3"/>
+              <a:srgbClr val="244A70"/>
             </a:solidFill>
           </a:ln>
         </p:spPr>
@@ -7549,7 +7549,7 @@
             <a:r>
               <a:rPr sz="890" b="0" i="0">
                 <a:solidFill>
-                  <a:srgbClr val="242424"/>
+                  <a:srgbClr val="E8F0FC"/>
                 </a:solidFill>
                 <a:latin typeface="Arial"/>
               </a:rPr>
@@ -7616,11 +7616,11 @@
             <a:avLst/>
           </a:prstGeom>
           <a:solidFill>
-            <a:srgbClr val="FFFFFF"/>
+            <a:srgbClr val="0F2845"/>
           </a:solidFill>
           <a:ln>
             <a:solidFill>
-              <a:srgbClr val="D9DDE3"/>
+              <a:srgbClr val="244A70"/>
             </a:solidFill>
           </a:ln>
         </p:spPr>
@@ -7828,7 +7828,7 @@
             <a:r>
               <a:rPr sz="890" b="0" i="0">
                 <a:solidFill>
-                  <a:srgbClr val="242424"/>
+                  <a:srgbClr val="E8F0FC"/>
                 </a:solidFill>
                 <a:latin typeface="Arial"/>
               </a:rPr>
@@ -7895,11 +7895,11 @@
             <a:avLst/>
           </a:prstGeom>
           <a:solidFill>
-            <a:srgbClr val="FFFFFF"/>
+            <a:srgbClr val="0F2845"/>
           </a:solidFill>
           <a:ln>
             <a:solidFill>
-              <a:srgbClr val="D9DDE3"/>
+              <a:srgbClr val="244A70"/>
             </a:solidFill>
           </a:ln>
         </p:spPr>
@@ -8107,7 +8107,7 @@
             <a:r>
               <a:rPr sz="890" b="0" i="0">
                 <a:solidFill>
-                  <a:srgbClr val="242424"/>
+                  <a:srgbClr val="E8F0FC"/>
                 </a:solidFill>
                 <a:latin typeface="Arial"/>
               </a:rPr>
@@ -8174,11 +8174,11 @@
             <a:avLst/>
           </a:prstGeom>
           <a:solidFill>
-            <a:srgbClr val="FFFFFF"/>
+            <a:srgbClr val="0F2845"/>
           </a:solidFill>
           <a:ln>
             <a:solidFill>
-              <a:srgbClr val="D9DDE3"/>
+              <a:srgbClr val="244A70"/>
             </a:solidFill>
           </a:ln>
         </p:spPr>
@@ -8386,7 +8386,7 @@
             <a:r>
               <a:rPr sz="890" b="0" i="0">
                 <a:solidFill>
-                  <a:srgbClr val="242424"/>
+                  <a:srgbClr val="E8F0FC"/>
                 </a:solidFill>
                 <a:latin typeface="Arial"/>
               </a:rPr>
@@ -8488,7 +8488,7 @@
             <a:avLst/>
           </a:prstGeom>
           <a:solidFill>
-            <a:srgbClr val="1F1F1F"/>
+            <a:srgbClr val="0E2A4A"/>
           </a:solidFill>
           <a:ln>
             <a:noFill/>
@@ -8542,7 +8542,7 @@
             <a:r>
               <a:rPr sz="850" b="0" i="0">
                 <a:solidFill>
-                  <a:srgbClr val="FFFFFF"/>
+                  <a:srgbClr val="B8D0EC"/>
                 </a:solidFill>
                 <a:latin typeface="Arial"/>
               </a:rPr>
@@ -8577,7 +8577,7 @@
             <a:r>
               <a:rPr sz="850" b="0" i="0">
                 <a:solidFill>
-                  <a:srgbClr val="FFFFFF"/>
+                  <a:srgbClr val="B8D0EC"/>
                 </a:solidFill>
                 <a:latin typeface="Arial"/>
               </a:rPr>
@@ -8680,13 +8680,13 @@
         <p:spPr>
           <a:xfrm>
             <a:off x="0" y="0"/>
-            <a:ext cx="9144000" cy="512064"/>
-          </a:xfrm>
-          <a:prstGeom prst="rect">
-            <a:avLst/>
-          </a:prstGeom>
-          <a:solidFill>
-            <a:srgbClr val="FFFFFF"/>
+            <a:ext cx="9144000" cy="54864"/>
+          </a:xfrm>
+          <a:prstGeom prst="rect">
+            <a:avLst/>
+          </a:prstGeom>
+          <a:solidFill>
+            <a:srgbClr val="00C8F0"/>
           </a:solidFill>
           <a:ln>
             <a:noFill/>
@@ -8716,20 +8716,20 @@
       </p:sp>
       <p:sp>
         <p:nvSpPr>
-          <p:cNvPr id="5" name="Rectangle 4"/>
+          <p:cNvPr id="5" name="Rounded Rectangle 4"/>
           <p:cNvSpPr/>
           <p:nvPr/>
         </p:nvSpPr>
         <p:spPr>
           <a:xfrm>
-            <a:off x="0" y="512064"/>
-            <a:ext cx="9144000" cy="45720"/>
-          </a:xfrm>
-          <a:prstGeom prst="rect">
-            <a:avLst/>
-          </a:prstGeom>
-          <a:solidFill>
-            <a:srgbClr val="D71920"/>
+            <a:off x="320040" y="411480"/>
+            <a:ext cx="2148840" cy="274320"/>
+          </a:xfrm>
+          <a:prstGeom prst="roundRect">
+            <a:avLst/>
+          </a:prstGeom>
+          <a:solidFill>
+            <a:srgbClr val="0066A4"/>
           </a:solidFill>
           <a:ln>
             <a:noFill/>
@@ -8765,8 +8765,8 @@
         </p:nvSpPr>
         <p:spPr>
           <a:xfrm>
-            <a:off x="320040" y="118872"/>
-            <a:ext cx="1737360" cy="256032"/>
+            <a:off x="320040" y="457200"/>
+            <a:ext cx="2148840" cy="109728"/>
           </a:xfrm>
           <a:prstGeom prst="rect">
             <a:avLst/>
@@ -8779,9 +8779,44 @@
           </a:bodyPr>
           <a:lstStyle/>
           <a:p>
-            <a:pPr algn="l"/>
-            <a:r>
-              <a:rPr sz="1400" b="1" i="0">
+            <a:pPr algn="ctr"/>
+            <a:r>
+              <a:rPr sz="800" b="1" i="0">
+                <a:solidFill>
+                  <a:srgbClr val="FFFFFF"/>
+                </a:solidFill>
+                <a:latin typeface="Arial"/>
+              </a:rPr>
+              <a:t>PG3 BUILD</a:t>
+            </a:r>
+          </a:p>
+        </p:txBody>
+      </p:sp>
+      <p:sp>
+        <p:nvSpPr>
+          <p:cNvPr id="7" name="TextBox 6"/>
+          <p:cNvSpPr txBox="1"/>
+          <p:nvPr/>
+        </p:nvSpPr>
+        <p:spPr>
+          <a:xfrm>
+            <a:off x="7498079" y="411480"/>
+            <a:ext cx="1325880" cy="201168"/>
+          </a:xfrm>
+          <a:prstGeom prst="rect">
+            <a:avLst/>
+          </a:prstGeom>
+          <a:noFill/>
+        </p:spPr>
+        <p:txBody>
+          <a:bodyPr wrap="square" lIns="36576" rIns="36576" tIns="18288" bIns="18288">
+            <a:spAutoFit/>
+          </a:bodyPr>
+          <a:lstStyle/>
+          <a:p>
+            <a:pPr algn="r"/>
+            <a:r>
+              <a:rPr sz="1050" b="1" i="0">
                 <a:solidFill>
                   <a:srgbClr val="D71920"/>
                 </a:solidFill>
@@ -8794,14 +8829,14 @@
       </p:sp>
       <p:sp>
         <p:nvSpPr>
-          <p:cNvPr id="7" name="TextBox 6"/>
+          <p:cNvPr id="8" name="TextBox 7"/>
           <p:cNvSpPr txBox="1"/>
           <p:nvPr/>
         </p:nvSpPr>
         <p:spPr>
           <a:xfrm>
-            <a:off x="6400800" y="146304"/>
-            <a:ext cx="2423160" cy="219456"/>
+            <a:off x="320040" y="749808"/>
+            <a:ext cx="8183879" cy="493776"/>
           </a:xfrm>
           <a:prstGeom prst="rect">
             <a:avLst/>
@@ -8814,41 +8849,6 @@
           </a:bodyPr>
           <a:lstStyle/>
           <a:p>
-            <a:pPr algn="r"/>
-            <a:r>
-              <a:rPr sz="850" b="1" i="0">
-                <a:solidFill>
-                  <a:srgbClr val="686868"/>
-                </a:solidFill>
-                <a:latin typeface="Arial"/>
-              </a:rPr>
-              <a:t>PG3 BUILD</a:t>
-            </a:r>
-          </a:p>
-        </p:txBody>
-      </p:sp>
-      <p:sp>
-        <p:nvSpPr>
-          <p:cNvPr id="8" name="TextBox 7"/>
-          <p:cNvSpPr txBox="1"/>
-          <p:nvPr/>
-        </p:nvSpPr>
-        <p:spPr>
-          <a:xfrm>
-            <a:off x="320040" y="749808"/>
-            <a:ext cx="8183879" cy="493776"/>
-          </a:xfrm>
-          <a:prstGeom prst="rect">
-            <a:avLst/>
-          </a:prstGeom>
-          <a:noFill/>
-        </p:spPr>
-        <p:txBody>
-          <a:bodyPr wrap="square" lIns="36576" rIns="36576" tIns="18288" bIns="18288">
-            <a:spAutoFit/>
-          </a:bodyPr>
-          <a:lstStyle/>
-          <a:p>
             <a:pPr algn="l"/>
             <a:r>
               <a:rPr sz="2500" b="1" i="0">
@@ -8877,7 +8877,7 @@
             <a:avLst/>
           </a:prstGeom>
           <a:solidFill>
-            <a:srgbClr val="D71920"/>
+            <a:srgbClr val="00C8F0"/>
           </a:solidFill>
           <a:ln>
             <a:noFill/>
@@ -8955,7 +8955,7 @@
             <a:avLst/>
           </a:prstGeom>
           <a:solidFill>
-            <a:srgbClr val="C8CCD2"/>
+            <a:srgbClr val="020A1A"/>
           </a:solidFill>
           <a:ln>
             <a:noFill/>
@@ -8998,11 +8998,11 @@
             <a:avLst/>
           </a:prstGeom>
           <a:solidFill>
-            <a:srgbClr val="FFFFFF"/>
+            <a:srgbClr val="0F2845"/>
           </a:solidFill>
           <a:ln>
             <a:solidFill>
-              <a:srgbClr val="D9DDE3"/>
+              <a:srgbClr val="244A70"/>
             </a:solidFill>
           </a:ln>
         </p:spPr>
@@ -9132,7 +9132,7 @@
             <a:r>
               <a:rPr sz="960" b="0" i="0">
                 <a:solidFill>
-                  <a:srgbClr val="242424"/>
+                  <a:srgbClr val="B8D0EC"/>
                 </a:solidFill>
                 <a:latin typeface="Arial"/>
               </a:rPr>
@@ -9160,7 +9160,7 @@
             <a:avLst/>
           </a:prstGeom>
           <a:solidFill>
-            <a:srgbClr val="C8CCD2"/>
+            <a:srgbClr val="020A1A"/>
           </a:solidFill>
           <a:ln>
             <a:noFill/>
@@ -9203,11 +9203,11 @@
             <a:avLst/>
           </a:prstGeom>
           <a:solidFill>
-            <a:srgbClr val="FFFFFF"/>
+            <a:srgbClr val="0F2845"/>
           </a:solidFill>
           <a:ln>
             <a:solidFill>
-              <a:srgbClr val="D9DDE3"/>
+              <a:srgbClr val="244A70"/>
             </a:solidFill>
           </a:ln>
         </p:spPr>
@@ -9337,7 +9337,7 @@
             <a:r>
               <a:rPr sz="960" b="0" i="0">
                 <a:solidFill>
-                  <a:srgbClr val="242424"/>
+                  <a:srgbClr val="B8D0EC"/>
                 </a:solidFill>
                 <a:latin typeface="Arial"/>
               </a:rPr>
@@ -9365,7 +9365,7 @@
             <a:avLst/>
           </a:prstGeom>
           <a:solidFill>
-            <a:srgbClr val="C8CCD2"/>
+            <a:srgbClr val="020A1A"/>
           </a:solidFill>
           <a:ln>
             <a:noFill/>
@@ -9408,11 +9408,11 @@
             <a:avLst/>
           </a:prstGeom>
           <a:solidFill>
-            <a:srgbClr val="FFFFFF"/>
+            <a:srgbClr val="0F2845"/>
           </a:solidFill>
           <a:ln>
             <a:solidFill>
-              <a:srgbClr val="D9DDE3"/>
+              <a:srgbClr val="244A70"/>
             </a:solidFill>
           </a:ln>
         </p:spPr>
@@ -9542,7 +9542,7 @@
             <a:r>
               <a:rPr sz="960" b="0" i="0">
                 <a:solidFill>
-                  <a:srgbClr val="242424"/>
+                  <a:srgbClr val="B8D0EC"/>
                 </a:solidFill>
                 <a:latin typeface="Arial"/>
               </a:rPr>
@@ -9648,7 +9648,7 @@
             <a:avLst/>
           </a:prstGeom>
           <a:solidFill>
-            <a:srgbClr val="1F1F1F"/>
+            <a:srgbClr val="0E2A4A"/>
           </a:solidFill>
           <a:ln>
             <a:noFill/>
@@ -9702,7 +9702,7 @@
             <a:r>
               <a:rPr sz="850" b="0" i="0">
                 <a:solidFill>
-                  <a:srgbClr val="FFFFFF"/>
+                  <a:srgbClr val="B8D0EC"/>
                 </a:solidFill>
                 <a:latin typeface="Arial"/>
               </a:rPr>
@@ -9737,7 +9737,7 @@
             <a:r>
               <a:rPr sz="850" b="0" i="0">
                 <a:solidFill>
-                  <a:srgbClr val="FFFFFF"/>
+                  <a:srgbClr val="B8D0EC"/>
                 </a:solidFill>
                 <a:latin typeface="Arial"/>
               </a:rPr>
@@ -9840,13 +9840,13 @@
         <p:spPr>
           <a:xfrm>
             <a:off x="0" y="0"/>
-            <a:ext cx="9144000" cy="512064"/>
-          </a:xfrm>
-          <a:prstGeom prst="rect">
-            <a:avLst/>
-          </a:prstGeom>
-          <a:solidFill>
-            <a:srgbClr val="FFFFFF"/>
+            <a:ext cx="9144000" cy="54864"/>
+          </a:xfrm>
+          <a:prstGeom prst="rect">
+            <a:avLst/>
+          </a:prstGeom>
+          <a:solidFill>
+            <a:srgbClr val="00C8F0"/>
           </a:solidFill>
           <a:ln>
             <a:noFill/>
@@ -9876,20 +9876,20 @@
       </p:sp>
       <p:sp>
         <p:nvSpPr>
-          <p:cNvPr id="5" name="Rectangle 4"/>
+          <p:cNvPr id="5" name="Rounded Rectangle 4"/>
           <p:cNvSpPr/>
           <p:nvPr/>
         </p:nvSpPr>
         <p:spPr>
           <a:xfrm>
-            <a:off x="0" y="512064"/>
-            <a:ext cx="9144000" cy="45720"/>
-          </a:xfrm>
-          <a:prstGeom prst="rect">
-            <a:avLst/>
-          </a:prstGeom>
-          <a:solidFill>
-            <a:srgbClr val="D71920"/>
+            <a:off x="320040" y="411480"/>
+            <a:ext cx="2148840" cy="274320"/>
+          </a:xfrm>
+          <a:prstGeom prst="roundRect">
+            <a:avLst/>
+          </a:prstGeom>
+          <a:solidFill>
+            <a:srgbClr val="0066A4"/>
           </a:solidFill>
           <a:ln>
             <a:noFill/>
@@ -9925,8 +9925,8 @@
         </p:nvSpPr>
         <p:spPr>
           <a:xfrm>
-            <a:off x="320040" y="118872"/>
-            <a:ext cx="1737360" cy="256032"/>
+            <a:off x="320040" y="457200"/>
+            <a:ext cx="2148840" cy="109728"/>
           </a:xfrm>
           <a:prstGeom prst="rect">
             <a:avLst/>
@@ -9939,9 +9939,44 @@
           </a:bodyPr>
           <a:lstStyle/>
           <a:p>
-            <a:pPr algn="l"/>
-            <a:r>
-              <a:rPr sz="1400" b="1" i="0">
+            <a:pPr algn="ctr"/>
+            <a:r>
+              <a:rPr sz="800" b="1" i="0">
+                <a:solidFill>
+                  <a:srgbClr val="FFFFFF"/>
+                </a:solidFill>
+                <a:latin typeface="Arial"/>
+              </a:rPr>
+              <a:t>JTAG DEBUG COPILOT</a:t>
+            </a:r>
+          </a:p>
+        </p:txBody>
+      </p:sp>
+      <p:sp>
+        <p:nvSpPr>
+          <p:cNvPr id="7" name="TextBox 6"/>
+          <p:cNvSpPr txBox="1"/>
+          <p:nvPr/>
+        </p:nvSpPr>
+        <p:spPr>
+          <a:xfrm>
+            <a:off x="7498079" y="411480"/>
+            <a:ext cx="1325880" cy="201168"/>
+          </a:xfrm>
+          <a:prstGeom prst="rect">
+            <a:avLst/>
+          </a:prstGeom>
+          <a:noFill/>
+        </p:spPr>
+        <p:txBody>
+          <a:bodyPr wrap="square" lIns="36576" rIns="36576" tIns="18288" bIns="18288">
+            <a:spAutoFit/>
+          </a:bodyPr>
+          <a:lstStyle/>
+          <a:p>
+            <a:pPr algn="r"/>
+            <a:r>
+              <a:rPr sz="1050" b="1" i="0">
                 <a:solidFill>
                   <a:srgbClr val="D71920"/>
                 </a:solidFill>
@@ -9954,14 +9989,14 @@
       </p:sp>
       <p:sp>
         <p:nvSpPr>
-          <p:cNvPr id="7" name="TextBox 6"/>
+          <p:cNvPr id="8" name="TextBox 7"/>
           <p:cNvSpPr txBox="1"/>
           <p:nvPr/>
         </p:nvSpPr>
         <p:spPr>
           <a:xfrm>
-            <a:off x="6400800" y="146304"/>
-            <a:ext cx="2423160" cy="219456"/>
+            <a:off x="320040" y="749808"/>
+            <a:ext cx="8183879" cy="493776"/>
           </a:xfrm>
           <a:prstGeom prst="rect">
             <a:avLst/>
@@ -9974,41 +10009,6 @@
           </a:bodyPr>
           <a:lstStyle/>
           <a:p>
-            <a:pPr algn="r"/>
-            <a:r>
-              <a:rPr sz="850" b="1" i="0">
-                <a:solidFill>
-                  <a:srgbClr val="686868"/>
-                </a:solidFill>
-                <a:latin typeface="Arial"/>
-              </a:rPr>
-              <a:t>JTAG DEBUG COPILOT</a:t>
-            </a:r>
-          </a:p>
-        </p:txBody>
-      </p:sp>
-      <p:sp>
-        <p:nvSpPr>
-          <p:cNvPr id="8" name="TextBox 7"/>
-          <p:cNvSpPr txBox="1"/>
-          <p:nvPr/>
-        </p:nvSpPr>
-        <p:spPr>
-          <a:xfrm>
-            <a:off x="320040" y="749808"/>
-            <a:ext cx="8183879" cy="493776"/>
-          </a:xfrm>
-          <a:prstGeom prst="rect">
-            <a:avLst/>
-          </a:prstGeom>
-          <a:noFill/>
-        </p:spPr>
-        <p:txBody>
-          <a:bodyPr wrap="square" lIns="36576" rIns="36576" tIns="18288" bIns="18288">
-            <a:spAutoFit/>
-          </a:bodyPr>
-          <a:lstStyle/>
-          <a:p>
             <a:pPr algn="l"/>
             <a:r>
               <a:rPr sz="2500" b="1" i="0">
@@ -10037,7 +10037,7 @@
             <a:avLst/>
           </a:prstGeom>
           <a:solidFill>
-            <a:srgbClr val="D71920"/>
+            <a:srgbClr val="00C8F0"/>
           </a:solidFill>
           <a:ln>
             <a:noFill/>
@@ -10115,11 +10115,11 @@
             <a:avLst/>
           </a:prstGeom>
           <a:solidFill>
-            <a:srgbClr val="FFFFFF"/>
+            <a:srgbClr val="0B1F3A"/>
           </a:solidFill>
           <a:ln>
             <a:solidFill>
-              <a:srgbClr val="D9DDE3"/>
+              <a:srgbClr val="244A70"/>
             </a:solidFill>
           </a:ln>
         </p:spPr>
@@ -10297,11 +10297,11 @@
             <a:avLst/>
           </a:prstGeom>
           <a:solidFill>
-            <a:srgbClr val="FFFFFF"/>
+            <a:srgbClr val="0F2845"/>
           </a:solidFill>
           <a:ln>
             <a:solidFill>
-              <a:srgbClr val="D9DDE3"/>
+              <a:srgbClr val="244A70"/>
             </a:solidFill>
           </a:ln>
         </p:spPr>
@@ -10431,7 +10431,7 @@
             <a:r>
               <a:rPr sz="840" b="0" i="0">
                 <a:solidFill>
-                  <a:srgbClr val="242424"/>
+                  <a:srgbClr val="E8F0FC"/>
                 </a:solidFill>
                 <a:latin typeface="Arial"/>
               </a:rPr>
@@ -10533,11 +10533,11 @@
             <a:avLst/>
           </a:prstGeom>
           <a:solidFill>
-            <a:srgbClr val="FFFFFF"/>
+            <a:srgbClr val="0F2845"/>
           </a:solidFill>
           <a:ln>
             <a:solidFill>
-              <a:srgbClr val="D9DDE3"/>
+              <a:srgbClr val="244A70"/>
             </a:solidFill>
           </a:ln>
         </p:spPr>
@@ -10667,7 +10667,7 @@
             <a:r>
               <a:rPr sz="840" b="0" i="0">
                 <a:solidFill>
-                  <a:srgbClr val="242424"/>
+                  <a:srgbClr val="E8F0FC"/>
                 </a:solidFill>
                 <a:latin typeface="Arial"/>
               </a:rPr>
@@ -10769,11 +10769,11 @@
             <a:avLst/>
           </a:prstGeom>
           <a:solidFill>
-            <a:srgbClr val="FFFFFF"/>
+            <a:srgbClr val="0F2845"/>
           </a:solidFill>
           <a:ln>
             <a:solidFill>
-              <a:srgbClr val="D9DDE3"/>
+              <a:srgbClr val="244A70"/>
             </a:solidFill>
           </a:ln>
         </p:spPr>
@@ -10903,7 +10903,7 @@
             <a:r>
               <a:rPr sz="840" b="0" i="0">
                 <a:solidFill>
-                  <a:srgbClr val="242424"/>
+                  <a:srgbClr val="E8F0FC"/>
                 </a:solidFill>
                 <a:latin typeface="Arial"/>
               </a:rPr>
@@ -11083,7 +11083,7 @@
             <a:avLst/>
           </a:prstGeom>
           <a:solidFill>
-            <a:srgbClr val="1F1F1F"/>
+            <a:srgbClr val="0E2A4A"/>
           </a:solidFill>
           <a:ln>
             <a:noFill/>
@@ -11137,7 +11137,7 @@
             <a:r>
               <a:rPr sz="850" b="0" i="0">
                 <a:solidFill>
-                  <a:srgbClr val="FFFFFF"/>
+                  <a:srgbClr val="B8D0EC"/>
                 </a:solidFill>
                 <a:latin typeface="Arial"/>
               </a:rPr>
@@ -11172,7 +11172,7 @@
             <a:r>
               <a:rPr sz="850" b="0" i="0">
                 <a:solidFill>
-                  <a:srgbClr val="FFFFFF"/>
+                  <a:srgbClr val="B8D0EC"/>
                 </a:solidFill>
                 <a:latin typeface="Arial"/>
               </a:rPr>
@@ -11238,7 +11238,7 @@
             <a:avLst/>
           </a:prstGeom>
           <a:solidFill>
-            <a:srgbClr val="FFFFFF"/>
+            <a:srgbClr val="020A1A"/>
           </a:solidFill>
           <a:ln>
             <a:noFill/>
@@ -11275,13 +11275,13 @@
         <p:spPr>
           <a:xfrm>
             <a:off x="0" y="0"/>
-            <a:ext cx="9144000" cy="512064"/>
-          </a:xfrm>
-          <a:prstGeom prst="rect">
-            <a:avLst/>
-          </a:prstGeom>
-          <a:solidFill>
-            <a:srgbClr val="FFFFFF"/>
+            <a:ext cx="9144000" cy="54864"/>
+          </a:xfrm>
+          <a:prstGeom prst="rect">
+            <a:avLst/>
+          </a:prstGeom>
+          <a:solidFill>
+            <a:srgbClr val="00C8F0"/>
           </a:solidFill>
           <a:ln>
             <a:noFill/>
@@ -11311,20 +11311,20 @@
       </p:sp>
       <p:sp>
         <p:nvSpPr>
-          <p:cNvPr id="5" name="Rectangle 4"/>
+          <p:cNvPr id="5" name="Rounded Rectangle 4"/>
           <p:cNvSpPr/>
           <p:nvPr/>
         </p:nvSpPr>
         <p:spPr>
           <a:xfrm>
-            <a:off x="0" y="512064"/>
-            <a:ext cx="9144000" cy="45720"/>
-          </a:xfrm>
-          <a:prstGeom prst="rect">
-            <a:avLst/>
-          </a:prstGeom>
-          <a:solidFill>
-            <a:srgbClr val="D71920"/>
+            <a:off x="320040" y="411480"/>
+            <a:ext cx="2148840" cy="274320"/>
+          </a:xfrm>
+          <a:prstGeom prst="roundRect">
+            <a:avLst/>
+          </a:prstGeom>
+          <a:solidFill>
+            <a:srgbClr val="0066A4"/>
           </a:solidFill>
           <a:ln>
             <a:noFill/>
@@ -11360,8 +11360,8 @@
         </p:nvSpPr>
         <p:spPr>
           <a:xfrm>
-            <a:off x="320040" y="118872"/>
-            <a:ext cx="1737360" cy="256032"/>
+            <a:off x="320040" y="457200"/>
+            <a:ext cx="2148840" cy="109728"/>
           </a:xfrm>
           <a:prstGeom prst="rect">
             <a:avLst/>
@@ -11374,9 +11374,44 @@
           </a:bodyPr>
           <a:lstStyle/>
           <a:p>
-            <a:pPr algn="l"/>
-            <a:r>
-              <a:rPr sz="1400" b="1" i="0">
+            <a:pPr algn="ctr"/>
+            <a:r>
+              <a:rPr sz="800" b="1" i="0">
+                <a:solidFill>
+                  <a:srgbClr val="FFFFFF"/>
+                </a:solidFill>
+                <a:latin typeface="Arial"/>
+              </a:rPr>
+              <a:t>QA RELEASE GATE</a:t>
+            </a:r>
+          </a:p>
+        </p:txBody>
+      </p:sp>
+      <p:sp>
+        <p:nvSpPr>
+          <p:cNvPr id="7" name="TextBox 6"/>
+          <p:cNvSpPr txBox="1"/>
+          <p:nvPr/>
+        </p:nvSpPr>
+        <p:spPr>
+          <a:xfrm>
+            <a:off x="7498079" y="411480"/>
+            <a:ext cx="1325880" cy="201168"/>
+          </a:xfrm>
+          <a:prstGeom prst="rect">
+            <a:avLst/>
+          </a:prstGeom>
+          <a:noFill/>
+        </p:spPr>
+        <p:txBody>
+          <a:bodyPr wrap="square" lIns="36576" rIns="36576" tIns="18288" bIns="18288">
+            <a:spAutoFit/>
+          </a:bodyPr>
+          <a:lstStyle/>
+          <a:p>
+            <a:pPr algn="r"/>
+            <a:r>
+              <a:rPr sz="1050" b="1" i="0">
                 <a:solidFill>
                   <a:srgbClr val="D71920"/>
                 </a:solidFill>
@@ -11389,14 +11424,14 @@
       </p:sp>
       <p:sp>
         <p:nvSpPr>
-          <p:cNvPr id="7" name="TextBox 6"/>
+          <p:cNvPr id="8" name="TextBox 7"/>
           <p:cNvSpPr txBox="1"/>
           <p:nvPr/>
         </p:nvSpPr>
         <p:spPr>
           <a:xfrm>
-            <a:off x="6400800" y="146304"/>
-            <a:ext cx="2423160" cy="219456"/>
+            <a:off x="320040" y="749808"/>
+            <a:ext cx="8183879" cy="493776"/>
           </a:xfrm>
           <a:prstGeom prst="rect">
             <a:avLst/>
@@ -11409,46 +11444,11 @@
           </a:bodyPr>
           <a:lstStyle/>
           <a:p>
-            <a:pPr algn="r"/>
-            <a:r>
-              <a:rPr sz="850" b="1" i="0">
-                <a:solidFill>
-                  <a:srgbClr val="686868"/>
-                </a:solidFill>
-                <a:latin typeface="Arial"/>
-              </a:rPr>
-              <a:t>QA RELEASE GATE</a:t>
-            </a:r>
-          </a:p>
-        </p:txBody>
-      </p:sp>
-      <p:sp>
-        <p:nvSpPr>
-          <p:cNvPr id="8" name="TextBox 7"/>
-          <p:cNvSpPr txBox="1"/>
-          <p:nvPr/>
-        </p:nvSpPr>
-        <p:spPr>
-          <a:xfrm>
-            <a:off x="320040" y="749808"/>
-            <a:ext cx="8183879" cy="493776"/>
-          </a:xfrm>
-          <a:prstGeom prst="rect">
-            <a:avLst/>
-          </a:prstGeom>
-          <a:noFill/>
-        </p:spPr>
-        <p:txBody>
-          <a:bodyPr wrap="square" lIns="36576" rIns="36576" tIns="18288" bIns="18288">
-            <a:spAutoFit/>
-          </a:bodyPr>
-          <a:lstStyle/>
-          <a:p>
             <a:pPr algn="l"/>
             <a:r>
               <a:rPr sz="2500" b="1" i="0">
                 <a:solidFill>
-                  <a:srgbClr val="242424"/>
+                  <a:srgbClr val="FFFFFF"/>
                 </a:solidFill>
                 <a:latin typeface="Arial"/>
               </a:rPr>
@@ -11472,7 +11472,7 @@
             <a:avLst/>
           </a:prstGeom>
           <a:solidFill>
-            <a:srgbClr val="D71920"/>
+            <a:srgbClr val="00C8F0"/>
           </a:solidFill>
           <a:ln>
             <a:noFill/>
@@ -11526,7 +11526,7 @@
             <a:r>
               <a:rPr sz="1180" b="0" i="1">
                 <a:solidFill>
-                  <a:srgbClr val="242424"/>
+                  <a:srgbClr val="E8F0FC"/>
                 </a:solidFill>
                 <a:latin typeface="Arial"/>
               </a:rPr>
@@ -11550,11 +11550,11 @@
             <a:avLst/>
           </a:prstGeom>
           <a:solidFill>
-            <a:srgbClr val="FFFFFF"/>
+            <a:srgbClr val="0F2845"/>
           </a:solidFill>
           <a:ln>
             <a:solidFill>
-              <a:srgbClr val="D9DDE3"/>
+              <a:srgbClr val="244A70"/>
             </a:solidFill>
           </a:ln>
         </p:spPr>
@@ -11762,7 +11762,7 @@
             <a:r>
               <a:rPr sz="830" b="0" i="0">
                 <a:solidFill>
-                  <a:srgbClr val="242424"/>
+                  <a:srgbClr val="E8F0FC"/>
                 </a:solidFill>
                 <a:latin typeface="Arial"/>
               </a:rPr>
@@ -11786,11 +11786,11 @@
             <a:avLst/>
           </a:prstGeom>
           <a:solidFill>
-            <a:srgbClr val="FFFFFF"/>
+            <a:srgbClr val="0F2845"/>
           </a:solidFill>
           <a:ln>
             <a:solidFill>
-              <a:srgbClr val="D9DDE3"/>
+              <a:srgbClr val="244A70"/>
             </a:solidFill>
           </a:ln>
         </p:spPr>
@@ -11998,7 +11998,7 @@
             <a:r>
               <a:rPr sz="830" b="0" i="0">
                 <a:solidFill>
-                  <a:srgbClr val="242424"/>
+                  <a:srgbClr val="E8F0FC"/>
                 </a:solidFill>
                 <a:latin typeface="Arial"/>
               </a:rPr>
@@ -12022,11 +12022,11 @@
             <a:avLst/>
           </a:prstGeom>
           <a:solidFill>
-            <a:srgbClr val="FFFFFF"/>
+            <a:srgbClr val="0F2845"/>
           </a:solidFill>
           <a:ln>
             <a:solidFill>
-              <a:srgbClr val="D9DDE3"/>
+              <a:srgbClr val="244A70"/>
             </a:solidFill>
           </a:ln>
         </p:spPr>
@@ -12234,7 +12234,7 @@
             <a:r>
               <a:rPr sz="830" b="0" i="0">
                 <a:solidFill>
-                  <a:srgbClr val="242424"/>
+                  <a:srgbClr val="E8F0FC"/>
                 </a:solidFill>
                 <a:latin typeface="Arial"/>
               </a:rPr>
@@ -12258,11 +12258,11 @@
             <a:avLst/>
           </a:prstGeom>
           <a:solidFill>
-            <a:srgbClr val="FFFFFF"/>
+            <a:srgbClr val="0F2845"/>
           </a:solidFill>
           <a:ln>
             <a:solidFill>
-              <a:srgbClr val="D9DDE3"/>
+              <a:srgbClr val="244A70"/>
             </a:solidFill>
           </a:ln>
         </p:spPr>
@@ -12470,7 +12470,7 @@
             <a:r>
               <a:rPr sz="830" b="0" i="0">
                 <a:solidFill>
-                  <a:srgbClr val="242424"/>
+                  <a:srgbClr val="E8F0FC"/>
                 </a:solidFill>
                 <a:latin typeface="Arial"/>
               </a:rPr>
@@ -12494,11 +12494,11 @@
             <a:avLst/>
           </a:prstGeom>
           <a:solidFill>
-            <a:srgbClr val="FFFFFF"/>
+            <a:srgbClr val="0F2845"/>
           </a:solidFill>
           <a:ln>
             <a:solidFill>
-              <a:srgbClr val="D9DDE3"/>
+              <a:srgbClr val="244A70"/>
             </a:solidFill>
           </a:ln>
         </p:spPr>
@@ -12706,7 +12706,7 @@
             <a:r>
               <a:rPr sz="830" b="0" i="0">
                 <a:solidFill>
-                  <a:srgbClr val="242424"/>
+                  <a:srgbClr val="E8F0FC"/>
                 </a:solidFill>
                 <a:latin typeface="Arial"/>
               </a:rPr>
@@ -12808,7 +12808,7 @@
             <a:avLst/>
           </a:prstGeom>
           <a:solidFill>
-            <a:srgbClr val="1F1F1F"/>
+            <a:srgbClr val="0E2A4A"/>
           </a:solidFill>
           <a:ln>
             <a:noFill/>
@@ -12862,7 +12862,7 @@
             <a:r>
               <a:rPr sz="850" b="0" i="0">
                 <a:solidFill>
-                  <a:srgbClr val="FFFFFF"/>
+                  <a:srgbClr val="B8D0EC"/>
                 </a:solidFill>
                 <a:latin typeface="Arial"/>
               </a:rPr>
@@ -12897,7 +12897,7 @@
             <a:r>
               <a:rPr sz="850" b="0" i="0">
                 <a:solidFill>
-                  <a:srgbClr val="FFFFFF"/>
+                  <a:srgbClr val="B8D0EC"/>
                 </a:solidFill>
                 <a:latin typeface="Arial"/>
               </a:rPr>
@@ -13000,13 +13000,13 @@
         <p:spPr>
           <a:xfrm>
             <a:off x="0" y="0"/>
-            <a:ext cx="9144000" cy="512064"/>
-          </a:xfrm>
-          <a:prstGeom prst="rect">
-            <a:avLst/>
-          </a:prstGeom>
-          <a:solidFill>
-            <a:srgbClr val="FFFFFF"/>
+            <a:ext cx="9144000" cy="54864"/>
+          </a:xfrm>
+          <a:prstGeom prst="rect">
+            <a:avLst/>
+          </a:prstGeom>
+          <a:solidFill>
+            <a:srgbClr val="00C8F0"/>
           </a:solidFill>
           <a:ln>
             <a:noFill/>
@@ -13036,20 +13036,20 @@
       </p:sp>
       <p:sp>
         <p:nvSpPr>
-          <p:cNvPr id="5" name="Rectangle 4"/>
+          <p:cNvPr id="5" name="Rounded Rectangle 4"/>
           <p:cNvSpPr/>
           <p:nvPr/>
         </p:nvSpPr>
         <p:spPr>
           <a:xfrm>
-            <a:off x="0" y="512064"/>
-            <a:ext cx="9144000" cy="45720"/>
-          </a:xfrm>
-          <a:prstGeom prst="rect">
-            <a:avLst/>
-          </a:prstGeom>
-          <a:solidFill>
-            <a:srgbClr val="D71920"/>
+            <a:off x="320040" y="411480"/>
+            <a:ext cx="2148840" cy="274320"/>
+          </a:xfrm>
+          <a:prstGeom prst="roundRect">
+            <a:avLst/>
+          </a:prstGeom>
+          <a:solidFill>
+            <a:srgbClr val="0066A4"/>
           </a:solidFill>
           <a:ln>
             <a:noFill/>
@@ -13085,8 +13085,8 @@
         </p:nvSpPr>
         <p:spPr>
           <a:xfrm>
-            <a:off x="320040" y="118872"/>
-            <a:ext cx="1737360" cy="256032"/>
+            <a:off x="320040" y="457200"/>
+            <a:ext cx="2148840" cy="109728"/>
           </a:xfrm>
           <a:prstGeom prst="rect">
             <a:avLst/>
@@ -13099,9 +13099,44 @@
           </a:bodyPr>
           <a:lstStyle/>
           <a:p>
-            <a:pPr algn="l"/>
-            <a:r>
-              <a:rPr sz="1400" b="1" i="0">
+            <a:pPr algn="ctr"/>
+            <a:r>
+              <a:rPr sz="800" b="1" i="0">
+                <a:solidFill>
+                  <a:srgbClr val="FFFFFF"/>
+                </a:solidFill>
+                <a:latin typeface="Arial"/>
+              </a:rPr>
+              <a:t>PG5 STQC AGENT</a:t>
+            </a:r>
+          </a:p>
+        </p:txBody>
+      </p:sp>
+      <p:sp>
+        <p:nvSpPr>
+          <p:cNvPr id="7" name="TextBox 6"/>
+          <p:cNvSpPr txBox="1"/>
+          <p:nvPr/>
+        </p:nvSpPr>
+        <p:spPr>
+          <a:xfrm>
+            <a:off x="7498079" y="411480"/>
+            <a:ext cx="1325880" cy="201168"/>
+          </a:xfrm>
+          <a:prstGeom prst="rect">
+            <a:avLst/>
+          </a:prstGeom>
+          <a:noFill/>
+        </p:spPr>
+        <p:txBody>
+          <a:bodyPr wrap="square" lIns="36576" rIns="36576" tIns="18288" bIns="18288">
+            <a:spAutoFit/>
+          </a:bodyPr>
+          <a:lstStyle/>
+          <a:p>
+            <a:pPr algn="r"/>
+            <a:r>
+              <a:rPr sz="1050" b="1" i="0">
                 <a:solidFill>
                   <a:srgbClr val="D71920"/>
                 </a:solidFill>
@@ -13114,14 +13149,14 @@
       </p:sp>
       <p:sp>
         <p:nvSpPr>
-          <p:cNvPr id="7" name="TextBox 6"/>
+          <p:cNvPr id="8" name="TextBox 7"/>
           <p:cNvSpPr txBox="1"/>
           <p:nvPr/>
         </p:nvSpPr>
         <p:spPr>
           <a:xfrm>
-            <a:off x="6400800" y="146304"/>
-            <a:ext cx="2423160" cy="219456"/>
+            <a:off x="320040" y="749808"/>
+            <a:ext cx="8183879" cy="493776"/>
           </a:xfrm>
           <a:prstGeom prst="rect">
             <a:avLst/>
@@ -13134,41 +13169,6 @@
           </a:bodyPr>
           <a:lstStyle/>
           <a:p>
-            <a:pPr algn="r"/>
-            <a:r>
-              <a:rPr sz="850" b="1" i="0">
-                <a:solidFill>
-                  <a:srgbClr val="686868"/>
-                </a:solidFill>
-                <a:latin typeface="Arial"/>
-              </a:rPr>
-              <a:t>PG5 STQC AGENT</a:t>
-            </a:r>
-          </a:p>
-        </p:txBody>
-      </p:sp>
-      <p:sp>
-        <p:nvSpPr>
-          <p:cNvPr id="8" name="TextBox 7"/>
-          <p:cNvSpPr txBox="1"/>
-          <p:nvPr/>
-        </p:nvSpPr>
-        <p:spPr>
-          <a:xfrm>
-            <a:off x="320040" y="749808"/>
-            <a:ext cx="8183879" cy="493776"/>
-          </a:xfrm>
-          <a:prstGeom prst="rect">
-            <a:avLst/>
-          </a:prstGeom>
-          <a:noFill/>
-        </p:spPr>
-        <p:txBody>
-          <a:bodyPr wrap="square" lIns="36576" rIns="36576" tIns="18288" bIns="18288">
-            <a:spAutoFit/>
-          </a:bodyPr>
-          <a:lstStyle/>
-          <a:p>
             <a:pPr algn="l"/>
             <a:r>
               <a:rPr sz="2500" b="1" i="0">
@@ -13197,7 +13197,7 @@
             <a:avLst/>
           </a:prstGeom>
           <a:solidFill>
-            <a:srgbClr val="D71920"/>
+            <a:srgbClr val="00C8F0"/>
           </a:solidFill>
           <a:ln>
             <a:noFill/>
@@ -13275,7 +13275,7 @@
             <a:avLst/>
           </a:prstGeom>
           <a:solidFill>
-            <a:srgbClr val="C8CCD2"/>
+            <a:srgbClr val="020A1A"/>
           </a:solidFill>
           <a:ln>
             <a:noFill/>
@@ -13318,11 +13318,11 @@
             <a:avLst/>
           </a:prstGeom>
           <a:solidFill>
-            <a:srgbClr val="FFFFFF"/>
+            <a:srgbClr val="0F2845"/>
           </a:solidFill>
           <a:ln>
             <a:solidFill>
-              <a:srgbClr val="D9DDE3"/>
+              <a:srgbClr val="244A70"/>
             </a:solidFill>
           </a:ln>
         </p:spPr>
@@ -13452,7 +13452,7 @@
             <a:r>
               <a:rPr sz="969" b="0" i="0">
                 <a:solidFill>
-                  <a:srgbClr val="242424"/>
+                  <a:srgbClr val="B8D0EC"/>
                 </a:solidFill>
                 <a:latin typeface="Arial"/>
               </a:rPr>
@@ -13477,7 +13477,7 @@
             <a:avLst/>
           </a:prstGeom>
           <a:solidFill>
-            <a:srgbClr val="C8CCD2"/>
+            <a:srgbClr val="020A1A"/>
           </a:solidFill>
           <a:ln>
             <a:noFill/>
@@ -13520,11 +13520,11 @@
             <a:avLst/>
           </a:prstGeom>
           <a:solidFill>
-            <a:srgbClr val="FFFFFF"/>
+            <a:srgbClr val="0F2845"/>
           </a:solidFill>
           <a:ln>
             <a:solidFill>
-              <a:srgbClr val="D9DDE3"/>
+              <a:srgbClr val="244A70"/>
             </a:solidFill>
           </a:ln>
         </p:spPr>
@@ -13654,7 +13654,7 @@
             <a:r>
               <a:rPr sz="919" b="0" i="0">
                 <a:solidFill>
-                  <a:srgbClr val="242424"/>
+                  <a:srgbClr val="B8D0EC"/>
                 </a:solidFill>
                 <a:latin typeface="Arial"/>
               </a:rPr>
@@ -13682,7 +13682,7 @@
             <a:avLst/>
           </a:prstGeom>
           <a:solidFill>
-            <a:srgbClr val="C8CCD2"/>
+            <a:srgbClr val="020A1A"/>
           </a:solidFill>
           <a:ln>
             <a:noFill/>
@@ -13725,11 +13725,11 @@
             <a:avLst/>
           </a:prstGeom>
           <a:solidFill>
-            <a:srgbClr val="FFFFFF"/>
+            <a:srgbClr val="0F2845"/>
           </a:solidFill>
           <a:ln>
             <a:solidFill>
-              <a:srgbClr val="D9DDE3"/>
+              <a:srgbClr val="244A70"/>
             </a:solidFill>
           </a:ln>
         </p:spPr>
@@ -13859,7 +13859,7 @@
             <a:r>
               <a:rPr sz="919" b="0" i="0">
                 <a:solidFill>
-                  <a:srgbClr val="242424"/>
+                  <a:srgbClr val="B8D0EC"/>
                 </a:solidFill>
                 <a:latin typeface="Arial"/>
               </a:rPr>
@@ -13965,7 +13965,7 @@
             <a:avLst/>
           </a:prstGeom>
           <a:solidFill>
-            <a:srgbClr val="1F1F1F"/>
+            <a:srgbClr val="0E2A4A"/>
           </a:solidFill>
           <a:ln>
             <a:noFill/>
@@ -14019,7 +14019,7 @@
             <a:r>
               <a:rPr sz="850" b="0" i="0">
                 <a:solidFill>
-                  <a:srgbClr val="FFFFFF"/>
+                  <a:srgbClr val="B8D0EC"/>
                 </a:solidFill>
                 <a:latin typeface="Arial"/>
               </a:rPr>
@@ -14054,7 +14054,7 @@
             <a:r>
               <a:rPr sz="850" b="0" i="0">
                 <a:solidFill>
-                  <a:srgbClr val="FFFFFF"/>
+                  <a:srgbClr val="B8D0EC"/>
                 </a:solidFill>
                 <a:latin typeface="Arial"/>
               </a:rPr>
@@ -14120,7 +14120,7 @@
             <a:avLst/>
           </a:prstGeom>
           <a:solidFill>
-            <a:srgbClr val="FFFFFF"/>
+            <a:srgbClr val="020A1A"/>
           </a:solidFill>
           <a:ln>
             <a:noFill/>
@@ -14157,13 +14157,13 @@
         <p:spPr>
           <a:xfrm>
             <a:off x="0" y="0"/>
-            <a:ext cx="9144000" cy="512064"/>
-          </a:xfrm>
-          <a:prstGeom prst="rect">
-            <a:avLst/>
-          </a:prstGeom>
-          <a:solidFill>
-            <a:srgbClr val="FFFFFF"/>
+            <a:ext cx="9144000" cy="54864"/>
+          </a:xfrm>
+          <a:prstGeom prst="rect">
+            <a:avLst/>
+          </a:prstGeom>
+          <a:solidFill>
+            <a:srgbClr val="00C8F0"/>
           </a:solidFill>
           <a:ln>
             <a:noFill/>
@@ -14193,20 +14193,20 @@
       </p:sp>
       <p:sp>
         <p:nvSpPr>
-          <p:cNvPr id="5" name="Rectangle 4"/>
+          <p:cNvPr id="5" name="Rounded Rectangle 4"/>
           <p:cNvSpPr/>
           <p:nvPr/>
         </p:nvSpPr>
         <p:spPr>
           <a:xfrm>
-            <a:off x="0" y="512064"/>
-            <a:ext cx="9144000" cy="45720"/>
-          </a:xfrm>
-          <a:prstGeom prst="rect">
-            <a:avLst/>
-          </a:prstGeom>
-          <a:solidFill>
-            <a:srgbClr val="D71920"/>
+            <a:off x="320040" y="411480"/>
+            <a:ext cx="2148840" cy="274320"/>
+          </a:xfrm>
+          <a:prstGeom prst="roundRect">
+            <a:avLst/>
+          </a:prstGeom>
+          <a:solidFill>
+            <a:srgbClr val="0066A4"/>
           </a:solidFill>
           <a:ln>
             <a:noFill/>
@@ -14242,8 +14242,8 @@
         </p:nvSpPr>
         <p:spPr>
           <a:xfrm>
-            <a:off x="320040" y="118872"/>
-            <a:ext cx="1737360" cy="256032"/>
+            <a:off x="320040" y="457200"/>
+            <a:ext cx="2148840" cy="109728"/>
           </a:xfrm>
           <a:prstGeom prst="rect">
             <a:avLst/>
@@ -14256,9 +14256,44 @@
           </a:bodyPr>
           <a:lstStyle/>
           <a:p>
-            <a:pPr algn="l"/>
-            <a:r>
-              <a:rPr sz="1400" b="1" i="0">
+            <a:pPr algn="ctr"/>
+            <a:r>
+              <a:rPr sz="800" b="1" i="0">
+                <a:solidFill>
+                  <a:srgbClr val="FFFFFF"/>
+                </a:solidFill>
+                <a:latin typeface="Arial"/>
+              </a:rPr>
+              <a:t>RESULTS</a:t>
+            </a:r>
+          </a:p>
+        </p:txBody>
+      </p:sp>
+      <p:sp>
+        <p:nvSpPr>
+          <p:cNvPr id="7" name="TextBox 6"/>
+          <p:cNvSpPr txBox="1"/>
+          <p:nvPr/>
+        </p:nvSpPr>
+        <p:spPr>
+          <a:xfrm>
+            <a:off x="7498079" y="411480"/>
+            <a:ext cx="1325880" cy="201168"/>
+          </a:xfrm>
+          <a:prstGeom prst="rect">
+            <a:avLst/>
+          </a:prstGeom>
+          <a:noFill/>
+        </p:spPr>
+        <p:txBody>
+          <a:bodyPr wrap="square" lIns="36576" rIns="36576" tIns="18288" bIns="18288">
+            <a:spAutoFit/>
+          </a:bodyPr>
+          <a:lstStyle/>
+          <a:p>
+            <a:pPr algn="r"/>
+            <a:r>
+              <a:rPr sz="1050" b="1" i="0">
                 <a:solidFill>
                   <a:srgbClr val="D71920"/>
                 </a:solidFill>
@@ -14271,14 +14306,14 @@
       </p:sp>
       <p:sp>
         <p:nvSpPr>
-          <p:cNvPr id="7" name="TextBox 6"/>
+          <p:cNvPr id="8" name="TextBox 7"/>
           <p:cNvSpPr txBox="1"/>
           <p:nvPr/>
         </p:nvSpPr>
         <p:spPr>
           <a:xfrm>
-            <a:off x="6400800" y="146304"/>
-            <a:ext cx="2423160" cy="219456"/>
+            <a:off x="320040" y="749808"/>
+            <a:ext cx="8183879" cy="493776"/>
           </a:xfrm>
           <a:prstGeom prst="rect">
             <a:avLst/>
@@ -14291,46 +14326,11 @@
           </a:bodyPr>
           <a:lstStyle/>
           <a:p>
-            <a:pPr algn="r"/>
-            <a:r>
-              <a:rPr sz="850" b="1" i="0">
-                <a:solidFill>
-                  <a:srgbClr val="686868"/>
-                </a:solidFill>
-                <a:latin typeface="Arial"/>
-              </a:rPr>
-              <a:t>RESULTS</a:t>
-            </a:r>
-          </a:p>
-        </p:txBody>
-      </p:sp>
-      <p:sp>
-        <p:nvSpPr>
-          <p:cNvPr id="8" name="TextBox 7"/>
-          <p:cNvSpPr txBox="1"/>
-          <p:nvPr/>
-        </p:nvSpPr>
-        <p:spPr>
-          <a:xfrm>
-            <a:off x="320040" y="749808"/>
-            <a:ext cx="8183879" cy="493776"/>
-          </a:xfrm>
-          <a:prstGeom prst="rect">
-            <a:avLst/>
-          </a:prstGeom>
-          <a:noFill/>
-        </p:spPr>
-        <p:txBody>
-          <a:bodyPr wrap="square" lIns="36576" rIns="36576" tIns="18288" bIns="18288">
-            <a:spAutoFit/>
-          </a:bodyPr>
-          <a:lstStyle/>
-          <a:p>
             <a:pPr algn="l"/>
             <a:r>
               <a:rPr sz="2500" b="1" i="0">
                 <a:solidFill>
-                  <a:srgbClr val="242424"/>
+                  <a:srgbClr val="FFFFFF"/>
                 </a:solidFill>
                 <a:latin typeface="Arial"/>
               </a:rPr>
@@ -14354,7 +14354,7 @@
             <a:avLst/>
           </a:prstGeom>
           <a:solidFill>
-            <a:srgbClr val="D71920"/>
+            <a:srgbClr val="00C8F0"/>
           </a:solidFill>
           <a:ln>
             <a:noFill/>
@@ -14408,7 +14408,7 @@
             <a:r>
               <a:rPr sz="1140" b="0" i="1">
                 <a:solidFill>
-                  <a:srgbClr val="242424"/>
+                  <a:srgbClr val="E8F0FC"/>
                 </a:solidFill>
                 <a:latin typeface="Arial"/>
               </a:rPr>
@@ -14432,11 +14432,11 @@
             <a:avLst/>
           </a:prstGeom>
           <a:solidFill>
-            <a:srgbClr val="FFFFFF"/>
+            <a:srgbClr val="0F2845"/>
           </a:solidFill>
           <a:ln>
             <a:solidFill>
-              <a:srgbClr val="D9DDE3"/>
+              <a:srgbClr val="244A70"/>
             </a:solidFill>
           </a:ln>
         </p:spPr>
@@ -14566,7 +14566,7 @@
             <a:r>
               <a:rPr sz="1220" b="1" i="0">
                 <a:solidFill>
-                  <a:srgbClr val="242424"/>
+                  <a:srgbClr val="FFFFFF"/>
                 </a:solidFill>
                 <a:latin typeface="Arial"/>
               </a:rPr>
@@ -14601,7 +14601,7 @@
             <a:r>
               <a:rPr sz="919" b="0" i="0">
                 <a:solidFill>
-                  <a:srgbClr val="686868"/>
+                  <a:srgbClr val="B8D0EC"/>
                 </a:solidFill>
                 <a:latin typeface="Arial"/>
               </a:rPr>
@@ -14625,11 +14625,11 @@
             <a:avLst/>
           </a:prstGeom>
           <a:solidFill>
-            <a:srgbClr val="FFFFFF"/>
+            <a:srgbClr val="0F2845"/>
           </a:solidFill>
           <a:ln>
             <a:solidFill>
-              <a:srgbClr val="D9DDE3"/>
+              <a:srgbClr val="244A70"/>
             </a:solidFill>
           </a:ln>
         </p:spPr>
@@ -14759,7 +14759,7 @@
             <a:r>
               <a:rPr sz="1220" b="1" i="0">
                 <a:solidFill>
-                  <a:srgbClr val="242424"/>
+                  <a:srgbClr val="FFFFFF"/>
                 </a:solidFill>
                 <a:latin typeface="Arial"/>
               </a:rPr>
@@ -14794,7 +14794,7 @@
             <a:r>
               <a:rPr sz="919" b="0" i="0">
                 <a:solidFill>
-                  <a:srgbClr val="686868"/>
+                  <a:srgbClr val="B8D0EC"/>
                 </a:solidFill>
                 <a:latin typeface="Arial"/>
               </a:rPr>
@@ -14818,11 +14818,11 @@
             <a:avLst/>
           </a:prstGeom>
           <a:solidFill>
-            <a:srgbClr val="FFFFFF"/>
+            <a:srgbClr val="0F2845"/>
           </a:solidFill>
           <a:ln>
             <a:solidFill>
-              <a:srgbClr val="D9DDE3"/>
+              <a:srgbClr val="244A70"/>
             </a:solidFill>
           </a:ln>
         </p:spPr>
@@ -14952,7 +14952,7 @@
             <a:r>
               <a:rPr sz="1220" b="1" i="0">
                 <a:solidFill>
-                  <a:srgbClr val="242424"/>
+                  <a:srgbClr val="FFFFFF"/>
                 </a:solidFill>
                 <a:latin typeface="Arial"/>
               </a:rPr>
@@ -14987,7 +14987,7 @@
             <a:r>
               <a:rPr sz="919" b="0" i="0">
                 <a:solidFill>
-                  <a:srgbClr val="686868"/>
+                  <a:srgbClr val="B8D0EC"/>
                 </a:solidFill>
                 <a:latin typeface="Arial"/>
               </a:rPr>
@@ -15011,11 +15011,11 @@
             <a:avLst/>
           </a:prstGeom>
           <a:solidFill>
-            <a:srgbClr val="FFFFFF"/>
+            <a:srgbClr val="0F2845"/>
           </a:solidFill>
           <a:ln>
             <a:solidFill>
-              <a:srgbClr val="D9DDE3"/>
+              <a:srgbClr val="244A70"/>
             </a:solidFill>
           </a:ln>
         </p:spPr>
@@ -15145,7 +15145,7 @@
             <a:r>
               <a:rPr sz="1220" b="1" i="0">
                 <a:solidFill>
-                  <a:srgbClr val="242424"/>
+                  <a:srgbClr val="FFFFFF"/>
                 </a:solidFill>
                 <a:latin typeface="Arial"/>
               </a:rPr>
@@ -15180,7 +15180,7 @@
             <a:r>
               <a:rPr sz="919" b="0" i="0">
                 <a:solidFill>
-                  <a:srgbClr val="686868"/>
+                  <a:srgbClr val="B8D0EC"/>
                 </a:solidFill>
                 <a:latin typeface="Arial"/>
               </a:rPr>
@@ -15204,11 +15204,11 @@
             <a:avLst/>
           </a:prstGeom>
           <a:solidFill>
-            <a:srgbClr val="FFFFFF"/>
+            <a:srgbClr val="0F2845"/>
           </a:solidFill>
           <a:ln>
             <a:solidFill>
-              <a:srgbClr val="D9DDE3"/>
+              <a:srgbClr val="244A70"/>
             </a:solidFill>
           </a:ln>
         </p:spPr>
@@ -15338,7 +15338,7 @@
             <a:r>
               <a:rPr sz="960" b="0" i="0">
                 <a:solidFill>
-                  <a:srgbClr val="242424"/>
+                  <a:srgbClr val="E8F0FC"/>
                 </a:solidFill>
                 <a:latin typeface="Arial"/>
               </a:rPr>
@@ -15397,7 +15397,7 @@
             <a:avLst/>
           </a:prstGeom>
           <a:solidFill>
-            <a:srgbClr val="1F1F1F"/>
+            <a:srgbClr val="0E2A4A"/>
           </a:solidFill>
           <a:ln>
             <a:noFill/>
@@ -15451,7 +15451,7 @@
             <a:r>
               <a:rPr sz="850" b="0" i="0">
                 <a:solidFill>
-                  <a:srgbClr val="FFFFFF"/>
+                  <a:srgbClr val="B8D0EC"/>
                 </a:solidFill>
                 <a:latin typeface="Arial"/>
               </a:rPr>
@@ -15486,7 +15486,7 @@
             <a:r>
               <a:rPr sz="850" b="0" i="0">
                 <a:solidFill>
-                  <a:srgbClr val="FFFFFF"/>
+                  <a:srgbClr val="B8D0EC"/>
                 </a:solidFill>
                 <a:latin typeface="Arial"/>
               </a:rPr>

</xml_diff>

<commit_message>
Finalize V10 three minute flow
Co-authored-by: Shyam <shyam.nexus@gmail.com>
</commit_message>
<xml_diff>
--- a/AI-Driven Embedded Product Lifecycle OrchestratorV10.pptx
+++ b/AI-Driven Embedded Product Lifecycle OrchestratorV10.pptx
@@ -17,8 +17,8 @@
     <p:sldId id="261" r:id="rId10"/>
     <p:sldId id="262" r:id="rId11"/>
     <p:sldId id="270" r:id="rId12"/>
+    <p:sldId id="264" r:id="rId14"/>
     <p:sldId id="263" r:id="rId13"/>
-    <p:sldId id="264" r:id="rId14"/>
     <p:sldId id="269" r:id="rId18"/>
   </p:sldIdLst>
   <p:sldSz cx="9144000" cy="6858000" type="screen4x3"/>
@@ -23293,7 +23293,7 @@
                 </a:solidFill>
                 <a:latin typeface="Arial"/>
               </a:rPr>
-              <a:t>8  /  9</a:t>
+              <a:t>7  /  9</a:t>
             </a:r>
           </a:p>
         </p:txBody>
@@ -24221,8 +24221,8 @@
                 </a:solidFill>
                 <a:latin typeface="Arial"/>
               </a:rPr>
-              <a:t>- Submission evidence pack: 6-10 weeks -&gt; 2-4 days
-- First-pack effort reduction: 85-92%
+              <a:t>- Submission evidence pack: 8-12 weeks -&gt; 1-3 days
+- First-pack effort reduction: 90-95%
 - Hard-rule checks: foreign characters, STQC ER coverage, missing sections</a:t>
             </a:r>
           </a:p>
@@ -39755,7 +39755,7 @@
                 </a:solidFill>
                 <a:latin typeface="Arial"/>
               </a:rPr>
-              <a:t>7  /  9</a:t>
+              <a:t>8  /  9</a:t>
             </a:r>
           </a:p>
         </p:txBody>

</xml_diff>

<commit_message>
Add logo icons to V10 deck
Co-authored-by: Shyam <shyam.nexus@gmail.com>
</commit_message>
<xml_diff>
--- a/AI-Driven Embedded Product Lifecycle OrchestratorV10.pptx
+++ b/AI-Driven Embedded Product Lifecycle OrchestratorV10.pptx
@@ -22101,6 +22101,150 @@
           </a:p>
         </p:txBody>
       </p:sp>
+      <p:pic>
+        <p:nvPicPr>
+          <p:cNvPr id="240" name="Picture 239" descr="confluence.png"/>
+          <p:cNvPicPr>
+            <a:picLocks noChangeAspect="1"/>
+          </p:cNvPicPr>
+          <p:nvPr/>
+        </p:nvPicPr>
+        <p:blipFill>
+          <a:blip r:embed="rId4"/>
+          <a:stretch>
+            <a:fillRect/>
+          </a:stretch>
+        </p:blipFill>
+        <p:spPr>
+          <a:xfrm>
+            <a:off x="502920" y="5687568"/>
+            <a:ext cx="329184" cy="329184"/>
+          </a:xfrm>
+          <a:prstGeom prst="rect">
+            <a:avLst/>
+          </a:prstGeom>
+        </p:spPr>
+      </p:pic>
+      <p:pic>
+        <p:nvPicPr>
+          <p:cNvPr id="241" name="Picture 240" descr="jira.png"/>
+          <p:cNvPicPr>
+            <a:picLocks noChangeAspect="1"/>
+          </p:cNvPicPr>
+          <p:nvPr/>
+        </p:nvPicPr>
+        <p:blipFill>
+          <a:blip r:embed="rId5"/>
+          <a:stretch>
+            <a:fillRect/>
+          </a:stretch>
+        </p:blipFill>
+        <p:spPr>
+          <a:xfrm>
+            <a:off x="978408" y="5687568"/>
+            <a:ext cx="329184" cy="329184"/>
+          </a:xfrm>
+          <a:prstGeom prst="rect">
+            <a:avLst/>
+          </a:prstGeom>
+        </p:spPr>
+      </p:pic>
+      <p:pic>
+        <p:nvPicPr>
+          <p:cNvPr id="242" name="Picture 241" descr="github.png"/>
+          <p:cNvPicPr>
+            <a:picLocks noChangeAspect="1"/>
+          </p:cNvPicPr>
+          <p:nvPr/>
+        </p:nvPicPr>
+        <p:blipFill>
+          <a:blip r:embed="rId6"/>
+          <a:stretch>
+            <a:fillRect/>
+          </a:stretch>
+        </p:blipFill>
+        <p:spPr>
+          <a:xfrm>
+            <a:off x="1453896" y="5687568"/>
+            <a:ext cx="329184" cy="329184"/>
+          </a:xfrm>
+          <a:prstGeom prst="rect">
+            <a:avLst/>
+          </a:prstGeom>
+        </p:spPr>
+      </p:pic>
+      <p:pic>
+        <p:nvPicPr>
+          <p:cNvPr id="243" name="Picture 242" descr="jtag.png"/>
+          <p:cNvPicPr>
+            <a:picLocks noChangeAspect="1"/>
+          </p:cNvPicPr>
+          <p:nvPr/>
+        </p:nvPicPr>
+        <p:blipFill>
+          <a:blip r:embed="rId7"/>
+          <a:stretch>
+            <a:fillRect/>
+          </a:stretch>
+        </p:blipFill>
+        <p:spPr>
+          <a:xfrm>
+            <a:off x="1929384" y="5687568"/>
+            <a:ext cx="329184" cy="329184"/>
+          </a:xfrm>
+          <a:prstGeom prst="rect">
+            <a:avLst/>
+          </a:prstGeom>
+        </p:spPr>
+      </p:pic>
+      <p:pic>
+        <p:nvPicPr>
+          <p:cNvPr id="244" name="Picture 243" descr="qa.png"/>
+          <p:cNvPicPr>
+            <a:picLocks noChangeAspect="1"/>
+          </p:cNvPicPr>
+          <p:nvPr/>
+        </p:nvPicPr>
+        <p:blipFill>
+          <a:blip r:embed="rId8"/>
+          <a:stretch>
+            <a:fillRect/>
+          </a:stretch>
+        </p:blipFill>
+        <p:spPr>
+          <a:xfrm>
+            <a:off x="2404872" y="5687568"/>
+            <a:ext cx="329184" cy="329184"/>
+          </a:xfrm>
+          <a:prstGeom prst="rect">
+            <a:avLst/>
+          </a:prstGeom>
+        </p:spPr>
+      </p:pic>
+      <p:pic>
+        <p:nvPicPr>
+          <p:cNvPr id="245" name="Picture 244" descr="stqc.png"/>
+          <p:cNvPicPr>
+            <a:picLocks noChangeAspect="1"/>
+          </p:cNvPicPr>
+          <p:nvPr/>
+        </p:nvPicPr>
+        <p:blipFill>
+          <a:blip r:embed="rId9"/>
+          <a:stretch>
+            <a:fillRect/>
+          </a:stretch>
+        </p:blipFill>
+        <p:spPr>
+          <a:xfrm>
+            <a:off x="2880360" y="5687568"/>
+            <a:ext cx="329184" cy="329184"/>
+          </a:xfrm>
+          <a:prstGeom prst="rect">
+            <a:avLst/>
+          </a:prstGeom>
+        </p:spPr>
+      </p:pic>
     </p:spTree>
   </p:cSld>
   <p:clrMapOvr>
@@ -23377,6 +23521,126 @@
           </a:p>
         </p:txBody>
       </p:sp>
+      <p:pic>
+        <p:nvPicPr>
+          <p:cNvPr id="36" name="Picture 35" descr="qa.png"/>
+          <p:cNvPicPr>
+            <a:picLocks noChangeAspect="1"/>
+          </p:cNvPicPr>
+          <p:nvPr/>
+        </p:nvPicPr>
+        <p:blipFill>
+          <a:blip r:embed="rId3"/>
+          <a:stretch>
+            <a:fillRect/>
+          </a:stretch>
+        </p:blipFill>
+        <p:spPr>
+          <a:xfrm>
+            <a:off x="676656" y="6053328"/>
+            <a:ext cx="292608" cy="292608"/>
+          </a:xfrm>
+          <a:prstGeom prst="rect">
+            <a:avLst/>
+          </a:prstGeom>
+        </p:spPr>
+      </p:pic>
+      <p:pic>
+        <p:nvPicPr>
+          <p:cNvPr id="37" name="Picture 36" descr="prd.png"/>
+          <p:cNvPicPr>
+            <a:picLocks noChangeAspect="1"/>
+          </p:cNvPicPr>
+          <p:nvPr/>
+        </p:nvPicPr>
+        <p:blipFill>
+          <a:blip r:embed="rId4"/>
+          <a:stretch>
+            <a:fillRect/>
+          </a:stretch>
+        </p:blipFill>
+        <p:spPr>
+          <a:xfrm>
+            <a:off x="1152144" y="6053328"/>
+            <a:ext cx="292608" cy="292608"/>
+          </a:xfrm>
+          <a:prstGeom prst="rect">
+            <a:avLst/>
+          </a:prstGeom>
+        </p:spPr>
+      </p:pic>
+      <p:pic>
+        <p:nvPicPr>
+          <p:cNvPr id="38" name="Picture 37" descr="jtag.png"/>
+          <p:cNvPicPr>
+            <a:picLocks noChangeAspect="1"/>
+          </p:cNvPicPr>
+          <p:nvPr/>
+        </p:nvPicPr>
+        <p:blipFill>
+          <a:blip r:embed="rId5"/>
+          <a:stretch>
+            <a:fillRect/>
+          </a:stretch>
+        </p:blipFill>
+        <p:spPr>
+          <a:xfrm>
+            <a:off x="1627632" y="6053328"/>
+            <a:ext cx="292608" cy="292608"/>
+          </a:xfrm>
+          <a:prstGeom prst="rect">
+            <a:avLst/>
+          </a:prstGeom>
+        </p:spPr>
+      </p:pic>
+      <p:pic>
+        <p:nvPicPr>
+          <p:cNvPr id="39" name="Picture 38" descr="jira.png"/>
+          <p:cNvPicPr>
+            <a:picLocks noChangeAspect="1"/>
+          </p:cNvPicPr>
+          <p:nvPr/>
+        </p:nvPicPr>
+        <p:blipFill>
+          <a:blip r:embed="rId6"/>
+          <a:stretch>
+            <a:fillRect/>
+          </a:stretch>
+        </p:blipFill>
+        <p:spPr>
+          <a:xfrm>
+            <a:off x="2103120" y="6053328"/>
+            <a:ext cx="292608" cy="292608"/>
+          </a:xfrm>
+          <a:prstGeom prst="rect">
+            <a:avLst/>
+          </a:prstGeom>
+        </p:spPr>
+      </p:pic>
+      <p:pic>
+        <p:nvPicPr>
+          <p:cNvPr id="40" name="Picture 39" descr="confluence.png"/>
+          <p:cNvPicPr>
+            <a:picLocks noChangeAspect="1"/>
+          </p:cNvPicPr>
+          <p:nvPr/>
+        </p:nvPicPr>
+        <p:blipFill>
+          <a:blip r:embed="rId7"/>
+          <a:stretch>
+            <a:fillRect/>
+          </a:stretch>
+        </p:blipFill>
+        <p:spPr>
+          <a:xfrm>
+            <a:off x="2578608" y="6053328"/>
+            <a:ext cx="292608" cy="292608"/>
+          </a:xfrm>
+          <a:prstGeom prst="rect">
+            <a:avLst/>
+          </a:prstGeom>
+        </p:spPr>
+      </p:pic>
     </p:spTree>
   </p:cSld>
   <p:clrMapOvr>
@@ -25784,6 +26048,126 @@
           </a:p>
         </p:txBody>
       </p:sp>
+      <p:pic>
+        <p:nvPicPr>
+          <p:cNvPr id="56" name="Picture 55" descr="stqc.png"/>
+          <p:cNvPicPr>
+            <a:picLocks noChangeAspect="1"/>
+          </p:cNvPicPr>
+          <p:nvPr/>
+        </p:nvPicPr>
+        <p:blipFill>
+          <a:blip r:embed="rId3"/>
+          <a:stretch>
+            <a:fillRect/>
+          </a:stretch>
+        </p:blipFill>
+        <p:spPr>
+          <a:xfrm>
+            <a:off x="1005840" y="6053328"/>
+            <a:ext cx="292608" cy="292608"/>
+          </a:xfrm>
+          <a:prstGeom prst="rect">
+            <a:avLst/>
+          </a:prstGeom>
+        </p:spPr>
+      </p:pic>
+      <p:pic>
+        <p:nvPicPr>
+          <p:cNvPr id="57" name="Picture 56" descr="sdk.png"/>
+          <p:cNvPicPr>
+            <a:picLocks noChangeAspect="1"/>
+          </p:cNvPicPr>
+          <p:nvPr/>
+        </p:nvPicPr>
+        <p:blipFill>
+          <a:blip r:embed="rId4"/>
+          <a:stretch>
+            <a:fillRect/>
+          </a:stretch>
+        </p:blipFill>
+        <p:spPr>
+          <a:xfrm>
+            <a:off x="1481328" y="6053328"/>
+            <a:ext cx="292608" cy="292608"/>
+          </a:xfrm>
+          <a:prstGeom prst="rect">
+            <a:avLst/>
+          </a:prstGeom>
+        </p:spPr>
+      </p:pic>
+      <p:pic>
+        <p:nvPicPr>
+          <p:cNvPr id="58" name="Picture 57" descr="jtag.png"/>
+          <p:cNvPicPr>
+            <a:picLocks noChangeAspect="1"/>
+          </p:cNvPicPr>
+          <p:nvPr/>
+        </p:nvPicPr>
+        <p:blipFill>
+          <a:blip r:embed="rId5"/>
+          <a:stretch>
+            <a:fillRect/>
+          </a:stretch>
+        </p:blipFill>
+        <p:spPr>
+          <a:xfrm>
+            <a:off x="1956816" y="6053328"/>
+            <a:ext cx="292608" cy="292608"/>
+          </a:xfrm>
+          <a:prstGeom prst="rect">
+            <a:avLst/>
+          </a:prstGeom>
+        </p:spPr>
+      </p:pic>
+      <p:pic>
+        <p:nvPicPr>
+          <p:cNvPr id="59" name="Picture 58" descr="qa.png"/>
+          <p:cNvPicPr>
+            <a:picLocks noChangeAspect="1"/>
+          </p:cNvPicPr>
+          <p:nvPr/>
+        </p:nvPicPr>
+        <p:blipFill>
+          <a:blip r:embed="rId6"/>
+          <a:stretch>
+            <a:fillRect/>
+          </a:stretch>
+        </p:blipFill>
+        <p:spPr>
+          <a:xfrm>
+            <a:off x="2432304" y="6053328"/>
+            <a:ext cx="292608" cy="292608"/>
+          </a:xfrm>
+          <a:prstGeom prst="rect">
+            <a:avLst/>
+          </a:prstGeom>
+        </p:spPr>
+      </p:pic>
+      <p:pic>
+        <p:nvPicPr>
+          <p:cNvPr id="60" name="Picture 59" descr="copilot.png"/>
+          <p:cNvPicPr>
+            <a:picLocks noChangeAspect="1"/>
+          </p:cNvPicPr>
+          <p:nvPr/>
+        </p:nvPicPr>
+        <p:blipFill>
+          <a:blip r:embed="rId7"/>
+          <a:stretch>
+            <a:fillRect/>
+          </a:stretch>
+        </p:blipFill>
+        <p:spPr>
+          <a:xfrm>
+            <a:off x="2907792" y="6053328"/>
+            <a:ext cx="292608" cy="292608"/>
+          </a:xfrm>
+          <a:prstGeom prst="rect">
+            <a:avLst/>
+          </a:prstGeom>
+        </p:spPr>
+      </p:pic>
     </p:spTree>
   </p:cSld>
   <p:clrMapOvr>
@@ -27698,6 +28082,126 @@
           </a:p>
         </p:txBody>
       </p:sp>
+      <p:pic>
+        <p:nvPicPr>
+          <p:cNvPr id="49" name="Picture 48" descr="jira.png"/>
+          <p:cNvPicPr>
+            <a:picLocks noChangeAspect="1"/>
+          </p:cNvPicPr>
+          <p:nvPr/>
+        </p:nvPicPr>
+        <p:blipFill>
+          <a:blip r:embed="rId3"/>
+          <a:stretch>
+            <a:fillRect/>
+          </a:stretch>
+        </p:blipFill>
+        <p:spPr>
+          <a:xfrm>
+            <a:off x="658368" y="6053328"/>
+            <a:ext cx="292608" cy="292608"/>
+          </a:xfrm>
+          <a:prstGeom prst="rect">
+            <a:avLst/>
+          </a:prstGeom>
+        </p:spPr>
+      </p:pic>
+      <p:pic>
+        <p:nvPicPr>
+          <p:cNvPr id="50" name="Picture 49" descr="confluence.png"/>
+          <p:cNvPicPr>
+            <a:picLocks noChangeAspect="1"/>
+          </p:cNvPicPr>
+          <p:nvPr/>
+        </p:nvPicPr>
+        <p:blipFill>
+          <a:blip r:embed="rId4"/>
+          <a:stretch>
+            <a:fillRect/>
+          </a:stretch>
+        </p:blipFill>
+        <p:spPr>
+          <a:xfrm>
+            <a:off x="1115568" y="6053328"/>
+            <a:ext cx="292608" cy="292608"/>
+          </a:xfrm>
+          <a:prstGeom prst="rect">
+            <a:avLst/>
+          </a:prstGeom>
+        </p:spPr>
+      </p:pic>
+      <p:pic>
+        <p:nvPicPr>
+          <p:cNvPr id="51" name="Picture 50" descr="github.png"/>
+          <p:cNvPicPr>
+            <a:picLocks noChangeAspect="1"/>
+          </p:cNvPicPr>
+          <p:nvPr/>
+        </p:nvPicPr>
+        <p:blipFill>
+          <a:blip r:embed="rId5"/>
+          <a:stretch>
+            <a:fillRect/>
+          </a:stretch>
+        </p:blipFill>
+        <p:spPr>
+          <a:xfrm>
+            <a:off x="1572768" y="6053328"/>
+            <a:ext cx="292608" cy="292608"/>
+          </a:xfrm>
+          <a:prstGeom prst="rect">
+            <a:avLst/>
+          </a:prstGeom>
+        </p:spPr>
+      </p:pic>
+      <p:pic>
+        <p:nvPicPr>
+          <p:cNvPr id="52" name="Picture 51" descr="jtag.png"/>
+          <p:cNvPicPr>
+            <a:picLocks noChangeAspect="1"/>
+          </p:cNvPicPr>
+          <p:nvPr/>
+        </p:nvPicPr>
+        <p:blipFill>
+          <a:blip r:embed="rId6"/>
+          <a:stretch>
+            <a:fillRect/>
+          </a:stretch>
+        </p:blipFill>
+        <p:spPr>
+          <a:xfrm>
+            <a:off x="2029967" y="6053328"/>
+            <a:ext cx="292608" cy="292608"/>
+          </a:xfrm>
+          <a:prstGeom prst="rect">
+            <a:avLst/>
+          </a:prstGeom>
+        </p:spPr>
+      </p:pic>
+      <p:pic>
+        <p:nvPicPr>
+          <p:cNvPr id="53" name="Picture 52" descr="qa.png"/>
+          <p:cNvPicPr>
+            <a:picLocks noChangeAspect="1"/>
+          </p:cNvPicPr>
+          <p:nvPr/>
+        </p:nvPicPr>
+        <p:blipFill>
+          <a:blip r:embed="rId7"/>
+          <a:stretch>
+            <a:fillRect/>
+          </a:stretch>
+        </p:blipFill>
+        <p:spPr>
+          <a:xfrm>
+            <a:off x="2487168" y="6053328"/>
+            <a:ext cx="292608" cy="292608"/>
+          </a:xfrm>
+          <a:prstGeom prst="rect">
+            <a:avLst/>
+          </a:prstGeom>
+        </p:spPr>
+      </p:pic>
     </p:spTree>
   </p:cSld>
   <p:clrMapOvr>
@@ -29538,6 +30042,198 @@
           </a:p>
         </p:txBody>
       </p:sp>
+      <p:pic>
+        <p:nvPicPr>
+          <p:cNvPr id="46" name="Picture 45" descr="jira.png"/>
+          <p:cNvPicPr>
+            <a:picLocks noChangeAspect="1"/>
+          </p:cNvPicPr>
+          <p:nvPr/>
+        </p:nvPicPr>
+        <p:blipFill>
+          <a:blip r:embed="rId3"/>
+          <a:stretch>
+            <a:fillRect/>
+          </a:stretch>
+        </p:blipFill>
+        <p:spPr>
+          <a:xfrm>
+            <a:off x="457200" y="6053328"/>
+            <a:ext cx="265176" cy="265176"/>
+          </a:xfrm>
+          <a:prstGeom prst="rect">
+            <a:avLst/>
+          </a:prstGeom>
+        </p:spPr>
+      </p:pic>
+      <p:pic>
+        <p:nvPicPr>
+          <p:cNvPr id="47" name="Picture 46" descr="confluence.png"/>
+          <p:cNvPicPr>
+            <a:picLocks noChangeAspect="1"/>
+          </p:cNvPicPr>
+          <p:nvPr/>
+        </p:nvPicPr>
+        <p:blipFill>
+          <a:blip r:embed="rId4"/>
+          <a:stretch>
+            <a:fillRect/>
+          </a:stretch>
+        </p:blipFill>
+        <p:spPr>
+          <a:xfrm>
+            <a:off x="850392" y="6053328"/>
+            <a:ext cx="265176" cy="265176"/>
+          </a:xfrm>
+          <a:prstGeom prst="rect">
+            <a:avLst/>
+          </a:prstGeom>
+        </p:spPr>
+      </p:pic>
+      <p:pic>
+        <p:nvPicPr>
+          <p:cNvPr id="48" name="Picture 47" descr="github.png"/>
+          <p:cNvPicPr>
+            <a:picLocks noChangeAspect="1"/>
+          </p:cNvPicPr>
+          <p:nvPr/>
+        </p:nvPicPr>
+        <p:blipFill>
+          <a:blip r:embed="rId5"/>
+          <a:stretch>
+            <a:fillRect/>
+          </a:stretch>
+        </p:blipFill>
+        <p:spPr>
+          <a:xfrm>
+            <a:off x="1243584" y="6053328"/>
+            <a:ext cx="265176" cy="265176"/>
+          </a:xfrm>
+          <a:prstGeom prst="rect">
+            <a:avLst/>
+          </a:prstGeom>
+        </p:spPr>
+      </p:pic>
+      <p:pic>
+        <p:nvPicPr>
+          <p:cNvPr id="49" name="Picture 48" descr="copilot.png"/>
+          <p:cNvPicPr>
+            <a:picLocks noChangeAspect="1"/>
+          </p:cNvPicPr>
+          <p:nvPr/>
+        </p:nvPicPr>
+        <p:blipFill>
+          <a:blip r:embed="rId6"/>
+          <a:stretch>
+            <a:fillRect/>
+          </a:stretch>
+        </p:blipFill>
+        <p:spPr>
+          <a:xfrm>
+            <a:off x="1636776" y="6053328"/>
+            <a:ext cx="265176" cy="265176"/>
+          </a:xfrm>
+          <a:prstGeom prst="rect">
+            <a:avLst/>
+          </a:prstGeom>
+        </p:spPr>
+      </p:pic>
+      <p:pic>
+        <p:nvPicPr>
+          <p:cNvPr id="50" name="Picture 49" descr="rovo.png"/>
+          <p:cNvPicPr>
+            <a:picLocks noChangeAspect="1"/>
+          </p:cNvPicPr>
+          <p:nvPr/>
+        </p:nvPicPr>
+        <p:blipFill>
+          <a:blip r:embed="rId7"/>
+          <a:stretch>
+            <a:fillRect/>
+          </a:stretch>
+        </p:blipFill>
+        <p:spPr>
+          <a:xfrm>
+            <a:off x="2029967" y="6053328"/>
+            <a:ext cx="265176" cy="265176"/>
+          </a:xfrm>
+          <a:prstGeom prst="rect">
+            <a:avLst/>
+          </a:prstGeom>
+        </p:spPr>
+      </p:pic>
+      <p:pic>
+        <p:nvPicPr>
+          <p:cNvPr id="51" name="Picture 50" descr="azure_devops.png"/>
+          <p:cNvPicPr>
+            <a:picLocks noChangeAspect="1"/>
+          </p:cNvPicPr>
+          <p:nvPr/>
+        </p:nvPicPr>
+        <p:blipFill>
+          <a:blip r:embed="rId8"/>
+          <a:stretch>
+            <a:fillRect/>
+          </a:stretch>
+        </p:blipFill>
+        <p:spPr>
+          <a:xfrm>
+            <a:off x="2423160" y="6053328"/>
+            <a:ext cx="265176" cy="265176"/>
+          </a:xfrm>
+          <a:prstGeom prst="rect">
+            <a:avLst/>
+          </a:prstGeom>
+        </p:spPr>
+      </p:pic>
+      <p:pic>
+        <p:nvPicPr>
+          <p:cNvPr id="52" name="Picture 51" descr="jtag.png"/>
+          <p:cNvPicPr>
+            <a:picLocks noChangeAspect="1"/>
+          </p:cNvPicPr>
+          <p:nvPr/>
+        </p:nvPicPr>
+        <p:blipFill>
+          <a:blip r:embed="rId9"/>
+          <a:stretch>
+            <a:fillRect/>
+          </a:stretch>
+        </p:blipFill>
+        <p:spPr>
+          <a:xfrm>
+            <a:off x="2816352" y="6053328"/>
+            <a:ext cx="265176" cy="265176"/>
+          </a:xfrm>
+          <a:prstGeom prst="rect">
+            <a:avLst/>
+          </a:prstGeom>
+        </p:spPr>
+      </p:pic>
+      <p:pic>
+        <p:nvPicPr>
+          <p:cNvPr id="53" name="Picture 52" descr="qa.png"/>
+          <p:cNvPicPr>
+            <a:picLocks noChangeAspect="1"/>
+          </p:cNvPicPr>
+          <p:nvPr/>
+        </p:nvPicPr>
+        <p:blipFill>
+          <a:blip r:embed="rId10"/>
+          <a:stretch>
+            <a:fillRect/>
+          </a:stretch>
+        </p:blipFill>
+        <p:spPr>
+          <a:xfrm>
+            <a:off x="3209544" y="6053328"/>
+            <a:ext cx="265176" cy="265176"/>
+          </a:xfrm>
+          <a:prstGeom prst="rect">
+            <a:avLst/>
+          </a:prstGeom>
+        </p:spPr>
+      </p:pic>
     </p:spTree>
   </p:cSld>
   <p:clrMapOvr>
@@ -31553,6 +32249,126 @@
           </a:p>
         </p:txBody>
       </p:sp>
+      <p:pic>
+        <p:nvPicPr>
+          <p:cNvPr id="50" name="Picture 49" descr="confluence.png"/>
+          <p:cNvPicPr>
+            <a:picLocks noChangeAspect="1"/>
+          </p:cNvPicPr>
+          <p:nvPr/>
+        </p:nvPicPr>
+        <p:blipFill>
+          <a:blip r:embed="rId3"/>
+          <a:stretch>
+            <a:fillRect/>
+          </a:stretch>
+        </p:blipFill>
+        <p:spPr>
+          <a:xfrm>
+            <a:off x="694944" y="6053328"/>
+            <a:ext cx="292608" cy="292608"/>
+          </a:xfrm>
+          <a:prstGeom prst="rect">
+            <a:avLst/>
+          </a:prstGeom>
+        </p:spPr>
+      </p:pic>
+      <p:pic>
+        <p:nvPicPr>
+          <p:cNvPr id="51" name="Picture 50" descr="rovo.png"/>
+          <p:cNvPicPr>
+            <a:picLocks noChangeAspect="1"/>
+          </p:cNvPicPr>
+          <p:nvPr/>
+        </p:nvPicPr>
+        <p:blipFill>
+          <a:blip r:embed="rId4"/>
+          <a:stretch>
+            <a:fillRect/>
+          </a:stretch>
+        </p:blipFill>
+        <p:spPr>
+          <a:xfrm>
+            <a:off x="1188720" y="6053328"/>
+            <a:ext cx="292608" cy="292608"/>
+          </a:xfrm>
+          <a:prstGeom prst="rect">
+            <a:avLst/>
+          </a:prstGeom>
+        </p:spPr>
+      </p:pic>
+      <p:pic>
+        <p:nvPicPr>
+          <p:cNvPr id="52" name="Picture 51" descr="jira.png"/>
+          <p:cNvPicPr>
+            <a:picLocks noChangeAspect="1"/>
+          </p:cNvPicPr>
+          <p:nvPr/>
+        </p:nvPicPr>
+        <p:blipFill>
+          <a:blip r:embed="rId5"/>
+          <a:stretch>
+            <a:fillRect/>
+          </a:stretch>
+        </p:blipFill>
+        <p:spPr>
+          <a:xfrm>
+            <a:off x="1682496" y="6053328"/>
+            <a:ext cx="292608" cy="292608"/>
+          </a:xfrm>
+          <a:prstGeom prst="rect">
+            <a:avLst/>
+          </a:prstGeom>
+        </p:spPr>
+      </p:pic>
+      <p:pic>
+        <p:nvPicPr>
+          <p:cNvPr id="53" name="Picture 52" descr="github.png"/>
+          <p:cNvPicPr>
+            <a:picLocks noChangeAspect="1"/>
+          </p:cNvPicPr>
+          <p:nvPr/>
+        </p:nvPicPr>
+        <p:blipFill>
+          <a:blip r:embed="rId6"/>
+          <a:stretch>
+            <a:fillRect/>
+          </a:stretch>
+        </p:blipFill>
+        <p:spPr>
+          <a:xfrm>
+            <a:off x="2176272" y="6053328"/>
+            <a:ext cx="292608" cy="292608"/>
+          </a:xfrm>
+          <a:prstGeom prst="rect">
+            <a:avLst/>
+          </a:prstGeom>
+        </p:spPr>
+      </p:pic>
+      <p:pic>
+        <p:nvPicPr>
+          <p:cNvPr id="54" name="Picture 53" descr="qa.png"/>
+          <p:cNvPicPr>
+            <a:picLocks noChangeAspect="1"/>
+          </p:cNvPicPr>
+          <p:nvPr/>
+        </p:nvPicPr>
+        <p:blipFill>
+          <a:blip r:embed="rId7"/>
+          <a:stretch>
+            <a:fillRect/>
+          </a:stretch>
+        </p:blipFill>
+        <p:spPr>
+          <a:xfrm>
+            <a:off x="2670048" y="6053328"/>
+            <a:ext cx="292608" cy="292608"/>
+          </a:xfrm>
+          <a:prstGeom prst="rect">
+            <a:avLst/>
+          </a:prstGeom>
+        </p:spPr>
+      </p:pic>
     </p:spTree>
   </p:cSld>
   <p:clrMapOvr>
@@ -35382,6 +36198,150 @@
           </a:p>
         </p:txBody>
       </p:sp>
+      <p:pic>
+        <p:nvPicPr>
+          <p:cNvPr id="93" name="Picture 92" descr="prd.png"/>
+          <p:cNvPicPr>
+            <a:picLocks noChangeAspect="1"/>
+          </p:cNvPicPr>
+          <p:nvPr/>
+        </p:nvPicPr>
+        <p:blipFill>
+          <a:blip r:embed="rId3"/>
+          <a:stretch>
+            <a:fillRect/>
+          </a:stretch>
+        </p:blipFill>
+        <p:spPr>
+          <a:xfrm>
+            <a:off x="658368" y="6089904"/>
+            <a:ext cx="274320" cy="274320"/>
+          </a:xfrm>
+          <a:prstGeom prst="rect">
+            <a:avLst/>
+          </a:prstGeom>
+        </p:spPr>
+      </p:pic>
+      <p:pic>
+        <p:nvPicPr>
+          <p:cNvPr id="94" name="Picture 93" descr="sdk.png"/>
+          <p:cNvPicPr>
+            <a:picLocks noChangeAspect="1"/>
+          </p:cNvPicPr>
+          <p:nvPr/>
+        </p:nvPicPr>
+        <p:blipFill>
+          <a:blip r:embed="rId4"/>
+          <a:stretch>
+            <a:fillRect/>
+          </a:stretch>
+        </p:blipFill>
+        <p:spPr>
+          <a:xfrm>
+            <a:off x="1097280" y="6089904"/>
+            <a:ext cx="274320" cy="274320"/>
+          </a:xfrm>
+          <a:prstGeom prst="rect">
+            <a:avLst/>
+          </a:prstGeom>
+        </p:spPr>
+      </p:pic>
+      <p:pic>
+        <p:nvPicPr>
+          <p:cNvPr id="95" name="Picture 94" descr="copilot.png"/>
+          <p:cNvPicPr>
+            <a:picLocks noChangeAspect="1"/>
+          </p:cNvPicPr>
+          <p:nvPr/>
+        </p:nvPicPr>
+        <p:blipFill>
+          <a:blip r:embed="rId5"/>
+          <a:stretch>
+            <a:fillRect/>
+          </a:stretch>
+        </p:blipFill>
+        <p:spPr>
+          <a:xfrm>
+            <a:off x="1536192" y="6089904"/>
+            <a:ext cx="274320" cy="274320"/>
+          </a:xfrm>
+          <a:prstGeom prst="rect">
+            <a:avLst/>
+          </a:prstGeom>
+        </p:spPr>
+      </p:pic>
+      <p:pic>
+        <p:nvPicPr>
+          <p:cNvPr id="96" name="Picture 95" descr="github.png"/>
+          <p:cNvPicPr>
+            <a:picLocks noChangeAspect="1"/>
+          </p:cNvPicPr>
+          <p:nvPr/>
+        </p:nvPicPr>
+        <p:blipFill>
+          <a:blip r:embed="rId6"/>
+          <a:stretch>
+            <a:fillRect/>
+          </a:stretch>
+        </p:blipFill>
+        <p:spPr>
+          <a:xfrm>
+            <a:off x="1975104" y="6089904"/>
+            <a:ext cx="274320" cy="274320"/>
+          </a:xfrm>
+          <a:prstGeom prst="rect">
+            <a:avLst/>
+          </a:prstGeom>
+        </p:spPr>
+      </p:pic>
+      <p:pic>
+        <p:nvPicPr>
+          <p:cNvPr id="97" name="Picture 96" descr="azure_devops.png"/>
+          <p:cNvPicPr>
+            <a:picLocks noChangeAspect="1"/>
+          </p:cNvPicPr>
+          <p:nvPr/>
+        </p:nvPicPr>
+        <p:blipFill>
+          <a:blip r:embed="rId7"/>
+          <a:stretch>
+            <a:fillRect/>
+          </a:stretch>
+        </p:blipFill>
+        <p:spPr>
+          <a:xfrm>
+            <a:off x="2414015" y="6089904"/>
+            <a:ext cx="274320" cy="274320"/>
+          </a:xfrm>
+          <a:prstGeom prst="rect">
+            <a:avLst/>
+          </a:prstGeom>
+        </p:spPr>
+      </p:pic>
+      <p:pic>
+        <p:nvPicPr>
+          <p:cNvPr id="98" name="Picture 97" descr="jtag.png"/>
+          <p:cNvPicPr>
+            <a:picLocks noChangeAspect="1"/>
+          </p:cNvPicPr>
+          <p:nvPr/>
+        </p:nvPicPr>
+        <p:blipFill>
+          <a:blip r:embed="rId8"/>
+          <a:stretch>
+            <a:fillRect/>
+          </a:stretch>
+        </p:blipFill>
+        <p:spPr>
+          <a:xfrm>
+            <a:off x="2852928" y="6089904"/>
+            <a:ext cx="274320" cy="274320"/>
+          </a:xfrm>
+          <a:prstGeom prst="rect">
+            <a:avLst/>
+          </a:prstGeom>
+        </p:spPr>
+      </p:pic>
     </p:spTree>
   </p:cSld>
   <p:clrMapOvr>
@@ -37993,6 +38953,78 @@
           </a:prstGeom>
         </p:spPr>
       </p:pic>
+      <p:pic>
+        <p:nvPicPr>
+          <p:cNvPr id="132" name="Picture 131" descr="jtag.png"/>
+          <p:cNvPicPr>
+            <a:picLocks noChangeAspect="1"/>
+          </p:cNvPicPr>
+          <p:nvPr/>
+        </p:nvPicPr>
+        <p:blipFill>
+          <a:blip r:embed="rId4"/>
+          <a:stretch>
+            <a:fillRect/>
+          </a:stretch>
+        </p:blipFill>
+        <p:spPr>
+          <a:xfrm>
+            <a:off x="502920" y="6053328"/>
+            <a:ext cx="292608" cy="292608"/>
+          </a:xfrm>
+          <a:prstGeom prst="rect">
+            <a:avLst/>
+          </a:prstGeom>
+        </p:spPr>
+      </p:pic>
+      <p:pic>
+        <p:nvPicPr>
+          <p:cNvPr id="133" name="Picture 132" descr="github.png"/>
+          <p:cNvPicPr>
+            <a:picLocks noChangeAspect="1"/>
+          </p:cNvPicPr>
+          <p:nvPr/>
+        </p:nvPicPr>
+        <p:blipFill>
+          <a:blip r:embed="rId5"/>
+          <a:stretch>
+            <a:fillRect/>
+          </a:stretch>
+        </p:blipFill>
+        <p:spPr>
+          <a:xfrm>
+            <a:off x="960120" y="6053328"/>
+            <a:ext cx="292608" cy="292608"/>
+          </a:xfrm>
+          <a:prstGeom prst="rect">
+            <a:avLst/>
+          </a:prstGeom>
+        </p:spPr>
+      </p:pic>
+      <p:pic>
+        <p:nvPicPr>
+          <p:cNvPr id="134" name="Picture 133" descr="jira.png"/>
+          <p:cNvPicPr>
+            <a:picLocks noChangeAspect="1"/>
+          </p:cNvPicPr>
+          <p:nvPr/>
+        </p:nvPicPr>
+        <p:blipFill>
+          <a:blip r:embed="rId6"/>
+          <a:stretch>
+            <a:fillRect/>
+          </a:stretch>
+        </p:blipFill>
+        <p:spPr>
+          <a:xfrm>
+            <a:off x="1417320" y="6053328"/>
+            <a:ext cx="292608" cy="292608"/>
+          </a:xfrm>
+          <a:prstGeom prst="rect">
+            <a:avLst/>
+          </a:prstGeom>
+        </p:spPr>
+      </p:pic>
     </p:spTree>
     <p:extLst>
       <p:ext uri="{BB962C8B-B14F-4D97-AF65-F5344CB8AC3E}">
@@ -39839,6 +40871,102 @@
           </a:p>
         </p:txBody>
       </p:sp>
+      <p:pic>
+        <p:nvPicPr>
+          <p:cNvPr id="47" name="Picture 46" descr="stqc.png"/>
+          <p:cNvPicPr>
+            <a:picLocks noChangeAspect="1"/>
+          </p:cNvPicPr>
+          <p:nvPr/>
+        </p:nvPicPr>
+        <p:blipFill>
+          <a:blip r:embed="rId3"/>
+          <a:stretch>
+            <a:fillRect/>
+          </a:stretch>
+        </p:blipFill>
+        <p:spPr>
+          <a:xfrm>
+            <a:off x="676656" y="6053328"/>
+            <a:ext cx="292608" cy="292608"/>
+          </a:xfrm>
+          <a:prstGeom prst="rect">
+            <a:avLst/>
+          </a:prstGeom>
+        </p:spPr>
+      </p:pic>
+      <p:pic>
+        <p:nvPicPr>
+          <p:cNvPr id="48" name="Picture 47" descr="prd.png"/>
+          <p:cNvPicPr>
+            <a:picLocks noChangeAspect="1"/>
+          </p:cNvPicPr>
+          <p:nvPr/>
+        </p:nvPicPr>
+        <p:blipFill>
+          <a:blip r:embed="rId4"/>
+          <a:stretch>
+            <a:fillRect/>
+          </a:stretch>
+        </p:blipFill>
+        <p:spPr>
+          <a:xfrm>
+            <a:off x="1152144" y="6053328"/>
+            <a:ext cx="292608" cy="292608"/>
+          </a:xfrm>
+          <a:prstGeom prst="rect">
+            <a:avLst/>
+          </a:prstGeom>
+        </p:spPr>
+      </p:pic>
+      <p:pic>
+        <p:nvPicPr>
+          <p:cNvPr id="49" name="Picture 48" descr="jira.png"/>
+          <p:cNvPicPr>
+            <a:picLocks noChangeAspect="1"/>
+          </p:cNvPicPr>
+          <p:nvPr/>
+        </p:nvPicPr>
+        <p:blipFill>
+          <a:blip r:embed="rId5"/>
+          <a:stretch>
+            <a:fillRect/>
+          </a:stretch>
+        </p:blipFill>
+        <p:spPr>
+          <a:xfrm>
+            <a:off x="1627632" y="6053328"/>
+            <a:ext cx="292608" cy="292608"/>
+          </a:xfrm>
+          <a:prstGeom prst="rect">
+            <a:avLst/>
+          </a:prstGeom>
+        </p:spPr>
+      </p:pic>
+      <p:pic>
+        <p:nvPicPr>
+          <p:cNvPr id="50" name="Picture 49" descr="confluence.png"/>
+          <p:cNvPicPr>
+            <a:picLocks noChangeAspect="1"/>
+          </p:cNvPicPr>
+          <p:nvPr/>
+        </p:nvPicPr>
+        <p:blipFill>
+          <a:blip r:embed="rId6"/>
+          <a:stretch>
+            <a:fillRect/>
+          </a:stretch>
+        </p:blipFill>
+        <p:spPr>
+          <a:xfrm>
+            <a:off x="2103120" y="6053328"/>
+            <a:ext cx="292608" cy="292608"/>
+          </a:xfrm>
+          <a:prstGeom prst="rect">
+            <a:avLst/>
+          </a:prstGeom>
+        </p:spPr>
+      </p:pic>
     </p:spTree>
   </p:cSld>
   <p:clrMapOvr>

</xml_diff>

<commit_message>
Revert "Add logo icons to V10 deck"
This reverts commit f0389f3e749923c9aca13aa3993fdf581e3ad4aa.
</commit_message>
<xml_diff>
--- a/AI-Driven Embedded Product Lifecycle OrchestratorV10.pptx
+++ b/AI-Driven Embedded Product Lifecycle OrchestratorV10.pptx
@@ -22101,150 +22101,6 @@
           </a:p>
         </p:txBody>
       </p:sp>
-      <p:pic>
-        <p:nvPicPr>
-          <p:cNvPr id="240" name="Picture 239" descr="confluence.png"/>
-          <p:cNvPicPr>
-            <a:picLocks noChangeAspect="1"/>
-          </p:cNvPicPr>
-          <p:nvPr/>
-        </p:nvPicPr>
-        <p:blipFill>
-          <a:blip r:embed="rId4"/>
-          <a:stretch>
-            <a:fillRect/>
-          </a:stretch>
-        </p:blipFill>
-        <p:spPr>
-          <a:xfrm>
-            <a:off x="502920" y="5687568"/>
-            <a:ext cx="329184" cy="329184"/>
-          </a:xfrm>
-          <a:prstGeom prst="rect">
-            <a:avLst/>
-          </a:prstGeom>
-        </p:spPr>
-      </p:pic>
-      <p:pic>
-        <p:nvPicPr>
-          <p:cNvPr id="241" name="Picture 240" descr="jira.png"/>
-          <p:cNvPicPr>
-            <a:picLocks noChangeAspect="1"/>
-          </p:cNvPicPr>
-          <p:nvPr/>
-        </p:nvPicPr>
-        <p:blipFill>
-          <a:blip r:embed="rId5"/>
-          <a:stretch>
-            <a:fillRect/>
-          </a:stretch>
-        </p:blipFill>
-        <p:spPr>
-          <a:xfrm>
-            <a:off x="978408" y="5687568"/>
-            <a:ext cx="329184" cy="329184"/>
-          </a:xfrm>
-          <a:prstGeom prst="rect">
-            <a:avLst/>
-          </a:prstGeom>
-        </p:spPr>
-      </p:pic>
-      <p:pic>
-        <p:nvPicPr>
-          <p:cNvPr id="242" name="Picture 241" descr="github.png"/>
-          <p:cNvPicPr>
-            <a:picLocks noChangeAspect="1"/>
-          </p:cNvPicPr>
-          <p:nvPr/>
-        </p:nvPicPr>
-        <p:blipFill>
-          <a:blip r:embed="rId6"/>
-          <a:stretch>
-            <a:fillRect/>
-          </a:stretch>
-        </p:blipFill>
-        <p:spPr>
-          <a:xfrm>
-            <a:off x="1453896" y="5687568"/>
-            <a:ext cx="329184" cy="329184"/>
-          </a:xfrm>
-          <a:prstGeom prst="rect">
-            <a:avLst/>
-          </a:prstGeom>
-        </p:spPr>
-      </p:pic>
-      <p:pic>
-        <p:nvPicPr>
-          <p:cNvPr id="243" name="Picture 242" descr="jtag.png"/>
-          <p:cNvPicPr>
-            <a:picLocks noChangeAspect="1"/>
-          </p:cNvPicPr>
-          <p:nvPr/>
-        </p:nvPicPr>
-        <p:blipFill>
-          <a:blip r:embed="rId7"/>
-          <a:stretch>
-            <a:fillRect/>
-          </a:stretch>
-        </p:blipFill>
-        <p:spPr>
-          <a:xfrm>
-            <a:off x="1929384" y="5687568"/>
-            <a:ext cx="329184" cy="329184"/>
-          </a:xfrm>
-          <a:prstGeom prst="rect">
-            <a:avLst/>
-          </a:prstGeom>
-        </p:spPr>
-      </p:pic>
-      <p:pic>
-        <p:nvPicPr>
-          <p:cNvPr id="244" name="Picture 243" descr="qa.png"/>
-          <p:cNvPicPr>
-            <a:picLocks noChangeAspect="1"/>
-          </p:cNvPicPr>
-          <p:nvPr/>
-        </p:nvPicPr>
-        <p:blipFill>
-          <a:blip r:embed="rId8"/>
-          <a:stretch>
-            <a:fillRect/>
-          </a:stretch>
-        </p:blipFill>
-        <p:spPr>
-          <a:xfrm>
-            <a:off x="2404872" y="5687568"/>
-            <a:ext cx="329184" cy="329184"/>
-          </a:xfrm>
-          <a:prstGeom prst="rect">
-            <a:avLst/>
-          </a:prstGeom>
-        </p:spPr>
-      </p:pic>
-      <p:pic>
-        <p:nvPicPr>
-          <p:cNvPr id="245" name="Picture 244" descr="stqc.png"/>
-          <p:cNvPicPr>
-            <a:picLocks noChangeAspect="1"/>
-          </p:cNvPicPr>
-          <p:nvPr/>
-        </p:nvPicPr>
-        <p:blipFill>
-          <a:blip r:embed="rId9"/>
-          <a:stretch>
-            <a:fillRect/>
-          </a:stretch>
-        </p:blipFill>
-        <p:spPr>
-          <a:xfrm>
-            <a:off x="2880360" y="5687568"/>
-            <a:ext cx="329184" cy="329184"/>
-          </a:xfrm>
-          <a:prstGeom prst="rect">
-            <a:avLst/>
-          </a:prstGeom>
-        </p:spPr>
-      </p:pic>
     </p:spTree>
   </p:cSld>
   <p:clrMapOvr>
@@ -23521,126 +23377,6 @@
           </a:p>
         </p:txBody>
       </p:sp>
-      <p:pic>
-        <p:nvPicPr>
-          <p:cNvPr id="36" name="Picture 35" descr="qa.png"/>
-          <p:cNvPicPr>
-            <a:picLocks noChangeAspect="1"/>
-          </p:cNvPicPr>
-          <p:nvPr/>
-        </p:nvPicPr>
-        <p:blipFill>
-          <a:blip r:embed="rId3"/>
-          <a:stretch>
-            <a:fillRect/>
-          </a:stretch>
-        </p:blipFill>
-        <p:spPr>
-          <a:xfrm>
-            <a:off x="676656" y="6053328"/>
-            <a:ext cx="292608" cy="292608"/>
-          </a:xfrm>
-          <a:prstGeom prst="rect">
-            <a:avLst/>
-          </a:prstGeom>
-        </p:spPr>
-      </p:pic>
-      <p:pic>
-        <p:nvPicPr>
-          <p:cNvPr id="37" name="Picture 36" descr="prd.png"/>
-          <p:cNvPicPr>
-            <a:picLocks noChangeAspect="1"/>
-          </p:cNvPicPr>
-          <p:nvPr/>
-        </p:nvPicPr>
-        <p:blipFill>
-          <a:blip r:embed="rId4"/>
-          <a:stretch>
-            <a:fillRect/>
-          </a:stretch>
-        </p:blipFill>
-        <p:spPr>
-          <a:xfrm>
-            <a:off x="1152144" y="6053328"/>
-            <a:ext cx="292608" cy="292608"/>
-          </a:xfrm>
-          <a:prstGeom prst="rect">
-            <a:avLst/>
-          </a:prstGeom>
-        </p:spPr>
-      </p:pic>
-      <p:pic>
-        <p:nvPicPr>
-          <p:cNvPr id="38" name="Picture 37" descr="jtag.png"/>
-          <p:cNvPicPr>
-            <a:picLocks noChangeAspect="1"/>
-          </p:cNvPicPr>
-          <p:nvPr/>
-        </p:nvPicPr>
-        <p:blipFill>
-          <a:blip r:embed="rId5"/>
-          <a:stretch>
-            <a:fillRect/>
-          </a:stretch>
-        </p:blipFill>
-        <p:spPr>
-          <a:xfrm>
-            <a:off x="1627632" y="6053328"/>
-            <a:ext cx="292608" cy="292608"/>
-          </a:xfrm>
-          <a:prstGeom prst="rect">
-            <a:avLst/>
-          </a:prstGeom>
-        </p:spPr>
-      </p:pic>
-      <p:pic>
-        <p:nvPicPr>
-          <p:cNvPr id="39" name="Picture 38" descr="jira.png"/>
-          <p:cNvPicPr>
-            <a:picLocks noChangeAspect="1"/>
-          </p:cNvPicPr>
-          <p:nvPr/>
-        </p:nvPicPr>
-        <p:blipFill>
-          <a:blip r:embed="rId6"/>
-          <a:stretch>
-            <a:fillRect/>
-          </a:stretch>
-        </p:blipFill>
-        <p:spPr>
-          <a:xfrm>
-            <a:off x="2103120" y="6053328"/>
-            <a:ext cx="292608" cy="292608"/>
-          </a:xfrm>
-          <a:prstGeom prst="rect">
-            <a:avLst/>
-          </a:prstGeom>
-        </p:spPr>
-      </p:pic>
-      <p:pic>
-        <p:nvPicPr>
-          <p:cNvPr id="40" name="Picture 39" descr="confluence.png"/>
-          <p:cNvPicPr>
-            <a:picLocks noChangeAspect="1"/>
-          </p:cNvPicPr>
-          <p:nvPr/>
-        </p:nvPicPr>
-        <p:blipFill>
-          <a:blip r:embed="rId7"/>
-          <a:stretch>
-            <a:fillRect/>
-          </a:stretch>
-        </p:blipFill>
-        <p:spPr>
-          <a:xfrm>
-            <a:off x="2578608" y="6053328"/>
-            <a:ext cx="292608" cy="292608"/>
-          </a:xfrm>
-          <a:prstGeom prst="rect">
-            <a:avLst/>
-          </a:prstGeom>
-        </p:spPr>
-      </p:pic>
     </p:spTree>
   </p:cSld>
   <p:clrMapOvr>
@@ -26048,126 +25784,6 @@
           </a:p>
         </p:txBody>
       </p:sp>
-      <p:pic>
-        <p:nvPicPr>
-          <p:cNvPr id="56" name="Picture 55" descr="stqc.png"/>
-          <p:cNvPicPr>
-            <a:picLocks noChangeAspect="1"/>
-          </p:cNvPicPr>
-          <p:nvPr/>
-        </p:nvPicPr>
-        <p:blipFill>
-          <a:blip r:embed="rId3"/>
-          <a:stretch>
-            <a:fillRect/>
-          </a:stretch>
-        </p:blipFill>
-        <p:spPr>
-          <a:xfrm>
-            <a:off x="1005840" y="6053328"/>
-            <a:ext cx="292608" cy="292608"/>
-          </a:xfrm>
-          <a:prstGeom prst="rect">
-            <a:avLst/>
-          </a:prstGeom>
-        </p:spPr>
-      </p:pic>
-      <p:pic>
-        <p:nvPicPr>
-          <p:cNvPr id="57" name="Picture 56" descr="sdk.png"/>
-          <p:cNvPicPr>
-            <a:picLocks noChangeAspect="1"/>
-          </p:cNvPicPr>
-          <p:nvPr/>
-        </p:nvPicPr>
-        <p:blipFill>
-          <a:blip r:embed="rId4"/>
-          <a:stretch>
-            <a:fillRect/>
-          </a:stretch>
-        </p:blipFill>
-        <p:spPr>
-          <a:xfrm>
-            <a:off x="1481328" y="6053328"/>
-            <a:ext cx="292608" cy="292608"/>
-          </a:xfrm>
-          <a:prstGeom prst="rect">
-            <a:avLst/>
-          </a:prstGeom>
-        </p:spPr>
-      </p:pic>
-      <p:pic>
-        <p:nvPicPr>
-          <p:cNvPr id="58" name="Picture 57" descr="jtag.png"/>
-          <p:cNvPicPr>
-            <a:picLocks noChangeAspect="1"/>
-          </p:cNvPicPr>
-          <p:nvPr/>
-        </p:nvPicPr>
-        <p:blipFill>
-          <a:blip r:embed="rId5"/>
-          <a:stretch>
-            <a:fillRect/>
-          </a:stretch>
-        </p:blipFill>
-        <p:spPr>
-          <a:xfrm>
-            <a:off x="1956816" y="6053328"/>
-            <a:ext cx="292608" cy="292608"/>
-          </a:xfrm>
-          <a:prstGeom prst="rect">
-            <a:avLst/>
-          </a:prstGeom>
-        </p:spPr>
-      </p:pic>
-      <p:pic>
-        <p:nvPicPr>
-          <p:cNvPr id="59" name="Picture 58" descr="qa.png"/>
-          <p:cNvPicPr>
-            <a:picLocks noChangeAspect="1"/>
-          </p:cNvPicPr>
-          <p:nvPr/>
-        </p:nvPicPr>
-        <p:blipFill>
-          <a:blip r:embed="rId6"/>
-          <a:stretch>
-            <a:fillRect/>
-          </a:stretch>
-        </p:blipFill>
-        <p:spPr>
-          <a:xfrm>
-            <a:off x="2432304" y="6053328"/>
-            <a:ext cx="292608" cy="292608"/>
-          </a:xfrm>
-          <a:prstGeom prst="rect">
-            <a:avLst/>
-          </a:prstGeom>
-        </p:spPr>
-      </p:pic>
-      <p:pic>
-        <p:nvPicPr>
-          <p:cNvPr id="60" name="Picture 59" descr="copilot.png"/>
-          <p:cNvPicPr>
-            <a:picLocks noChangeAspect="1"/>
-          </p:cNvPicPr>
-          <p:nvPr/>
-        </p:nvPicPr>
-        <p:blipFill>
-          <a:blip r:embed="rId7"/>
-          <a:stretch>
-            <a:fillRect/>
-          </a:stretch>
-        </p:blipFill>
-        <p:spPr>
-          <a:xfrm>
-            <a:off x="2907792" y="6053328"/>
-            <a:ext cx="292608" cy="292608"/>
-          </a:xfrm>
-          <a:prstGeom prst="rect">
-            <a:avLst/>
-          </a:prstGeom>
-        </p:spPr>
-      </p:pic>
     </p:spTree>
   </p:cSld>
   <p:clrMapOvr>
@@ -28082,126 +27698,6 @@
           </a:p>
         </p:txBody>
       </p:sp>
-      <p:pic>
-        <p:nvPicPr>
-          <p:cNvPr id="49" name="Picture 48" descr="jira.png"/>
-          <p:cNvPicPr>
-            <a:picLocks noChangeAspect="1"/>
-          </p:cNvPicPr>
-          <p:nvPr/>
-        </p:nvPicPr>
-        <p:blipFill>
-          <a:blip r:embed="rId3"/>
-          <a:stretch>
-            <a:fillRect/>
-          </a:stretch>
-        </p:blipFill>
-        <p:spPr>
-          <a:xfrm>
-            <a:off x="658368" y="6053328"/>
-            <a:ext cx="292608" cy="292608"/>
-          </a:xfrm>
-          <a:prstGeom prst="rect">
-            <a:avLst/>
-          </a:prstGeom>
-        </p:spPr>
-      </p:pic>
-      <p:pic>
-        <p:nvPicPr>
-          <p:cNvPr id="50" name="Picture 49" descr="confluence.png"/>
-          <p:cNvPicPr>
-            <a:picLocks noChangeAspect="1"/>
-          </p:cNvPicPr>
-          <p:nvPr/>
-        </p:nvPicPr>
-        <p:blipFill>
-          <a:blip r:embed="rId4"/>
-          <a:stretch>
-            <a:fillRect/>
-          </a:stretch>
-        </p:blipFill>
-        <p:spPr>
-          <a:xfrm>
-            <a:off x="1115568" y="6053328"/>
-            <a:ext cx="292608" cy="292608"/>
-          </a:xfrm>
-          <a:prstGeom prst="rect">
-            <a:avLst/>
-          </a:prstGeom>
-        </p:spPr>
-      </p:pic>
-      <p:pic>
-        <p:nvPicPr>
-          <p:cNvPr id="51" name="Picture 50" descr="github.png"/>
-          <p:cNvPicPr>
-            <a:picLocks noChangeAspect="1"/>
-          </p:cNvPicPr>
-          <p:nvPr/>
-        </p:nvPicPr>
-        <p:blipFill>
-          <a:blip r:embed="rId5"/>
-          <a:stretch>
-            <a:fillRect/>
-          </a:stretch>
-        </p:blipFill>
-        <p:spPr>
-          <a:xfrm>
-            <a:off x="1572768" y="6053328"/>
-            <a:ext cx="292608" cy="292608"/>
-          </a:xfrm>
-          <a:prstGeom prst="rect">
-            <a:avLst/>
-          </a:prstGeom>
-        </p:spPr>
-      </p:pic>
-      <p:pic>
-        <p:nvPicPr>
-          <p:cNvPr id="52" name="Picture 51" descr="jtag.png"/>
-          <p:cNvPicPr>
-            <a:picLocks noChangeAspect="1"/>
-          </p:cNvPicPr>
-          <p:nvPr/>
-        </p:nvPicPr>
-        <p:blipFill>
-          <a:blip r:embed="rId6"/>
-          <a:stretch>
-            <a:fillRect/>
-          </a:stretch>
-        </p:blipFill>
-        <p:spPr>
-          <a:xfrm>
-            <a:off x="2029967" y="6053328"/>
-            <a:ext cx="292608" cy="292608"/>
-          </a:xfrm>
-          <a:prstGeom prst="rect">
-            <a:avLst/>
-          </a:prstGeom>
-        </p:spPr>
-      </p:pic>
-      <p:pic>
-        <p:nvPicPr>
-          <p:cNvPr id="53" name="Picture 52" descr="qa.png"/>
-          <p:cNvPicPr>
-            <a:picLocks noChangeAspect="1"/>
-          </p:cNvPicPr>
-          <p:nvPr/>
-        </p:nvPicPr>
-        <p:blipFill>
-          <a:blip r:embed="rId7"/>
-          <a:stretch>
-            <a:fillRect/>
-          </a:stretch>
-        </p:blipFill>
-        <p:spPr>
-          <a:xfrm>
-            <a:off x="2487168" y="6053328"/>
-            <a:ext cx="292608" cy="292608"/>
-          </a:xfrm>
-          <a:prstGeom prst="rect">
-            <a:avLst/>
-          </a:prstGeom>
-        </p:spPr>
-      </p:pic>
     </p:spTree>
   </p:cSld>
   <p:clrMapOvr>
@@ -30042,198 +29538,6 @@
           </a:p>
         </p:txBody>
       </p:sp>
-      <p:pic>
-        <p:nvPicPr>
-          <p:cNvPr id="46" name="Picture 45" descr="jira.png"/>
-          <p:cNvPicPr>
-            <a:picLocks noChangeAspect="1"/>
-          </p:cNvPicPr>
-          <p:nvPr/>
-        </p:nvPicPr>
-        <p:blipFill>
-          <a:blip r:embed="rId3"/>
-          <a:stretch>
-            <a:fillRect/>
-          </a:stretch>
-        </p:blipFill>
-        <p:spPr>
-          <a:xfrm>
-            <a:off x="457200" y="6053328"/>
-            <a:ext cx="265176" cy="265176"/>
-          </a:xfrm>
-          <a:prstGeom prst="rect">
-            <a:avLst/>
-          </a:prstGeom>
-        </p:spPr>
-      </p:pic>
-      <p:pic>
-        <p:nvPicPr>
-          <p:cNvPr id="47" name="Picture 46" descr="confluence.png"/>
-          <p:cNvPicPr>
-            <a:picLocks noChangeAspect="1"/>
-          </p:cNvPicPr>
-          <p:nvPr/>
-        </p:nvPicPr>
-        <p:blipFill>
-          <a:blip r:embed="rId4"/>
-          <a:stretch>
-            <a:fillRect/>
-          </a:stretch>
-        </p:blipFill>
-        <p:spPr>
-          <a:xfrm>
-            <a:off x="850392" y="6053328"/>
-            <a:ext cx="265176" cy="265176"/>
-          </a:xfrm>
-          <a:prstGeom prst="rect">
-            <a:avLst/>
-          </a:prstGeom>
-        </p:spPr>
-      </p:pic>
-      <p:pic>
-        <p:nvPicPr>
-          <p:cNvPr id="48" name="Picture 47" descr="github.png"/>
-          <p:cNvPicPr>
-            <a:picLocks noChangeAspect="1"/>
-          </p:cNvPicPr>
-          <p:nvPr/>
-        </p:nvPicPr>
-        <p:blipFill>
-          <a:blip r:embed="rId5"/>
-          <a:stretch>
-            <a:fillRect/>
-          </a:stretch>
-        </p:blipFill>
-        <p:spPr>
-          <a:xfrm>
-            <a:off x="1243584" y="6053328"/>
-            <a:ext cx="265176" cy="265176"/>
-          </a:xfrm>
-          <a:prstGeom prst="rect">
-            <a:avLst/>
-          </a:prstGeom>
-        </p:spPr>
-      </p:pic>
-      <p:pic>
-        <p:nvPicPr>
-          <p:cNvPr id="49" name="Picture 48" descr="copilot.png"/>
-          <p:cNvPicPr>
-            <a:picLocks noChangeAspect="1"/>
-          </p:cNvPicPr>
-          <p:nvPr/>
-        </p:nvPicPr>
-        <p:blipFill>
-          <a:blip r:embed="rId6"/>
-          <a:stretch>
-            <a:fillRect/>
-          </a:stretch>
-        </p:blipFill>
-        <p:spPr>
-          <a:xfrm>
-            <a:off x="1636776" y="6053328"/>
-            <a:ext cx="265176" cy="265176"/>
-          </a:xfrm>
-          <a:prstGeom prst="rect">
-            <a:avLst/>
-          </a:prstGeom>
-        </p:spPr>
-      </p:pic>
-      <p:pic>
-        <p:nvPicPr>
-          <p:cNvPr id="50" name="Picture 49" descr="rovo.png"/>
-          <p:cNvPicPr>
-            <a:picLocks noChangeAspect="1"/>
-          </p:cNvPicPr>
-          <p:nvPr/>
-        </p:nvPicPr>
-        <p:blipFill>
-          <a:blip r:embed="rId7"/>
-          <a:stretch>
-            <a:fillRect/>
-          </a:stretch>
-        </p:blipFill>
-        <p:spPr>
-          <a:xfrm>
-            <a:off x="2029967" y="6053328"/>
-            <a:ext cx="265176" cy="265176"/>
-          </a:xfrm>
-          <a:prstGeom prst="rect">
-            <a:avLst/>
-          </a:prstGeom>
-        </p:spPr>
-      </p:pic>
-      <p:pic>
-        <p:nvPicPr>
-          <p:cNvPr id="51" name="Picture 50" descr="azure_devops.png"/>
-          <p:cNvPicPr>
-            <a:picLocks noChangeAspect="1"/>
-          </p:cNvPicPr>
-          <p:nvPr/>
-        </p:nvPicPr>
-        <p:blipFill>
-          <a:blip r:embed="rId8"/>
-          <a:stretch>
-            <a:fillRect/>
-          </a:stretch>
-        </p:blipFill>
-        <p:spPr>
-          <a:xfrm>
-            <a:off x="2423160" y="6053328"/>
-            <a:ext cx="265176" cy="265176"/>
-          </a:xfrm>
-          <a:prstGeom prst="rect">
-            <a:avLst/>
-          </a:prstGeom>
-        </p:spPr>
-      </p:pic>
-      <p:pic>
-        <p:nvPicPr>
-          <p:cNvPr id="52" name="Picture 51" descr="jtag.png"/>
-          <p:cNvPicPr>
-            <a:picLocks noChangeAspect="1"/>
-          </p:cNvPicPr>
-          <p:nvPr/>
-        </p:nvPicPr>
-        <p:blipFill>
-          <a:blip r:embed="rId9"/>
-          <a:stretch>
-            <a:fillRect/>
-          </a:stretch>
-        </p:blipFill>
-        <p:spPr>
-          <a:xfrm>
-            <a:off x="2816352" y="6053328"/>
-            <a:ext cx="265176" cy="265176"/>
-          </a:xfrm>
-          <a:prstGeom prst="rect">
-            <a:avLst/>
-          </a:prstGeom>
-        </p:spPr>
-      </p:pic>
-      <p:pic>
-        <p:nvPicPr>
-          <p:cNvPr id="53" name="Picture 52" descr="qa.png"/>
-          <p:cNvPicPr>
-            <a:picLocks noChangeAspect="1"/>
-          </p:cNvPicPr>
-          <p:nvPr/>
-        </p:nvPicPr>
-        <p:blipFill>
-          <a:blip r:embed="rId10"/>
-          <a:stretch>
-            <a:fillRect/>
-          </a:stretch>
-        </p:blipFill>
-        <p:spPr>
-          <a:xfrm>
-            <a:off x="3209544" y="6053328"/>
-            <a:ext cx="265176" cy="265176"/>
-          </a:xfrm>
-          <a:prstGeom prst="rect">
-            <a:avLst/>
-          </a:prstGeom>
-        </p:spPr>
-      </p:pic>
     </p:spTree>
   </p:cSld>
   <p:clrMapOvr>
@@ -32249,126 +31553,6 @@
           </a:p>
         </p:txBody>
       </p:sp>
-      <p:pic>
-        <p:nvPicPr>
-          <p:cNvPr id="50" name="Picture 49" descr="confluence.png"/>
-          <p:cNvPicPr>
-            <a:picLocks noChangeAspect="1"/>
-          </p:cNvPicPr>
-          <p:nvPr/>
-        </p:nvPicPr>
-        <p:blipFill>
-          <a:blip r:embed="rId3"/>
-          <a:stretch>
-            <a:fillRect/>
-          </a:stretch>
-        </p:blipFill>
-        <p:spPr>
-          <a:xfrm>
-            <a:off x="694944" y="6053328"/>
-            <a:ext cx="292608" cy="292608"/>
-          </a:xfrm>
-          <a:prstGeom prst="rect">
-            <a:avLst/>
-          </a:prstGeom>
-        </p:spPr>
-      </p:pic>
-      <p:pic>
-        <p:nvPicPr>
-          <p:cNvPr id="51" name="Picture 50" descr="rovo.png"/>
-          <p:cNvPicPr>
-            <a:picLocks noChangeAspect="1"/>
-          </p:cNvPicPr>
-          <p:nvPr/>
-        </p:nvPicPr>
-        <p:blipFill>
-          <a:blip r:embed="rId4"/>
-          <a:stretch>
-            <a:fillRect/>
-          </a:stretch>
-        </p:blipFill>
-        <p:spPr>
-          <a:xfrm>
-            <a:off x="1188720" y="6053328"/>
-            <a:ext cx="292608" cy="292608"/>
-          </a:xfrm>
-          <a:prstGeom prst="rect">
-            <a:avLst/>
-          </a:prstGeom>
-        </p:spPr>
-      </p:pic>
-      <p:pic>
-        <p:nvPicPr>
-          <p:cNvPr id="52" name="Picture 51" descr="jira.png"/>
-          <p:cNvPicPr>
-            <a:picLocks noChangeAspect="1"/>
-          </p:cNvPicPr>
-          <p:nvPr/>
-        </p:nvPicPr>
-        <p:blipFill>
-          <a:blip r:embed="rId5"/>
-          <a:stretch>
-            <a:fillRect/>
-          </a:stretch>
-        </p:blipFill>
-        <p:spPr>
-          <a:xfrm>
-            <a:off x="1682496" y="6053328"/>
-            <a:ext cx="292608" cy="292608"/>
-          </a:xfrm>
-          <a:prstGeom prst="rect">
-            <a:avLst/>
-          </a:prstGeom>
-        </p:spPr>
-      </p:pic>
-      <p:pic>
-        <p:nvPicPr>
-          <p:cNvPr id="53" name="Picture 52" descr="github.png"/>
-          <p:cNvPicPr>
-            <a:picLocks noChangeAspect="1"/>
-          </p:cNvPicPr>
-          <p:nvPr/>
-        </p:nvPicPr>
-        <p:blipFill>
-          <a:blip r:embed="rId6"/>
-          <a:stretch>
-            <a:fillRect/>
-          </a:stretch>
-        </p:blipFill>
-        <p:spPr>
-          <a:xfrm>
-            <a:off x="2176272" y="6053328"/>
-            <a:ext cx="292608" cy="292608"/>
-          </a:xfrm>
-          <a:prstGeom prst="rect">
-            <a:avLst/>
-          </a:prstGeom>
-        </p:spPr>
-      </p:pic>
-      <p:pic>
-        <p:nvPicPr>
-          <p:cNvPr id="54" name="Picture 53" descr="qa.png"/>
-          <p:cNvPicPr>
-            <a:picLocks noChangeAspect="1"/>
-          </p:cNvPicPr>
-          <p:nvPr/>
-        </p:nvPicPr>
-        <p:blipFill>
-          <a:blip r:embed="rId7"/>
-          <a:stretch>
-            <a:fillRect/>
-          </a:stretch>
-        </p:blipFill>
-        <p:spPr>
-          <a:xfrm>
-            <a:off x="2670048" y="6053328"/>
-            <a:ext cx="292608" cy="292608"/>
-          </a:xfrm>
-          <a:prstGeom prst="rect">
-            <a:avLst/>
-          </a:prstGeom>
-        </p:spPr>
-      </p:pic>
     </p:spTree>
   </p:cSld>
   <p:clrMapOvr>
@@ -36198,150 +35382,6 @@
           </a:p>
         </p:txBody>
       </p:sp>
-      <p:pic>
-        <p:nvPicPr>
-          <p:cNvPr id="93" name="Picture 92" descr="prd.png"/>
-          <p:cNvPicPr>
-            <a:picLocks noChangeAspect="1"/>
-          </p:cNvPicPr>
-          <p:nvPr/>
-        </p:nvPicPr>
-        <p:blipFill>
-          <a:blip r:embed="rId3"/>
-          <a:stretch>
-            <a:fillRect/>
-          </a:stretch>
-        </p:blipFill>
-        <p:spPr>
-          <a:xfrm>
-            <a:off x="658368" y="6089904"/>
-            <a:ext cx="274320" cy="274320"/>
-          </a:xfrm>
-          <a:prstGeom prst="rect">
-            <a:avLst/>
-          </a:prstGeom>
-        </p:spPr>
-      </p:pic>
-      <p:pic>
-        <p:nvPicPr>
-          <p:cNvPr id="94" name="Picture 93" descr="sdk.png"/>
-          <p:cNvPicPr>
-            <a:picLocks noChangeAspect="1"/>
-          </p:cNvPicPr>
-          <p:nvPr/>
-        </p:nvPicPr>
-        <p:blipFill>
-          <a:blip r:embed="rId4"/>
-          <a:stretch>
-            <a:fillRect/>
-          </a:stretch>
-        </p:blipFill>
-        <p:spPr>
-          <a:xfrm>
-            <a:off x="1097280" y="6089904"/>
-            <a:ext cx="274320" cy="274320"/>
-          </a:xfrm>
-          <a:prstGeom prst="rect">
-            <a:avLst/>
-          </a:prstGeom>
-        </p:spPr>
-      </p:pic>
-      <p:pic>
-        <p:nvPicPr>
-          <p:cNvPr id="95" name="Picture 94" descr="copilot.png"/>
-          <p:cNvPicPr>
-            <a:picLocks noChangeAspect="1"/>
-          </p:cNvPicPr>
-          <p:nvPr/>
-        </p:nvPicPr>
-        <p:blipFill>
-          <a:blip r:embed="rId5"/>
-          <a:stretch>
-            <a:fillRect/>
-          </a:stretch>
-        </p:blipFill>
-        <p:spPr>
-          <a:xfrm>
-            <a:off x="1536192" y="6089904"/>
-            <a:ext cx="274320" cy="274320"/>
-          </a:xfrm>
-          <a:prstGeom prst="rect">
-            <a:avLst/>
-          </a:prstGeom>
-        </p:spPr>
-      </p:pic>
-      <p:pic>
-        <p:nvPicPr>
-          <p:cNvPr id="96" name="Picture 95" descr="github.png"/>
-          <p:cNvPicPr>
-            <a:picLocks noChangeAspect="1"/>
-          </p:cNvPicPr>
-          <p:nvPr/>
-        </p:nvPicPr>
-        <p:blipFill>
-          <a:blip r:embed="rId6"/>
-          <a:stretch>
-            <a:fillRect/>
-          </a:stretch>
-        </p:blipFill>
-        <p:spPr>
-          <a:xfrm>
-            <a:off x="1975104" y="6089904"/>
-            <a:ext cx="274320" cy="274320"/>
-          </a:xfrm>
-          <a:prstGeom prst="rect">
-            <a:avLst/>
-          </a:prstGeom>
-        </p:spPr>
-      </p:pic>
-      <p:pic>
-        <p:nvPicPr>
-          <p:cNvPr id="97" name="Picture 96" descr="azure_devops.png"/>
-          <p:cNvPicPr>
-            <a:picLocks noChangeAspect="1"/>
-          </p:cNvPicPr>
-          <p:nvPr/>
-        </p:nvPicPr>
-        <p:blipFill>
-          <a:blip r:embed="rId7"/>
-          <a:stretch>
-            <a:fillRect/>
-          </a:stretch>
-        </p:blipFill>
-        <p:spPr>
-          <a:xfrm>
-            <a:off x="2414015" y="6089904"/>
-            <a:ext cx="274320" cy="274320"/>
-          </a:xfrm>
-          <a:prstGeom prst="rect">
-            <a:avLst/>
-          </a:prstGeom>
-        </p:spPr>
-      </p:pic>
-      <p:pic>
-        <p:nvPicPr>
-          <p:cNvPr id="98" name="Picture 97" descr="jtag.png"/>
-          <p:cNvPicPr>
-            <a:picLocks noChangeAspect="1"/>
-          </p:cNvPicPr>
-          <p:nvPr/>
-        </p:nvPicPr>
-        <p:blipFill>
-          <a:blip r:embed="rId8"/>
-          <a:stretch>
-            <a:fillRect/>
-          </a:stretch>
-        </p:blipFill>
-        <p:spPr>
-          <a:xfrm>
-            <a:off x="2852928" y="6089904"/>
-            <a:ext cx="274320" cy="274320"/>
-          </a:xfrm>
-          <a:prstGeom prst="rect">
-            <a:avLst/>
-          </a:prstGeom>
-        </p:spPr>
-      </p:pic>
     </p:spTree>
   </p:cSld>
   <p:clrMapOvr>
@@ -38953,78 +37993,6 @@
           </a:prstGeom>
         </p:spPr>
       </p:pic>
-      <p:pic>
-        <p:nvPicPr>
-          <p:cNvPr id="132" name="Picture 131" descr="jtag.png"/>
-          <p:cNvPicPr>
-            <a:picLocks noChangeAspect="1"/>
-          </p:cNvPicPr>
-          <p:nvPr/>
-        </p:nvPicPr>
-        <p:blipFill>
-          <a:blip r:embed="rId4"/>
-          <a:stretch>
-            <a:fillRect/>
-          </a:stretch>
-        </p:blipFill>
-        <p:spPr>
-          <a:xfrm>
-            <a:off x="502920" y="6053328"/>
-            <a:ext cx="292608" cy="292608"/>
-          </a:xfrm>
-          <a:prstGeom prst="rect">
-            <a:avLst/>
-          </a:prstGeom>
-        </p:spPr>
-      </p:pic>
-      <p:pic>
-        <p:nvPicPr>
-          <p:cNvPr id="133" name="Picture 132" descr="github.png"/>
-          <p:cNvPicPr>
-            <a:picLocks noChangeAspect="1"/>
-          </p:cNvPicPr>
-          <p:nvPr/>
-        </p:nvPicPr>
-        <p:blipFill>
-          <a:blip r:embed="rId5"/>
-          <a:stretch>
-            <a:fillRect/>
-          </a:stretch>
-        </p:blipFill>
-        <p:spPr>
-          <a:xfrm>
-            <a:off x="960120" y="6053328"/>
-            <a:ext cx="292608" cy="292608"/>
-          </a:xfrm>
-          <a:prstGeom prst="rect">
-            <a:avLst/>
-          </a:prstGeom>
-        </p:spPr>
-      </p:pic>
-      <p:pic>
-        <p:nvPicPr>
-          <p:cNvPr id="134" name="Picture 133" descr="jira.png"/>
-          <p:cNvPicPr>
-            <a:picLocks noChangeAspect="1"/>
-          </p:cNvPicPr>
-          <p:nvPr/>
-        </p:nvPicPr>
-        <p:blipFill>
-          <a:blip r:embed="rId6"/>
-          <a:stretch>
-            <a:fillRect/>
-          </a:stretch>
-        </p:blipFill>
-        <p:spPr>
-          <a:xfrm>
-            <a:off x="1417320" y="6053328"/>
-            <a:ext cx="292608" cy="292608"/>
-          </a:xfrm>
-          <a:prstGeom prst="rect">
-            <a:avLst/>
-          </a:prstGeom>
-        </p:spPr>
-      </p:pic>
     </p:spTree>
     <p:extLst>
       <p:ext uri="{BB962C8B-B14F-4D97-AF65-F5344CB8AC3E}">
@@ -40871,102 +39839,6 @@
           </a:p>
         </p:txBody>
       </p:sp>
-      <p:pic>
-        <p:nvPicPr>
-          <p:cNvPr id="47" name="Picture 46" descr="stqc.png"/>
-          <p:cNvPicPr>
-            <a:picLocks noChangeAspect="1"/>
-          </p:cNvPicPr>
-          <p:nvPr/>
-        </p:nvPicPr>
-        <p:blipFill>
-          <a:blip r:embed="rId3"/>
-          <a:stretch>
-            <a:fillRect/>
-          </a:stretch>
-        </p:blipFill>
-        <p:spPr>
-          <a:xfrm>
-            <a:off x="676656" y="6053328"/>
-            <a:ext cx="292608" cy="292608"/>
-          </a:xfrm>
-          <a:prstGeom prst="rect">
-            <a:avLst/>
-          </a:prstGeom>
-        </p:spPr>
-      </p:pic>
-      <p:pic>
-        <p:nvPicPr>
-          <p:cNvPr id="48" name="Picture 47" descr="prd.png"/>
-          <p:cNvPicPr>
-            <a:picLocks noChangeAspect="1"/>
-          </p:cNvPicPr>
-          <p:nvPr/>
-        </p:nvPicPr>
-        <p:blipFill>
-          <a:blip r:embed="rId4"/>
-          <a:stretch>
-            <a:fillRect/>
-          </a:stretch>
-        </p:blipFill>
-        <p:spPr>
-          <a:xfrm>
-            <a:off x="1152144" y="6053328"/>
-            <a:ext cx="292608" cy="292608"/>
-          </a:xfrm>
-          <a:prstGeom prst="rect">
-            <a:avLst/>
-          </a:prstGeom>
-        </p:spPr>
-      </p:pic>
-      <p:pic>
-        <p:nvPicPr>
-          <p:cNvPr id="49" name="Picture 48" descr="jira.png"/>
-          <p:cNvPicPr>
-            <a:picLocks noChangeAspect="1"/>
-          </p:cNvPicPr>
-          <p:nvPr/>
-        </p:nvPicPr>
-        <p:blipFill>
-          <a:blip r:embed="rId5"/>
-          <a:stretch>
-            <a:fillRect/>
-          </a:stretch>
-        </p:blipFill>
-        <p:spPr>
-          <a:xfrm>
-            <a:off x="1627632" y="6053328"/>
-            <a:ext cx="292608" cy="292608"/>
-          </a:xfrm>
-          <a:prstGeom prst="rect">
-            <a:avLst/>
-          </a:prstGeom>
-        </p:spPr>
-      </p:pic>
-      <p:pic>
-        <p:nvPicPr>
-          <p:cNvPr id="50" name="Picture 49" descr="confluence.png"/>
-          <p:cNvPicPr>
-            <a:picLocks noChangeAspect="1"/>
-          </p:cNvPicPr>
-          <p:nvPr/>
-        </p:nvPicPr>
-        <p:blipFill>
-          <a:blip r:embed="rId6"/>
-          <a:stretch>
-            <a:fillRect/>
-          </a:stretch>
-        </p:blipFill>
-        <p:spPr>
-          <a:xfrm>
-            <a:off x="2103120" y="6053328"/>
-            <a:ext cx="292608" cy="292608"/>
-          </a:xfrm>
-          <a:prstGeom prst="rect">
-            <a:avLst/>
-          </a:prstGeom>
-        </p:spPr>
-      </p:pic>
     </p:spTree>
   </p:cSld>
   <p:clrMapOvr>

</xml_diff>

<commit_message>
Restyle combined slide to match V9 theme
Co-authored-by: Shyam <shyam.nexus@gmail.com>
</commit_message>
<xml_diff>
--- a/AI-Driven Embedded Product Lifecycle OrchestratorV10.pptx
+++ b/AI-Driven Embedded Product Lifecycle OrchestratorV10.pptx
@@ -21910,20 +21910,20 @@
       </p:sp>
       <p:sp>
         <p:nvSpPr>
-          <p:cNvPr id="4" name="Rectangle 3"/>
-          <p:cNvSpPr/>
-          <p:nvPr/>
-        </p:nvSpPr>
-        <p:spPr>
-          <a:xfrm>
-            <a:off x="0" y="640080"/>
-            <a:ext cx="9144000" cy="5486"/>
-          </a:xfrm>
-          <a:prstGeom prst="rect">
-            <a:avLst/>
-          </a:prstGeom>
-          <a:solidFill>
-            <a:srgbClr val="082240"/>
+          <p:cNvPr id="4" name="Rounded Rectangle 3"/>
+          <p:cNvSpPr/>
+          <p:nvPr/>
+        </p:nvSpPr>
+        <p:spPr>
+          <a:xfrm>
+            <a:off x="347472" y="438912"/>
+            <a:ext cx="2011680" cy="274320"/>
+          </a:xfrm>
+          <a:prstGeom prst="roundRect">
+            <a:avLst/>
+          </a:prstGeom>
+          <a:solidFill>
+            <a:srgbClr val="00A89A"/>
           </a:solidFill>
           <a:ln>
             <a:noFill/>
@@ -21953,1347 +21953,14 @@
       </p:sp>
       <p:sp>
         <p:nvSpPr>
-          <p:cNvPr id="5" name="Rectangle 4"/>
-          <p:cNvSpPr/>
-          <p:nvPr/>
-        </p:nvSpPr>
-        <p:spPr>
-          <a:xfrm>
-            <a:off x="0" y="950976"/>
-            <a:ext cx="9144000" cy="5486"/>
-          </a:xfrm>
-          <a:prstGeom prst="rect">
-            <a:avLst/>
-          </a:prstGeom>
-          <a:solidFill>
-            <a:srgbClr val="082240"/>
-          </a:solidFill>
-          <a:ln>
-            <a:noFill/>
-          </a:ln>
-        </p:spPr>
-        <p:style>
-          <a:lnRef idx="1">
-            <a:schemeClr val="accent1"/>
-          </a:lnRef>
-          <a:fillRef idx="3">
-            <a:schemeClr val="accent1"/>
-          </a:fillRef>
-          <a:effectRef idx="2">
-            <a:schemeClr val="accent1"/>
-          </a:effectRef>
-          <a:fontRef idx="minor">
-            <a:schemeClr val="lt1"/>
-          </a:fontRef>
-        </p:style>
-        <p:txBody>
-          <a:bodyPr rtlCol="0" anchor="ctr"/>
-          <a:lstStyle/>
-          <a:p>
-            <a:pPr algn="ctr"/>
-          </a:p>
-        </p:txBody>
-      </p:sp>
-      <p:sp>
-        <p:nvSpPr>
-          <p:cNvPr id="6" name="Rectangle 5"/>
-          <p:cNvSpPr/>
-          <p:nvPr/>
-        </p:nvSpPr>
-        <p:spPr>
-          <a:xfrm>
-            <a:off x="0" y="1261872"/>
-            <a:ext cx="9144000" cy="5486"/>
-          </a:xfrm>
-          <a:prstGeom prst="rect">
-            <a:avLst/>
-          </a:prstGeom>
-          <a:solidFill>
-            <a:srgbClr val="082240"/>
-          </a:solidFill>
-          <a:ln>
-            <a:noFill/>
-          </a:ln>
-        </p:spPr>
-        <p:style>
-          <a:lnRef idx="1">
-            <a:schemeClr val="accent1"/>
-          </a:lnRef>
-          <a:fillRef idx="3">
-            <a:schemeClr val="accent1"/>
-          </a:fillRef>
-          <a:effectRef idx="2">
-            <a:schemeClr val="accent1"/>
-          </a:effectRef>
-          <a:fontRef idx="minor">
-            <a:schemeClr val="lt1"/>
-          </a:fontRef>
-        </p:style>
-        <p:txBody>
-          <a:bodyPr rtlCol="0" anchor="ctr"/>
-          <a:lstStyle/>
-          <a:p>
-            <a:pPr algn="ctr"/>
-          </a:p>
-        </p:txBody>
-      </p:sp>
-      <p:sp>
-        <p:nvSpPr>
-          <p:cNvPr id="7" name="Rectangle 6"/>
-          <p:cNvSpPr/>
-          <p:nvPr/>
-        </p:nvSpPr>
-        <p:spPr>
-          <a:xfrm>
-            <a:off x="0" y="1572768"/>
-            <a:ext cx="9144000" cy="5486"/>
-          </a:xfrm>
-          <a:prstGeom prst="rect">
-            <a:avLst/>
-          </a:prstGeom>
-          <a:solidFill>
-            <a:srgbClr val="082240"/>
-          </a:solidFill>
-          <a:ln>
-            <a:noFill/>
-          </a:ln>
-        </p:spPr>
-        <p:style>
-          <a:lnRef idx="1">
-            <a:schemeClr val="accent1"/>
-          </a:lnRef>
-          <a:fillRef idx="3">
-            <a:schemeClr val="accent1"/>
-          </a:fillRef>
-          <a:effectRef idx="2">
-            <a:schemeClr val="accent1"/>
-          </a:effectRef>
-          <a:fontRef idx="minor">
-            <a:schemeClr val="lt1"/>
-          </a:fontRef>
-        </p:style>
-        <p:txBody>
-          <a:bodyPr rtlCol="0" anchor="ctr"/>
-          <a:lstStyle/>
-          <a:p>
-            <a:pPr algn="ctr"/>
-          </a:p>
-        </p:txBody>
-      </p:sp>
-      <p:sp>
-        <p:nvSpPr>
-          <p:cNvPr id="8" name="Rectangle 7"/>
-          <p:cNvSpPr/>
-          <p:nvPr/>
-        </p:nvSpPr>
-        <p:spPr>
-          <a:xfrm>
-            <a:off x="0" y="1883664"/>
-            <a:ext cx="9144000" cy="5486"/>
-          </a:xfrm>
-          <a:prstGeom prst="rect">
-            <a:avLst/>
-          </a:prstGeom>
-          <a:solidFill>
-            <a:srgbClr val="082240"/>
-          </a:solidFill>
-          <a:ln>
-            <a:noFill/>
-          </a:ln>
-        </p:spPr>
-        <p:style>
-          <a:lnRef idx="1">
-            <a:schemeClr val="accent1"/>
-          </a:lnRef>
-          <a:fillRef idx="3">
-            <a:schemeClr val="accent1"/>
-          </a:fillRef>
-          <a:effectRef idx="2">
-            <a:schemeClr val="accent1"/>
-          </a:effectRef>
-          <a:fontRef idx="minor">
-            <a:schemeClr val="lt1"/>
-          </a:fontRef>
-        </p:style>
-        <p:txBody>
-          <a:bodyPr rtlCol="0" anchor="ctr"/>
-          <a:lstStyle/>
-          <a:p>
-            <a:pPr algn="ctr"/>
-          </a:p>
-        </p:txBody>
-      </p:sp>
-      <p:sp>
-        <p:nvSpPr>
-          <p:cNvPr id="9" name="Rectangle 8"/>
-          <p:cNvSpPr/>
-          <p:nvPr/>
-        </p:nvSpPr>
-        <p:spPr>
-          <a:xfrm>
-            <a:off x="0" y="2194560"/>
-            <a:ext cx="9144000" cy="5486"/>
-          </a:xfrm>
-          <a:prstGeom prst="rect">
-            <a:avLst/>
-          </a:prstGeom>
-          <a:solidFill>
-            <a:srgbClr val="082240"/>
-          </a:solidFill>
-          <a:ln>
-            <a:noFill/>
-          </a:ln>
-        </p:spPr>
-        <p:style>
-          <a:lnRef idx="1">
-            <a:schemeClr val="accent1"/>
-          </a:lnRef>
-          <a:fillRef idx="3">
-            <a:schemeClr val="accent1"/>
-          </a:fillRef>
-          <a:effectRef idx="2">
-            <a:schemeClr val="accent1"/>
-          </a:effectRef>
-          <a:fontRef idx="minor">
-            <a:schemeClr val="lt1"/>
-          </a:fontRef>
-        </p:style>
-        <p:txBody>
-          <a:bodyPr rtlCol="0" anchor="ctr"/>
-          <a:lstStyle/>
-          <a:p>
-            <a:pPr algn="ctr"/>
-          </a:p>
-        </p:txBody>
-      </p:sp>
-      <p:sp>
-        <p:nvSpPr>
-          <p:cNvPr id="10" name="Rectangle 9"/>
-          <p:cNvSpPr/>
-          <p:nvPr/>
-        </p:nvSpPr>
-        <p:spPr>
-          <a:xfrm>
-            <a:off x="0" y="2505456"/>
-            <a:ext cx="9144000" cy="5486"/>
-          </a:xfrm>
-          <a:prstGeom prst="rect">
-            <a:avLst/>
-          </a:prstGeom>
-          <a:solidFill>
-            <a:srgbClr val="082240"/>
-          </a:solidFill>
-          <a:ln>
-            <a:noFill/>
-          </a:ln>
-        </p:spPr>
-        <p:style>
-          <a:lnRef idx="1">
-            <a:schemeClr val="accent1"/>
-          </a:lnRef>
-          <a:fillRef idx="3">
-            <a:schemeClr val="accent1"/>
-          </a:fillRef>
-          <a:effectRef idx="2">
-            <a:schemeClr val="accent1"/>
-          </a:effectRef>
-          <a:fontRef idx="minor">
-            <a:schemeClr val="lt1"/>
-          </a:fontRef>
-        </p:style>
-        <p:txBody>
-          <a:bodyPr rtlCol="0" anchor="ctr"/>
-          <a:lstStyle/>
-          <a:p>
-            <a:pPr algn="ctr"/>
-          </a:p>
-        </p:txBody>
-      </p:sp>
-      <p:sp>
-        <p:nvSpPr>
-          <p:cNvPr id="11" name="Rectangle 10"/>
-          <p:cNvSpPr/>
-          <p:nvPr/>
-        </p:nvSpPr>
-        <p:spPr>
-          <a:xfrm>
-            <a:off x="0" y="2816352"/>
-            <a:ext cx="9144000" cy="5486"/>
-          </a:xfrm>
-          <a:prstGeom prst="rect">
-            <a:avLst/>
-          </a:prstGeom>
-          <a:solidFill>
-            <a:srgbClr val="082240"/>
-          </a:solidFill>
-          <a:ln>
-            <a:noFill/>
-          </a:ln>
-        </p:spPr>
-        <p:style>
-          <a:lnRef idx="1">
-            <a:schemeClr val="accent1"/>
-          </a:lnRef>
-          <a:fillRef idx="3">
-            <a:schemeClr val="accent1"/>
-          </a:fillRef>
-          <a:effectRef idx="2">
-            <a:schemeClr val="accent1"/>
-          </a:effectRef>
-          <a:fontRef idx="minor">
-            <a:schemeClr val="lt1"/>
-          </a:fontRef>
-        </p:style>
-        <p:txBody>
-          <a:bodyPr rtlCol="0" anchor="ctr"/>
-          <a:lstStyle/>
-          <a:p>
-            <a:pPr algn="ctr"/>
-          </a:p>
-        </p:txBody>
-      </p:sp>
-      <p:sp>
-        <p:nvSpPr>
-          <p:cNvPr id="12" name="Rectangle 11"/>
-          <p:cNvSpPr/>
-          <p:nvPr/>
-        </p:nvSpPr>
-        <p:spPr>
-          <a:xfrm>
-            <a:off x="0" y="3127248"/>
-            <a:ext cx="9144000" cy="5486"/>
-          </a:xfrm>
-          <a:prstGeom prst="rect">
-            <a:avLst/>
-          </a:prstGeom>
-          <a:solidFill>
-            <a:srgbClr val="082240"/>
-          </a:solidFill>
-          <a:ln>
-            <a:noFill/>
-          </a:ln>
-        </p:spPr>
-        <p:style>
-          <a:lnRef idx="1">
-            <a:schemeClr val="accent1"/>
-          </a:lnRef>
-          <a:fillRef idx="3">
-            <a:schemeClr val="accent1"/>
-          </a:fillRef>
-          <a:effectRef idx="2">
-            <a:schemeClr val="accent1"/>
-          </a:effectRef>
-          <a:fontRef idx="minor">
-            <a:schemeClr val="lt1"/>
-          </a:fontRef>
-        </p:style>
-        <p:txBody>
-          <a:bodyPr rtlCol="0" anchor="ctr"/>
-          <a:lstStyle/>
-          <a:p>
-            <a:pPr algn="ctr"/>
-          </a:p>
-        </p:txBody>
-      </p:sp>
-      <p:sp>
-        <p:nvSpPr>
-          <p:cNvPr id="13" name="Rectangle 12"/>
-          <p:cNvSpPr/>
-          <p:nvPr/>
-        </p:nvSpPr>
-        <p:spPr>
-          <a:xfrm>
-            <a:off x="0" y="3438144"/>
-            <a:ext cx="9144000" cy="5486"/>
-          </a:xfrm>
-          <a:prstGeom prst="rect">
-            <a:avLst/>
-          </a:prstGeom>
-          <a:solidFill>
-            <a:srgbClr val="082240"/>
-          </a:solidFill>
-          <a:ln>
-            <a:noFill/>
-          </a:ln>
-        </p:spPr>
-        <p:style>
-          <a:lnRef idx="1">
-            <a:schemeClr val="accent1"/>
-          </a:lnRef>
-          <a:fillRef idx="3">
-            <a:schemeClr val="accent1"/>
-          </a:fillRef>
-          <a:effectRef idx="2">
-            <a:schemeClr val="accent1"/>
-          </a:effectRef>
-          <a:fontRef idx="minor">
-            <a:schemeClr val="lt1"/>
-          </a:fontRef>
-        </p:style>
-        <p:txBody>
-          <a:bodyPr rtlCol="0" anchor="ctr"/>
-          <a:lstStyle/>
-          <a:p>
-            <a:pPr algn="ctr"/>
-          </a:p>
-        </p:txBody>
-      </p:sp>
-      <p:sp>
-        <p:nvSpPr>
-          <p:cNvPr id="14" name="Rectangle 13"/>
-          <p:cNvSpPr/>
-          <p:nvPr/>
-        </p:nvSpPr>
-        <p:spPr>
-          <a:xfrm>
-            <a:off x="0" y="3749040"/>
-            <a:ext cx="9144000" cy="5486"/>
-          </a:xfrm>
-          <a:prstGeom prst="rect">
-            <a:avLst/>
-          </a:prstGeom>
-          <a:solidFill>
-            <a:srgbClr val="082240"/>
-          </a:solidFill>
-          <a:ln>
-            <a:noFill/>
-          </a:ln>
-        </p:spPr>
-        <p:style>
-          <a:lnRef idx="1">
-            <a:schemeClr val="accent1"/>
-          </a:lnRef>
-          <a:fillRef idx="3">
-            <a:schemeClr val="accent1"/>
-          </a:fillRef>
-          <a:effectRef idx="2">
-            <a:schemeClr val="accent1"/>
-          </a:effectRef>
-          <a:fontRef idx="minor">
-            <a:schemeClr val="lt1"/>
-          </a:fontRef>
-        </p:style>
-        <p:txBody>
-          <a:bodyPr rtlCol="0" anchor="ctr"/>
-          <a:lstStyle/>
-          <a:p>
-            <a:pPr algn="ctr"/>
-          </a:p>
-        </p:txBody>
-      </p:sp>
-      <p:sp>
-        <p:nvSpPr>
-          <p:cNvPr id="15" name="Rectangle 14"/>
-          <p:cNvSpPr/>
-          <p:nvPr/>
-        </p:nvSpPr>
-        <p:spPr>
-          <a:xfrm>
-            <a:off x="0" y="4059936"/>
-            <a:ext cx="9144000" cy="5486"/>
-          </a:xfrm>
-          <a:prstGeom prst="rect">
-            <a:avLst/>
-          </a:prstGeom>
-          <a:solidFill>
-            <a:srgbClr val="082240"/>
-          </a:solidFill>
-          <a:ln>
-            <a:noFill/>
-          </a:ln>
-        </p:spPr>
-        <p:style>
-          <a:lnRef idx="1">
-            <a:schemeClr val="accent1"/>
-          </a:lnRef>
-          <a:fillRef idx="3">
-            <a:schemeClr val="accent1"/>
-          </a:fillRef>
-          <a:effectRef idx="2">
-            <a:schemeClr val="accent1"/>
-          </a:effectRef>
-          <a:fontRef idx="minor">
-            <a:schemeClr val="lt1"/>
-          </a:fontRef>
-        </p:style>
-        <p:txBody>
-          <a:bodyPr rtlCol="0" anchor="ctr"/>
-          <a:lstStyle/>
-          <a:p>
-            <a:pPr algn="ctr"/>
-          </a:p>
-        </p:txBody>
-      </p:sp>
-      <p:sp>
-        <p:nvSpPr>
-          <p:cNvPr id="16" name="Rectangle 15"/>
-          <p:cNvSpPr/>
-          <p:nvPr/>
-        </p:nvSpPr>
-        <p:spPr>
-          <a:xfrm>
-            <a:off x="0" y="4370832"/>
-            <a:ext cx="9144000" cy="5486"/>
-          </a:xfrm>
-          <a:prstGeom prst="rect">
-            <a:avLst/>
-          </a:prstGeom>
-          <a:solidFill>
-            <a:srgbClr val="082240"/>
-          </a:solidFill>
-          <a:ln>
-            <a:noFill/>
-          </a:ln>
-        </p:spPr>
-        <p:style>
-          <a:lnRef idx="1">
-            <a:schemeClr val="accent1"/>
-          </a:lnRef>
-          <a:fillRef idx="3">
-            <a:schemeClr val="accent1"/>
-          </a:fillRef>
-          <a:effectRef idx="2">
-            <a:schemeClr val="accent1"/>
-          </a:effectRef>
-          <a:fontRef idx="minor">
-            <a:schemeClr val="lt1"/>
-          </a:fontRef>
-        </p:style>
-        <p:txBody>
-          <a:bodyPr rtlCol="0" anchor="ctr"/>
-          <a:lstStyle/>
-          <a:p>
-            <a:pPr algn="ctr"/>
-          </a:p>
-        </p:txBody>
-      </p:sp>
-      <p:sp>
-        <p:nvSpPr>
-          <p:cNvPr id="17" name="Rectangle 16"/>
-          <p:cNvSpPr/>
-          <p:nvPr/>
-        </p:nvSpPr>
-        <p:spPr>
-          <a:xfrm>
-            <a:off x="0" y="4681728"/>
-            <a:ext cx="9144000" cy="5486"/>
-          </a:xfrm>
-          <a:prstGeom prst="rect">
-            <a:avLst/>
-          </a:prstGeom>
-          <a:solidFill>
-            <a:srgbClr val="082240"/>
-          </a:solidFill>
-          <a:ln>
-            <a:noFill/>
-          </a:ln>
-        </p:spPr>
-        <p:style>
-          <a:lnRef idx="1">
-            <a:schemeClr val="accent1"/>
-          </a:lnRef>
-          <a:fillRef idx="3">
-            <a:schemeClr val="accent1"/>
-          </a:fillRef>
-          <a:effectRef idx="2">
-            <a:schemeClr val="accent1"/>
-          </a:effectRef>
-          <a:fontRef idx="minor">
-            <a:schemeClr val="lt1"/>
-          </a:fontRef>
-        </p:style>
-        <p:txBody>
-          <a:bodyPr rtlCol="0" anchor="ctr"/>
-          <a:lstStyle/>
-          <a:p>
-            <a:pPr algn="ctr"/>
-          </a:p>
-        </p:txBody>
-      </p:sp>
-      <p:sp>
-        <p:nvSpPr>
-          <p:cNvPr id="18" name="Rectangle 17"/>
-          <p:cNvSpPr/>
-          <p:nvPr/>
-        </p:nvSpPr>
-        <p:spPr>
-          <a:xfrm>
-            <a:off x="0" y="4992624"/>
-            <a:ext cx="9144000" cy="5486"/>
-          </a:xfrm>
-          <a:prstGeom prst="rect">
-            <a:avLst/>
-          </a:prstGeom>
-          <a:solidFill>
-            <a:srgbClr val="082240"/>
-          </a:solidFill>
-          <a:ln>
-            <a:noFill/>
-          </a:ln>
-        </p:spPr>
-        <p:style>
-          <a:lnRef idx="1">
-            <a:schemeClr val="accent1"/>
-          </a:lnRef>
-          <a:fillRef idx="3">
-            <a:schemeClr val="accent1"/>
-          </a:fillRef>
-          <a:effectRef idx="2">
-            <a:schemeClr val="accent1"/>
-          </a:effectRef>
-          <a:fontRef idx="minor">
-            <a:schemeClr val="lt1"/>
-          </a:fontRef>
-        </p:style>
-        <p:txBody>
-          <a:bodyPr rtlCol="0" anchor="ctr"/>
-          <a:lstStyle/>
-          <a:p>
-            <a:pPr algn="ctr"/>
-          </a:p>
-        </p:txBody>
-      </p:sp>
-      <p:sp>
-        <p:nvSpPr>
-          <p:cNvPr id="19" name="Rectangle 18"/>
-          <p:cNvSpPr/>
-          <p:nvPr/>
-        </p:nvSpPr>
-        <p:spPr>
-          <a:xfrm>
-            <a:off x="0" y="5303520"/>
-            <a:ext cx="9144000" cy="5486"/>
-          </a:xfrm>
-          <a:prstGeom prst="rect">
-            <a:avLst/>
-          </a:prstGeom>
-          <a:solidFill>
-            <a:srgbClr val="082240"/>
-          </a:solidFill>
-          <a:ln>
-            <a:noFill/>
-          </a:ln>
-        </p:spPr>
-        <p:style>
-          <a:lnRef idx="1">
-            <a:schemeClr val="accent1"/>
-          </a:lnRef>
-          <a:fillRef idx="3">
-            <a:schemeClr val="accent1"/>
-          </a:fillRef>
-          <a:effectRef idx="2">
-            <a:schemeClr val="accent1"/>
-          </a:effectRef>
-          <a:fontRef idx="minor">
-            <a:schemeClr val="lt1"/>
-          </a:fontRef>
-        </p:style>
-        <p:txBody>
-          <a:bodyPr rtlCol="0" anchor="ctr"/>
-          <a:lstStyle/>
-          <a:p>
-            <a:pPr algn="ctr"/>
-          </a:p>
-        </p:txBody>
-      </p:sp>
-      <p:sp>
-        <p:nvSpPr>
-          <p:cNvPr id="20" name="Rectangle 19"/>
-          <p:cNvSpPr/>
-          <p:nvPr/>
-        </p:nvSpPr>
-        <p:spPr>
-          <a:xfrm>
-            <a:off x="0" y="5614416"/>
-            <a:ext cx="9144000" cy="5486"/>
-          </a:xfrm>
-          <a:prstGeom prst="rect">
-            <a:avLst/>
-          </a:prstGeom>
-          <a:solidFill>
-            <a:srgbClr val="082240"/>
-          </a:solidFill>
-          <a:ln>
-            <a:noFill/>
-          </a:ln>
-        </p:spPr>
-        <p:style>
-          <a:lnRef idx="1">
-            <a:schemeClr val="accent1"/>
-          </a:lnRef>
-          <a:fillRef idx="3">
-            <a:schemeClr val="accent1"/>
-          </a:fillRef>
-          <a:effectRef idx="2">
-            <a:schemeClr val="accent1"/>
-          </a:effectRef>
-          <a:fontRef idx="minor">
-            <a:schemeClr val="lt1"/>
-          </a:fontRef>
-        </p:style>
-        <p:txBody>
-          <a:bodyPr rtlCol="0" anchor="ctr"/>
-          <a:lstStyle/>
-          <a:p>
-            <a:pPr algn="ctr"/>
-          </a:p>
-        </p:txBody>
-      </p:sp>
-      <p:sp>
-        <p:nvSpPr>
-          <p:cNvPr id="21" name="Rectangle 20"/>
-          <p:cNvSpPr/>
-          <p:nvPr/>
-        </p:nvSpPr>
-        <p:spPr>
-          <a:xfrm>
-            <a:off x="0" y="5925312"/>
-            <a:ext cx="9144000" cy="5486"/>
-          </a:xfrm>
-          <a:prstGeom prst="rect">
-            <a:avLst/>
-          </a:prstGeom>
-          <a:solidFill>
-            <a:srgbClr val="082240"/>
-          </a:solidFill>
-          <a:ln>
-            <a:noFill/>
-          </a:ln>
-        </p:spPr>
-        <p:style>
-          <a:lnRef idx="1">
-            <a:schemeClr val="accent1"/>
-          </a:lnRef>
-          <a:fillRef idx="3">
-            <a:schemeClr val="accent1"/>
-          </a:fillRef>
-          <a:effectRef idx="2">
-            <a:schemeClr val="accent1"/>
-          </a:effectRef>
-          <a:fontRef idx="minor">
-            <a:schemeClr val="lt1"/>
-          </a:fontRef>
-        </p:style>
-        <p:txBody>
-          <a:bodyPr rtlCol="0" anchor="ctr"/>
-          <a:lstStyle/>
-          <a:p>
-            <a:pPr algn="ctr"/>
-          </a:p>
-        </p:txBody>
-      </p:sp>
-      <p:sp>
-        <p:nvSpPr>
-          <p:cNvPr id="22" name="Rectangle 21"/>
-          <p:cNvSpPr/>
-          <p:nvPr/>
-        </p:nvSpPr>
-        <p:spPr>
-          <a:xfrm>
-            <a:off x="365760" y="640080"/>
-            <a:ext cx="5486" cy="5349240"/>
-          </a:xfrm>
-          <a:prstGeom prst="rect">
-            <a:avLst/>
-          </a:prstGeom>
-          <a:solidFill>
-            <a:srgbClr val="082240"/>
-          </a:solidFill>
-          <a:ln>
-            <a:noFill/>
-          </a:ln>
-        </p:spPr>
-        <p:style>
-          <a:lnRef idx="1">
-            <a:schemeClr val="accent1"/>
-          </a:lnRef>
-          <a:fillRef idx="3">
-            <a:schemeClr val="accent1"/>
-          </a:fillRef>
-          <a:effectRef idx="2">
-            <a:schemeClr val="accent1"/>
-          </a:effectRef>
-          <a:fontRef idx="minor">
-            <a:schemeClr val="lt1"/>
-          </a:fontRef>
-        </p:style>
-        <p:txBody>
-          <a:bodyPr rtlCol="0" anchor="ctr"/>
-          <a:lstStyle/>
-          <a:p>
-            <a:pPr algn="ctr"/>
-          </a:p>
-        </p:txBody>
-      </p:sp>
-      <p:sp>
-        <p:nvSpPr>
-          <p:cNvPr id="23" name="Rectangle 22"/>
-          <p:cNvSpPr/>
-          <p:nvPr/>
-        </p:nvSpPr>
-        <p:spPr>
-          <a:xfrm>
-            <a:off x="1051560" y="640080"/>
-            <a:ext cx="5486" cy="5349240"/>
-          </a:xfrm>
-          <a:prstGeom prst="rect">
-            <a:avLst/>
-          </a:prstGeom>
-          <a:solidFill>
-            <a:srgbClr val="082240"/>
-          </a:solidFill>
-          <a:ln>
-            <a:noFill/>
-          </a:ln>
-        </p:spPr>
-        <p:style>
-          <a:lnRef idx="1">
-            <a:schemeClr val="accent1"/>
-          </a:lnRef>
-          <a:fillRef idx="3">
-            <a:schemeClr val="accent1"/>
-          </a:fillRef>
-          <a:effectRef idx="2">
-            <a:schemeClr val="accent1"/>
-          </a:effectRef>
-          <a:fontRef idx="minor">
-            <a:schemeClr val="lt1"/>
-          </a:fontRef>
-        </p:style>
-        <p:txBody>
-          <a:bodyPr rtlCol="0" anchor="ctr"/>
-          <a:lstStyle/>
-          <a:p>
-            <a:pPr algn="ctr"/>
-          </a:p>
-        </p:txBody>
-      </p:sp>
-      <p:sp>
-        <p:nvSpPr>
-          <p:cNvPr id="24" name="Rectangle 23"/>
-          <p:cNvSpPr/>
-          <p:nvPr/>
-        </p:nvSpPr>
-        <p:spPr>
-          <a:xfrm>
-            <a:off x="1737360" y="640080"/>
-            <a:ext cx="5486" cy="5349240"/>
-          </a:xfrm>
-          <a:prstGeom prst="rect">
-            <a:avLst/>
-          </a:prstGeom>
-          <a:solidFill>
-            <a:srgbClr val="082240"/>
-          </a:solidFill>
-          <a:ln>
-            <a:noFill/>
-          </a:ln>
-        </p:spPr>
-        <p:style>
-          <a:lnRef idx="1">
-            <a:schemeClr val="accent1"/>
-          </a:lnRef>
-          <a:fillRef idx="3">
-            <a:schemeClr val="accent1"/>
-          </a:fillRef>
-          <a:effectRef idx="2">
-            <a:schemeClr val="accent1"/>
-          </a:effectRef>
-          <a:fontRef idx="minor">
-            <a:schemeClr val="lt1"/>
-          </a:fontRef>
-        </p:style>
-        <p:txBody>
-          <a:bodyPr rtlCol="0" anchor="ctr"/>
-          <a:lstStyle/>
-          <a:p>
-            <a:pPr algn="ctr"/>
-          </a:p>
-        </p:txBody>
-      </p:sp>
-      <p:sp>
-        <p:nvSpPr>
-          <p:cNvPr id="25" name="Rectangle 24"/>
-          <p:cNvSpPr/>
-          <p:nvPr/>
-        </p:nvSpPr>
-        <p:spPr>
-          <a:xfrm>
-            <a:off x="2423160" y="640080"/>
-            <a:ext cx="5486" cy="5349240"/>
-          </a:xfrm>
-          <a:prstGeom prst="rect">
-            <a:avLst/>
-          </a:prstGeom>
-          <a:solidFill>
-            <a:srgbClr val="082240"/>
-          </a:solidFill>
-          <a:ln>
-            <a:noFill/>
-          </a:ln>
-        </p:spPr>
-        <p:style>
-          <a:lnRef idx="1">
-            <a:schemeClr val="accent1"/>
-          </a:lnRef>
-          <a:fillRef idx="3">
-            <a:schemeClr val="accent1"/>
-          </a:fillRef>
-          <a:effectRef idx="2">
-            <a:schemeClr val="accent1"/>
-          </a:effectRef>
-          <a:fontRef idx="minor">
-            <a:schemeClr val="lt1"/>
-          </a:fontRef>
-        </p:style>
-        <p:txBody>
-          <a:bodyPr rtlCol="0" anchor="ctr"/>
-          <a:lstStyle/>
-          <a:p>
-            <a:pPr algn="ctr"/>
-          </a:p>
-        </p:txBody>
-      </p:sp>
-      <p:sp>
-        <p:nvSpPr>
-          <p:cNvPr id="26" name="Rectangle 25"/>
-          <p:cNvSpPr/>
-          <p:nvPr/>
-        </p:nvSpPr>
-        <p:spPr>
-          <a:xfrm>
-            <a:off x="3108960" y="640080"/>
-            <a:ext cx="5486" cy="5349240"/>
-          </a:xfrm>
-          <a:prstGeom prst="rect">
-            <a:avLst/>
-          </a:prstGeom>
-          <a:solidFill>
-            <a:srgbClr val="082240"/>
-          </a:solidFill>
-          <a:ln>
-            <a:noFill/>
-          </a:ln>
-        </p:spPr>
-        <p:style>
-          <a:lnRef idx="1">
-            <a:schemeClr val="accent1"/>
-          </a:lnRef>
-          <a:fillRef idx="3">
-            <a:schemeClr val="accent1"/>
-          </a:fillRef>
-          <a:effectRef idx="2">
-            <a:schemeClr val="accent1"/>
-          </a:effectRef>
-          <a:fontRef idx="minor">
-            <a:schemeClr val="lt1"/>
-          </a:fontRef>
-        </p:style>
-        <p:txBody>
-          <a:bodyPr rtlCol="0" anchor="ctr"/>
-          <a:lstStyle/>
-          <a:p>
-            <a:pPr algn="ctr"/>
-          </a:p>
-        </p:txBody>
-      </p:sp>
-      <p:sp>
-        <p:nvSpPr>
-          <p:cNvPr id="27" name="Rectangle 26"/>
-          <p:cNvSpPr/>
-          <p:nvPr/>
-        </p:nvSpPr>
-        <p:spPr>
-          <a:xfrm>
-            <a:off x="3794760" y="640080"/>
-            <a:ext cx="5486" cy="5349240"/>
-          </a:xfrm>
-          <a:prstGeom prst="rect">
-            <a:avLst/>
-          </a:prstGeom>
-          <a:solidFill>
-            <a:srgbClr val="082240"/>
-          </a:solidFill>
-          <a:ln>
-            <a:noFill/>
-          </a:ln>
-        </p:spPr>
-        <p:style>
-          <a:lnRef idx="1">
-            <a:schemeClr val="accent1"/>
-          </a:lnRef>
-          <a:fillRef idx="3">
-            <a:schemeClr val="accent1"/>
-          </a:fillRef>
-          <a:effectRef idx="2">
-            <a:schemeClr val="accent1"/>
-          </a:effectRef>
-          <a:fontRef idx="minor">
-            <a:schemeClr val="lt1"/>
-          </a:fontRef>
-        </p:style>
-        <p:txBody>
-          <a:bodyPr rtlCol="0" anchor="ctr"/>
-          <a:lstStyle/>
-          <a:p>
-            <a:pPr algn="ctr"/>
-          </a:p>
-        </p:txBody>
-      </p:sp>
-      <p:sp>
-        <p:nvSpPr>
-          <p:cNvPr id="28" name="Rectangle 27"/>
-          <p:cNvSpPr/>
-          <p:nvPr/>
-        </p:nvSpPr>
-        <p:spPr>
-          <a:xfrm>
-            <a:off x="4480560" y="640080"/>
-            <a:ext cx="5486" cy="5349240"/>
-          </a:xfrm>
-          <a:prstGeom prst="rect">
-            <a:avLst/>
-          </a:prstGeom>
-          <a:solidFill>
-            <a:srgbClr val="082240"/>
-          </a:solidFill>
-          <a:ln>
-            <a:noFill/>
-          </a:ln>
-        </p:spPr>
-        <p:style>
-          <a:lnRef idx="1">
-            <a:schemeClr val="accent1"/>
-          </a:lnRef>
-          <a:fillRef idx="3">
-            <a:schemeClr val="accent1"/>
-          </a:fillRef>
-          <a:effectRef idx="2">
-            <a:schemeClr val="accent1"/>
-          </a:effectRef>
-          <a:fontRef idx="minor">
-            <a:schemeClr val="lt1"/>
-          </a:fontRef>
-        </p:style>
-        <p:txBody>
-          <a:bodyPr rtlCol="0" anchor="ctr"/>
-          <a:lstStyle/>
-          <a:p>
-            <a:pPr algn="ctr"/>
-          </a:p>
-        </p:txBody>
-      </p:sp>
-      <p:sp>
-        <p:nvSpPr>
-          <p:cNvPr id="29" name="Rectangle 28"/>
-          <p:cNvSpPr/>
-          <p:nvPr/>
-        </p:nvSpPr>
-        <p:spPr>
-          <a:xfrm>
-            <a:off x="5166360" y="640080"/>
-            <a:ext cx="5486" cy="5349240"/>
-          </a:xfrm>
-          <a:prstGeom prst="rect">
-            <a:avLst/>
-          </a:prstGeom>
-          <a:solidFill>
-            <a:srgbClr val="082240"/>
-          </a:solidFill>
-          <a:ln>
-            <a:noFill/>
-          </a:ln>
-        </p:spPr>
-        <p:style>
-          <a:lnRef idx="1">
-            <a:schemeClr val="accent1"/>
-          </a:lnRef>
-          <a:fillRef idx="3">
-            <a:schemeClr val="accent1"/>
-          </a:fillRef>
-          <a:effectRef idx="2">
-            <a:schemeClr val="accent1"/>
-          </a:effectRef>
-          <a:fontRef idx="minor">
-            <a:schemeClr val="lt1"/>
-          </a:fontRef>
-        </p:style>
-        <p:txBody>
-          <a:bodyPr rtlCol="0" anchor="ctr"/>
-          <a:lstStyle/>
-          <a:p>
-            <a:pPr algn="ctr"/>
-          </a:p>
-        </p:txBody>
-      </p:sp>
-      <p:sp>
-        <p:nvSpPr>
-          <p:cNvPr id="30" name="Rectangle 29"/>
-          <p:cNvSpPr/>
-          <p:nvPr/>
-        </p:nvSpPr>
-        <p:spPr>
-          <a:xfrm>
-            <a:off x="5852160" y="640080"/>
-            <a:ext cx="5486" cy="5349240"/>
-          </a:xfrm>
-          <a:prstGeom prst="rect">
-            <a:avLst/>
-          </a:prstGeom>
-          <a:solidFill>
-            <a:srgbClr val="082240"/>
-          </a:solidFill>
-          <a:ln>
-            <a:noFill/>
-          </a:ln>
-        </p:spPr>
-        <p:style>
-          <a:lnRef idx="1">
-            <a:schemeClr val="accent1"/>
-          </a:lnRef>
-          <a:fillRef idx="3">
-            <a:schemeClr val="accent1"/>
-          </a:fillRef>
-          <a:effectRef idx="2">
-            <a:schemeClr val="accent1"/>
-          </a:effectRef>
-          <a:fontRef idx="minor">
-            <a:schemeClr val="lt1"/>
-          </a:fontRef>
-        </p:style>
-        <p:txBody>
-          <a:bodyPr rtlCol="0" anchor="ctr"/>
-          <a:lstStyle/>
-          <a:p>
-            <a:pPr algn="ctr"/>
-          </a:p>
-        </p:txBody>
-      </p:sp>
-      <p:sp>
-        <p:nvSpPr>
-          <p:cNvPr id="31" name="Rectangle 30"/>
-          <p:cNvSpPr/>
-          <p:nvPr/>
-        </p:nvSpPr>
-        <p:spPr>
-          <a:xfrm>
-            <a:off x="6537960" y="640080"/>
-            <a:ext cx="5486" cy="5349240"/>
-          </a:xfrm>
-          <a:prstGeom prst="rect">
-            <a:avLst/>
-          </a:prstGeom>
-          <a:solidFill>
-            <a:srgbClr val="082240"/>
-          </a:solidFill>
-          <a:ln>
-            <a:noFill/>
-          </a:ln>
-        </p:spPr>
-        <p:style>
-          <a:lnRef idx="1">
-            <a:schemeClr val="accent1"/>
-          </a:lnRef>
-          <a:fillRef idx="3">
-            <a:schemeClr val="accent1"/>
-          </a:fillRef>
-          <a:effectRef idx="2">
-            <a:schemeClr val="accent1"/>
-          </a:effectRef>
-          <a:fontRef idx="minor">
-            <a:schemeClr val="lt1"/>
-          </a:fontRef>
-        </p:style>
-        <p:txBody>
-          <a:bodyPr rtlCol="0" anchor="ctr"/>
-          <a:lstStyle/>
-          <a:p>
-            <a:pPr algn="ctr"/>
-          </a:p>
-        </p:txBody>
-      </p:sp>
-      <p:sp>
-        <p:nvSpPr>
-          <p:cNvPr id="32" name="Rectangle 31"/>
-          <p:cNvSpPr/>
-          <p:nvPr/>
-        </p:nvSpPr>
-        <p:spPr>
-          <a:xfrm>
-            <a:off x="7223760" y="640080"/>
-            <a:ext cx="5486" cy="5349240"/>
-          </a:xfrm>
-          <a:prstGeom prst="rect">
-            <a:avLst/>
-          </a:prstGeom>
-          <a:solidFill>
-            <a:srgbClr val="082240"/>
-          </a:solidFill>
-          <a:ln>
-            <a:noFill/>
-          </a:ln>
-        </p:spPr>
-        <p:style>
-          <a:lnRef idx="1">
-            <a:schemeClr val="accent1"/>
-          </a:lnRef>
-          <a:fillRef idx="3">
-            <a:schemeClr val="accent1"/>
-          </a:fillRef>
-          <a:effectRef idx="2">
-            <a:schemeClr val="accent1"/>
-          </a:effectRef>
-          <a:fontRef idx="minor">
-            <a:schemeClr val="lt1"/>
-          </a:fontRef>
-        </p:style>
-        <p:txBody>
-          <a:bodyPr rtlCol="0" anchor="ctr"/>
-          <a:lstStyle/>
-          <a:p>
-            <a:pPr algn="ctr"/>
-          </a:p>
-        </p:txBody>
-      </p:sp>
-      <p:sp>
-        <p:nvSpPr>
-          <p:cNvPr id="33" name="Rectangle 32"/>
-          <p:cNvSpPr/>
-          <p:nvPr/>
-        </p:nvSpPr>
-        <p:spPr>
-          <a:xfrm>
-            <a:off x="7909560" y="640080"/>
-            <a:ext cx="5486" cy="5349240"/>
-          </a:xfrm>
-          <a:prstGeom prst="rect">
-            <a:avLst/>
-          </a:prstGeom>
-          <a:solidFill>
-            <a:srgbClr val="082240"/>
-          </a:solidFill>
-          <a:ln>
-            <a:noFill/>
-          </a:ln>
-        </p:spPr>
-        <p:style>
-          <a:lnRef idx="1">
-            <a:schemeClr val="accent1"/>
-          </a:lnRef>
-          <a:fillRef idx="3">
-            <a:schemeClr val="accent1"/>
-          </a:fillRef>
-          <a:effectRef idx="2">
-            <a:schemeClr val="accent1"/>
-          </a:effectRef>
-          <a:fontRef idx="minor">
-            <a:schemeClr val="lt1"/>
-          </a:fontRef>
-        </p:style>
-        <p:txBody>
-          <a:bodyPr rtlCol="0" anchor="ctr"/>
-          <a:lstStyle/>
-          <a:p>
-            <a:pPr algn="ctr"/>
-          </a:p>
-        </p:txBody>
-      </p:sp>
-      <p:sp>
-        <p:nvSpPr>
-          <p:cNvPr id="34" name="Rectangle 33"/>
-          <p:cNvSpPr/>
-          <p:nvPr/>
-        </p:nvSpPr>
-        <p:spPr>
-          <a:xfrm>
-            <a:off x="8595360" y="640080"/>
-            <a:ext cx="5486" cy="5349240"/>
-          </a:xfrm>
-          <a:prstGeom prst="rect">
-            <a:avLst/>
-          </a:prstGeom>
-          <a:solidFill>
-            <a:srgbClr val="082240"/>
-          </a:solidFill>
-          <a:ln>
-            <a:noFill/>
-          </a:ln>
-        </p:spPr>
-        <p:style>
-          <a:lnRef idx="1">
-            <a:schemeClr val="accent1"/>
-          </a:lnRef>
-          <a:fillRef idx="3">
-            <a:schemeClr val="accent1"/>
-          </a:fillRef>
-          <a:effectRef idx="2">
-            <a:schemeClr val="accent1"/>
-          </a:effectRef>
-          <a:fontRef idx="minor">
-            <a:schemeClr val="lt1"/>
-          </a:fontRef>
-        </p:style>
-        <p:txBody>
-          <a:bodyPr rtlCol="0" anchor="ctr"/>
-          <a:lstStyle/>
-          <a:p>
-            <a:pPr algn="ctr"/>
-          </a:p>
-        </p:txBody>
-      </p:sp>
-      <p:sp>
-        <p:nvSpPr>
-          <p:cNvPr id="35" name="Rounded Rectangle 34"/>
-          <p:cNvSpPr/>
-          <p:nvPr/>
-        </p:nvSpPr>
-        <p:spPr>
-          <a:xfrm>
-            <a:off x="347472" y="438912"/>
-            <a:ext cx="2148840" cy="274320"/>
-          </a:xfrm>
-          <a:prstGeom prst="roundRect">
-            <a:avLst/>
-          </a:prstGeom>
-          <a:solidFill>
-            <a:srgbClr val="0072C6"/>
-          </a:solidFill>
-          <a:ln>
-            <a:noFill/>
-          </a:ln>
-        </p:spPr>
-        <p:style>
-          <a:lnRef idx="1">
-            <a:schemeClr val="accent1"/>
-          </a:lnRef>
-          <a:fillRef idx="3">
-            <a:schemeClr val="accent1"/>
-          </a:fillRef>
-          <a:effectRef idx="2">
-            <a:schemeClr val="accent1"/>
-          </a:effectRef>
-          <a:fontRef idx="minor">
-            <a:schemeClr val="lt1"/>
-          </a:fontRef>
-        </p:style>
-        <p:txBody>
-          <a:bodyPr rtlCol="0" anchor="ctr"/>
-          <a:lstStyle/>
-          <a:p>
-            <a:pPr algn="ctr"/>
-          </a:p>
-        </p:txBody>
-      </p:sp>
-      <p:sp>
-        <p:nvSpPr>
-          <p:cNvPr id="36" name="TextBox 35"/>
+          <p:cNvPr id="5" name="TextBox 4"/>
           <p:cNvSpPr txBox="1"/>
           <p:nvPr/>
         </p:nvSpPr>
         <p:spPr>
           <a:xfrm>
             <a:off x="347472" y="484632"/>
-            <a:ext cx="2148840" cy="109728"/>
+            <a:ext cx="2011680" cy="109728"/>
           </a:xfrm>
           <a:prstGeom prst="rect">
             <a:avLst/>
@@ -23314,21 +21981,21 @@
                 </a:solidFill>
                 <a:latin typeface="Segoe UI"/>
               </a:rPr>
-              <a:t>COMBINED FLOW</a:t>
+              <a:t>LIFECYCLE FLOW</a:t>
             </a:r>
           </a:p>
         </p:txBody>
       </p:sp>
       <p:sp>
         <p:nvSpPr>
-          <p:cNvPr id="37" name="TextBox 36"/>
+          <p:cNvPr id="6" name="TextBox 5"/>
           <p:cNvSpPr txBox="1"/>
           <p:nvPr/>
         </p:nvSpPr>
         <p:spPr>
           <a:xfrm>
-            <a:off x="347472" y="786384"/>
-            <a:ext cx="8229600" cy="438912"/>
+            <a:off x="347472" y="749808"/>
+            <a:ext cx="8229600" cy="530352"/>
           </a:xfrm>
           <a:prstGeom prst="rect">
             <a:avLst/>
@@ -23343,33 +22010,33 @@
           <a:p>
             <a:pPr algn="l"/>
             <a:r>
-              <a:rPr sz="2300" b="1" i="0">
+              <a:rPr sz="2800" b="1" i="0">
                 <a:solidFill>
                   <a:srgbClr val="FFFFFF"/>
                 </a:solidFill>
                 <a:latin typeface="Segoe UI"/>
               </a:rPr>
-              <a:t>One Slide Summary: Problem -&gt; Architecture -&gt; PRD -&gt; PG3 -&gt; QA Gate</a:t>
+              <a:t>Combined Lifecycle Summary</a:t>
             </a:r>
           </a:p>
         </p:txBody>
       </p:sp>
       <p:sp>
         <p:nvSpPr>
-          <p:cNvPr id="38" name="Rectangle 37"/>
-          <p:cNvSpPr/>
-          <p:nvPr/>
-        </p:nvSpPr>
-        <p:spPr>
-          <a:xfrm>
-            <a:off x="347472" y="1298448"/>
-            <a:ext cx="8412480" cy="16459"/>
+          <p:cNvPr id="7" name="Rectangle 6"/>
+          <p:cNvSpPr/>
+          <p:nvPr/>
+        </p:nvSpPr>
+        <p:spPr>
+          <a:xfrm>
+            <a:off x="347472" y="1325880"/>
+            <a:ext cx="8449056" cy="14630"/>
           </a:xfrm>
           <a:prstGeom prst="rect">
             <a:avLst/>
           </a:prstGeom>
           <a:solidFill>
-            <a:srgbClr val="00C8F0"/>
+            <a:srgbClr val="00A89A"/>
           </a:solidFill>
           <a:ln>
             <a:noFill/>
@@ -23399,14 +22066,14 @@
       </p:sp>
       <p:sp>
         <p:nvSpPr>
-          <p:cNvPr id="39" name="TextBox 38"/>
+          <p:cNvPr id="8" name="TextBox 7"/>
           <p:cNvSpPr txBox="1"/>
           <p:nvPr/>
         </p:nvSpPr>
         <p:spPr>
           <a:xfrm>
-            <a:off x="347472" y="1408176"/>
-            <a:ext cx="8458200" cy="329184"/>
+            <a:off x="347472" y="1417320"/>
+            <a:ext cx="8503920" cy="411480"/>
           </a:xfrm>
           <a:prstGeom prst="rect">
             <a:avLst/>
@@ -23421,27 +22088,70 @@
           <a:p>
             <a:pPr algn="l"/>
             <a:r>
-              <a:rPr sz="1050" b="0" i="1">
+              <a:rPr sz="1200" b="0" i="1">
                 <a:solidFill>
                   <a:srgbClr val="B8D0EC"/>
                 </a:solidFill>
                 <a:latin typeface="Segoe UI"/>
               </a:rPr>
-              <a:t>Combines original pages 2, 3, 4, 5 and 7 while preserving the requested V10 pages 1, 6, 8 and 9 unchanged.</a:t>
+              <a:t>Pages 2, 3, 4, 5 and 7 compressed into one V9-style flow: problem and architecture, PRD-to-work selection, PG3 generation and QA release gating.</a:t>
             </a:r>
           </a:p>
         </p:txBody>
       </p:sp>
       <p:sp>
         <p:nvSpPr>
-          <p:cNvPr id="40" name="Rounded Rectangle 39"/>
-          <p:cNvSpPr/>
-          <p:nvPr/>
-        </p:nvSpPr>
-        <p:spPr>
-          <a:xfrm>
-            <a:off x="384048" y="2057400"/>
-            <a:ext cx="1554480" cy="3063240"/>
+          <p:cNvPr id="9" name="Rectangle 8"/>
+          <p:cNvSpPr/>
+          <p:nvPr/>
+        </p:nvSpPr>
+        <p:spPr>
+          <a:xfrm>
+            <a:off x="347472" y="3296412"/>
+            <a:ext cx="8449056" cy="27432"/>
+          </a:xfrm>
+          <a:prstGeom prst="rect">
+            <a:avLst/>
+          </a:prstGeom>
+          <a:solidFill>
+            <a:srgbClr val="082848"/>
+          </a:solidFill>
+          <a:ln>
+            <a:noFill/>
+          </a:ln>
+        </p:spPr>
+        <p:style>
+          <a:lnRef idx="1">
+            <a:schemeClr val="accent1"/>
+          </a:lnRef>
+          <a:fillRef idx="3">
+            <a:schemeClr val="accent1"/>
+          </a:fillRef>
+          <a:effectRef idx="2">
+            <a:schemeClr val="accent1"/>
+          </a:effectRef>
+          <a:fontRef idx="minor">
+            <a:schemeClr val="lt1"/>
+          </a:fontRef>
+        </p:style>
+        <p:txBody>
+          <a:bodyPr rtlCol="0" anchor="ctr"/>
+          <a:lstStyle/>
+          <a:p>
+            <a:pPr algn="ctr"/>
+          </a:p>
+        </p:txBody>
+      </p:sp>
+      <p:sp>
+        <p:nvSpPr>
+          <p:cNvPr id="10" name="Rounded Rectangle 9"/>
+          <p:cNvSpPr/>
+          <p:nvPr/>
+        </p:nvSpPr>
+        <p:spPr>
+          <a:xfrm>
+            <a:off x="347472" y="2011680"/>
+            <a:ext cx="2633472" cy="4133087"/>
           </a:xfrm>
           <a:prstGeom prst="roundRect">
             <a:avLst/>
@@ -23477,20 +22187,20 @@
       </p:sp>
       <p:sp>
         <p:nvSpPr>
-          <p:cNvPr id="41" name="Rectangle 40"/>
-          <p:cNvSpPr/>
-          <p:nvPr/>
-        </p:nvSpPr>
-        <p:spPr>
-          <a:xfrm>
-            <a:off x="384048" y="2057400"/>
-            <a:ext cx="1554480" cy="50292"/>
+          <p:cNvPr id="11" name="Rectangle 10"/>
+          <p:cNvSpPr/>
+          <p:nvPr/>
+        </p:nvSpPr>
+        <p:spPr>
+          <a:xfrm>
+            <a:off x="347472" y="2011680"/>
+            <a:ext cx="2633472" cy="45720"/>
           </a:xfrm>
           <a:prstGeom prst="rect">
             <a:avLst/>
           </a:prstGeom>
           <a:solidFill>
-            <a:srgbClr val="FF8C00"/>
+            <a:srgbClr val="00A89A"/>
           </a:solidFill>
           <a:ln>
             <a:noFill/>
@@ -23520,20 +22230,20 @@
       </p:sp>
       <p:sp>
         <p:nvSpPr>
-          <p:cNvPr id="42" name="Oval 41"/>
-          <p:cNvSpPr/>
-          <p:nvPr/>
-        </p:nvSpPr>
-        <p:spPr>
-          <a:xfrm>
-            <a:off x="886968" y="2313432"/>
-            <a:ext cx="530352" cy="530352"/>
+          <p:cNvPr id="12" name="Oval 11"/>
+          <p:cNvSpPr/>
+          <p:nvPr/>
+        </p:nvSpPr>
+        <p:spPr>
+          <a:xfrm>
+            <a:off x="1280160" y="2926080"/>
+            <a:ext cx="768096" cy="768096"/>
           </a:xfrm>
           <a:prstGeom prst="ellipse">
             <a:avLst/>
           </a:prstGeom>
           <a:solidFill>
-            <a:srgbClr val="FF8C00"/>
+            <a:srgbClr val="00A89A"/>
           </a:solidFill>
           <a:ln>
             <a:noFill/>
@@ -23563,14 +22273,342 @@
       </p:sp>
       <p:sp>
         <p:nvSpPr>
-          <p:cNvPr id="43" name="TextBox 42"/>
+          <p:cNvPr id="13" name="TextBox 12"/>
           <p:cNvSpPr txBox="1"/>
           <p:nvPr/>
         </p:nvSpPr>
         <p:spPr>
           <a:xfrm>
-            <a:off x="886968" y="2441448"/>
-            <a:ext cx="530352" cy="109728"/>
+            <a:off x="1280160" y="3090672"/>
+            <a:ext cx="768096" cy="146304"/>
+          </a:xfrm>
+          <a:prstGeom prst="rect">
+            <a:avLst/>
+          </a:prstGeom>
+          <a:noFill/>
+        </p:spPr>
+        <p:txBody>
+          <a:bodyPr wrap="square" lIns="36576" rIns="36576" tIns="18288" bIns="18288">
+            <a:spAutoFit/>
+          </a:bodyPr>
+          <a:lstStyle/>
+          <a:p>
+            <a:pPr algn="ctr"/>
+            <a:r>
+              <a:rPr sz="1400" b="1" i="0">
+                <a:solidFill>
+                  <a:srgbClr val="FFFFFF"/>
+                </a:solidFill>
+                <a:latin typeface="Segoe UI"/>
+              </a:rPr>
+              <a:t>01</a:t>
+            </a:r>
+          </a:p>
+        </p:txBody>
+      </p:sp>
+      <p:sp>
+        <p:nvSpPr>
+          <p:cNvPr id="14" name="Rectangle 13"/>
+          <p:cNvSpPr/>
+          <p:nvPr/>
+        </p:nvSpPr>
+        <p:spPr>
+          <a:xfrm>
+            <a:off x="3017520" y="3295498"/>
+            <a:ext cx="18288" cy="29260"/>
+          </a:xfrm>
+          <a:prstGeom prst="rect">
+            <a:avLst/>
+          </a:prstGeom>
+          <a:solidFill>
+            <a:srgbClr val="00A89A"/>
+          </a:solidFill>
+          <a:ln>
+            <a:noFill/>
+          </a:ln>
+        </p:spPr>
+        <p:style>
+          <a:lnRef idx="1">
+            <a:schemeClr val="accent1"/>
+          </a:lnRef>
+          <a:fillRef idx="3">
+            <a:schemeClr val="accent1"/>
+          </a:fillRef>
+          <a:effectRef idx="2">
+            <a:schemeClr val="accent1"/>
+          </a:effectRef>
+          <a:fontRef idx="minor">
+            <a:schemeClr val="lt1"/>
+          </a:fontRef>
+        </p:style>
+        <p:txBody>
+          <a:bodyPr rtlCol="0" anchor="ctr"/>
+          <a:lstStyle/>
+          <a:p>
+            <a:pPr algn="ctr"/>
+          </a:p>
+        </p:txBody>
+      </p:sp>
+      <p:sp>
+        <p:nvSpPr>
+          <p:cNvPr id="15" name="Rectangle 14"/>
+          <p:cNvSpPr/>
+          <p:nvPr/>
+        </p:nvSpPr>
+        <p:spPr>
+          <a:xfrm>
+            <a:off x="3043123" y="3295498"/>
+            <a:ext cx="18288" cy="29260"/>
+          </a:xfrm>
+          <a:prstGeom prst="rect">
+            <a:avLst/>
+          </a:prstGeom>
+          <a:solidFill>
+            <a:srgbClr val="00A89A"/>
+          </a:solidFill>
+          <a:ln>
+            <a:noFill/>
+          </a:ln>
+        </p:spPr>
+        <p:style>
+          <a:lnRef idx="1">
+            <a:schemeClr val="accent1"/>
+          </a:lnRef>
+          <a:fillRef idx="3">
+            <a:schemeClr val="accent1"/>
+          </a:fillRef>
+          <a:effectRef idx="2">
+            <a:schemeClr val="accent1"/>
+          </a:effectRef>
+          <a:fontRef idx="minor">
+            <a:schemeClr val="lt1"/>
+          </a:fontRef>
+        </p:style>
+        <p:txBody>
+          <a:bodyPr rtlCol="0" anchor="ctr"/>
+          <a:lstStyle/>
+          <a:p>
+            <a:pPr algn="ctr"/>
+          </a:p>
+        </p:txBody>
+      </p:sp>
+      <p:sp>
+        <p:nvSpPr>
+          <p:cNvPr id="16" name="Rectangle 15"/>
+          <p:cNvSpPr/>
+          <p:nvPr/>
+        </p:nvSpPr>
+        <p:spPr>
+          <a:xfrm>
+            <a:off x="3068726" y="3295498"/>
+            <a:ext cx="18288" cy="29260"/>
+          </a:xfrm>
+          <a:prstGeom prst="rect">
+            <a:avLst/>
+          </a:prstGeom>
+          <a:solidFill>
+            <a:srgbClr val="00A89A"/>
+          </a:solidFill>
+          <a:ln>
+            <a:noFill/>
+          </a:ln>
+        </p:spPr>
+        <p:style>
+          <a:lnRef idx="1">
+            <a:schemeClr val="accent1"/>
+          </a:lnRef>
+          <a:fillRef idx="3">
+            <a:schemeClr val="accent1"/>
+          </a:fillRef>
+          <a:effectRef idx="2">
+            <a:schemeClr val="accent1"/>
+          </a:effectRef>
+          <a:fontRef idx="minor">
+            <a:schemeClr val="lt1"/>
+          </a:fontRef>
+        </p:style>
+        <p:txBody>
+          <a:bodyPr rtlCol="0" anchor="ctr"/>
+          <a:lstStyle/>
+          <a:p>
+            <a:pPr algn="ctr"/>
+          </a:p>
+        </p:txBody>
+      </p:sp>
+      <p:sp>
+        <p:nvSpPr>
+          <p:cNvPr id="17" name="Rectangle 16"/>
+          <p:cNvSpPr/>
+          <p:nvPr/>
+        </p:nvSpPr>
+        <p:spPr>
+          <a:xfrm>
+            <a:off x="3094329" y="3295498"/>
+            <a:ext cx="18288" cy="29260"/>
+          </a:xfrm>
+          <a:prstGeom prst="rect">
+            <a:avLst/>
+          </a:prstGeom>
+          <a:solidFill>
+            <a:srgbClr val="00A89A"/>
+          </a:solidFill>
+          <a:ln>
+            <a:noFill/>
+          </a:ln>
+        </p:spPr>
+        <p:style>
+          <a:lnRef idx="1">
+            <a:schemeClr val="accent1"/>
+          </a:lnRef>
+          <a:fillRef idx="3">
+            <a:schemeClr val="accent1"/>
+          </a:fillRef>
+          <a:effectRef idx="2">
+            <a:schemeClr val="accent1"/>
+          </a:effectRef>
+          <a:fontRef idx="minor">
+            <a:schemeClr val="lt1"/>
+          </a:fontRef>
+        </p:style>
+        <p:txBody>
+          <a:bodyPr rtlCol="0" anchor="ctr"/>
+          <a:lstStyle/>
+          <a:p>
+            <a:pPr algn="ctr"/>
+          </a:p>
+        </p:txBody>
+      </p:sp>
+      <p:sp>
+        <p:nvSpPr>
+          <p:cNvPr id="18" name="Rectangle 17"/>
+          <p:cNvSpPr/>
+          <p:nvPr/>
+        </p:nvSpPr>
+        <p:spPr>
+          <a:xfrm>
+            <a:off x="3119932" y="3295498"/>
+            <a:ext cx="18288" cy="29260"/>
+          </a:xfrm>
+          <a:prstGeom prst="rect">
+            <a:avLst/>
+          </a:prstGeom>
+          <a:solidFill>
+            <a:srgbClr val="00A89A"/>
+          </a:solidFill>
+          <a:ln>
+            <a:noFill/>
+          </a:ln>
+        </p:spPr>
+        <p:style>
+          <a:lnRef idx="1">
+            <a:schemeClr val="accent1"/>
+          </a:lnRef>
+          <a:fillRef idx="3">
+            <a:schemeClr val="accent1"/>
+          </a:fillRef>
+          <a:effectRef idx="2">
+            <a:schemeClr val="accent1"/>
+          </a:effectRef>
+          <a:fontRef idx="minor">
+            <a:schemeClr val="lt1"/>
+          </a:fontRef>
+        </p:style>
+        <p:txBody>
+          <a:bodyPr rtlCol="0" anchor="ctr"/>
+          <a:lstStyle/>
+          <a:p>
+            <a:pPr algn="ctr"/>
+          </a:p>
+        </p:txBody>
+      </p:sp>
+      <p:sp>
+        <p:nvSpPr>
+          <p:cNvPr id="19" name="Rectangle 18"/>
+          <p:cNvSpPr/>
+          <p:nvPr/>
+        </p:nvSpPr>
+        <p:spPr>
+          <a:xfrm>
+            <a:off x="3145535" y="3295498"/>
+            <a:ext cx="18288" cy="29260"/>
+          </a:xfrm>
+          <a:prstGeom prst="rect">
+            <a:avLst/>
+          </a:prstGeom>
+          <a:solidFill>
+            <a:srgbClr val="00A89A"/>
+          </a:solidFill>
+          <a:ln>
+            <a:noFill/>
+          </a:ln>
+        </p:spPr>
+        <p:style>
+          <a:lnRef idx="1">
+            <a:schemeClr val="accent1"/>
+          </a:lnRef>
+          <a:fillRef idx="3">
+            <a:schemeClr val="accent1"/>
+          </a:fillRef>
+          <a:effectRef idx="2">
+            <a:schemeClr val="accent1"/>
+          </a:effectRef>
+          <a:fontRef idx="minor">
+            <a:schemeClr val="lt1"/>
+          </a:fontRef>
+        </p:style>
+        <p:txBody>
+          <a:bodyPr rtlCol="0" anchor="ctr"/>
+          <a:lstStyle/>
+          <a:p>
+            <a:pPr algn="ctr"/>
+          </a:p>
+        </p:txBody>
+      </p:sp>
+      <p:sp>
+        <p:nvSpPr>
+          <p:cNvPr id="20" name="TextBox 19"/>
+          <p:cNvSpPr txBox="1"/>
+          <p:nvPr/>
+        </p:nvSpPr>
+        <p:spPr>
+          <a:xfrm>
+            <a:off x="347472" y="2148840"/>
+            <a:ext cx="2633472" cy="411480"/>
+          </a:xfrm>
+          <a:prstGeom prst="rect">
+            <a:avLst/>
+          </a:prstGeom>
+          <a:noFill/>
+        </p:spPr>
+        <p:txBody>
+          <a:bodyPr wrap="square" lIns="36576" rIns="36576" tIns="18288" bIns="18288">
+            <a:spAutoFit/>
+          </a:bodyPr>
+          <a:lstStyle/>
+          <a:p>
+            <a:pPr algn="ctr"/>
+            <a:r>
+              <a:rPr sz="2000" b="1" i="0">
+                <a:solidFill>
+                  <a:srgbClr val="00A89A"/>
+                </a:solidFill>
+                <a:latin typeface="Segoe UI"/>
+              </a:rPr>
+              <a:t>UNIFY</a:t>
+            </a:r>
+          </a:p>
+        </p:txBody>
+      </p:sp>
+      <p:sp>
+        <p:nvSpPr>
+          <p:cNvPr id="21" name="TextBox 20"/>
+          <p:cNvSpPr txBox="1"/>
+          <p:nvPr/>
+        </p:nvSpPr>
+        <p:spPr>
+          <a:xfrm>
+            <a:off x="347472" y="2578608"/>
+            <a:ext cx="2633472" cy="365760"/>
           </a:xfrm>
           <a:prstGeom prst="rect">
             <a:avLst/>
@@ -23591,21 +22629,64 @@
                 </a:solidFill>
                 <a:latin typeface="Segoe UI"/>
               </a:rPr>
-              <a:t>1</a:t>
+              <a:t>Problem + Architecture</a:t>
             </a:r>
           </a:p>
         </p:txBody>
       </p:sp>
       <p:sp>
         <p:nvSpPr>
-          <p:cNvPr id="44" name="TextBox 43"/>
+          <p:cNvPr id="22" name="Rectangle 21"/>
+          <p:cNvSpPr/>
+          <p:nvPr/>
+        </p:nvSpPr>
+        <p:spPr>
+          <a:xfrm>
+            <a:off x="512064" y="2999232"/>
+            <a:ext cx="2304288" cy="14630"/>
+          </a:xfrm>
+          <a:prstGeom prst="rect">
+            <a:avLst/>
+          </a:prstGeom>
+          <a:solidFill>
+            <a:srgbClr val="00A89A"/>
+          </a:solidFill>
+          <a:ln>
+            <a:noFill/>
+          </a:ln>
+        </p:spPr>
+        <p:style>
+          <a:lnRef idx="1">
+            <a:schemeClr val="accent1"/>
+          </a:lnRef>
+          <a:fillRef idx="3">
+            <a:schemeClr val="accent1"/>
+          </a:fillRef>
+          <a:effectRef idx="2">
+            <a:schemeClr val="accent1"/>
+          </a:effectRef>
+          <a:fontRef idx="minor">
+            <a:schemeClr val="lt1"/>
+          </a:fontRef>
+        </p:style>
+        <p:txBody>
+          <a:bodyPr rtlCol="0" anchor="ctr"/>
+          <a:lstStyle/>
+          <a:p>
+            <a:pPr algn="ctr"/>
+          </a:p>
+        </p:txBody>
+      </p:sp>
+      <p:sp>
+        <p:nvSpPr>
+          <p:cNvPr id="23" name="TextBox 22"/>
           <p:cNvSpPr txBox="1"/>
           <p:nvPr/>
         </p:nvSpPr>
         <p:spPr>
           <a:xfrm>
-            <a:off x="493776" y="3008376"/>
-            <a:ext cx="1335024" cy="320040"/>
+            <a:off x="512064" y="3127248"/>
+            <a:ext cx="2304288" cy="2834640"/>
           </a:xfrm>
           <a:prstGeom prst="rect">
             <a:avLst/>
@@ -23618,70 +22699,78 @@
           </a:bodyPr>
           <a:lstStyle/>
           <a:p>
-            <a:pPr algn="ctr"/>
+            <a:pPr algn="l"/>
             <a:r>
-              <a:rPr sz="1060" b="1" i="0">
-                <a:solidFill>
-                  <a:srgbClr val="FF8C00"/>
-                </a:solidFill>
-                <a:latin typeface="Segoe UI"/>
-              </a:rPr>
-              <a:t>Problem</a:t>
-            </a:r>
-          </a:p>
-        </p:txBody>
-      </p:sp>
-      <p:sp>
-        <p:nvSpPr>
-          <p:cNvPr id="45" name="TextBox 44"/>
-          <p:cNvSpPr txBox="1"/>
-          <p:nvPr/>
-        </p:nvSpPr>
-        <p:spPr>
-          <a:xfrm>
-            <a:off x="512064" y="3474720"/>
-            <a:ext cx="1298448" cy="1143000"/>
-          </a:xfrm>
-          <a:prstGeom prst="rect">
-            <a:avLst/>
-          </a:prstGeom>
-          <a:noFill/>
-        </p:spPr>
-        <p:txBody>
-          <a:bodyPr wrap="square" lIns="36576" rIns="36576" tIns="18288" bIns="18288">
-            <a:spAutoFit/>
-          </a:bodyPr>
-          <a:lstStyle/>
-          <a:p>
-            <a:pPr algn="ctr"/>
-            <a:r>
-              <a:rPr sz="840" b="0" i="0">
+              <a:rPr sz="1120" b="0" i="0">
                 <a:solidFill>
                   <a:srgbClr val="B8D0EC"/>
                 </a:solidFill>
                 <a:latin typeface="Segoe UI"/>
               </a:rPr>
-              <a:t>Fragmented PRD, Jira, Confluence, GitHub, QA and hardware evidence slow PG1-to-PG5 decisions.</a:t>
+              <a:t>Fragmented PRD, Jira, Confluence, GitHub, QA and hardware evidence are connected into AEPLO's knowledge graph and orchestration core.</a:t>
             </a:r>
           </a:p>
         </p:txBody>
       </p:sp>
       <p:sp>
         <p:nvSpPr>
-          <p:cNvPr id="46" name="Rectangle 45"/>
-          <p:cNvSpPr/>
-          <p:nvPr/>
-        </p:nvSpPr>
-        <p:spPr>
-          <a:xfrm>
-            <a:off x="1956816" y="3575304"/>
-            <a:ext cx="128016" cy="36576"/>
+          <p:cNvPr id="24" name="Rounded Rectangle 23"/>
+          <p:cNvSpPr/>
+          <p:nvPr/>
+        </p:nvSpPr>
+        <p:spPr>
+          <a:xfrm>
+            <a:off x="3200400" y="2011680"/>
+            <a:ext cx="2633472" cy="4133087"/>
+          </a:xfrm>
+          <a:prstGeom prst="roundRect">
+            <a:avLst/>
+          </a:prstGeom>
+          <a:solidFill>
+            <a:srgbClr val="0F2845"/>
+          </a:solidFill>
+          <a:ln>
+            <a:noFill/>
+          </a:ln>
+        </p:spPr>
+        <p:style>
+          <a:lnRef idx="1">
+            <a:schemeClr val="accent1"/>
+          </a:lnRef>
+          <a:fillRef idx="3">
+            <a:schemeClr val="accent1"/>
+          </a:fillRef>
+          <a:effectRef idx="2">
+            <a:schemeClr val="accent1"/>
+          </a:effectRef>
+          <a:fontRef idx="minor">
+            <a:schemeClr val="lt1"/>
+          </a:fontRef>
+        </p:style>
+        <p:txBody>
+          <a:bodyPr rtlCol="0" anchor="ctr"/>
+          <a:lstStyle/>
+          <a:p>
+            <a:pPr algn="ctr"/>
+          </a:p>
+        </p:txBody>
+      </p:sp>
+      <p:sp>
+        <p:nvSpPr>
+          <p:cNvPr id="25" name="Rectangle 24"/>
+          <p:cNvSpPr/>
+          <p:nvPr/>
+        </p:nvSpPr>
+        <p:spPr>
+          <a:xfrm>
+            <a:off x="3200400" y="2011680"/>
+            <a:ext cx="2633472" cy="45720"/>
           </a:xfrm>
           <a:prstGeom prst="rect">
             <a:avLst/>
           </a:prstGeom>
           <a:solidFill>
-            <a:srgbClr val="00C8F0"/>
+            <a:srgbClr val="0072C6"/>
           </a:solidFill>
           <a:ln>
             <a:noFill/>
@@ -23711,20 +22800,20 @@
       </p:sp>
       <p:sp>
         <p:nvSpPr>
-          <p:cNvPr id="47" name="Rounded Rectangle 46"/>
-          <p:cNvSpPr/>
-          <p:nvPr/>
-        </p:nvSpPr>
-        <p:spPr>
-          <a:xfrm>
-            <a:off x="2103120" y="2057400"/>
-            <a:ext cx="1554480" cy="3063240"/>
-          </a:xfrm>
-          <a:prstGeom prst="roundRect">
-            <a:avLst/>
-          </a:prstGeom>
-          <a:solidFill>
-            <a:srgbClr val="0F2845"/>
+          <p:cNvPr id="26" name="Oval 25"/>
+          <p:cNvSpPr/>
+          <p:nvPr/>
+        </p:nvSpPr>
+        <p:spPr>
+          <a:xfrm>
+            <a:off x="4133088" y="2926080"/>
+            <a:ext cx="768096" cy="768096"/>
+          </a:xfrm>
+          <a:prstGeom prst="ellipse">
+            <a:avLst/>
+          </a:prstGeom>
+          <a:solidFill>
+            <a:srgbClr val="0072C6"/>
           </a:solidFill>
           <a:ln>
             <a:noFill/>
@@ -23754,63 +22843,55 @@
       </p:sp>
       <p:sp>
         <p:nvSpPr>
-          <p:cNvPr id="48" name="Rectangle 47"/>
-          <p:cNvSpPr/>
-          <p:nvPr/>
-        </p:nvSpPr>
-        <p:spPr>
-          <a:xfrm>
-            <a:off x="2103120" y="2057400"/>
-            <a:ext cx="1554480" cy="50292"/>
+          <p:cNvPr id="27" name="TextBox 26"/>
+          <p:cNvSpPr txBox="1"/>
+          <p:nvPr/>
+        </p:nvSpPr>
+        <p:spPr>
+          <a:xfrm>
+            <a:off x="4133088" y="3090672"/>
+            <a:ext cx="768096" cy="146304"/>
           </a:xfrm>
           <a:prstGeom prst="rect">
             <a:avLst/>
           </a:prstGeom>
-          <a:solidFill>
-            <a:srgbClr val="0072C6"/>
-          </a:solidFill>
-          <a:ln>
-            <a:noFill/>
-          </a:ln>
-        </p:spPr>
-        <p:style>
-          <a:lnRef idx="1">
-            <a:schemeClr val="accent1"/>
-          </a:lnRef>
-          <a:fillRef idx="3">
-            <a:schemeClr val="accent1"/>
-          </a:fillRef>
-          <a:effectRef idx="2">
-            <a:schemeClr val="accent1"/>
-          </a:effectRef>
-          <a:fontRef idx="minor">
-            <a:schemeClr val="lt1"/>
-          </a:fontRef>
-        </p:style>
-        <p:txBody>
-          <a:bodyPr rtlCol="0" anchor="ctr"/>
+          <a:noFill/>
+        </p:spPr>
+        <p:txBody>
+          <a:bodyPr wrap="square" lIns="36576" rIns="36576" tIns="18288" bIns="18288">
+            <a:spAutoFit/>
+          </a:bodyPr>
           <a:lstStyle/>
           <a:p>
             <a:pPr algn="ctr"/>
-          </a:p>
-        </p:txBody>
-      </p:sp>
-      <p:sp>
-        <p:nvSpPr>
-          <p:cNvPr id="49" name="Oval 48"/>
-          <p:cNvSpPr/>
-          <p:nvPr/>
-        </p:nvSpPr>
-        <p:spPr>
-          <a:xfrm>
-            <a:off x="2606040" y="2313432"/>
-            <a:ext cx="530352" cy="530352"/>
-          </a:xfrm>
-          <a:prstGeom prst="ellipse">
-            <a:avLst/>
-          </a:prstGeom>
-          <a:solidFill>
-            <a:srgbClr val="0072C6"/>
+            <a:r>
+              <a:rPr sz="1400" b="1" i="0">
+                <a:solidFill>
+                  <a:srgbClr val="FFFFFF"/>
+                </a:solidFill>
+                <a:latin typeface="Segoe UI"/>
+              </a:rPr>
+              <a:t>02</a:t>
+            </a:r>
+          </a:p>
+        </p:txBody>
+      </p:sp>
+      <p:sp>
+        <p:nvSpPr>
+          <p:cNvPr id="28" name="Rectangle 27"/>
+          <p:cNvSpPr/>
+          <p:nvPr/>
+        </p:nvSpPr>
+        <p:spPr>
+          <a:xfrm>
+            <a:off x="5870448" y="3295498"/>
+            <a:ext cx="18288" cy="29260"/>
+          </a:xfrm>
+          <a:prstGeom prst="rect">
+            <a:avLst/>
+          </a:prstGeom>
+          <a:solidFill>
+            <a:srgbClr val="00A89A"/>
           </a:solidFill>
           <a:ln>
             <a:noFill/>
@@ -23840,14 +22921,264 @@
       </p:sp>
       <p:sp>
         <p:nvSpPr>
-          <p:cNvPr id="50" name="TextBox 49"/>
+          <p:cNvPr id="29" name="Rectangle 28"/>
+          <p:cNvSpPr/>
+          <p:nvPr/>
+        </p:nvSpPr>
+        <p:spPr>
+          <a:xfrm>
+            <a:off x="5896051" y="3295498"/>
+            <a:ext cx="18288" cy="29260"/>
+          </a:xfrm>
+          <a:prstGeom prst="rect">
+            <a:avLst/>
+          </a:prstGeom>
+          <a:solidFill>
+            <a:srgbClr val="00A89A"/>
+          </a:solidFill>
+          <a:ln>
+            <a:noFill/>
+          </a:ln>
+        </p:spPr>
+        <p:style>
+          <a:lnRef idx="1">
+            <a:schemeClr val="accent1"/>
+          </a:lnRef>
+          <a:fillRef idx="3">
+            <a:schemeClr val="accent1"/>
+          </a:fillRef>
+          <a:effectRef idx="2">
+            <a:schemeClr val="accent1"/>
+          </a:effectRef>
+          <a:fontRef idx="minor">
+            <a:schemeClr val="lt1"/>
+          </a:fontRef>
+        </p:style>
+        <p:txBody>
+          <a:bodyPr rtlCol="0" anchor="ctr"/>
+          <a:lstStyle/>
+          <a:p>
+            <a:pPr algn="ctr"/>
+          </a:p>
+        </p:txBody>
+      </p:sp>
+      <p:sp>
+        <p:nvSpPr>
+          <p:cNvPr id="30" name="Rectangle 29"/>
+          <p:cNvSpPr/>
+          <p:nvPr/>
+        </p:nvSpPr>
+        <p:spPr>
+          <a:xfrm>
+            <a:off x="5921654" y="3295498"/>
+            <a:ext cx="18288" cy="29260"/>
+          </a:xfrm>
+          <a:prstGeom prst="rect">
+            <a:avLst/>
+          </a:prstGeom>
+          <a:solidFill>
+            <a:srgbClr val="00A89A"/>
+          </a:solidFill>
+          <a:ln>
+            <a:noFill/>
+          </a:ln>
+        </p:spPr>
+        <p:style>
+          <a:lnRef idx="1">
+            <a:schemeClr val="accent1"/>
+          </a:lnRef>
+          <a:fillRef idx="3">
+            <a:schemeClr val="accent1"/>
+          </a:fillRef>
+          <a:effectRef idx="2">
+            <a:schemeClr val="accent1"/>
+          </a:effectRef>
+          <a:fontRef idx="minor">
+            <a:schemeClr val="lt1"/>
+          </a:fontRef>
+        </p:style>
+        <p:txBody>
+          <a:bodyPr rtlCol="0" anchor="ctr"/>
+          <a:lstStyle/>
+          <a:p>
+            <a:pPr algn="ctr"/>
+          </a:p>
+        </p:txBody>
+      </p:sp>
+      <p:sp>
+        <p:nvSpPr>
+          <p:cNvPr id="31" name="Rectangle 30"/>
+          <p:cNvSpPr/>
+          <p:nvPr/>
+        </p:nvSpPr>
+        <p:spPr>
+          <a:xfrm>
+            <a:off x="5947257" y="3295498"/>
+            <a:ext cx="18288" cy="29260"/>
+          </a:xfrm>
+          <a:prstGeom prst="rect">
+            <a:avLst/>
+          </a:prstGeom>
+          <a:solidFill>
+            <a:srgbClr val="00A89A"/>
+          </a:solidFill>
+          <a:ln>
+            <a:noFill/>
+          </a:ln>
+        </p:spPr>
+        <p:style>
+          <a:lnRef idx="1">
+            <a:schemeClr val="accent1"/>
+          </a:lnRef>
+          <a:fillRef idx="3">
+            <a:schemeClr val="accent1"/>
+          </a:fillRef>
+          <a:effectRef idx="2">
+            <a:schemeClr val="accent1"/>
+          </a:effectRef>
+          <a:fontRef idx="minor">
+            <a:schemeClr val="lt1"/>
+          </a:fontRef>
+        </p:style>
+        <p:txBody>
+          <a:bodyPr rtlCol="0" anchor="ctr"/>
+          <a:lstStyle/>
+          <a:p>
+            <a:pPr algn="ctr"/>
+          </a:p>
+        </p:txBody>
+      </p:sp>
+      <p:sp>
+        <p:nvSpPr>
+          <p:cNvPr id="32" name="Rectangle 31"/>
+          <p:cNvSpPr/>
+          <p:nvPr/>
+        </p:nvSpPr>
+        <p:spPr>
+          <a:xfrm>
+            <a:off x="5972860" y="3295498"/>
+            <a:ext cx="18288" cy="29260"/>
+          </a:xfrm>
+          <a:prstGeom prst="rect">
+            <a:avLst/>
+          </a:prstGeom>
+          <a:solidFill>
+            <a:srgbClr val="00A89A"/>
+          </a:solidFill>
+          <a:ln>
+            <a:noFill/>
+          </a:ln>
+        </p:spPr>
+        <p:style>
+          <a:lnRef idx="1">
+            <a:schemeClr val="accent1"/>
+          </a:lnRef>
+          <a:fillRef idx="3">
+            <a:schemeClr val="accent1"/>
+          </a:fillRef>
+          <a:effectRef idx="2">
+            <a:schemeClr val="accent1"/>
+          </a:effectRef>
+          <a:fontRef idx="minor">
+            <a:schemeClr val="lt1"/>
+          </a:fontRef>
+        </p:style>
+        <p:txBody>
+          <a:bodyPr rtlCol="0" anchor="ctr"/>
+          <a:lstStyle/>
+          <a:p>
+            <a:pPr algn="ctr"/>
+          </a:p>
+        </p:txBody>
+      </p:sp>
+      <p:sp>
+        <p:nvSpPr>
+          <p:cNvPr id="33" name="Rectangle 32"/>
+          <p:cNvSpPr/>
+          <p:nvPr/>
+        </p:nvSpPr>
+        <p:spPr>
+          <a:xfrm>
+            <a:off x="5998463" y="3295498"/>
+            <a:ext cx="18288" cy="29260"/>
+          </a:xfrm>
+          <a:prstGeom prst="rect">
+            <a:avLst/>
+          </a:prstGeom>
+          <a:solidFill>
+            <a:srgbClr val="00A89A"/>
+          </a:solidFill>
+          <a:ln>
+            <a:noFill/>
+          </a:ln>
+        </p:spPr>
+        <p:style>
+          <a:lnRef idx="1">
+            <a:schemeClr val="accent1"/>
+          </a:lnRef>
+          <a:fillRef idx="3">
+            <a:schemeClr val="accent1"/>
+          </a:fillRef>
+          <a:effectRef idx="2">
+            <a:schemeClr val="accent1"/>
+          </a:effectRef>
+          <a:fontRef idx="minor">
+            <a:schemeClr val="lt1"/>
+          </a:fontRef>
+        </p:style>
+        <p:txBody>
+          <a:bodyPr rtlCol="0" anchor="ctr"/>
+          <a:lstStyle/>
+          <a:p>
+            <a:pPr algn="ctr"/>
+          </a:p>
+        </p:txBody>
+      </p:sp>
+      <p:sp>
+        <p:nvSpPr>
+          <p:cNvPr id="34" name="TextBox 33"/>
           <p:cNvSpPr txBox="1"/>
           <p:nvPr/>
         </p:nvSpPr>
         <p:spPr>
           <a:xfrm>
-            <a:off x="2606040" y="2441448"/>
-            <a:ext cx="530352" cy="109728"/>
+            <a:off x="3200400" y="2148840"/>
+            <a:ext cx="2633472" cy="411480"/>
+          </a:xfrm>
+          <a:prstGeom prst="rect">
+            <a:avLst/>
+          </a:prstGeom>
+          <a:noFill/>
+        </p:spPr>
+        <p:txBody>
+          <a:bodyPr wrap="square" lIns="36576" rIns="36576" tIns="18288" bIns="18288">
+            <a:spAutoFit/>
+          </a:bodyPr>
+          <a:lstStyle/>
+          <a:p>
+            <a:pPr algn="ctr"/>
+            <a:r>
+              <a:rPr sz="2000" b="1" i="0">
+                <a:solidFill>
+                  <a:srgbClr val="0072C6"/>
+                </a:solidFill>
+                <a:latin typeface="Segoe UI"/>
+              </a:rPr>
+              <a:t>PICK</a:t>
+            </a:r>
+          </a:p>
+        </p:txBody>
+      </p:sp>
+      <p:sp>
+        <p:nvSpPr>
+          <p:cNvPr id="35" name="TextBox 34"/>
+          <p:cNvSpPr txBox="1"/>
+          <p:nvPr/>
+        </p:nvSpPr>
+        <p:spPr>
+          <a:xfrm>
+            <a:off x="3200400" y="2578608"/>
+            <a:ext cx="2633472" cy="365760"/>
           </a:xfrm>
           <a:prstGeom prst="rect">
             <a:avLst/>
@@ -23868,21 +23199,64 @@
                 </a:solidFill>
                 <a:latin typeface="Segoe UI"/>
               </a:rPr>
-              <a:t>2</a:t>
+              <a:t>PRD -&gt; Epics -&gt; Branch</a:t>
             </a:r>
           </a:p>
         </p:txBody>
       </p:sp>
       <p:sp>
         <p:nvSpPr>
-          <p:cNvPr id="51" name="TextBox 50"/>
+          <p:cNvPr id="36" name="Rectangle 35"/>
+          <p:cNvSpPr/>
+          <p:nvPr/>
+        </p:nvSpPr>
+        <p:spPr>
+          <a:xfrm>
+            <a:off x="3364992" y="2999232"/>
+            <a:ext cx="2304288" cy="14630"/>
+          </a:xfrm>
+          <a:prstGeom prst="rect">
+            <a:avLst/>
+          </a:prstGeom>
+          <a:solidFill>
+            <a:srgbClr val="0072C6"/>
+          </a:solidFill>
+          <a:ln>
+            <a:noFill/>
+          </a:ln>
+        </p:spPr>
+        <p:style>
+          <a:lnRef idx="1">
+            <a:schemeClr val="accent1"/>
+          </a:lnRef>
+          <a:fillRef idx="3">
+            <a:schemeClr val="accent1"/>
+          </a:fillRef>
+          <a:effectRef idx="2">
+            <a:schemeClr val="accent1"/>
+          </a:effectRef>
+          <a:fontRef idx="minor">
+            <a:schemeClr val="lt1"/>
+          </a:fontRef>
+        </p:style>
+        <p:txBody>
+          <a:bodyPr rtlCol="0" anchor="ctr"/>
+          <a:lstStyle/>
+          <a:p>
+            <a:pPr algn="ctr"/>
+          </a:p>
+        </p:txBody>
+      </p:sp>
+      <p:sp>
+        <p:nvSpPr>
+          <p:cNvPr id="37" name="TextBox 36"/>
           <p:cNvSpPr txBox="1"/>
           <p:nvPr/>
         </p:nvSpPr>
         <p:spPr>
           <a:xfrm>
-            <a:off x="2212848" y="3008376"/>
-            <a:ext cx="1335024" cy="320040"/>
+            <a:off x="3364992" y="3127248"/>
+            <a:ext cx="2304288" cy="2834640"/>
           </a:xfrm>
           <a:prstGeom prst="rect">
             <a:avLst/>
@@ -23895,70 +23269,78 @@
           </a:bodyPr>
           <a:lstStyle/>
           <a:p>
-            <a:pPr algn="ctr"/>
+            <a:pPr algn="l"/>
             <a:r>
-              <a:rPr sz="1060" b="1" i="0">
-                <a:solidFill>
-                  <a:srgbClr val="0072C6"/>
-                </a:solidFill>
-                <a:latin typeface="Segoe UI"/>
-              </a:rPr>
-              <a:t>Architecture</a:t>
-            </a:r>
-          </a:p>
-        </p:txBody>
-      </p:sp>
-      <p:sp>
-        <p:nvSpPr>
-          <p:cNvPr id="52" name="TextBox 51"/>
-          <p:cNvSpPr txBox="1"/>
-          <p:nvPr/>
-        </p:nvSpPr>
-        <p:spPr>
-          <a:xfrm>
-            <a:off x="2231136" y="3474720"/>
-            <a:ext cx="1298448" cy="1143000"/>
-          </a:xfrm>
-          <a:prstGeom prst="rect">
-            <a:avLst/>
-          </a:prstGeom>
-          <a:noFill/>
-        </p:spPr>
-        <p:txBody>
-          <a:bodyPr wrap="square" lIns="36576" rIns="36576" tIns="18288" bIns="18288">
-            <a:spAutoFit/>
-          </a:bodyPr>
-          <a:lstStyle/>
-          <a:p>
-            <a:pPr algn="ctr"/>
-            <a:r>
-              <a:rPr sz="840" b="0" i="0">
+              <a:rPr sz="1120" b="0" i="0">
                 <a:solidFill>
                   <a:srgbClr val="B8D0EC"/>
                 </a:solidFill>
                 <a:latin typeface="Segoe UI"/>
               </a:rPr>
-              <a:t>AEPLO connects inputs into a knowledge graph, orchestration core, automation and release-gate outcomes.</a:t>
+              <a:t>Confluence PRD guided by SDE Elements and PSJIRA creates epics/stories for users to pick; selected work creates a feature branch.</a:t>
             </a:r>
           </a:p>
         </p:txBody>
       </p:sp>
       <p:sp>
         <p:nvSpPr>
-          <p:cNvPr id="53" name="Rectangle 52"/>
-          <p:cNvSpPr/>
-          <p:nvPr/>
-        </p:nvSpPr>
-        <p:spPr>
-          <a:xfrm>
-            <a:off x="3675888" y="3575304"/>
-            <a:ext cx="128016" cy="36576"/>
+          <p:cNvPr id="38" name="Rounded Rectangle 37"/>
+          <p:cNvSpPr/>
+          <p:nvPr/>
+        </p:nvSpPr>
+        <p:spPr>
+          <a:xfrm>
+            <a:off x="6053328" y="2011680"/>
+            <a:ext cx="2633472" cy="4133087"/>
+          </a:xfrm>
+          <a:prstGeom prst="roundRect">
+            <a:avLst/>
+          </a:prstGeom>
+          <a:solidFill>
+            <a:srgbClr val="0F2845"/>
+          </a:solidFill>
+          <a:ln>
+            <a:noFill/>
+          </a:ln>
+        </p:spPr>
+        <p:style>
+          <a:lnRef idx="1">
+            <a:schemeClr val="accent1"/>
+          </a:lnRef>
+          <a:fillRef idx="3">
+            <a:schemeClr val="accent1"/>
+          </a:fillRef>
+          <a:effectRef idx="2">
+            <a:schemeClr val="accent1"/>
+          </a:effectRef>
+          <a:fontRef idx="minor">
+            <a:schemeClr val="lt1"/>
+          </a:fontRef>
+        </p:style>
+        <p:txBody>
+          <a:bodyPr rtlCol="0" anchor="ctr"/>
+          <a:lstStyle/>
+          <a:p>
+            <a:pPr algn="ctr"/>
+          </a:p>
+        </p:txBody>
+      </p:sp>
+      <p:sp>
+        <p:nvSpPr>
+          <p:cNvPr id="39" name="Rectangle 38"/>
+          <p:cNvSpPr/>
+          <p:nvPr/>
+        </p:nvSpPr>
+        <p:spPr>
+          <a:xfrm>
+            <a:off x="6053328" y="2011680"/>
+            <a:ext cx="2633472" cy="45720"/>
           </a:xfrm>
           <a:prstGeom prst="rect">
             <a:avLst/>
           </a:prstGeom>
           <a:solidFill>
-            <a:srgbClr val="00C8F0"/>
+            <a:srgbClr val="00D48A"/>
           </a:solidFill>
           <a:ln>
             <a:noFill/>
@@ -23988,20 +23370,20 @@
       </p:sp>
       <p:sp>
         <p:nvSpPr>
-          <p:cNvPr id="54" name="Rounded Rectangle 53"/>
-          <p:cNvSpPr/>
-          <p:nvPr/>
-        </p:nvSpPr>
-        <p:spPr>
-          <a:xfrm>
-            <a:off x="3822191" y="2057400"/>
-            <a:ext cx="1554480" cy="3063240"/>
-          </a:xfrm>
-          <a:prstGeom prst="roundRect">
-            <a:avLst/>
-          </a:prstGeom>
-          <a:solidFill>
-            <a:srgbClr val="0F2845"/>
+          <p:cNvPr id="40" name="Oval 39"/>
+          <p:cNvSpPr/>
+          <p:nvPr/>
+        </p:nvSpPr>
+        <p:spPr>
+          <a:xfrm>
+            <a:off x="6986016" y="2926080"/>
+            <a:ext cx="768096" cy="768096"/>
+          </a:xfrm>
+          <a:prstGeom prst="ellipse">
+            <a:avLst/>
+          </a:prstGeom>
+          <a:solidFill>
+            <a:srgbClr val="00D48A"/>
           </a:solidFill>
           <a:ln>
             <a:noFill/>
@@ -24031,100 +23413,84 @@
       </p:sp>
       <p:sp>
         <p:nvSpPr>
-          <p:cNvPr id="55" name="Rectangle 54"/>
-          <p:cNvSpPr/>
-          <p:nvPr/>
-        </p:nvSpPr>
-        <p:spPr>
-          <a:xfrm>
-            <a:off x="3822191" y="2057400"/>
-            <a:ext cx="1554480" cy="50292"/>
+          <p:cNvPr id="41" name="TextBox 40"/>
+          <p:cNvSpPr txBox="1"/>
+          <p:nvPr/>
+        </p:nvSpPr>
+        <p:spPr>
+          <a:xfrm>
+            <a:off x="6986016" y="3090672"/>
+            <a:ext cx="768096" cy="146304"/>
           </a:xfrm>
           <a:prstGeom prst="rect">
             <a:avLst/>
           </a:prstGeom>
-          <a:solidFill>
-            <a:srgbClr val="00A89A"/>
-          </a:solidFill>
-          <a:ln>
-            <a:noFill/>
-          </a:ln>
-        </p:spPr>
-        <p:style>
-          <a:lnRef idx="1">
-            <a:schemeClr val="accent1"/>
-          </a:lnRef>
-          <a:fillRef idx="3">
-            <a:schemeClr val="accent1"/>
-          </a:fillRef>
-          <a:effectRef idx="2">
-            <a:schemeClr val="accent1"/>
-          </a:effectRef>
-          <a:fontRef idx="minor">
-            <a:schemeClr val="lt1"/>
-          </a:fontRef>
-        </p:style>
-        <p:txBody>
-          <a:bodyPr rtlCol="0" anchor="ctr"/>
+          <a:noFill/>
+        </p:spPr>
+        <p:txBody>
+          <a:bodyPr wrap="square" lIns="36576" rIns="36576" tIns="18288" bIns="18288">
+            <a:spAutoFit/>
+          </a:bodyPr>
           <a:lstStyle/>
           <a:p>
             <a:pPr algn="ctr"/>
-          </a:p>
-        </p:txBody>
-      </p:sp>
-      <p:sp>
-        <p:nvSpPr>
-          <p:cNvPr id="56" name="Oval 55"/>
-          <p:cNvSpPr/>
-          <p:nvPr/>
-        </p:nvSpPr>
-        <p:spPr>
-          <a:xfrm>
-            <a:off x="4325111" y="2313432"/>
-            <a:ext cx="530352" cy="530352"/>
-          </a:xfrm>
-          <a:prstGeom prst="ellipse">
-            <a:avLst/>
-          </a:prstGeom>
-          <a:solidFill>
-            <a:srgbClr val="00A89A"/>
-          </a:solidFill>
-          <a:ln>
-            <a:noFill/>
-          </a:ln>
-        </p:spPr>
-        <p:style>
-          <a:lnRef idx="1">
-            <a:schemeClr val="accent1"/>
-          </a:lnRef>
-          <a:fillRef idx="3">
-            <a:schemeClr val="accent1"/>
-          </a:fillRef>
-          <a:effectRef idx="2">
-            <a:schemeClr val="accent1"/>
-          </a:effectRef>
-          <a:fontRef idx="minor">
-            <a:schemeClr val="lt1"/>
-          </a:fontRef>
-        </p:style>
-        <p:txBody>
-          <a:bodyPr rtlCol="0" anchor="ctr"/>
+            <a:r>
+              <a:rPr sz="1400" b="1" i="0">
+                <a:solidFill>
+                  <a:srgbClr val="FFFFFF"/>
+                </a:solidFill>
+                <a:latin typeface="Segoe UI"/>
+              </a:rPr>
+              <a:t>03</a:t>
+            </a:r>
+          </a:p>
+        </p:txBody>
+      </p:sp>
+      <p:sp>
+        <p:nvSpPr>
+          <p:cNvPr id="42" name="TextBox 41"/>
+          <p:cNvSpPr txBox="1"/>
+          <p:nvPr/>
+        </p:nvSpPr>
+        <p:spPr>
+          <a:xfrm>
+            <a:off x="6053328" y="2148840"/>
+            <a:ext cx="2633472" cy="411480"/>
+          </a:xfrm>
+          <a:prstGeom prst="rect">
+            <a:avLst/>
+          </a:prstGeom>
+          <a:noFill/>
+        </p:spPr>
+        <p:txBody>
+          <a:bodyPr wrap="square" lIns="36576" rIns="36576" tIns="18288" bIns="18288">
+            <a:spAutoFit/>
+          </a:bodyPr>
           <a:lstStyle/>
           <a:p>
             <a:pPr algn="ctr"/>
-          </a:p>
-        </p:txBody>
-      </p:sp>
-      <p:sp>
-        <p:nvSpPr>
-          <p:cNvPr id="57" name="TextBox 56"/>
+            <a:r>
+              <a:rPr sz="2000" b="1" i="0">
+                <a:solidFill>
+                  <a:srgbClr val="00D48A"/>
+                </a:solidFill>
+                <a:latin typeface="Segoe UI"/>
+              </a:rPr>
+              <a:t>VALIDATE</a:t>
+            </a:r>
+          </a:p>
+        </p:txBody>
+      </p:sp>
+      <p:sp>
+        <p:nvSpPr>
+          <p:cNvPr id="43" name="TextBox 42"/>
           <p:cNvSpPr txBox="1"/>
           <p:nvPr/>
         </p:nvSpPr>
         <p:spPr>
           <a:xfrm>
-            <a:off x="4325111" y="2441448"/>
-            <a:ext cx="530352" cy="109728"/>
+            <a:off x="6053328" y="2578608"/>
+            <a:ext cx="2633472" cy="365760"/>
           </a:xfrm>
           <a:prstGeom prst="rect">
             <a:avLst/>
@@ -24145,21 +23511,64 @@
                 </a:solidFill>
                 <a:latin typeface="Segoe UI"/>
               </a:rPr>
-              <a:t>3</a:t>
+              <a:t>PG3 Firmware -&gt; QA Gate</a:t>
             </a:r>
           </a:p>
         </p:txBody>
       </p:sp>
       <p:sp>
         <p:nvSpPr>
-          <p:cNvPr id="58" name="TextBox 57"/>
+          <p:cNvPr id="44" name="Rectangle 43"/>
+          <p:cNvSpPr/>
+          <p:nvPr/>
+        </p:nvSpPr>
+        <p:spPr>
+          <a:xfrm>
+            <a:off x="6217920" y="2999232"/>
+            <a:ext cx="2304288" cy="14630"/>
+          </a:xfrm>
+          <a:prstGeom prst="rect">
+            <a:avLst/>
+          </a:prstGeom>
+          <a:solidFill>
+            <a:srgbClr val="00D48A"/>
+          </a:solidFill>
+          <a:ln>
+            <a:noFill/>
+          </a:ln>
+        </p:spPr>
+        <p:style>
+          <a:lnRef idx="1">
+            <a:schemeClr val="accent1"/>
+          </a:lnRef>
+          <a:fillRef idx="3">
+            <a:schemeClr val="accent1"/>
+          </a:fillRef>
+          <a:effectRef idx="2">
+            <a:schemeClr val="accent1"/>
+          </a:effectRef>
+          <a:fontRef idx="minor">
+            <a:schemeClr val="lt1"/>
+          </a:fontRef>
+        </p:style>
+        <p:txBody>
+          <a:bodyPr rtlCol="0" anchor="ctr"/>
+          <a:lstStyle/>
+          <a:p>
+            <a:pPr algn="ctr"/>
+          </a:p>
+        </p:txBody>
+      </p:sp>
+      <p:sp>
+        <p:nvSpPr>
+          <p:cNvPr id="45" name="TextBox 44"/>
           <p:cNvSpPr txBox="1"/>
           <p:nvPr/>
         </p:nvSpPr>
         <p:spPr>
           <a:xfrm>
-            <a:off x="3931919" y="3008376"/>
-            <a:ext cx="1335024" cy="320040"/>
+            <a:off x="6217920" y="3127248"/>
+            <a:ext cx="2304288" cy="2834640"/>
           </a:xfrm>
           <a:prstGeom prst="rect">
             <a:avLst/>
@@ -24172,681 +23581,135 @@
           </a:bodyPr>
           <a:lstStyle/>
           <a:p>
+            <a:pPr algn="l"/>
+            <a:r>
+              <a:rPr sz="1120" b="0" i="0">
+                <a:solidFill>
+                  <a:srgbClr val="B8D0EC"/>
+                </a:solidFill>
+                <a:latin typeface="Segoe UI"/>
+              </a:rPr>
+              <a:t>Datasheet + PRD + SDK/BSP + OS/RTOS generate firmware; QA inputs, PRD and JTAG evidence produce READY / NOT_READY.</a:t>
+            </a:r>
+          </a:p>
+        </p:txBody>
+      </p:sp>
+      <p:sp>
+        <p:nvSpPr>
+          <p:cNvPr id="46" name="Rounded Rectangle 45"/>
+          <p:cNvSpPr/>
+          <p:nvPr/>
+        </p:nvSpPr>
+        <p:spPr>
+          <a:xfrm>
+            <a:off x="320040" y="6400800"/>
+            <a:ext cx="8503920" cy="310896"/>
+          </a:xfrm>
+          <a:prstGeom prst="roundRect">
+            <a:avLst/>
+          </a:prstGeom>
+          <a:solidFill>
+            <a:srgbClr val="0E2A4A"/>
+          </a:solidFill>
+          <a:ln>
+            <a:noFill/>
+          </a:ln>
+        </p:spPr>
+        <p:style>
+          <a:lnRef idx="1">
+            <a:schemeClr val="accent1"/>
+          </a:lnRef>
+          <a:fillRef idx="3">
+            <a:schemeClr val="accent1"/>
+          </a:fillRef>
+          <a:effectRef idx="2">
+            <a:schemeClr val="accent1"/>
+          </a:effectRef>
+          <a:fontRef idx="minor">
+            <a:schemeClr val="lt1"/>
+          </a:fontRef>
+        </p:style>
+        <p:txBody>
+          <a:bodyPr rtlCol="0" anchor="ctr"/>
+          <a:lstStyle/>
+          <a:p>
+            <a:pPr algn="ctr"/>
+          </a:p>
+        </p:txBody>
+      </p:sp>
+      <p:sp>
+        <p:nvSpPr>
+          <p:cNvPr id="47" name="Rectangle 46"/>
+          <p:cNvSpPr/>
+          <p:nvPr/>
+        </p:nvSpPr>
+        <p:spPr>
+          <a:xfrm>
+            <a:off x="320040" y="6400800"/>
+            <a:ext cx="45720" cy="310896"/>
+          </a:xfrm>
+          <a:prstGeom prst="rect">
+            <a:avLst/>
+          </a:prstGeom>
+          <a:solidFill>
+            <a:srgbClr val="00A89A"/>
+          </a:solidFill>
+          <a:ln>
+            <a:noFill/>
+          </a:ln>
+        </p:spPr>
+        <p:style>
+          <a:lnRef idx="1">
+            <a:schemeClr val="accent1"/>
+          </a:lnRef>
+          <a:fillRef idx="3">
+            <a:schemeClr val="accent1"/>
+          </a:fillRef>
+          <a:effectRef idx="2">
+            <a:schemeClr val="accent1"/>
+          </a:effectRef>
+          <a:fontRef idx="minor">
+            <a:schemeClr val="lt1"/>
+          </a:fontRef>
+        </p:style>
+        <p:txBody>
+          <a:bodyPr rtlCol="0" anchor="ctr"/>
+          <a:lstStyle/>
+          <a:p>
+            <a:pPr algn="ctr"/>
+          </a:p>
+        </p:txBody>
+      </p:sp>
+      <p:sp>
+        <p:nvSpPr>
+          <p:cNvPr id="48" name="TextBox 47"/>
+          <p:cNvSpPr txBox="1"/>
+          <p:nvPr/>
+        </p:nvSpPr>
+        <p:spPr>
+          <a:xfrm>
+            <a:off x="502920" y="6400800"/>
+            <a:ext cx="8229600" cy="310896"/>
+          </a:xfrm>
+          <a:prstGeom prst="rect">
+            <a:avLst/>
+          </a:prstGeom>
+          <a:noFill/>
+        </p:spPr>
+        <p:txBody>
+          <a:bodyPr wrap="square" lIns="36576" rIns="36576" tIns="18288" bIns="18288">
+            <a:spAutoFit/>
+          </a:bodyPr>
+          <a:lstStyle/>
+          <a:p>
             <a:pPr algn="ctr"/>
             <a:r>
-              <a:rPr sz="1060" b="1" i="0">
+              <a:rPr sz="1000" b="1" i="0">
                 <a:solidFill>
                   <a:srgbClr val="00A89A"/>
                 </a:solidFill>
                 <a:latin typeface="Segoe UI"/>
               </a:rPr>
-              <a:t>PRD -&gt; Stories</a:t>
-            </a:r>
-          </a:p>
-        </p:txBody>
-      </p:sp>
-      <p:sp>
-        <p:nvSpPr>
-          <p:cNvPr id="59" name="TextBox 58"/>
-          <p:cNvSpPr txBox="1"/>
-          <p:nvPr/>
-        </p:nvSpPr>
-        <p:spPr>
-          <a:xfrm>
-            <a:off x="3950207" y="3474720"/>
-            <a:ext cx="1298448" cy="1143000"/>
-          </a:xfrm>
-          <a:prstGeom prst="rect">
-            <a:avLst/>
-          </a:prstGeom>
-          <a:noFill/>
-        </p:spPr>
-        <p:txBody>
-          <a:bodyPr wrap="square" lIns="36576" rIns="36576" tIns="18288" bIns="18288">
-            <a:spAutoFit/>
-          </a:bodyPr>
-          <a:lstStyle/>
-          <a:p>
-            <a:pPr algn="ctr"/>
-            <a:r>
-              <a:rPr sz="840" b="0" i="0">
-                <a:solidFill>
-                  <a:srgbClr val="B8D0EC"/>
-                </a:solidFill>
-                <a:latin typeface="Segoe UI"/>
-              </a:rPr>
-              <a:t>Confluence PRD guided by SDE Elements and PSJIRA creates epics/stories for users to pick and branch.</a:t>
-            </a:r>
-          </a:p>
-        </p:txBody>
-      </p:sp>
-      <p:sp>
-        <p:nvSpPr>
-          <p:cNvPr id="60" name="Rectangle 59"/>
-          <p:cNvSpPr/>
-          <p:nvPr/>
-        </p:nvSpPr>
-        <p:spPr>
-          <a:xfrm>
-            <a:off x="5394959" y="3575304"/>
-            <a:ext cx="128016" cy="36576"/>
-          </a:xfrm>
-          <a:prstGeom prst="rect">
-            <a:avLst/>
-          </a:prstGeom>
-          <a:solidFill>
-            <a:srgbClr val="00C8F0"/>
-          </a:solidFill>
-          <a:ln>
-            <a:noFill/>
-          </a:ln>
-        </p:spPr>
-        <p:style>
-          <a:lnRef idx="1">
-            <a:schemeClr val="accent1"/>
-          </a:lnRef>
-          <a:fillRef idx="3">
-            <a:schemeClr val="accent1"/>
-          </a:fillRef>
-          <a:effectRef idx="2">
-            <a:schemeClr val="accent1"/>
-          </a:effectRef>
-          <a:fontRef idx="minor">
-            <a:schemeClr val="lt1"/>
-          </a:fontRef>
-        </p:style>
-        <p:txBody>
-          <a:bodyPr rtlCol="0" anchor="ctr"/>
-          <a:lstStyle/>
-          <a:p>
-            <a:pPr algn="ctr"/>
-          </a:p>
-        </p:txBody>
-      </p:sp>
-      <p:sp>
-        <p:nvSpPr>
-          <p:cNvPr id="61" name="Rounded Rectangle 60"/>
-          <p:cNvSpPr/>
-          <p:nvPr/>
-        </p:nvSpPr>
-        <p:spPr>
-          <a:xfrm>
-            <a:off x="5541264" y="2057400"/>
-            <a:ext cx="1554480" cy="3063240"/>
-          </a:xfrm>
-          <a:prstGeom prst="roundRect">
-            <a:avLst/>
-          </a:prstGeom>
-          <a:solidFill>
-            <a:srgbClr val="0F2845"/>
-          </a:solidFill>
-          <a:ln>
-            <a:noFill/>
-          </a:ln>
-        </p:spPr>
-        <p:style>
-          <a:lnRef idx="1">
-            <a:schemeClr val="accent1"/>
-          </a:lnRef>
-          <a:fillRef idx="3">
-            <a:schemeClr val="accent1"/>
-          </a:fillRef>
-          <a:effectRef idx="2">
-            <a:schemeClr val="accent1"/>
-          </a:effectRef>
-          <a:fontRef idx="minor">
-            <a:schemeClr val="lt1"/>
-          </a:fontRef>
-        </p:style>
-        <p:txBody>
-          <a:bodyPr rtlCol="0" anchor="ctr"/>
-          <a:lstStyle/>
-          <a:p>
-            <a:pPr algn="ctr"/>
-          </a:p>
-        </p:txBody>
-      </p:sp>
-      <p:sp>
-        <p:nvSpPr>
-          <p:cNvPr id="62" name="Rectangle 61"/>
-          <p:cNvSpPr/>
-          <p:nvPr/>
-        </p:nvSpPr>
-        <p:spPr>
-          <a:xfrm>
-            <a:off x="5541264" y="2057400"/>
-            <a:ext cx="1554480" cy="50292"/>
-          </a:xfrm>
-          <a:prstGeom prst="rect">
-            <a:avLst/>
-          </a:prstGeom>
-          <a:solidFill>
-            <a:srgbClr val="8B5CF6"/>
-          </a:solidFill>
-          <a:ln>
-            <a:noFill/>
-          </a:ln>
-        </p:spPr>
-        <p:style>
-          <a:lnRef idx="1">
-            <a:schemeClr val="accent1"/>
-          </a:lnRef>
-          <a:fillRef idx="3">
-            <a:schemeClr val="accent1"/>
-          </a:fillRef>
-          <a:effectRef idx="2">
-            <a:schemeClr val="accent1"/>
-          </a:effectRef>
-          <a:fontRef idx="minor">
-            <a:schemeClr val="lt1"/>
-          </a:fontRef>
-        </p:style>
-        <p:txBody>
-          <a:bodyPr rtlCol="0" anchor="ctr"/>
-          <a:lstStyle/>
-          <a:p>
-            <a:pPr algn="ctr"/>
-          </a:p>
-        </p:txBody>
-      </p:sp>
-      <p:sp>
-        <p:nvSpPr>
-          <p:cNvPr id="63" name="Oval 62"/>
-          <p:cNvSpPr/>
-          <p:nvPr/>
-        </p:nvSpPr>
-        <p:spPr>
-          <a:xfrm>
-            <a:off x="6044184" y="2313432"/>
-            <a:ext cx="530352" cy="530352"/>
-          </a:xfrm>
-          <a:prstGeom prst="ellipse">
-            <a:avLst/>
-          </a:prstGeom>
-          <a:solidFill>
-            <a:srgbClr val="8B5CF6"/>
-          </a:solidFill>
-          <a:ln>
-            <a:noFill/>
-          </a:ln>
-        </p:spPr>
-        <p:style>
-          <a:lnRef idx="1">
-            <a:schemeClr val="accent1"/>
-          </a:lnRef>
-          <a:fillRef idx="3">
-            <a:schemeClr val="accent1"/>
-          </a:fillRef>
-          <a:effectRef idx="2">
-            <a:schemeClr val="accent1"/>
-          </a:effectRef>
-          <a:fontRef idx="minor">
-            <a:schemeClr val="lt1"/>
-          </a:fontRef>
-        </p:style>
-        <p:txBody>
-          <a:bodyPr rtlCol="0" anchor="ctr"/>
-          <a:lstStyle/>
-          <a:p>
-            <a:pPr algn="ctr"/>
-          </a:p>
-        </p:txBody>
-      </p:sp>
-      <p:sp>
-        <p:nvSpPr>
-          <p:cNvPr id="64" name="TextBox 63"/>
-          <p:cNvSpPr txBox="1"/>
-          <p:nvPr/>
-        </p:nvSpPr>
-        <p:spPr>
-          <a:xfrm>
-            <a:off x="6044184" y="2441448"/>
-            <a:ext cx="530352" cy="109728"/>
-          </a:xfrm>
-          <a:prstGeom prst="rect">
-            <a:avLst/>
-          </a:prstGeom>
-          <a:noFill/>
-        </p:spPr>
-        <p:txBody>
-          <a:bodyPr wrap="square" lIns="36576" rIns="36576" tIns="18288" bIns="18288">
-            <a:spAutoFit/>
-          </a:bodyPr>
-          <a:lstStyle/>
-          <a:p>
-            <a:pPr algn="ctr"/>
-            <a:r>
-              <a:rPr sz="1200" b="1" i="0">
-                <a:solidFill>
-                  <a:srgbClr val="FFFFFF"/>
-                </a:solidFill>
-                <a:latin typeface="Segoe UI"/>
-              </a:rPr>
-              <a:t>4</a:t>
-            </a:r>
-          </a:p>
-        </p:txBody>
-      </p:sp>
-      <p:sp>
-        <p:nvSpPr>
-          <p:cNvPr id="65" name="TextBox 64"/>
-          <p:cNvSpPr txBox="1"/>
-          <p:nvPr/>
-        </p:nvSpPr>
-        <p:spPr>
-          <a:xfrm>
-            <a:off x="5650992" y="3008376"/>
-            <a:ext cx="1335024" cy="320040"/>
-          </a:xfrm>
-          <a:prstGeom prst="rect">
-            <a:avLst/>
-          </a:prstGeom>
-          <a:noFill/>
-        </p:spPr>
-        <p:txBody>
-          <a:bodyPr wrap="square" lIns="36576" rIns="36576" tIns="18288" bIns="18288">
-            <a:spAutoFit/>
-          </a:bodyPr>
-          <a:lstStyle/>
-          <a:p>
-            <a:pPr algn="ctr"/>
-            <a:r>
-              <a:rPr sz="1060" b="1" i="0">
-                <a:solidFill>
-                  <a:srgbClr val="8B5CF6"/>
-                </a:solidFill>
-                <a:latin typeface="Segoe UI"/>
-              </a:rPr>
-              <a:t>PG3 Firmware</a:t>
-            </a:r>
-          </a:p>
-        </p:txBody>
-      </p:sp>
-      <p:sp>
-        <p:nvSpPr>
-          <p:cNvPr id="66" name="TextBox 65"/>
-          <p:cNvSpPr txBox="1"/>
-          <p:nvPr/>
-        </p:nvSpPr>
-        <p:spPr>
-          <a:xfrm>
-            <a:off x="5669280" y="3474720"/>
-            <a:ext cx="1298448" cy="1143000"/>
-          </a:xfrm>
-          <a:prstGeom prst="rect">
-            <a:avLst/>
-          </a:prstGeom>
-          <a:noFill/>
-        </p:spPr>
-        <p:txBody>
-          <a:bodyPr wrap="square" lIns="36576" rIns="36576" tIns="18288" bIns="18288">
-            <a:spAutoFit/>
-          </a:bodyPr>
-          <a:lstStyle/>
-          <a:p>
-            <a:pPr algn="ctr"/>
-            <a:r>
-              <a:rPr sz="840" b="0" i="0">
-                <a:solidFill>
-                  <a:srgbClr val="B8D0EC"/>
-                </a:solidFill>
-                <a:latin typeface="Segoe UI"/>
-              </a:rPr>
-              <a:t>Datasheet + PRD + SDK/BSP + OS/RTOS context generate and validate firmware/code.</a:t>
-            </a:r>
-          </a:p>
-        </p:txBody>
-      </p:sp>
-      <p:sp>
-        <p:nvSpPr>
-          <p:cNvPr id="67" name="Rectangle 66"/>
-          <p:cNvSpPr/>
-          <p:nvPr/>
-        </p:nvSpPr>
-        <p:spPr>
-          <a:xfrm>
-            <a:off x="7114032" y="3575304"/>
-            <a:ext cx="128016" cy="36576"/>
-          </a:xfrm>
-          <a:prstGeom prst="rect">
-            <a:avLst/>
-          </a:prstGeom>
-          <a:solidFill>
-            <a:srgbClr val="00C8F0"/>
-          </a:solidFill>
-          <a:ln>
-            <a:noFill/>
-          </a:ln>
-        </p:spPr>
-        <p:style>
-          <a:lnRef idx="1">
-            <a:schemeClr val="accent1"/>
-          </a:lnRef>
-          <a:fillRef idx="3">
-            <a:schemeClr val="accent1"/>
-          </a:fillRef>
-          <a:effectRef idx="2">
-            <a:schemeClr val="accent1"/>
-          </a:effectRef>
-          <a:fontRef idx="minor">
-            <a:schemeClr val="lt1"/>
-          </a:fontRef>
-        </p:style>
-        <p:txBody>
-          <a:bodyPr rtlCol="0" anchor="ctr"/>
-          <a:lstStyle/>
-          <a:p>
-            <a:pPr algn="ctr"/>
-          </a:p>
-        </p:txBody>
-      </p:sp>
-      <p:sp>
-        <p:nvSpPr>
-          <p:cNvPr id="68" name="Rounded Rectangle 67"/>
-          <p:cNvSpPr/>
-          <p:nvPr/>
-        </p:nvSpPr>
-        <p:spPr>
-          <a:xfrm>
-            <a:off x="7260336" y="2057400"/>
-            <a:ext cx="1554480" cy="3063240"/>
-          </a:xfrm>
-          <a:prstGeom prst="roundRect">
-            <a:avLst/>
-          </a:prstGeom>
-          <a:solidFill>
-            <a:srgbClr val="0F2845"/>
-          </a:solidFill>
-          <a:ln>
-            <a:noFill/>
-          </a:ln>
-        </p:spPr>
-        <p:style>
-          <a:lnRef idx="1">
-            <a:schemeClr val="accent1"/>
-          </a:lnRef>
-          <a:fillRef idx="3">
-            <a:schemeClr val="accent1"/>
-          </a:fillRef>
-          <a:effectRef idx="2">
-            <a:schemeClr val="accent1"/>
-          </a:effectRef>
-          <a:fontRef idx="minor">
-            <a:schemeClr val="lt1"/>
-          </a:fontRef>
-        </p:style>
-        <p:txBody>
-          <a:bodyPr rtlCol="0" anchor="ctr"/>
-          <a:lstStyle/>
-          <a:p>
-            <a:pPr algn="ctr"/>
-          </a:p>
-        </p:txBody>
-      </p:sp>
-      <p:sp>
-        <p:nvSpPr>
-          <p:cNvPr id="69" name="Rectangle 68"/>
-          <p:cNvSpPr/>
-          <p:nvPr/>
-        </p:nvSpPr>
-        <p:spPr>
-          <a:xfrm>
-            <a:off x="7260336" y="2057400"/>
-            <a:ext cx="1554480" cy="50292"/>
-          </a:xfrm>
-          <a:prstGeom prst="rect">
-            <a:avLst/>
-          </a:prstGeom>
-          <a:solidFill>
-            <a:srgbClr val="00D48A"/>
-          </a:solidFill>
-          <a:ln>
-            <a:noFill/>
-          </a:ln>
-        </p:spPr>
-        <p:style>
-          <a:lnRef idx="1">
-            <a:schemeClr val="accent1"/>
-          </a:lnRef>
-          <a:fillRef idx="3">
-            <a:schemeClr val="accent1"/>
-          </a:fillRef>
-          <a:effectRef idx="2">
-            <a:schemeClr val="accent1"/>
-          </a:effectRef>
-          <a:fontRef idx="minor">
-            <a:schemeClr val="lt1"/>
-          </a:fontRef>
-        </p:style>
-        <p:txBody>
-          <a:bodyPr rtlCol="0" anchor="ctr"/>
-          <a:lstStyle/>
-          <a:p>
-            <a:pPr algn="ctr"/>
-          </a:p>
-        </p:txBody>
-      </p:sp>
-      <p:sp>
-        <p:nvSpPr>
-          <p:cNvPr id="70" name="Oval 69"/>
-          <p:cNvSpPr/>
-          <p:nvPr/>
-        </p:nvSpPr>
-        <p:spPr>
-          <a:xfrm>
-            <a:off x="7763256" y="2313432"/>
-            <a:ext cx="530352" cy="530352"/>
-          </a:xfrm>
-          <a:prstGeom prst="ellipse">
-            <a:avLst/>
-          </a:prstGeom>
-          <a:solidFill>
-            <a:srgbClr val="00D48A"/>
-          </a:solidFill>
-          <a:ln>
-            <a:noFill/>
-          </a:ln>
-        </p:spPr>
-        <p:style>
-          <a:lnRef idx="1">
-            <a:schemeClr val="accent1"/>
-          </a:lnRef>
-          <a:fillRef idx="3">
-            <a:schemeClr val="accent1"/>
-          </a:fillRef>
-          <a:effectRef idx="2">
-            <a:schemeClr val="accent1"/>
-          </a:effectRef>
-          <a:fontRef idx="minor">
-            <a:schemeClr val="lt1"/>
-          </a:fontRef>
-        </p:style>
-        <p:txBody>
-          <a:bodyPr rtlCol="0" anchor="ctr"/>
-          <a:lstStyle/>
-          <a:p>
-            <a:pPr algn="ctr"/>
-          </a:p>
-        </p:txBody>
-      </p:sp>
-      <p:sp>
-        <p:nvSpPr>
-          <p:cNvPr id="71" name="TextBox 70"/>
-          <p:cNvSpPr txBox="1"/>
-          <p:nvPr/>
-        </p:nvSpPr>
-        <p:spPr>
-          <a:xfrm>
-            <a:off x="7763256" y="2441448"/>
-            <a:ext cx="530352" cy="109728"/>
-          </a:xfrm>
-          <a:prstGeom prst="rect">
-            <a:avLst/>
-          </a:prstGeom>
-          <a:noFill/>
-        </p:spPr>
-        <p:txBody>
-          <a:bodyPr wrap="square" lIns="36576" rIns="36576" tIns="18288" bIns="18288">
-            <a:spAutoFit/>
-          </a:bodyPr>
-          <a:lstStyle/>
-          <a:p>
-            <a:pPr algn="ctr"/>
-            <a:r>
-              <a:rPr sz="1200" b="1" i="0">
-                <a:solidFill>
-                  <a:srgbClr val="FFFFFF"/>
-                </a:solidFill>
-                <a:latin typeface="Segoe UI"/>
-              </a:rPr>
-              <a:t>5</a:t>
-            </a:r>
-          </a:p>
-        </p:txBody>
-      </p:sp>
-      <p:sp>
-        <p:nvSpPr>
-          <p:cNvPr id="72" name="TextBox 71"/>
-          <p:cNvSpPr txBox="1"/>
-          <p:nvPr/>
-        </p:nvSpPr>
-        <p:spPr>
-          <a:xfrm>
-            <a:off x="7370064" y="3008376"/>
-            <a:ext cx="1335024" cy="320040"/>
-          </a:xfrm>
-          <a:prstGeom prst="rect">
-            <a:avLst/>
-          </a:prstGeom>
-          <a:noFill/>
-        </p:spPr>
-        <p:txBody>
-          <a:bodyPr wrap="square" lIns="36576" rIns="36576" tIns="18288" bIns="18288">
-            <a:spAutoFit/>
-          </a:bodyPr>
-          <a:lstStyle/>
-          <a:p>
-            <a:pPr algn="ctr"/>
-            <a:r>
-              <a:rPr sz="1060" b="1" i="0">
-                <a:solidFill>
-                  <a:srgbClr val="00D48A"/>
-                </a:solidFill>
-                <a:latin typeface="Segoe UI"/>
-              </a:rPr>
-              <a:t>QA Closed Loop</a:t>
-            </a:r>
-          </a:p>
-        </p:txBody>
-      </p:sp>
-      <p:sp>
-        <p:nvSpPr>
-          <p:cNvPr id="73" name="TextBox 72"/>
-          <p:cNvSpPr txBox="1"/>
-          <p:nvPr/>
-        </p:nvSpPr>
-        <p:spPr>
-          <a:xfrm>
-            <a:off x="7388352" y="3474720"/>
-            <a:ext cx="1298448" cy="1143000"/>
-          </a:xfrm>
-          <a:prstGeom prst="rect">
-            <a:avLst/>
-          </a:prstGeom>
-          <a:noFill/>
-        </p:spPr>
-        <p:txBody>
-          <a:bodyPr wrap="square" lIns="36576" rIns="36576" tIns="18288" bIns="18288">
-            <a:spAutoFit/>
-          </a:bodyPr>
-          <a:lstStyle/>
-          <a:p>
-            <a:pPr algn="ctr"/>
-            <a:r>
-              <a:rPr sz="840" b="0" i="0">
-                <a:solidFill>
-                  <a:srgbClr val="B8D0EC"/>
-                </a:solidFill>
-                <a:latin typeface="Segoe UI"/>
-              </a:rPr>
-              <a:t>QA inputs, PRD and JTAG evidence produce READY / NOT_READY; gaps become next-release priorities.</a:t>
-            </a:r>
-          </a:p>
-        </p:txBody>
-      </p:sp>
-      <p:sp>
-        <p:nvSpPr>
-          <p:cNvPr id="74" name="Rounded Rectangle 73"/>
-          <p:cNvSpPr/>
-          <p:nvPr/>
-        </p:nvSpPr>
-        <p:spPr>
-          <a:xfrm>
-            <a:off x="658368" y="5559552"/>
-            <a:ext cx="7818120" cy="457200"/>
-          </a:xfrm>
-          <a:prstGeom prst="roundRect">
-            <a:avLst/>
-          </a:prstGeom>
-          <a:solidFill>
-            <a:srgbClr val="0B1F3A"/>
-          </a:solidFill>
-          <a:ln>
-            <a:noFill/>
-          </a:ln>
-        </p:spPr>
-        <p:style>
-          <a:lnRef idx="1">
-            <a:schemeClr val="accent1"/>
-          </a:lnRef>
-          <a:fillRef idx="3">
-            <a:schemeClr val="accent1"/>
-          </a:fillRef>
-          <a:effectRef idx="2">
-            <a:schemeClr val="accent1"/>
-          </a:effectRef>
-          <a:fontRef idx="minor">
-            <a:schemeClr val="lt1"/>
-          </a:fontRef>
-        </p:style>
-        <p:txBody>
-          <a:bodyPr rtlCol="0" anchor="ctr"/>
-          <a:lstStyle/>
-          <a:p>
-            <a:pPr algn="ctr"/>
-          </a:p>
-        </p:txBody>
-      </p:sp>
-      <p:sp>
-        <p:nvSpPr>
-          <p:cNvPr id="75" name="TextBox 74"/>
-          <p:cNvSpPr txBox="1"/>
-          <p:nvPr/>
-        </p:nvSpPr>
-        <p:spPr>
-          <a:xfrm>
-            <a:off x="822960" y="5687568"/>
-            <a:ext cx="7498079" cy="146304"/>
-          </a:xfrm>
-          <a:prstGeom prst="rect">
-            <a:avLst/>
-          </a:prstGeom>
-          <a:noFill/>
-        </p:spPr>
-        <p:txBody>
-          <a:bodyPr wrap="square" lIns="36576" rIns="36576" tIns="18288" bIns="18288">
-            <a:spAutoFit/>
-          </a:bodyPr>
-          <a:lstStyle/>
-          <a:p>
-            <a:pPr algn="ctr"/>
-            <a:r>
-              <a:rPr sz="919" b="1" i="0">
-                <a:solidFill>
-                  <a:srgbClr val="00C8F0"/>
-                </a:solidFill>
-                <a:latin typeface="Segoe UI"/>
-              </a:rPr>
               <a:t>Output: users pick traceable work, create feature branches, validate PG3 firmware with JTAG evidence, and loop through QA until READY.</a:t>
             </a:r>
           </a:p>
@@ -24854,57 +23717,14 @@
       </p:sp>
       <p:sp>
         <p:nvSpPr>
-          <p:cNvPr id="76" name="Rectangle 75"/>
-          <p:cNvSpPr/>
-          <p:nvPr/>
-        </p:nvSpPr>
-        <p:spPr>
-          <a:xfrm>
-            <a:off x="0" y="6473952"/>
-            <a:ext cx="9144000" cy="384048"/>
-          </a:xfrm>
-          <a:prstGeom prst="rect">
-            <a:avLst/>
-          </a:prstGeom>
-          <a:solidFill>
-            <a:srgbClr val="0E2A4A"/>
-          </a:solidFill>
-          <a:ln>
-            <a:noFill/>
-          </a:ln>
-        </p:spPr>
-        <p:style>
-          <a:lnRef idx="1">
-            <a:schemeClr val="accent1"/>
-          </a:lnRef>
-          <a:fillRef idx="3">
-            <a:schemeClr val="accent1"/>
-          </a:fillRef>
-          <a:effectRef idx="2">
-            <a:schemeClr val="accent1"/>
-          </a:effectRef>
-          <a:fontRef idx="minor">
-            <a:schemeClr val="lt1"/>
-          </a:fontRef>
-        </p:style>
-        <p:txBody>
-          <a:bodyPr rtlCol="0" anchor="ctr"/>
-          <a:lstStyle/>
-          <a:p>
-            <a:pPr algn="ctr"/>
-          </a:p>
-        </p:txBody>
-      </p:sp>
-      <p:sp>
-        <p:nvSpPr>
-          <p:cNvPr id="77" name="TextBox 76"/>
+          <p:cNvPr id="49" name="TextBox 48"/>
           <p:cNvSpPr txBox="1"/>
           <p:nvPr/>
         </p:nvSpPr>
         <p:spPr>
           <a:xfrm>
-            <a:off x="8156448" y="6565392"/>
-            <a:ext cx="594360" cy="146304"/>
+            <a:off x="8275320" y="6556248"/>
+            <a:ext cx="411480" cy="146304"/>
           </a:xfrm>
           <a:prstGeom prst="rect">
             <a:avLst/>
@@ -24932,14 +23752,14 @@
       </p:sp>
       <p:sp>
         <p:nvSpPr>
-          <p:cNvPr id="78" name="TextBox 77"/>
+          <p:cNvPr id="50" name="TextBox 49"/>
           <p:cNvSpPr txBox="1"/>
           <p:nvPr/>
         </p:nvSpPr>
         <p:spPr>
           <a:xfrm>
-            <a:off x="7498079" y="6565392"/>
-            <a:ext cx="822960" cy="146304"/>
+            <a:off x="7406640" y="6556248"/>
+            <a:ext cx="777240" cy="146304"/>
           </a:xfrm>
           <a:prstGeom prst="rect">
             <a:avLst/>
@@ -24973,7 +23793,7 @@
 </p:sld>
 </file>
 
-<file path=ppt/slides/slide6.xml><?xml version="1.0" encoding="utf-8"?>
+<file path=ppt/slides/slide3.xml><?xml version="1.0" encoding="utf-8"?>
 <p:sld xmlns:a="http://schemas.openxmlformats.org/drawingml/2006/main" xmlns:r="http://schemas.openxmlformats.org/officeDocument/2006/relationships" xmlns:p="http://schemas.openxmlformats.org/presentationml/2006/main">
   <p:cSld>
     <p:spTree>
@@ -27619,7 +26439,7 @@
 </p:sld>
 </file>
 
-<file path=ppt/slides/slide8.xml><?xml version="1.0" encoding="utf-8"?>
+<file path=ppt/slides/slide4.xml><?xml version="1.0" encoding="utf-8"?>
 <p:sld xmlns:a="http://schemas.openxmlformats.org/drawingml/2006/main" xmlns:r="http://schemas.openxmlformats.org/officeDocument/2006/relationships" xmlns:p="http://schemas.openxmlformats.org/presentationml/2006/main">
   <p:cSld>
     <p:spTree>
@@ -29460,7 +28280,7 @@
 </p:sld>
 </file>
 
-<file path=ppt/slides/slide9.xml><?xml version="1.0" encoding="utf-8"?>
+<file path=ppt/slides/slide5.xml><?xml version="1.0" encoding="utf-8"?>
 <p:sld xmlns:a="http://schemas.openxmlformats.org/drawingml/2006/main" xmlns:r="http://schemas.openxmlformats.org/officeDocument/2006/relationships" xmlns:p="http://schemas.openxmlformats.org/presentationml/2006/main">
   <p:cSld>
     <p:spTree>

</xml_diff>

<commit_message>
Restore five-card combined slide with V9 colors
Co-authored-by: Shyam <shyam.nexus@gmail.com>
</commit_message>
<xml_diff>
--- a/AI-Driven Embedded Product Lifecycle OrchestratorV10.pptx
+++ b/AI-Driven Embedded Product Lifecycle OrchestratorV10.pptx
@@ -21923,7 +21923,7 @@
             <a:avLst/>
           </a:prstGeom>
           <a:solidFill>
-            <a:srgbClr val="00A89A"/>
+            <a:srgbClr val="0072C6"/>
           </a:solidFill>
           <a:ln>
             <a:noFill/>
@@ -21981,7 +21981,7 @@
                 </a:solidFill>
                 <a:latin typeface="Segoe UI"/>
               </a:rPr>
-              <a:t>LIFECYCLE FLOW</a:t>
+              <a:t>COMBINED FLOW</a:t>
             </a:r>
           </a:p>
         </p:txBody>
@@ -22010,13 +22010,13 @@
           <a:p>
             <a:pPr algn="l"/>
             <a:r>
-              <a:rPr sz="2800" b="1" i="0">
+              <a:rPr sz="2300" b="1" i="0">
                 <a:solidFill>
                   <a:srgbClr val="FFFFFF"/>
                 </a:solidFill>
                 <a:latin typeface="Segoe UI"/>
               </a:rPr>
-              <a:t>Combined Lifecycle Summary</a:t>
+              <a:t>One Slide Summary: Problem -&gt; Architecture -&gt; PRD -&gt; PG3 -&gt; QA Gate</a:t>
             </a:r>
           </a:p>
         </p:txBody>
@@ -22036,7 +22036,7 @@
             <a:avLst/>
           </a:prstGeom>
           <a:solidFill>
-            <a:srgbClr val="00A89A"/>
+            <a:srgbClr val="00C8F0"/>
           </a:solidFill>
           <a:ln>
             <a:noFill/>
@@ -22094,7 +22094,7 @@
                 </a:solidFill>
                 <a:latin typeface="Segoe UI"/>
               </a:rPr>
-              <a:t>Pages 2, 3, 4, 5 and 7 compressed into one V9-style flow: problem and architecture, PRD-to-work selection, PG3 generation and QA release gating.</a:t>
+              <a:t>Combines original pages 2, 3, 4, 5 and 7 while preserving the requested V10 pages 1, 6, 8 and 9 unchanged.</a:t>
             </a:r>
           </a:p>
         </p:txBody>
@@ -22107,8 +22107,8 @@
         </p:nvSpPr>
         <p:spPr>
           <a:xfrm>
-            <a:off x="347472" y="3296412"/>
-            <a:ext cx="8449056" cy="27432"/>
+            <a:off x="384048" y="3584448"/>
+            <a:ext cx="8375904" cy="32004"/>
           </a:xfrm>
           <a:prstGeom prst="rect">
             <a:avLst/>
@@ -22150,8 +22150,8 @@
         </p:nvSpPr>
         <p:spPr>
           <a:xfrm>
-            <a:off x="347472" y="2011680"/>
-            <a:ext cx="2633472" cy="4133087"/>
+            <a:off x="384048" y="2057400"/>
+            <a:ext cx="1554480" cy="3063240"/>
           </a:xfrm>
           <a:prstGeom prst="roundRect">
             <a:avLst/>
@@ -22193,14 +22193,14 @@
         </p:nvSpPr>
         <p:spPr>
           <a:xfrm>
-            <a:off x="347472" y="2011680"/>
-            <a:ext cx="2633472" cy="45720"/>
+            <a:off x="384048" y="2057400"/>
+            <a:ext cx="1554480" cy="50292"/>
           </a:xfrm>
           <a:prstGeom prst="rect">
             <a:avLst/>
           </a:prstGeom>
           <a:solidFill>
-            <a:srgbClr val="00A89A"/>
+            <a:srgbClr val="FF8C00"/>
           </a:solidFill>
           <a:ln>
             <a:noFill/>
@@ -22236,14 +22236,14 @@
         </p:nvSpPr>
         <p:spPr>
           <a:xfrm>
-            <a:off x="1280160" y="2926080"/>
-            <a:ext cx="768096" cy="768096"/>
+            <a:off x="896112" y="2350008"/>
+            <a:ext cx="530352" cy="530352"/>
           </a:xfrm>
           <a:prstGeom prst="ellipse">
             <a:avLst/>
           </a:prstGeom>
           <a:solidFill>
-            <a:srgbClr val="00A89A"/>
+            <a:srgbClr val="FF8C00"/>
           </a:solidFill>
           <a:ln>
             <a:noFill/>
@@ -22279,336 +22279,8 @@
         </p:nvSpPr>
         <p:spPr>
           <a:xfrm>
-            <a:off x="1280160" y="3090672"/>
-            <a:ext cx="768096" cy="146304"/>
-          </a:xfrm>
-          <a:prstGeom prst="rect">
-            <a:avLst/>
-          </a:prstGeom>
-          <a:noFill/>
-        </p:spPr>
-        <p:txBody>
-          <a:bodyPr wrap="square" lIns="36576" rIns="36576" tIns="18288" bIns="18288">
-            <a:spAutoFit/>
-          </a:bodyPr>
-          <a:lstStyle/>
-          <a:p>
-            <a:pPr algn="ctr"/>
-            <a:r>
-              <a:rPr sz="1400" b="1" i="0">
-                <a:solidFill>
-                  <a:srgbClr val="FFFFFF"/>
-                </a:solidFill>
-                <a:latin typeface="Segoe UI"/>
-              </a:rPr>
-              <a:t>01</a:t>
-            </a:r>
-          </a:p>
-        </p:txBody>
-      </p:sp>
-      <p:sp>
-        <p:nvSpPr>
-          <p:cNvPr id="14" name="Rectangle 13"/>
-          <p:cNvSpPr/>
-          <p:nvPr/>
-        </p:nvSpPr>
-        <p:spPr>
-          <a:xfrm>
-            <a:off x="3017520" y="3295498"/>
-            <a:ext cx="18288" cy="29260"/>
-          </a:xfrm>
-          <a:prstGeom prst="rect">
-            <a:avLst/>
-          </a:prstGeom>
-          <a:solidFill>
-            <a:srgbClr val="00A89A"/>
-          </a:solidFill>
-          <a:ln>
-            <a:noFill/>
-          </a:ln>
-        </p:spPr>
-        <p:style>
-          <a:lnRef idx="1">
-            <a:schemeClr val="accent1"/>
-          </a:lnRef>
-          <a:fillRef idx="3">
-            <a:schemeClr val="accent1"/>
-          </a:fillRef>
-          <a:effectRef idx="2">
-            <a:schemeClr val="accent1"/>
-          </a:effectRef>
-          <a:fontRef idx="minor">
-            <a:schemeClr val="lt1"/>
-          </a:fontRef>
-        </p:style>
-        <p:txBody>
-          <a:bodyPr rtlCol="0" anchor="ctr"/>
-          <a:lstStyle/>
-          <a:p>
-            <a:pPr algn="ctr"/>
-          </a:p>
-        </p:txBody>
-      </p:sp>
-      <p:sp>
-        <p:nvSpPr>
-          <p:cNvPr id="15" name="Rectangle 14"/>
-          <p:cNvSpPr/>
-          <p:nvPr/>
-        </p:nvSpPr>
-        <p:spPr>
-          <a:xfrm>
-            <a:off x="3043123" y="3295498"/>
-            <a:ext cx="18288" cy="29260"/>
-          </a:xfrm>
-          <a:prstGeom prst="rect">
-            <a:avLst/>
-          </a:prstGeom>
-          <a:solidFill>
-            <a:srgbClr val="00A89A"/>
-          </a:solidFill>
-          <a:ln>
-            <a:noFill/>
-          </a:ln>
-        </p:spPr>
-        <p:style>
-          <a:lnRef idx="1">
-            <a:schemeClr val="accent1"/>
-          </a:lnRef>
-          <a:fillRef idx="3">
-            <a:schemeClr val="accent1"/>
-          </a:fillRef>
-          <a:effectRef idx="2">
-            <a:schemeClr val="accent1"/>
-          </a:effectRef>
-          <a:fontRef idx="minor">
-            <a:schemeClr val="lt1"/>
-          </a:fontRef>
-        </p:style>
-        <p:txBody>
-          <a:bodyPr rtlCol="0" anchor="ctr"/>
-          <a:lstStyle/>
-          <a:p>
-            <a:pPr algn="ctr"/>
-          </a:p>
-        </p:txBody>
-      </p:sp>
-      <p:sp>
-        <p:nvSpPr>
-          <p:cNvPr id="16" name="Rectangle 15"/>
-          <p:cNvSpPr/>
-          <p:nvPr/>
-        </p:nvSpPr>
-        <p:spPr>
-          <a:xfrm>
-            <a:off x="3068726" y="3295498"/>
-            <a:ext cx="18288" cy="29260"/>
-          </a:xfrm>
-          <a:prstGeom prst="rect">
-            <a:avLst/>
-          </a:prstGeom>
-          <a:solidFill>
-            <a:srgbClr val="00A89A"/>
-          </a:solidFill>
-          <a:ln>
-            <a:noFill/>
-          </a:ln>
-        </p:spPr>
-        <p:style>
-          <a:lnRef idx="1">
-            <a:schemeClr val="accent1"/>
-          </a:lnRef>
-          <a:fillRef idx="3">
-            <a:schemeClr val="accent1"/>
-          </a:fillRef>
-          <a:effectRef idx="2">
-            <a:schemeClr val="accent1"/>
-          </a:effectRef>
-          <a:fontRef idx="minor">
-            <a:schemeClr val="lt1"/>
-          </a:fontRef>
-        </p:style>
-        <p:txBody>
-          <a:bodyPr rtlCol="0" anchor="ctr"/>
-          <a:lstStyle/>
-          <a:p>
-            <a:pPr algn="ctr"/>
-          </a:p>
-        </p:txBody>
-      </p:sp>
-      <p:sp>
-        <p:nvSpPr>
-          <p:cNvPr id="17" name="Rectangle 16"/>
-          <p:cNvSpPr/>
-          <p:nvPr/>
-        </p:nvSpPr>
-        <p:spPr>
-          <a:xfrm>
-            <a:off x="3094329" y="3295498"/>
-            <a:ext cx="18288" cy="29260"/>
-          </a:xfrm>
-          <a:prstGeom prst="rect">
-            <a:avLst/>
-          </a:prstGeom>
-          <a:solidFill>
-            <a:srgbClr val="00A89A"/>
-          </a:solidFill>
-          <a:ln>
-            <a:noFill/>
-          </a:ln>
-        </p:spPr>
-        <p:style>
-          <a:lnRef idx="1">
-            <a:schemeClr val="accent1"/>
-          </a:lnRef>
-          <a:fillRef idx="3">
-            <a:schemeClr val="accent1"/>
-          </a:fillRef>
-          <a:effectRef idx="2">
-            <a:schemeClr val="accent1"/>
-          </a:effectRef>
-          <a:fontRef idx="minor">
-            <a:schemeClr val="lt1"/>
-          </a:fontRef>
-        </p:style>
-        <p:txBody>
-          <a:bodyPr rtlCol="0" anchor="ctr"/>
-          <a:lstStyle/>
-          <a:p>
-            <a:pPr algn="ctr"/>
-          </a:p>
-        </p:txBody>
-      </p:sp>
-      <p:sp>
-        <p:nvSpPr>
-          <p:cNvPr id="18" name="Rectangle 17"/>
-          <p:cNvSpPr/>
-          <p:nvPr/>
-        </p:nvSpPr>
-        <p:spPr>
-          <a:xfrm>
-            <a:off x="3119932" y="3295498"/>
-            <a:ext cx="18288" cy="29260"/>
-          </a:xfrm>
-          <a:prstGeom prst="rect">
-            <a:avLst/>
-          </a:prstGeom>
-          <a:solidFill>
-            <a:srgbClr val="00A89A"/>
-          </a:solidFill>
-          <a:ln>
-            <a:noFill/>
-          </a:ln>
-        </p:spPr>
-        <p:style>
-          <a:lnRef idx="1">
-            <a:schemeClr val="accent1"/>
-          </a:lnRef>
-          <a:fillRef idx="3">
-            <a:schemeClr val="accent1"/>
-          </a:fillRef>
-          <a:effectRef idx="2">
-            <a:schemeClr val="accent1"/>
-          </a:effectRef>
-          <a:fontRef idx="minor">
-            <a:schemeClr val="lt1"/>
-          </a:fontRef>
-        </p:style>
-        <p:txBody>
-          <a:bodyPr rtlCol="0" anchor="ctr"/>
-          <a:lstStyle/>
-          <a:p>
-            <a:pPr algn="ctr"/>
-          </a:p>
-        </p:txBody>
-      </p:sp>
-      <p:sp>
-        <p:nvSpPr>
-          <p:cNvPr id="19" name="Rectangle 18"/>
-          <p:cNvSpPr/>
-          <p:nvPr/>
-        </p:nvSpPr>
-        <p:spPr>
-          <a:xfrm>
-            <a:off x="3145535" y="3295498"/>
-            <a:ext cx="18288" cy="29260"/>
-          </a:xfrm>
-          <a:prstGeom prst="rect">
-            <a:avLst/>
-          </a:prstGeom>
-          <a:solidFill>
-            <a:srgbClr val="00A89A"/>
-          </a:solidFill>
-          <a:ln>
-            <a:noFill/>
-          </a:ln>
-        </p:spPr>
-        <p:style>
-          <a:lnRef idx="1">
-            <a:schemeClr val="accent1"/>
-          </a:lnRef>
-          <a:fillRef idx="3">
-            <a:schemeClr val="accent1"/>
-          </a:fillRef>
-          <a:effectRef idx="2">
-            <a:schemeClr val="accent1"/>
-          </a:effectRef>
-          <a:fontRef idx="minor">
-            <a:schemeClr val="lt1"/>
-          </a:fontRef>
-        </p:style>
-        <p:txBody>
-          <a:bodyPr rtlCol="0" anchor="ctr"/>
-          <a:lstStyle/>
-          <a:p>
-            <a:pPr algn="ctr"/>
-          </a:p>
-        </p:txBody>
-      </p:sp>
-      <p:sp>
-        <p:nvSpPr>
-          <p:cNvPr id="20" name="TextBox 19"/>
-          <p:cNvSpPr txBox="1"/>
-          <p:nvPr/>
-        </p:nvSpPr>
-        <p:spPr>
-          <a:xfrm>
-            <a:off x="347472" y="2148840"/>
-            <a:ext cx="2633472" cy="411480"/>
-          </a:xfrm>
-          <a:prstGeom prst="rect">
-            <a:avLst/>
-          </a:prstGeom>
-          <a:noFill/>
-        </p:spPr>
-        <p:txBody>
-          <a:bodyPr wrap="square" lIns="36576" rIns="36576" tIns="18288" bIns="18288">
-            <a:spAutoFit/>
-          </a:bodyPr>
-          <a:lstStyle/>
-          <a:p>
-            <a:pPr algn="ctr"/>
-            <a:r>
-              <a:rPr sz="2000" b="1" i="0">
-                <a:solidFill>
-                  <a:srgbClr val="00A89A"/>
-                </a:solidFill>
-                <a:latin typeface="Segoe UI"/>
-              </a:rPr>
-              <a:t>UNIFY</a:t>
-            </a:r>
-          </a:p>
-        </p:txBody>
-      </p:sp>
-      <p:sp>
-        <p:nvSpPr>
-          <p:cNvPr id="21" name="TextBox 20"/>
-          <p:cNvSpPr txBox="1"/>
-          <p:nvPr/>
-        </p:nvSpPr>
-        <p:spPr>
-          <a:xfrm>
-            <a:off x="347472" y="2578608"/>
-            <a:ext cx="2633472" cy="365760"/>
+            <a:off x="896112" y="2478024"/>
+            <a:ext cx="530352" cy="109728"/>
           </a:xfrm>
           <a:prstGeom prst="rect">
             <a:avLst/>
@@ -22629,64 +22301,21 @@
                 </a:solidFill>
                 <a:latin typeface="Segoe UI"/>
               </a:rPr>
-              <a:t>Problem + Architecture</a:t>
+              <a:t>1</a:t>
             </a:r>
           </a:p>
         </p:txBody>
       </p:sp>
       <p:sp>
         <p:nvSpPr>
-          <p:cNvPr id="22" name="Rectangle 21"/>
-          <p:cNvSpPr/>
-          <p:nvPr/>
-        </p:nvSpPr>
-        <p:spPr>
-          <a:xfrm>
-            <a:off x="512064" y="2999232"/>
-            <a:ext cx="2304288" cy="14630"/>
-          </a:xfrm>
-          <a:prstGeom prst="rect">
-            <a:avLst/>
-          </a:prstGeom>
-          <a:solidFill>
-            <a:srgbClr val="00A89A"/>
-          </a:solidFill>
-          <a:ln>
-            <a:noFill/>
-          </a:ln>
-        </p:spPr>
-        <p:style>
-          <a:lnRef idx="1">
-            <a:schemeClr val="accent1"/>
-          </a:lnRef>
-          <a:fillRef idx="3">
-            <a:schemeClr val="accent1"/>
-          </a:fillRef>
-          <a:effectRef idx="2">
-            <a:schemeClr val="accent1"/>
-          </a:effectRef>
-          <a:fontRef idx="minor">
-            <a:schemeClr val="lt1"/>
-          </a:fontRef>
-        </p:style>
-        <p:txBody>
-          <a:bodyPr rtlCol="0" anchor="ctr"/>
-          <a:lstStyle/>
-          <a:p>
-            <a:pPr algn="ctr"/>
-          </a:p>
-        </p:txBody>
-      </p:sp>
-      <p:sp>
-        <p:nvSpPr>
-          <p:cNvPr id="23" name="TextBox 22"/>
+          <p:cNvPr id="14" name="TextBox 13"/>
           <p:cNvSpPr txBox="1"/>
           <p:nvPr/>
         </p:nvSpPr>
         <p:spPr>
           <a:xfrm>
-            <a:off x="512064" y="3127248"/>
-            <a:ext cx="2304288" cy="2834640"/>
+            <a:off x="493776" y="3017520"/>
+            <a:ext cx="1335024" cy="320040"/>
           </a:xfrm>
           <a:prstGeom prst="rect">
             <a:avLst/>
@@ -22699,29 +22328,279 @@
           </a:bodyPr>
           <a:lstStyle/>
           <a:p>
-            <a:pPr algn="l"/>
+            <a:pPr algn="ctr"/>
             <a:r>
-              <a:rPr sz="1120" b="0" i="0">
+              <a:rPr sz="1050" b="1" i="0">
+                <a:solidFill>
+                  <a:srgbClr val="FF8C00"/>
+                </a:solidFill>
+                <a:latin typeface="Segoe UI"/>
+              </a:rPr>
+              <a:t>Problem</a:t>
+            </a:r>
+          </a:p>
+        </p:txBody>
+      </p:sp>
+      <p:sp>
+        <p:nvSpPr>
+          <p:cNvPr id="15" name="Rectangle 14"/>
+          <p:cNvSpPr/>
+          <p:nvPr/>
+        </p:nvSpPr>
+        <p:spPr>
+          <a:xfrm>
+            <a:off x="548640" y="3383280"/>
+            <a:ext cx="1225296" cy="12801"/>
+          </a:xfrm>
+          <a:prstGeom prst="rect">
+            <a:avLst/>
+          </a:prstGeom>
+          <a:solidFill>
+            <a:srgbClr val="FF8C00"/>
+          </a:solidFill>
+          <a:ln>
+            <a:noFill/>
+          </a:ln>
+        </p:spPr>
+        <p:style>
+          <a:lnRef idx="1">
+            <a:schemeClr val="accent1"/>
+          </a:lnRef>
+          <a:fillRef idx="3">
+            <a:schemeClr val="accent1"/>
+          </a:fillRef>
+          <a:effectRef idx="2">
+            <a:schemeClr val="accent1"/>
+          </a:effectRef>
+          <a:fontRef idx="minor">
+            <a:schemeClr val="lt1"/>
+          </a:fontRef>
+        </p:style>
+        <p:txBody>
+          <a:bodyPr rtlCol="0" anchor="ctr"/>
+          <a:lstStyle/>
+          <a:p>
+            <a:pPr algn="ctr"/>
+          </a:p>
+        </p:txBody>
+      </p:sp>
+      <p:sp>
+        <p:nvSpPr>
+          <p:cNvPr id="16" name="TextBox 15"/>
+          <p:cNvSpPr txBox="1"/>
+          <p:nvPr/>
+        </p:nvSpPr>
+        <p:spPr>
+          <a:xfrm>
+            <a:off x="512064" y="3538728"/>
+            <a:ext cx="1298448" cy="1078992"/>
+          </a:xfrm>
+          <a:prstGeom prst="rect">
+            <a:avLst/>
+          </a:prstGeom>
+          <a:noFill/>
+        </p:spPr>
+        <p:txBody>
+          <a:bodyPr wrap="square" lIns="36576" rIns="36576" tIns="18288" bIns="18288">
+            <a:spAutoFit/>
+          </a:bodyPr>
+          <a:lstStyle/>
+          <a:p>
+            <a:pPr algn="ctr"/>
+            <a:r>
+              <a:rPr sz="840" b="0" i="0">
                 <a:solidFill>
                   <a:srgbClr val="B8D0EC"/>
                 </a:solidFill>
                 <a:latin typeface="Segoe UI"/>
               </a:rPr>
-              <a:t>Fragmented PRD, Jira, Confluence, GitHub, QA and hardware evidence are connected into AEPLO's knowledge graph and orchestration core.</a:t>
+              <a:t>Fragmented PRD, Jira, Confluence, GitHub, QA and hardware evidence slow PG1-to-PG5 decisions.</a:t>
             </a:r>
           </a:p>
         </p:txBody>
       </p:sp>
       <p:sp>
         <p:nvSpPr>
-          <p:cNvPr id="24" name="Rounded Rectangle 23"/>
-          <p:cNvSpPr/>
-          <p:nvPr/>
-        </p:nvSpPr>
-        <p:spPr>
-          <a:xfrm>
-            <a:off x="3200400" y="2011680"/>
-            <a:ext cx="2633472" cy="4133087"/>
+          <p:cNvPr id="17" name="Rectangle 16"/>
+          <p:cNvSpPr/>
+          <p:nvPr/>
+        </p:nvSpPr>
+        <p:spPr>
+          <a:xfrm>
+            <a:off x="1956816" y="3575304"/>
+            <a:ext cx="16459" cy="29260"/>
+          </a:xfrm>
+          <a:prstGeom prst="rect">
+            <a:avLst/>
+          </a:prstGeom>
+          <a:solidFill>
+            <a:srgbClr val="00C8F0"/>
+          </a:solidFill>
+          <a:ln>
+            <a:noFill/>
+          </a:ln>
+        </p:spPr>
+        <p:style>
+          <a:lnRef idx="1">
+            <a:schemeClr val="accent1"/>
+          </a:lnRef>
+          <a:fillRef idx="3">
+            <a:schemeClr val="accent1"/>
+          </a:fillRef>
+          <a:effectRef idx="2">
+            <a:schemeClr val="accent1"/>
+          </a:effectRef>
+          <a:fontRef idx="minor">
+            <a:schemeClr val="lt1"/>
+          </a:fontRef>
+        </p:style>
+        <p:txBody>
+          <a:bodyPr rtlCol="0" anchor="ctr"/>
+          <a:lstStyle/>
+          <a:p>
+            <a:pPr algn="ctr"/>
+          </a:p>
+        </p:txBody>
+      </p:sp>
+      <p:sp>
+        <p:nvSpPr>
+          <p:cNvPr id="18" name="Rectangle 17"/>
+          <p:cNvSpPr/>
+          <p:nvPr/>
+        </p:nvSpPr>
+        <p:spPr>
+          <a:xfrm>
+            <a:off x="1982419" y="3575304"/>
+            <a:ext cx="16459" cy="29260"/>
+          </a:xfrm>
+          <a:prstGeom prst="rect">
+            <a:avLst/>
+          </a:prstGeom>
+          <a:solidFill>
+            <a:srgbClr val="00C8F0"/>
+          </a:solidFill>
+          <a:ln>
+            <a:noFill/>
+          </a:ln>
+        </p:spPr>
+        <p:style>
+          <a:lnRef idx="1">
+            <a:schemeClr val="accent1"/>
+          </a:lnRef>
+          <a:fillRef idx="3">
+            <a:schemeClr val="accent1"/>
+          </a:fillRef>
+          <a:effectRef idx="2">
+            <a:schemeClr val="accent1"/>
+          </a:effectRef>
+          <a:fontRef idx="minor">
+            <a:schemeClr val="lt1"/>
+          </a:fontRef>
+        </p:style>
+        <p:txBody>
+          <a:bodyPr rtlCol="0" anchor="ctr"/>
+          <a:lstStyle/>
+          <a:p>
+            <a:pPr algn="ctr"/>
+          </a:p>
+        </p:txBody>
+      </p:sp>
+      <p:sp>
+        <p:nvSpPr>
+          <p:cNvPr id="19" name="Rectangle 18"/>
+          <p:cNvSpPr/>
+          <p:nvPr/>
+        </p:nvSpPr>
+        <p:spPr>
+          <a:xfrm>
+            <a:off x="2008022" y="3575304"/>
+            <a:ext cx="16459" cy="29260"/>
+          </a:xfrm>
+          <a:prstGeom prst="rect">
+            <a:avLst/>
+          </a:prstGeom>
+          <a:solidFill>
+            <a:srgbClr val="00C8F0"/>
+          </a:solidFill>
+          <a:ln>
+            <a:noFill/>
+          </a:ln>
+        </p:spPr>
+        <p:style>
+          <a:lnRef idx="1">
+            <a:schemeClr val="accent1"/>
+          </a:lnRef>
+          <a:fillRef idx="3">
+            <a:schemeClr val="accent1"/>
+          </a:fillRef>
+          <a:effectRef idx="2">
+            <a:schemeClr val="accent1"/>
+          </a:effectRef>
+          <a:fontRef idx="minor">
+            <a:schemeClr val="lt1"/>
+          </a:fontRef>
+        </p:style>
+        <p:txBody>
+          <a:bodyPr rtlCol="0" anchor="ctr"/>
+          <a:lstStyle/>
+          <a:p>
+            <a:pPr algn="ctr"/>
+          </a:p>
+        </p:txBody>
+      </p:sp>
+      <p:sp>
+        <p:nvSpPr>
+          <p:cNvPr id="20" name="Rectangle 19"/>
+          <p:cNvSpPr/>
+          <p:nvPr/>
+        </p:nvSpPr>
+        <p:spPr>
+          <a:xfrm>
+            <a:off x="2033625" y="3575304"/>
+            <a:ext cx="16459" cy="29260"/>
+          </a:xfrm>
+          <a:prstGeom prst="rect">
+            <a:avLst/>
+          </a:prstGeom>
+          <a:solidFill>
+            <a:srgbClr val="00C8F0"/>
+          </a:solidFill>
+          <a:ln>
+            <a:noFill/>
+          </a:ln>
+        </p:spPr>
+        <p:style>
+          <a:lnRef idx="1">
+            <a:schemeClr val="accent1"/>
+          </a:lnRef>
+          <a:fillRef idx="3">
+            <a:schemeClr val="accent1"/>
+          </a:fillRef>
+          <a:effectRef idx="2">
+            <a:schemeClr val="accent1"/>
+          </a:effectRef>
+          <a:fontRef idx="minor">
+            <a:schemeClr val="lt1"/>
+          </a:fontRef>
+        </p:style>
+        <p:txBody>
+          <a:bodyPr rtlCol="0" anchor="ctr"/>
+          <a:lstStyle/>
+          <a:p>
+            <a:pPr algn="ctr"/>
+          </a:p>
+        </p:txBody>
+      </p:sp>
+      <p:sp>
+        <p:nvSpPr>
+          <p:cNvPr id="21" name="Rounded Rectangle 20"/>
+          <p:cNvSpPr/>
+          <p:nvPr/>
+        </p:nvSpPr>
+        <p:spPr>
+          <a:xfrm>
+            <a:off x="2103120" y="2057400"/>
+            <a:ext cx="1554480" cy="3063240"/>
           </a:xfrm>
           <a:prstGeom prst="roundRect">
             <a:avLst/>
@@ -22757,14 +22636,14 @@
       </p:sp>
       <p:sp>
         <p:nvSpPr>
-          <p:cNvPr id="25" name="Rectangle 24"/>
-          <p:cNvSpPr/>
-          <p:nvPr/>
-        </p:nvSpPr>
-        <p:spPr>
-          <a:xfrm>
-            <a:off x="3200400" y="2011680"/>
-            <a:ext cx="2633472" cy="45720"/>
+          <p:cNvPr id="22" name="Rectangle 21"/>
+          <p:cNvSpPr/>
+          <p:nvPr/>
+        </p:nvSpPr>
+        <p:spPr>
+          <a:xfrm>
+            <a:off x="2103120" y="2057400"/>
+            <a:ext cx="1554480" cy="50292"/>
           </a:xfrm>
           <a:prstGeom prst="rect">
             <a:avLst/>
@@ -22800,14 +22679,14 @@
       </p:sp>
       <p:sp>
         <p:nvSpPr>
-          <p:cNvPr id="26" name="Oval 25"/>
-          <p:cNvSpPr/>
-          <p:nvPr/>
-        </p:nvSpPr>
-        <p:spPr>
-          <a:xfrm>
-            <a:off x="4133088" y="2926080"/>
-            <a:ext cx="768096" cy="768096"/>
+          <p:cNvPr id="23" name="Oval 22"/>
+          <p:cNvSpPr/>
+          <p:nvPr/>
+        </p:nvSpPr>
+        <p:spPr>
+          <a:xfrm>
+            <a:off x="2615184" y="2350008"/>
+            <a:ext cx="530352" cy="530352"/>
           </a:xfrm>
           <a:prstGeom prst="ellipse">
             <a:avLst/>
@@ -22843,342 +22722,14 @@
       </p:sp>
       <p:sp>
         <p:nvSpPr>
-          <p:cNvPr id="27" name="TextBox 26"/>
+          <p:cNvPr id="24" name="TextBox 23"/>
           <p:cNvSpPr txBox="1"/>
           <p:nvPr/>
         </p:nvSpPr>
         <p:spPr>
           <a:xfrm>
-            <a:off x="4133088" y="3090672"/>
-            <a:ext cx="768096" cy="146304"/>
-          </a:xfrm>
-          <a:prstGeom prst="rect">
-            <a:avLst/>
-          </a:prstGeom>
-          <a:noFill/>
-        </p:spPr>
-        <p:txBody>
-          <a:bodyPr wrap="square" lIns="36576" rIns="36576" tIns="18288" bIns="18288">
-            <a:spAutoFit/>
-          </a:bodyPr>
-          <a:lstStyle/>
-          <a:p>
-            <a:pPr algn="ctr"/>
-            <a:r>
-              <a:rPr sz="1400" b="1" i="0">
-                <a:solidFill>
-                  <a:srgbClr val="FFFFFF"/>
-                </a:solidFill>
-                <a:latin typeface="Segoe UI"/>
-              </a:rPr>
-              <a:t>02</a:t>
-            </a:r>
-          </a:p>
-        </p:txBody>
-      </p:sp>
-      <p:sp>
-        <p:nvSpPr>
-          <p:cNvPr id="28" name="Rectangle 27"/>
-          <p:cNvSpPr/>
-          <p:nvPr/>
-        </p:nvSpPr>
-        <p:spPr>
-          <a:xfrm>
-            <a:off x="5870448" y="3295498"/>
-            <a:ext cx="18288" cy="29260"/>
-          </a:xfrm>
-          <a:prstGeom prst="rect">
-            <a:avLst/>
-          </a:prstGeom>
-          <a:solidFill>
-            <a:srgbClr val="00A89A"/>
-          </a:solidFill>
-          <a:ln>
-            <a:noFill/>
-          </a:ln>
-        </p:spPr>
-        <p:style>
-          <a:lnRef idx="1">
-            <a:schemeClr val="accent1"/>
-          </a:lnRef>
-          <a:fillRef idx="3">
-            <a:schemeClr val="accent1"/>
-          </a:fillRef>
-          <a:effectRef idx="2">
-            <a:schemeClr val="accent1"/>
-          </a:effectRef>
-          <a:fontRef idx="minor">
-            <a:schemeClr val="lt1"/>
-          </a:fontRef>
-        </p:style>
-        <p:txBody>
-          <a:bodyPr rtlCol="0" anchor="ctr"/>
-          <a:lstStyle/>
-          <a:p>
-            <a:pPr algn="ctr"/>
-          </a:p>
-        </p:txBody>
-      </p:sp>
-      <p:sp>
-        <p:nvSpPr>
-          <p:cNvPr id="29" name="Rectangle 28"/>
-          <p:cNvSpPr/>
-          <p:nvPr/>
-        </p:nvSpPr>
-        <p:spPr>
-          <a:xfrm>
-            <a:off x="5896051" y="3295498"/>
-            <a:ext cx="18288" cy="29260"/>
-          </a:xfrm>
-          <a:prstGeom prst="rect">
-            <a:avLst/>
-          </a:prstGeom>
-          <a:solidFill>
-            <a:srgbClr val="00A89A"/>
-          </a:solidFill>
-          <a:ln>
-            <a:noFill/>
-          </a:ln>
-        </p:spPr>
-        <p:style>
-          <a:lnRef idx="1">
-            <a:schemeClr val="accent1"/>
-          </a:lnRef>
-          <a:fillRef idx="3">
-            <a:schemeClr val="accent1"/>
-          </a:fillRef>
-          <a:effectRef idx="2">
-            <a:schemeClr val="accent1"/>
-          </a:effectRef>
-          <a:fontRef idx="minor">
-            <a:schemeClr val="lt1"/>
-          </a:fontRef>
-        </p:style>
-        <p:txBody>
-          <a:bodyPr rtlCol="0" anchor="ctr"/>
-          <a:lstStyle/>
-          <a:p>
-            <a:pPr algn="ctr"/>
-          </a:p>
-        </p:txBody>
-      </p:sp>
-      <p:sp>
-        <p:nvSpPr>
-          <p:cNvPr id="30" name="Rectangle 29"/>
-          <p:cNvSpPr/>
-          <p:nvPr/>
-        </p:nvSpPr>
-        <p:spPr>
-          <a:xfrm>
-            <a:off x="5921654" y="3295498"/>
-            <a:ext cx="18288" cy="29260"/>
-          </a:xfrm>
-          <a:prstGeom prst="rect">
-            <a:avLst/>
-          </a:prstGeom>
-          <a:solidFill>
-            <a:srgbClr val="00A89A"/>
-          </a:solidFill>
-          <a:ln>
-            <a:noFill/>
-          </a:ln>
-        </p:spPr>
-        <p:style>
-          <a:lnRef idx="1">
-            <a:schemeClr val="accent1"/>
-          </a:lnRef>
-          <a:fillRef idx="3">
-            <a:schemeClr val="accent1"/>
-          </a:fillRef>
-          <a:effectRef idx="2">
-            <a:schemeClr val="accent1"/>
-          </a:effectRef>
-          <a:fontRef idx="minor">
-            <a:schemeClr val="lt1"/>
-          </a:fontRef>
-        </p:style>
-        <p:txBody>
-          <a:bodyPr rtlCol="0" anchor="ctr"/>
-          <a:lstStyle/>
-          <a:p>
-            <a:pPr algn="ctr"/>
-          </a:p>
-        </p:txBody>
-      </p:sp>
-      <p:sp>
-        <p:nvSpPr>
-          <p:cNvPr id="31" name="Rectangle 30"/>
-          <p:cNvSpPr/>
-          <p:nvPr/>
-        </p:nvSpPr>
-        <p:spPr>
-          <a:xfrm>
-            <a:off x="5947257" y="3295498"/>
-            <a:ext cx="18288" cy="29260"/>
-          </a:xfrm>
-          <a:prstGeom prst="rect">
-            <a:avLst/>
-          </a:prstGeom>
-          <a:solidFill>
-            <a:srgbClr val="00A89A"/>
-          </a:solidFill>
-          <a:ln>
-            <a:noFill/>
-          </a:ln>
-        </p:spPr>
-        <p:style>
-          <a:lnRef idx="1">
-            <a:schemeClr val="accent1"/>
-          </a:lnRef>
-          <a:fillRef idx="3">
-            <a:schemeClr val="accent1"/>
-          </a:fillRef>
-          <a:effectRef idx="2">
-            <a:schemeClr val="accent1"/>
-          </a:effectRef>
-          <a:fontRef idx="minor">
-            <a:schemeClr val="lt1"/>
-          </a:fontRef>
-        </p:style>
-        <p:txBody>
-          <a:bodyPr rtlCol="0" anchor="ctr"/>
-          <a:lstStyle/>
-          <a:p>
-            <a:pPr algn="ctr"/>
-          </a:p>
-        </p:txBody>
-      </p:sp>
-      <p:sp>
-        <p:nvSpPr>
-          <p:cNvPr id="32" name="Rectangle 31"/>
-          <p:cNvSpPr/>
-          <p:nvPr/>
-        </p:nvSpPr>
-        <p:spPr>
-          <a:xfrm>
-            <a:off x="5972860" y="3295498"/>
-            <a:ext cx="18288" cy="29260"/>
-          </a:xfrm>
-          <a:prstGeom prst="rect">
-            <a:avLst/>
-          </a:prstGeom>
-          <a:solidFill>
-            <a:srgbClr val="00A89A"/>
-          </a:solidFill>
-          <a:ln>
-            <a:noFill/>
-          </a:ln>
-        </p:spPr>
-        <p:style>
-          <a:lnRef idx="1">
-            <a:schemeClr val="accent1"/>
-          </a:lnRef>
-          <a:fillRef idx="3">
-            <a:schemeClr val="accent1"/>
-          </a:fillRef>
-          <a:effectRef idx="2">
-            <a:schemeClr val="accent1"/>
-          </a:effectRef>
-          <a:fontRef idx="minor">
-            <a:schemeClr val="lt1"/>
-          </a:fontRef>
-        </p:style>
-        <p:txBody>
-          <a:bodyPr rtlCol="0" anchor="ctr"/>
-          <a:lstStyle/>
-          <a:p>
-            <a:pPr algn="ctr"/>
-          </a:p>
-        </p:txBody>
-      </p:sp>
-      <p:sp>
-        <p:nvSpPr>
-          <p:cNvPr id="33" name="Rectangle 32"/>
-          <p:cNvSpPr/>
-          <p:nvPr/>
-        </p:nvSpPr>
-        <p:spPr>
-          <a:xfrm>
-            <a:off x="5998463" y="3295498"/>
-            <a:ext cx="18288" cy="29260"/>
-          </a:xfrm>
-          <a:prstGeom prst="rect">
-            <a:avLst/>
-          </a:prstGeom>
-          <a:solidFill>
-            <a:srgbClr val="00A89A"/>
-          </a:solidFill>
-          <a:ln>
-            <a:noFill/>
-          </a:ln>
-        </p:spPr>
-        <p:style>
-          <a:lnRef idx="1">
-            <a:schemeClr val="accent1"/>
-          </a:lnRef>
-          <a:fillRef idx="3">
-            <a:schemeClr val="accent1"/>
-          </a:fillRef>
-          <a:effectRef idx="2">
-            <a:schemeClr val="accent1"/>
-          </a:effectRef>
-          <a:fontRef idx="minor">
-            <a:schemeClr val="lt1"/>
-          </a:fontRef>
-        </p:style>
-        <p:txBody>
-          <a:bodyPr rtlCol="0" anchor="ctr"/>
-          <a:lstStyle/>
-          <a:p>
-            <a:pPr algn="ctr"/>
-          </a:p>
-        </p:txBody>
-      </p:sp>
-      <p:sp>
-        <p:nvSpPr>
-          <p:cNvPr id="34" name="TextBox 33"/>
-          <p:cNvSpPr txBox="1"/>
-          <p:nvPr/>
-        </p:nvSpPr>
-        <p:spPr>
-          <a:xfrm>
-            <a:off x="3200400" y="2148840"/>
-            <a:ext cx="2633472" cy="411480"/>
-          </a:xfrm>
-          <a:prstGeom prst="rect">
-            <a:avLst/>
-          </a:prstGeom>
-          <a:noFill/>
-        </p:spPr>
-        <p:txBody>
-          <a:bodyPr wrap="square" lIns="36576" rIns="36576" tIns="18288" bIns="18288">
-            <a:spAutoFit/>
-          </a:bodyPr>
-          <a:lstStyle/>
-          <a:p>
-            <a:pPr algn="ctr"/>
-            <a:r>
-              <a:rPr sz="2000" b="1" i="0">
-                <a:solidFill>
-                  <a:srgbClr val="0072C6"/>
-                </a:solidFill>
-                <a:latin typeface="Segoe UI"/>
-              </a:rPr>
-              <a:t>PICK</a:t>
-            </a:r>
-          </a:p>
-        </p:txBody>
-      </p:sp>
-      <p:sp>
-        <p:nvSpPr>
-          <p:cNvPr id="35" name="TextBox 34"/>
-          <p:cNvSpPr txBox="1"/>
-          <p:nvPr/>
-        </p:nvSpPr>
-        <p:spPr>
-          <a:xfrm>
-            <a:off x="3200400" y="2578608"/>
-            <a:ext cx="2633472" cy="365760"/>
+            <a:off x="2615184" y="2478024"/>
+            <a:ext cx="530352" cy="109728"/>
           </a:xfrm>
           <a:prstGeom prst="rect">
             <a:avLst/>
@@ -23199,64 +22750,21 @@
                 </a:solidFill>
                 <a:latin typeface="Segoe UI"/>
               </a:rPr>
-              <a:t>PRD -&gt; Epics -&gt; Branch</a:t>
+              <a:t>2</a:t>
             </a:r>
           </a:p>
         </p:txBody>
       </p:sp>
       <p:sp>
         <p:nvSpPr>
-          <p:cNvPr id="36" name="Rectangle 35"/>
-          <p:cNvSpPr/>
-          <p:nvPr/>
-        </p:nvSpPr>
-        <p:spPr>
-          <a:xfrm>
-            <a:off x="3364992" y="2999232"/>
-            <a:ext cx="2304288" cy="14630"/>
-          </a:xfrm>
-          <a:prstGeom prst="rect">
-            <a:avLst/>
-          </a:prstGeom>
-          <a:solidFill>
-            <a:srgbClr val="0072C6"/>
-          </a:solidFill>
-          <a:ln>
-            <a:noFill/>
-          </a:ln>
-        </p:spPr>
-        <p:style>
-          <a:lnRef idx="1">
-            <a:schemeClr val="accent1"/>
-          </a:lnRef>
-          <a:fillRef idx="3">
-            <a:schemeClr val="accent1"/>
-          </a:fillRef>
-          <a:effectRef idx="2">
-            <a:schemeClr val="accent1"/>
-          </a:effectRef>
-          <a:fontRef idx="minor">
-            <a:schemeClr val="lt1"/>
-          </a:fontRef>
-        </p:style>
-        <p:txBody>
-          <a:bodyPr rtlCol="0" anchor="ctr"/>
-          <a:lstStyle/>
-          <a:p>
-            <a:pPr algn="ctr"/>
-          </a:p>
-        </p:txBody>
-      </p:sp>
-      <p:sp>
-        <p:nvSpPr>
-          <p:cNvPr id="37" name="TextBox 36"/>
+          <p:cNvPr id="25" name="TextBox 24"/>
           <p:cNvSpPr txBox="1"/>
           <p:nvPr/>
         </p:nvSpPr>
         <p:spPr>
           <a:xfrm>
-            <a:off x="3364992" y="3127248"/>
-            <a:ext cx="2304288" cy="2834640"/>
+            <a:off x="2212848" y="3017520"/>
+            <a:ext cx="1335024" cy="320040"/>
           </a:xfrm>
           <a:prstGeom prst="rect">
             <a:avLst/>
@@ -23269,29 +22777,279 @@
           </a:bodyPr>
           <a:lstStyle/>
           <a:p>
-            <a:pPr algn="l"/>
+            <a:pPr algn="ctr"/>
             <a:r>
-              <a:rPr sz="1120" b="0" i="0">
+              <a:rPr sz="1050" b="1" i="0">
+                <a:solidFill>
+                  <a:srgbClr val="0072C6"/>
+                </a:solidFill>
+                <a:latin typeface="Segoe UI"/>
+              </a:rPr>
+              <a:t>Architecture</a:t>
+            </a:r>
+          </a:p>
+        </p:txBody>
+      </p:sp>
+      <p:sp>
+        <p:nvSpPr>
+          <p:cNvPr id="26" name="Rectangle 25"/>
+          <p:cNvSpPr/>
+          <p:nvPr/>
+        </p:nvSpPr>
+        <p:spPr>
+          <a:xfrm>
+            <a:off x="2267712" y="3383280"/>
+            <a:ext cx="1225296" cy="12801"/>
+          </a:xfrm>
+          <a:prstGeom prst="rect">
+            <a:avLst/>
+          </a:prstGeom>
+          <a:solidFill>
+            <a:srgbClr val="0072C6"/>
+          </a:solidFill>
+          <a:ln>
+            <a:noFill/>
+          </a:ln>
+        </p:spPr>
+        <p:style>
+          <a:lnRef idx="1">
+            <a:schemeClr val="accent1"/>
+          </a:lnRef>
+          <a:fillRef idx="3">
+            <a:schemeClr val="accent1"/>
+          </a:fillRef>
+          <a:effectRef idx="2">
+            <a:schemeClr val="accent1"/>
+          </a:effectRef>
+          <a:fontRef idx="minor">
+            <a:schemeClr val="lt1"/>
+          </a:fontRef>
+        </p:style>
+        <p:txBody>
+          <a:bodyPr rtlCol="0" anchor="ctr"/>
+          <a:lstStyle/>
+          <a:p>
+            <a:pPr algn="ctr"/>
+          </a:p>
+        </p:txBody>
+      </p:sp>
+      <p:sp>
+        <p:nvSpPr>
+          <p:cNvPr id="27" name="TextBox 26"/>
+          <p:cNvSpPr txBox="1"/>
+          <p:nvPr/>
+        </p:nvSpPr>
+        <p:spPr>
+          <a:xfrm>
+            <a:off x="2231136" y="3538728"/>
+            <a:ext cx="1298448" cy="1078992"/>
+          </a:xfrm>
+          <a:prstGeom prst="rect">
+            <a:avLst/>
+          </a:prstGeom>
+          <a:noFill/>
+        </p:spPr>
+        <p:txBody>
+          <a:bodyPr wrap="square" lIns="36576" rIns="36576" tIns="18288" bIns="18288">
+            <a:spAutoFit/>
+          </a:bodyPr>
+          <a:lstStyle/>
+          <a:p>
+            <a:pPr algn="ctr"/>
+            <a:r>
+              <a:rPr sz="840" b="0" i="0">
                 <a:solidFill>
                   <a:srgbClr val="B8D0EC"/>
                 </a:solidFill>
                 <a:latin typeface="Segoe UI"/>
               </a:rPr>
-              <a:t>Confluence PRD guided by SDE Elements and PSJIRA creates epics/stories for users to pick; selected work creates a feature branch.</a:t>
+              <a:t>AEPLO connects inputs into a knowledge graph, orchestration core, automation and release-gate outcomes.</a:t>
             </a:r>
           </a:p>
         </p:txBody>
       </p:sp>
       <p:sp>
         <p:nvSpPr>
-          <p:cNvPr id="38" name="Rounded Rectangle 37"/>
-          <p:cNvSpPr/>
-          <p:nvPr/>
-        </p:nvSpPr>
-        <p:spPr>
-          <a:xfrm>
-            <a:off x="6053328" y="2011680"/>
-            <a:ext cx="2633472" cy="4133087"/>
+          <p:cNvPr id="28" name="Rectangle 27"/>
+          <p:cNvSpPr/>
+          <p:nvPr/>
+        </p:nvSpPr>
+        <p:spPr>
+          <a:xfrm>
+            <a:off x="3675888" y="3575304"/>
+            <a:ext cx="16459" cy="29260"/>
+          </a:xfrm>
+          <a:prstGeom prst="rect">
+            <a:avLst/>
+          </a:prstGeom>
+          <a:solidFill>
+            <a:srgbClr val="00C8F0"/>
+          </a:solidFill>
+          <a:ln>
+            <a:noFill/>
+          </a:ln>
+        </p:spPr>
+        <p:style>
+          <a:lnRef idx="1">
+            <a:schemeClr val="accent1"/>
+          </a:lnRef>
+          <a:fillRef idx="3">
+            <a:schemeClr val="accent1"/>
+          </a:fillRef>
+          <a:effectRef idx="2">
+            <a:schemeClr val="accent1"/>
+          </a:effectRef>
+          <a:fontRef idx="minor">
+            <a:schemeClr val="lt1"/>
+          </a:fontRef>
+        </p:style>
+        <p:txBody>
+          <a:bodyPr rtlCol="0" anchor="ctr"/>
+          <a:lstStyle/>
+          <a:p>
+            <a:pPr algn="ctr"/>
+          </a:p>
+        </p:txBody>
+      </p:sp>
+      <p:sp>
+        <p:nvSpPr>
+          <p:cNvPr id="29" name="Rectangle 28"/>
+          <p:cNvSpPr/>
+          <p:nvPr/>
+        </p:nvSpPr>
+        <p:spPr>
+          <a:xfrm>
+            <a:off x="3701491" y="3575304"/>
+            <a:ext cx="16459" cy="29260"/>
+          </a:xfrm>
+          <a:prstGeom prst="rect">
+            <a:avLst/>
+          </a:prstGeom>
+          <a:solidFill>
+            <a:srgbClr val="00C8F0"/>
+          </a:solidFill>
+          <a:ln>
+            <a:noFill/>
+          </a:ln>
+        </p:spPr>
+        <p:style>
+          <a:lnRef idx="1">
+            <a:schemeClr val="accent1"/>
+          </a:lnRef>
+          <a:fillRef idx="3">
+            <a:schemeClr val="accent1"/>
+          </a:fillRef>
+          <a:effectRef idx="2">
+            <a:schemeClr val="accent1"/>
+          </a:effectRef>
+          <a:fontRef idx="minor">
+            <a:schemeClr val="lt1"/>
+          </a:fontRef>
+        </p:style>
+        <p:txBody>
+          <a:bodyPr rtlCol="0" anchor="ctr"/>
+          <a:lstStyle/>
+          <a:p>
+            <a:pPr algn="ctr"/>
+          </a:p>
+        </p:txBody>
+      </p:sp>
+      <p:sp>
+        <p:nvSpPr>
+          <p:cNvPr id="30" name="Rectangle 29"/>
+          <p:cNvSpPr/>
+          <p:nvPr/>
+        </p:nvSpPr>
+        <p:spPr>
+          <a:xfrm>
+            <a:off x="3727094" y="3575304"/>
+            <a:ext cx="16459" cy="29260"/>
+          </a:xfrm>
+          <a:prstGeom prst="rect">
+            <a:avLst/>
+          </a:prstGeom>
+          <a:solidFill>
+            <a:srgbClr val="00C8F0"/>
+          </a:solidFill>
+          <a:ln>
+            <a:noFill/>
+          </a:ln>
+        </p:spPr>
+        <p:style>
+          <a:lnRef idx="1">
+            <a:schemeClr val="accent1"/>
+          </a:lnRef>
+          <a:fillRef idx="3">
+            <a:schemeClr val="accent1"/>
+          </a:fillRef>
+          <a:effectRef idx="2">
+            <a:schemeClr val="accent1"/>
+          </a:effectRef>
+          <a:fontRef idx="minor">
+            <a:schemeClr val="lt1"/>
+          </a:fontRef>
+        </p:style>
+        <p:txBody>
+          <a:bodyPr rtlCol="0" anchor="ctr"/>
+          <a:lstStyle/>
+          <a:p>
+            <a:pPr algn="ctr"/>
+          </a:p>
+        </p:txBody>
+      </p:sp>
+      <p:sp>
+        <p:nvSpPr>
+          <p:cNvPr id="31" name="Rectangle 30"/>
+          <p:cNvSpPr/>
+          <p:nvPr/>
+        </p:nvSpPr>
+        <p:spPr>
+          <a:xfrm>
+            <a:off x="3752697" y="3575304"/>
+            <a:ext cx="16459" cy="29260"/>
+          </a:xfrm>
+          <a:prstGeom prst="rect">
+            <a:avLst/>
+          </a:prstGeom>
+          <a:solidFill>
+            <a:srgbClr val="00C8F0"/>
+          </a:solidFill>
+          <a:ln>
+            <a:noFill/>
+          </a:ln>
+        </p:spPr>
+        <p:style>
+          <a:lnRef idx="1">
+            <a:schemeClr val="accent1"/>
+          </a:lnRef>
+          <a:fillRef idx="3">
+            <a:schemeClr val="accent1"/>
+          </a:fillRef>
+          <a:effectRef idx="2">
+            <a:schemeClr val="accent1"/>
+          </a:effectRef>
+          <a:fontRef idx="minor">
+            <a:schemeClr val="lt1"/>
+          </a:fontRef>
+        </p:style>
+        <p:txBody>
+          <a:bodyPr rtlCol="0" anchor="ctr"/>
+          <a:lstStyle/>
+          <a:p>
+            <a:pPr algn="ctr"/>
+          </a:p>
+        </p:txBody>
+      </p:sp>
+      <p:sp>
+        <p:nvSpPr>
+          <p:cNvPr id="32" name="Rounded Rectangle 31"/>
+          <p:cNvSpPr/>
+          <p:nvPr/>
+        </p:nvSpPr>
+        <p:spPr>
+          <a:xfrm>
+            <a:off x="3822191" y="2057400"/>
+            <a:ext cx="1554480" cy="3063240"/>
           </a:xfrm>
           <a:prstGeom prst="roundRect">
             <a:avLst/>
@@ -23327,20 +23085,20 @@
       </p:sp>
       <p:sp>
         <p:nvSpPr>
-          <p:cNvPr id="39" name="Rectangle 38"/>
-          <p:cNvSpPr/>
-          <p:nvPr/>
-        </p:nvSpPr>
-        <p:spPr>
-          <a:xfrm>
-            <a:off x="6053328" y="2011680"/>
-            <a:ext cx="2633472" cy="45720"/>
+          <p:cNvPr id="33" name="Rectangle 32"/>
+          <p:cNvSpPr/>
+          <p:nvPr/>
+        </p:nvSpPr>
+        <p:spPr>
+          <a:xfrm>
+            <a:off x="3822191" y="2057400"/>
+            <a:ext cx="1554480" cy="50292"/>
           </a:xfrm>
           <a:prstGeom prst="rect">
             <a:avLst/>
           </a:prstGeom>
           <a:solidFill>
-            <a:srgbClr val="00D48A"/>
+            <a:srgbClr val="00A89A"/>
           </a:solidFill>
           <a:ln>
             <a:noFill/>
@@ -23370,20 +23128,20 @@
       </p:sp>
       <p:sp>
         <p:nvSpPr>
-          <p:cNvPr id="40" name="Oval 39"/>
-          <p:cNvSpPr/>
-          <p:nvPr/>
-        </p:nvSpPr>
-        <p:spPr>
-          <a:xfrm>
-            <a:off x="6986016" y="2926080"/>
-            <a:ext cx="768096" cy="768096"/>
+          <p:cNvPr id="34" name="Oval 33"/>
+          <p:cNvSpPr/>
+          <p:nvPr/>
+        </p:nvSpPr>
+        <p:spPr>
+          <a:xfrm>
+            <a:off x="4334255" y="2350008"/>
+            <a:ext cx="530352" cy="530352"/>
           </a:xfrm>
           <a:prstGeom prst="ellipse">
             <a:avLst/>
           </a:prstGeom>
           <a:solidFill>
-            <a:srgbClr val="00D48A"/>
+            <a:srgbClr val="00A89A"/>
           </a:solidFill>
           <a:ln>
             <a:noFill/>
@@ -23413,84 +23171,14 @@
       </p:sp>
       <p:sp>
         <p:nvSpPr>
-          <p:cNvPr id="41" name="TextBox 40"/>
+          <p:cNvPr id="35" name="TextBox 34"/>
           <p:cNvSpPr txBox="1"/>
           <p:nvPr/>
         </p:nvSpPr>
         <p:spPr>
           <a:xfrm>
-            <a:off x="6986016" y="3090672"/>
-            <a:ext cx="768096" cy="146304"/>
-          </a:xfrm>
-          <a:prstGeom prst="rect">
-            <a:avLst/>
-          </a:prstGeom>
-          <a:noFill/>
-        </p:spPr>
-        <p:txBody>
-          <a:bodyPr wrap="square" lIns="36576" rIns="36576" tIns="18288" bIns="18288">
-            <a:spAutoFit/>
-          </a:bodyPr>
-          <a:lstStyle/>
-          <a:p>
-            <a:pPr algn="ctr"/>
-            <a:r>
-              <a:rPr sz="1400" b="1" i="0">
-                <a:solidFill>
-                  <a:srgbClr val="FFFFFF"/>
-                </a:solidFill>
-                <a:latin typeface="Segoe UI"/>
-              </a:rPr>
-              <a:t>03</a:t>
-            </a:r>
-          </a:p>
-        </p:txBody>
-      </p:sp>
-      <p:sp>
-        <p:nvSpPr>
-          <p:cNvPr id="42" name="TextBox 41"/>
-          <p:cNvSpPr txBox="1"/>
-          <p:nvPr/>
-        </p:nvSpPr>
-        <p:spPr>
-          <a:xfrm>
-            <a:off x="6053328" y="2148840"/>
-            <a:ext cx="2633472" cy="411480"/>
-          </a:xfrm>
-          <a:prstGeom prst="rect">
-            <a:avLst/>
-          </a:prstGeom>
-          <a:noFill/>
-        </p:spPr>
-        <p:txBody>
-          <a:bodyPr wrap="square" lIns="36576" rIns="36576" tIns="18288" bIns="18288">
-            <a:spAutoFit/>
-          </a:bodyPr>
-          <a:lstStyle/>
-          <a:p>
-            <a:pPr algn="ctr"/>
-            <a:r>
-              <a:rPr sz="2000" b="1" i="0">
-                <a:solidFill>
-                  <a:srgbClr val="00D48A"/>
-                </a:solidFill>
-                <a:latin typeface="Segoe UI"/>
-              </a:rPr>
-              <a:t>VALIDATE</a:t>
-            </a:r>
-          </a:p>
-        </p:txBody>
-      </p:sp>
-      <p:sp>
-        <p:nvSpPr>
-          <p:cNvPr id="43" name="TextBox 42"/>
-          <p:cNvSpPr txBox="1"/>
-          <p:nvPr/>
-        </p:nvSpPr>
-        <p:spPr>
-          <a:xfrm>
-            <a:off x="6053328" y="2578608"/>
-            <a:ext cx="2633472" cy="365760"/>
+            <a:off x="4334255" y="2478024"/>
+            <a:ext cx="530352" cy="109728"/>
           </a:xfrm>
           <a:prstGeom prst="rect">
             <a:avLst/>
@@ -23511,64 +23199,21 @@
                 </a:solidFill>
                 <a:latin typeface="Segoe UI"/>
               </a:rPr>
-              <a:t>PG3 Firmware -&gt; QA Gate</a:t>
+              <a:t>3</a:t>
             </a:r>
           </a:p>
         </p:txBody>
       </p:sp>
       <p:sp>
         <p:nvSpPr>
-          <p:cNvPr id="44" name="Rectangle 43"/>
-          <p:cNvSpPr/>
-          <p:nvPr/>
-        </p:nvSpPr>
-        <p:spPr>
-          <a:xfrm>
-            <a:off x="6217920" y="2999232"/>
-            <a:ext cx="2304288" cy="14630"/>
-          </a:xfrm>
-          <a:prstGeom prst="rect">
-            <a:avLst/>
-          </a:prstGeom>
-          <a:solidFill>
-            <a:srgbClr val="00D48A"/>
-          </a:solidFill>
-          <a:ln>
-            <a:noFill/>
-          </a:ln>
-        </p:spPr>
-        <p:style>
-          <a:lnRef idx="1">
-            <a:schemeClr val="accent1"/>
-          </a:lnRef>
-          <a:fillRef idx="3">
-            <a:schemeClr val="accent1"/>
-          </a:fillRef>
-          <a:effectRef idx="2">
-            <a:schemeClr val="accent1"/>
-          </a:effectRef>
-          <a:fontRef idx="minor">
-            <a:schemeClr val="lt1"/>
-          </a:fontRef>
-        </p:style>
-        <p:txBody>
-          <a:bodyPr rtlCol="0" anchor="ctr"/>
-          <a:lstStyle/>
-          <a:p>
-            <a:pPr algn="ctr"/>
-          </a:p>
-        </p:txBody>
-      </p:sp>
-      <p:sp>
-        <p:nvSpPr>
-          <p:cNvPr id="45" name="TextBox 44"/>
+          <p:cNvPr id="36" name="TextBox 35"/>
           <p:cNvSpPr txBox="1"/>
           <p:nvPr/>
         </p:nvSpPr>
         <p:spPr>
           <a:xfrm>
-            <a:off x="6217920" y="3127248"/>
-            <a:ext cx="2304288" cy="2834640"/>
+            <a:off x="3931919" y="3017520"/>
+            <a:ext cx="1335024" cy="320040"/>
           </a:xfrm>
           <a:prstGeom prst="rect">
             <a:avLst/>
@@ -23581,35 +23226,285 @@
           </a:bodyPr>
           <a:lstStyle/>
           <a:p>
-            <a:pPr algn="l"/>
+            <a:pPr algn="ctr"/>
             <a:r>
-              <a:rPr sz="1120" b="0" i="0">
+              <a:rPr sz="1050" b="1" i="0">
+                <a:solidFill>
+                  <a:srgbClr val="00A89A"/>
+                </a:solidFill>
+                <a:latin typeface="Segoe UI"/>
+              </a:rPr>
+              <a:t>PRD -&gt; Stories</a:t>
+            </a:r>
+          </a:p>
+        </p:txBody>
+      </p:sp>
+      <p:sp>
+        <p:nvSpPr>
+          <p:cNvPr id="37" name="Rectangle 36"/>
+          <p:cNvSpPr/>
+          <p:nvPr/>
+        </p:nvSpPr>
+        <p:spPr>
+          <a:xfrm>
+            <a:off x="3986783" y="3383280"/>
+            <a:ext cx="1225296" cy="12801"/>
+          </a:xfrm>
+          <a:prstGeom prst="rect">
+            <a:avLst/>
+          </a:prstGeom>
+          <a:solidFill>
+            <a:srgbClr val="00A89A"/>
+          </a:solidFill>
+          <a:ln>
+            <a:noFill/>
+          </a:ln>
+        </p:spPr>
+        <p:style>
+          <a:lnRef idx="1">
+            <a:schemeClr val="accent1"/>
+          </a:lnRef>
+          <a:fillRef idx="3">
+            <a:schemeClr val="accent1"/>
+          </a:fillRef>
+          <a:effectRef idx="2">
+            <a:schemeClr val="accent1"/>
+          </a:effectRef>
+          <a:fontRef idx="minor">
+            <a:schemeClr val="lt1"/>
+          </a:fontRef>
+        </p:style>
+        <p:txBody>
+          <a:bodyPr rtlCol="0" anchor="ctr"/>
+          <a:lstStyle/>
+          <a:p>
+            <a:pPr algn="ctr"/>
+          </a:p>
+        </p:txBody>
+      </p:sp>
+      <p:sp>
+        <p:nvSpPr>
+          <p:cNvPr id="38" name="TextBox 37"/>
+          <p:cNvSpPr txBox="1"/>
+          <p:nvPr/>
+        </p:nvSpPr>
+        <p:spPr>
+          <a:xfrm>
+            <a:off x="3950207" y="3538728"/>
+            <a:ext cx="1298448" cy="1078992"/>
+          </a:xfrm>
+          <a:prstGeom prst="rect">
+            <a:avLst/>
+          </a:prstGeom>
+          <a:noFill/>
+        </p:spPr>
+        <p:txBody>
+          <a:bodyPr wrap="square" lIns="36576" rIns="36576" tIns="18288" bIns="18288">
+            <a:spAutoFit/>
+          </a:bodyPr>
+          <a:lstStyle/>
+          <a:p>
+            <a:pPr algn="ctr"/>
+            <a:r>
+              <a:rPr sz="840" b="0" i="0">
                 <a:solidFill>
                   <a:srgbClr val="B8D0EC"/>
                 </a:solidFill>
                 <a:latin typeface="Segoe UI"/>
               </a:rPr>
-              <a:t>Datasheet + PRD + SDK/BSP + OS/RTOS generate firmware; QA inputs, PRD and JTAG evidence produce READY / NOT_READY.</a:t>
+              <a:t>Confluence PRD guided by SDE Elements and PSJIRA creates epics/stories for users to pick and branch.</a:t>
             </a:r>
           </a:p>
         </p:txBody>
       </p:sp>
       <p:sp>
         <p:nvSpPr>
-          <p:cNvPr id="46" name="Rounded Rectangle 45"/>
-          <p:cNvSpPr/>
-          <p:nvPr/>
-        </p:nvSpPr>
-        <p:spPr>
-          <a:xfrm>
-            <a:off x="320040" y="6400800"/>
-            <a:ext cx="8503920" cy="310896"/>
+          <p:cNvPr id="39" name="Rectangle 38"/>
+          <p:cNvSpPr/>
+          <p:nvPr/>
+        </p:nvSpPr>
+        <p:spPr>
+          <a:xfrm>
+            <a:off x="5394959" y="3575304"/>
+            <a:ext cx="16459" cy="29260"/>
+          </a:xfrm>
+          <a:prstGeom prst="rect">
+            <a:avLst/>
+          </a:prstGeom>
+          <a:solidFill>
+            <a:srgbClr val="00C8F0"/>
+          </a:solidFill>
+          <a:ln>
+            <a:noFill/>
+          </a:ln>
+        </p:spPr>
+        <p:style>
+          <a:lnRef idx="1">
+            <a:schemeClr val="accent1"/>
+          </a:lnRef>
+          <a:fillRef idx="3">
+            <a:schemeClr val="accent1"/>
+          </a:fillRef>
+          <a:effectRef idx="2">
+            <a:schemeClr val="accent1"/>
+          </a:effectRef>
+          <a:fontRef idx="minor">
+            <a:schemeClr val="lt1"/>
+          </a:fontRef>
+        </p:style>
+        <p:txBody>
+          <a:bodyPr rtlCol="0" anchor="ctr"/>
+          <a:lstStyle/>
+          <a:p>
+            <a:pPr algn="ctr"/>
+          </a:p>
+        </p:txBody>
+      </p:sp>
+      <p:sp>
+        <p:nvSpPr>
+          <p:cNvPr id="40" name="Rectangle 39"/>
+          <p:cNvSpPr/>
+          <p:nvPr/>
+        </p:nvSpPr>
+        <p:spPr>
+          <a:xfrm>
+            <a:off x="5420562" y="3575304"/>
+            <a:ext cx="16459" cy="29260"/>
+          </a:xfrm>
+          <a:prstGeom prst="rect">
+            <a:avLst/>
+          </a:prstGeom>
+          <a:solidFill>
+            <a:srgbClr val="00C8F0"/>
+          </a:solidFill>
+          <a:ln>
+            <a:noFill/>
+          </a:ln>
+        </p:spPr>
+        <p:style>
+          <a:lnRef idx="1">
+            <a:schemeClr val="accent1"/>
+          </a:lnRef>
+          <a:fillRef idx="3">
+            <a:schemeClr val="accent1"/>
+          </a:fillRef>
+          <a:effectRef idx="2">
+            <a:schemeClr val="accent1"/>
+          </a:effectRef>
+          <a:fontRef idx="minor">
+            <a:schemeClr val="lt1"/>
+          </a:fontRef>
+        </p:style>
+        <p:txBody>
+          <a:bodyPr rtlCol="0" anchor="ctr"/>
+          <a:lstStyle/>
+          <a:p>
+            <a:pPr algn="ctr"/>
+          </a:p>
+        </p:txBody>
+      </p:sp>
+      <p:sp>
+        <p:nvSpPr>
+          <p:cNvPr id="41" name="Rectangle 40"/>
+          <p:cNvSpPr/>
+          <p:nvPr/>
+        </p:nvSpPr>
+        <p:spPr>
+          <a:xfrm>
+            <a:off x="5446165" y="3575304"/>
+            <a:ext cx="16459" cy="29260"/>
+          </a:xfrm>
+          <a:prstGeom prst="rect">
+            <a:avLst/>
+          </a:prstGeom>
+          <a:solidFill>
+            <a:srgbClr val="00C8F0"/>
+          </a:solidFill>
+          <a:ln>
+            <a:noFill/>
+          </a:ln>
+        </p:spPr>
+        <p:style>
+          <a:lnRef idx="1">
+            <a:schemeClr val="accent1"/>
+          </a:lnRef>
+          <a:fillRef idx="3">
+            <a:schemeClr val="accent1"/>
+          </a:fillRef>
+          <a:effectRef idx="2">
+            <a:schemeClr val="accent1"/>
+          </a:effectRef>
+          <a:fontRef idx="minor">
+            <a:schemeClr val="lt1"/>
+          </a:fontRef>
+        </p:style>
+        <p:txBody>
+          <a:bodyPr rtlCol="0" anchor="ctr"/>
+          <a:lstStyle/>
+          <a:p>
+            <a:pPr algn="ctr"/>
+          </a:p>
+        </p:txBody>
+      </p:sp>
+      <p:sp>
+        <p:nvSpPr>
+          <p:cNvPr id="42" name="Rectangle 41"/>
+          <p:cNvSpPr/>
+          <p:nvPr/>
+        </p:nvSpPr>
+        <p:spPr>
+          <a:xfrm>
+            <a:off x="5471768" y="3575304"/>
+            <a:ext cx="16459" cy="29260"/>
+          </a:xfrm>
+          <a:prstGeom prst="rect">
+            <a:avLst/>
+          </a:prstGeom>
+          <a:solidFill>
+            <a:srgbClr val="00C8F0"/>
+          </a:solidFill>
+          <a:ln>
+            <a:noFill/>
+          </a:ln>
+        </p:spPr>
+        <p:style>
+          <a:lnRef idx="1">
+            <a:schemeClr val="accent1"/>
+          </a:lnRef>
+          <a:fillRef idx="3">
+            <a:schemeClr val="accent1"/>
+          </a:fillRef>
+          <a:effectRef idx="2">
+            <a:schemeClr val="accent1"/>
+          </a:effectRef>
+          <a:fontRef idx="minor">
+            <a:schemeClr val="lt1"/>
+          </a:fontRef>
+        </p:style>
+        <p:txBody>
+          <a:bodyPr rtlCol="0" anchor="ctr"/>
+          <a:lstStyle/>
+          <a:p>
+            <a:pPr algn="ctr"/>
+          </a:p>
+        </p:txBody>
+      </p:sp>
+      <p:sp>
+        <p:nvSpPr>
+          <p:cNvPr id="43" name="Rounded Rectangle 42"/>
+          <p:cNvSpPr/>
+          <p:nvPr/>
+        </p:nvSpPr>
+        <p:spPr>
+          <a:xfrm>
+            <a:off x="5541264" y="2057400"/>
+            <a:ext cx="1554480" cy="3063240"/>
           </a:xfrm>
           <a:prstGeom prst="roundRect">
             <a:avLst/>
           </a:prstGeom>
           <a:solidFill>
-            <a:srgbClr val="0E2A4A"/>
+            <a:srgbClr val="0F2845"/>
           </a:solidFill>
           <a:ln>
             <a:noFill/>
@@ -23639,20 +23534,20 @@
       </p:sp>
       <p:sp>
         <p:nvSpPr>
-          <p:cNvPr id="47" name="Rectangle 46"/>
-          <p:cNvSpPr/>
-          <p:nvPr/>
-        </p:nvSpPr>
-        <p:spPr>
-          <a:xfrm>
-            <a:off x="320040" y="6400800"/>
-            <a:ext cx="45720" cy="310896"/>
+          <p:cNvPr id="44" name="Rectangle 43"/>
+          <p:cNvSpPr/>
+          <p:nvPr/>
+        </p:nvSpPr>
+        <p:spPr>
+          <a:xfrm>
+            <a:off x="5541264" y="2057400"/>
+            <a:ext cx="1554480" cy="50292"/>
           </a:xfrm>
           <a:prstGeom prst="rect">
             <a:avLst/>
           </a:prstGeom>
           <a:solidFill>
-            <a:srgbClr val="00A89A"/>
+            <a:srgbClr val="8B5CF6"/>
           </a:solidFill>
           <a:ln>
             <a:noFill/>
@@ -23682,14 +23577,57 @@
       </p:sp>
       <p:sp>
         <p:nvSpPr>
-          <p:cNvPr id="48" name="TextBox 47"/>
+          <p:cNvPr id="45" name="Oval 44"/>
+          <p:cNvSpPr/>
+          <p:nvPr/>
+        </p:nvSpPr>
+        <p:spPr>
+          <a:xfrm>
+            <a:off x="6053328" y="2350008"/>
+            <a:ext cx="530352" cy="530352"/>
+          </a:xfrm>
+          <a:prstGeom prst="ellipse">
+            <a:avLst/>
+          </a:prstGeom>
+          <a:solidFill>
+            <a:srgbClr val="8B5CF6"/>
+          </a:solidFill>
+          <a:ln>
+            <a:noFill/>
+          </a:ln>
+        </p:spPr>
+        <p:style>
+          <a:lnRef idx="1">
+            <a:schemeClr val="accent1"/>
+          </a:lnRef>
+          <a:fillRef idx="3">
+            <a:schemeClr val="accent1"/>
+          </a:fillRef>
+          <a:effectRef idx="2">
+            <a:schemeClr val="accent1"/>
+          </a:effectRef>
+          <a:fontRef idx="minor">
+            <a:schemeClr val="lt1"/>
+          </a:fontRef>
+        </p:style>
+        <p:txBody>
+          <a:bodyPr rtlCol="0" anchor="ctr"/>
+          <a:lstStyle/>
+          <a:p>
+            <a:pPr algn="ctr"/>
+          </a:p>
+        </p:txBody>
+      </p:sp>
+      <p:sp>
+        <p:nvSpPr>
+          <p:cNvPr id="46" name="TextBox 45"/>
           <p:cNvSpPr txBox="1"/>
           <p:nvPr/>
         </p:nvSpPr>
         <p:spPr>
           <a:xfrm>
-            <a:off x="502920" y="6400800"/>
-            <a:ext cx="8229600" cy="310896"/>
+            <a:off x="6053328" y="2478024"/>
+            <a:ext cx="530352" cy="109728"/>
           </a:xfrm>
           <a:prstGeom prst="rect">
             <a:avLst/>
@@ -23704,9 +23642,692 @@
           <a:p>
             <a:pPr algn="ctr"/>
             <a:r>
-              <a:rPr sz="1000" b="1" i="0">
+              <a:rPr sz="1200" b="1" i="0">
                 <a:solidFill>
-                  <a:srgbClr val="00A89A"/>
+                  <a:srgbClr val="FFFFFF"/>
+                </a:solidFill>
+                <a:latin typeface="Segoe UI"/>
+              </a:rPr>
+              <a:t>4</a:t>
+            </a:r>
+          </a:p>
+        </p:txBody>
+      </p:sp>
+      <p:sp>
+        <p:nvSpPr>
+          <p:cNvPr id="47" name="TextBox 46"/>
+          <p:cNvSpPr txBox="1"/>
+          <p:nvPr/>
+        </p:nvSpPr>
+        <p:spPr>
+          <a:xfrm>
+            <a:off x="5650992" y="3017520"/>
+            <a:ext cx="1335024" cy="320040"/>
+          </a:xfrm>
+          <a:prstGeom prst="rect">
+            <a:avLst/>
+          </a:prstGeom>
+          <a:noFill/>
+        </p:spPr>
+        <p:txBody>
+          <a:bodyPr wrap="square" lIns="36576" rIns="36576" tIns="18288" bIns="18288">
+            <a:spAutoFit/>
+          </a:bodyPr>
+          <a:lstStyle/>
+          <a:p>
+            <a:pPr algn="ctr"/>
+            <a:r>
+              <a:rPr sz="1050" b="1" i="0">
+                <a:solidFill>
+                  <a:srgbClr val="8B5CF6"/>
+                </a:solidFill>
+                <a:latin typeface="Segoe UI"/>
+              </a:rPr>
+              <a:t>PG3 Firmware</a:t>
+            </a:r>
+          </a:p>
+        </p:txBody>
+      </p:sp>
+      <p:sp>
+        <p:nvSpPr>
+          <p:cNvPr id="48" name="Rectangle 47"/>
+          <p:cNvSpPr/>
+          <p:nvPr/>
+        </p:nvSpPr>
+        <p:spPr>
+          <a:xfrm>
+            <a:off x="5705856" y="3383280"/>
+            <a:ext cx="1225296" cy="12801"/>
+          </a:xfrm>
+          <a:prstGeom prst="rect">
+            <a:avLst/>
+          </a:prstGeom>
+          <a:solidFill>
+            <a:srgbClr val="8B5CF6"/>
+          </a:solidFill>
+          <a:ln>
+            <a:noFill/>
+          </a:ln>
+        </p:spPr>
+        <p:style>
+          <a:lnRef idx="1">
+            <a:schemeClr val="accent1"/>
+          </a:lnRef>
+          <a:fillRef idx="3">
+            <a:schemeClr val="accent1"/>
+          </a:fillRef>
+          <a:effectRef idx="2">
+            <a:schemeClr val="accent1"/>
+          </a:effectRef>
+          <a:fontRef idx="minor">
+            <a:schemeClr val="lt1"/>
+          </a:fontRef>
+        </p:style>
+        <p:txBody>
+          <a:bodyPr rtlCol="0" anchor="ctr"/>
+          <a:lstStyle/>
+          <a:p>
+            <a:pPr algn="ctr"/>
+          </a:p>
+        </p:txBody>
+      </p:sp>
+      <p:sp>
+        <p:nvSpPr>
+          <p:cNvPr id="49" name="TextBox 48"/>
+          <p:cNvSpPr txBox="1"/>
+          <p:nvPr/>
+        </p:nvSpPr>
+        <p:spPr>
+          <a:xfrm>
+            <a:off x="5669280" y="3538728"/>
+            <a:ext cx="1298448" cy="1078992"/>
+          </a:xfrm>
+          <a:prstGeom prst="rect">
+            <a:avLst/>
+          </a:prstGeom>
+          <a:noFill/>
+        </p:spPr>
+        <p:txBody>
+          <a:bodyPr wrap="square" lIns="36576" rIns="36576" tIns="18288" bIns="18288">
+            <a:spAutoFit/>
+          </a:bodyPr>
+          <a:lstStyle/>
+          <a:p>
+            <a:pPr algn="ctr"/>
+            <a:r>
+              <a:rPr sz="840" b="0" i="0">
+                <a:solidFill>
+                  <a:srgbClr val="B8D0EC"/>
+                </a:solidFill>
+                <a:latin typeface="Segoe UI"/>
+              </a:rPr>
+              <a:t>Datasheet + PRD + SDK/BSP + OS/RTOS context generate and validate firmware/code.</a:t>
+            </a:r>
+          </a:p>
+        </p:txBody>
+      </p:sp>
+      <p:sp>
+        <p:nvSpPr>
+          <p:cNvPr id="50" name="Rectangle 49"/>
+          <p:cNvSpPr/>
+          <p:nvPr/>
+        </p:nvSpPr>
+        <p:spPr>
+          <a:xfrm>
+            <a:off x="7114032" y="3575304"/>
+            <a:ext cx="16459" cy="29260"/>
+          </a:xfrm>
+          <a:prstGeom prst="rect">
+            <a:avLst/>
+          </a:prstGeom>
+          <a:solidFill>
+            <a:srgbClr val="00C8F0"/>
+          </a:solidFill>
+          <a:ln>
+            <a:noFill/>
+          </a:ln>
+        </p:spPr>
+        <p:style>
+          <a:lnRef idx="1">
+            <a:schemeClr val="accent1"/>
+          </a:lnRef>
+          <a:fillRef idx="3">
+            <a:schemeClr val="accent1"/>
+          </a:fillRef>
+          <a:effectRef idx="2">
+            <a:schemeClr val="accent1"/>
+          </a:effectRef>
+          <a:fontRef idx="minor">
+            <a:schemeClr val="lt1"/>
+          </a:fontRef>
+        </p:style>
+        <p:txBody>
+          <a:bodyPr rtlCol="0" anchor="ctr"/>
+          <a:lstStyle/>
+          <a:p>
+            <a:pPr algn="ctr"/>
+          </a:p>
+        </p:txBody>
+      </p:sp>
+      <p:sp>
+        <p:nvSpPr>
+          <p:cNvPr id="51" name="Rectangle 50"/>
+          <p:cNvSpPr/>
+          <p:nvPr/>
+        </p:nvSpPr>
+        <p:spPr>
+          <a:xfrm>
+            <a:off x="7139635" y="3575304"/>
+            <a:ext cx="16459" cy="29260"/>
+          </a:xfrm>
+          <a:prstGeom prst="rect">
+            <a:avLst/>
+          </a:prstGeom>
+          <a:solidFill>
+            <a:srgbClr val="00C8F0"/>
+          </a:solidFill>
+          <a:ln>
+            <a:noFill/>
+          </a:ln>
+        </p:spPr>
+        <p:style>
+          <a:lnRef idx="1">
+            <a:schemeClr val="accent1"/>
+          </a:lnRef>
+          <a:fillRef idx="3">
+            <a:schemeClr val="accent1"/>
+          </a:fillRef>
+          <a:effectRef idx="2">
+            <a:schemeClr val="accent1"/>
+          </a:effectRef>
+          <a:fontRef idx="minor">
+            <a:schemeClr val="lt1"/>
+          </a:fontRef>
+        </p:style>
+        <p:txBody>
+          <a:bodyPr rtlCol="0" anchor="ctr"/>
+          <a:lstStyle/>
+          <a:p>
+            <a:pPr algn="ctr"/>
+          </a:p>
+        </p:txBody>
+      </p:sp>
+      <p:sp>
+        <p:nvSpPr>
+          <p:cNvPr id="52" name="Rectangle 51"/>
+          <p:cNvSpPr/>
+          <p:nvPr/>
+        </p:nvSpPr>
+        <p:spPr>
+          <a:xfrm>
+            <a:off x="7165238" y="3575304"/>
+            <a:ext cx="16459" cy="29260"/>
+          </a:xfrm>
+          <a:prstGeom prst="rect">
+            <a:avLst/>
+          </a:prstGeom>
+          <a:solidFill>
+            <a:srgbClr val="00C8F0"/>
+          </a:solidFill>
+          <a:ln>
+            <a:noFill/>
+          </a:ln>
+        </p:spPr>
+        <p:style>
+          <a:lnRef idx="1">
+            <a:schemeClr val="accent1"/>
+          </a:lnRef>
+          <a:fillRef idx="3">
+            <a:schemeClr val="accent1"/>
+          </a:fillRef>
+          <a:effectRef idx="2">
+            <a:schemeClr val="accent1"/>
+          </a:effectRef>
+          <a:fontRef idx="minor">
+            <a:schemeClr val="lt1"/>
+          </a:fontRef>
+        </p:style>
+        <p:txBody>
+          <a:bodyPr rtlCol="0" anchor="ctr"/>
+          <a:lstStyle/>
+          <a:p>
+            <a:pPr algn="ctr"/>
+          </a:p>
+        </p:txBody>
+      </p:sp>
+      <p:sp>
+        <p:nvSpPr>
+          <p:cNvPr id="53" name="Rectangle 52"/>
+          <p:cNvSpPr/>
+          <p:nvPr/>
+        </p:nvSpPr>
+        <p:spPr>
+          <a:xfrm>
+            <a:off x="7190841" y="3575304"/>
+            <a:ext cx="16459" cy="29260"/>
+          </a:xfrm>
+          <a:prstGeom prst="rect">
+            <a:avLst/>
+          </a:prstGeom>
+          <a:solidFill>
+            <a:srgbClr val="00C8F0"/>
+          </a:solidFill>
+          <a:ln>
+            <a:noFill/>
+          </a:ln>
+        </p:spPr>
+        <p:style>
+          <a:lnRef idx="1">
+            <a:schemeClr val="accent1"/>
+          </a:lnRef>
+          <a:fillRef idx="3">
+            <a:schemeClr val="accent1"/>
+          </a:fillRef>
+          <a:effectRef idx="2">
+            <a:schemeClr val="accent1"/>
+          </a:effectRef>
+          <a:fontRef idx="minor">
+            <a:schemeClr val="lt1"/>
+          </a:fontRef>
+        </p:style>
+        <p:txBody>
+          <a:bodyPr rtlCol="0" anchor="ctr"/>
+          <a:lstStyle/>
+          <a:p>
+            <a:pPr algn="ctr"/>
+          </a:p>
+        </p:txBody>
+      </p:sp>
+      <p:sp>
+        <p:nvSpPr>
+          <p:cNvPr id="54" name="Rounded Rectangle 53"/>
+          <p:cNvSpPr/>
+          <p:nvPr/>
+        </p:nvSpPr>
+        <p:spPr>
+          <a:xfrm>
+            <a:off x="7260336" y="2057400"/>
+            <a:ext cx="1554480" cy="3063240"/>
+          </a:xfrm>
+          <a:prstGeom prst="roundRect">
+            <a:avLst/>
+          </a:prstGeom>
+          <a:solidFill>
+            <a:srgbClr val="0F2845"/>
+          </a:solidFill>
+          <a:ln>
+            <a:noFill/>
+          </a:ln>
+        </p:spPr>
+        <p:style>
+          <a:lnRef idx="1">
+            <a:schemeClr val="accent1"/>
+          </a:lnRef>
+          <a:fillRef idx="3">
+            <a:schemeClr val="accent1"/>
+          </a:fillRef>
+          <a:effectRef idx="2">
+            <a:schemeClr val="accent1"/>
+          </a:effectRef>
+          <a:fontRef idx="minor">
+            <a:schemeClr val="lt1"/>
+          </a:fontRef>
+        </p:style>
+        <p:txBody>
+          <a:bodyPr rtlCol="0" anchor="ctr"/>
+          <a:lstStyle/>
+          <a:p>
+            <a:pPr algn="ctr"/>
+          </a:p>
+        </p:txBody>
+      </p:sp>
+      <p:sp>
+        <p:nvSpPr>
+          <p:cNvPr id="55" name="Rectangle 54"/>
+          <p:cNvSpPr/>
+          <p:nvPr/>
+        </p:nvSpPr>
+        <p:spPr>
+          <a:xfrm>
+            <a:off x="7260336" y="2057400"/>
+            <a:ext cx="1554480" cy="50292"/>
+          </a:xfrm>
+          <a:prstGeom prst="rect">
+            <a:avLst/>
+          </a:prstGeom>
+          <a:solidFill>
+            <a:srgbClr val="00D48A"/>
+          </a:solidFill>
+          <a:ln>
+            <a:noFill/>
+          </a:ln>
+        </p:spPr>
+        <p:style>
+          <a:lnRef idx="1">
+            <a:schemeClr val="accent1"/>
+          </a:lnRef>
+          <a:fillRef idx="3">
+            <a:schemeClr val="accent1"/>
+          </a:fillRef>
+          <a:effectRef idx="2">
+            <a:schemeClr val="accent1"/>
+          </a:effectRef>
+          <a:fontRef idx="minor">
+            <a:schemeClr val="lt1"/>
+          </a:fontRef>
+        </p:style>
+        <p:txBody>
+          <a:bodyPr rtlCol="0" anchor="ctr"/>
+          <a:lstStyle/>
+          <a:p>
+            <a:pPr algn="ctr"/>
+          </a:p>
+        </p:txBody>
+      </p:sp>
+      <p:sp>
+        <p:nvSpPr>
+          <p:cNvPr id="56" name="Oval 55"/>
+          <p:cNvSpPr/>
+          <p:nvPr/>
+        </p:nvSpPr>
+        <p:spPr>
+          <a:xfrm>
+            <a:off x="7772400" y="2350008"/>
+            <a:ext cx="530352" cy="530352"/>
+          </a:xfrm>
+          <a:prstGeom prst="ellipse">
+            <a:avLst/>
+          </a:prstGeom>
+          <a:solidFill>
+            <a:srgbClr val="00D48A"/>
+          </a:solidFill>
+          <a:ln>
+            <a:noFill/>
+          </a:ln>
+        </p:spPr>
+        <p:style>
+          <a:lnRef idx="1">
+            <a:schemeClr val="accent1"/>
+          </a:lnRef>
+          <a:fillRef idx="3">
+            <a:schemeClr val="accent1"/>
+          </a:fillRef>
+          <a:effectRef idx="2">
+            <a:schemeClr val="accent1"/>
+          </a:effectRef>
+          <a:fontRef idx="minor">
+            <a:schemeClr val="lt1"/>
+          </a:fontRef>
+        </p:style>
+        <p:txBody>
+          <a:bodyPr rtlCol="0" anchor="ctr"/>
+          <a:lstStyle/>
+          <a:p>
+            <a:pPr algn="ctr"/>
+          </a:p>
+        </p:txBody>
+      </p:sp>
+      <p:sp>
+        <p:nvSpPr>
+          <p:cNvPr id="57" name="TextBox 56"/>
+          <p:cNvSpPr txBox="1"/>
+          <p:nvPr/>
+        </p:nvSpPr>
+        <p:spPr>
+          <a:xfrm>
+            <a:off x="7772400" y="2478024"/>
+            <a:ext cx="530352" cy="109728"/>
+          </a:xfrm>
+          <a:prstGeom prst="rect">
+            <a:avLst/>
+          </a:prstGeom>
+          <a:noFill/>
+        </p:spPr>
+        <p:txBody>
+          <a:bodyPr wrap="square" lIns="36576" rIns="36576" tIns="18288" bIns="18288">
+            <a:spAutoFit/>
+          </a:bodyPr>
+          <a:lstStyle/>
+          <a:p>
+            <a:pPr algn="ctr"/>
+            <a:r>
+              <a:rPr sz="1200" b="1" i="0">
+                <a:solidFill>
+                  <a:srgbClr val="FFFFFF"/>
+                </a:solidFill>
+                <a:latin typeface="Segoe UI"/>
+              </a:rPr>
+              <a:t>5</a:t>
+            </a:r>
+          </a:p>
+        </p:txBody>
+      </p:sp>
+      <p:sp>
+        <p:nvSpPr>
+          <p:cNvPr id="58" name="TextBox 57"/>
+          <p:cNvSpPr txBox="1"/>
+          <p:nvPr/>
+        </p:nvSpPr>
+        <p:spPr>
+          <a:xfrm>
+            <a:off x="7370064" y="3017520"/>
+            <a:ext cx="1335024" cy="320040"/>
+          </a:xfrm>
+          <a:prstGeom prst="rect">
+            <a:avLst/>
+          </a:prstGeom>
+          <a:noFill/>
+        </p:spPr>
+        <p:txBody>
+          <a:bodyPr wrap="square" lIns="36576" rIns="36576" tIns="18288" bIns="18288">
+            <a:spAutoFit/>
+          </a:bodyPr>
+          <a:lstStyle/>
+          <a:p>
+            <a:pPr algn="ctr"/>
+            <a:r>
+              <a:rPr sz="1050" b="1" i="0">
+                <a:solidFill>
+                  <a:srgbClr val="00D48A"/>
+                </a:solidFill>
+                <a:latin typeface="Segoe UI"/>
+              </a:rPr>
+              <a:t>QA Closed Loop</a:t>
+            </a:r>
+          </a:p>
+        </p:txBody>
+      </p:sp>
+      <p:sp>
+        <p:nvSpPr>
+          <p:cNvPr id="59" name="Rectangle 58"/>
+          <p:cNvSpPr/>
+          <p:nvPr/>
+        </p:nvSpPr>
+        <p:spPr>
+          <a:xfrm>
+            <a:off x="7424928" y="3383280"/>
+            <a:ext cx="1225296" cy="12801"/>
+          </a:xfrm>
+          <a:prstGeom prst="rect">
+            <a:avLst/>
+          </a:prstGeom>
+          <a:solidFill>
+            <a:srgbClr val="00D48A"/>
+          </a:solidFill>
+          <a:ln>
+            <a:noFill/>
+          </a:ln>
+        </p:spPr>
+        <p:style>
+          <a:lnRef idx="1">
+            <a:schemeClr val="accent1"/>
+          </a:lnRef>
+          <a:fillRef idx="3">
+            <a:schemeClr val="accent1"/>
+          </a:fillRef>
+          <a:effectRef idx="2">
+            <a:schemeClr val="accent1"/>
+          </a:effectRef>
+          <a:fontRef idx="minor">
+            <a:schemeClr val="lt1"/>
+          </a:fontRef>
+        </p:style>
+        <p:txBody>
+          <a:bodyPr rtlCol="0" anchor="ctr"/>
+          <a:lstStyle/>
+          <a:p>
+            <a:pPr algn="ctr"/>
+          </a:p>
+        </p:txBody>
+      </p:sp>
+      <p:sp>
+        <p:nvSpPr>
+          <p:cNvPr id="60" name="TextBox 59"/>
+          <p:cNvSpPr txBox="1"/>
+          <p:nvPr/>
+        </p:nvSpPr>
+        <p:spPr>
+          <a:xfrm>
+            <a:off x="7388352" y="3538728"/>
+            <a:ext cx="1298448" cy="1078992"/>
+          </a:xfrm>
+          <a:prstGeom prst="rect">
+            <a:avLst/>
+          </a:prstGeom>
+          <a:noFill/>
+        </p:spPr>
+        <p:txBody>
+          <a:bodyPr wrap="square" lIns="36576" rIns="36576" tIns="18288" bIns="18288">
+            <a:spAutoFit/>
+          </a:bodyPr>
+          <a:lstStyle/>
+          <a:p>
+            <a:pPr algn="ctr"/>
+            <a:r>
+              <a:rPr sz="840" b="0" i="0">
+                <a:solidFill>
+                  <a:srgbClr val="B8D0EC"/>
+                </a:solidFill>
+                <a:latin typeface="Segoe UI"/>
+              </a:rPr>
+              <a:t>QA inputs, PRD and JTAG evidence produce READY / NOT_READY; gaps become next-release priorities.</a:t>
+            </a:r>
+          </a:p>
+        </p:txBody>
+      </p:sp>
+      <p:sp>
+        <p:nvSpPr>
+          <p:cNvPr id="61" name="Rounded Rectangle 60"/>
+          <p:cNvSpPr/>
+          <p:nvPr/>
+        </p:nvSpPr>
+        <p:spPr>
+          <a:xfrm>
+            <a:off x="320040" y="6144768"/>
+            <a:ext cx="8503920" cy="310896"/>
+          </a:xfrm>
+          <a:prstGeom prst="roundRect">
+            <a:avLst/>
+          </a:prstGeom>
+          <a:solidFill>
+            <a:srgbClr val="0E2A4A"/>
+          </a:solidFill>
+          <a:ln>
+            <a:noFill/>
+          </a:ln>
+        </p:spPr>
+        <p:style>
+          <a:lnRef idx="1">
+            <a:schemeClr val="accent1"/>
+          </a:lnRef>
+          <a:fillRef idx="3">
+            <a:schemeClr val="accent1"/>
+          </a:fillRef>
+          <a:effectRef idx="2">
+            <a:schemeClr val="accent1"/>
+          </a:effectRef>
+          <a:fontRef idx="minor">
+            <a:schemeClr val="lt1"/>
+          </a:fontRef>
+        </p:style>
+        <p:txBody>
+          <a:bodyPr rtlCol="0" anchor="ctr"/>
+          <a:lstStyle/>
+          <a:p>
+            <a:pPr algn="ctr"/>
+          </a:p>
+        </p:txBody>
+      </p:sp>
+      <p:sp>
+        <p:nvSpPr>
+          <p:cNvPr id="62" name="Rectangle 61"/>
+          <p:cNvSpPr/>
+          <p:nvPr/>
+        </p:nvSpPr>
+        <p:spPr>
+          <a:xfrm>
+            <a:off x="320040" y="6144768"/>
+            <a:ext cx="45720" cy="310896"/>
+          </a:xfrm>
+          <a:prstGeom prst="rect">
+            <a:avLst/>
+          </a:prstGeom>
+          <a:solidFill>
+            <a:srgbClr val="0072C6"/>
+          </a:solidFill>
+          <a:ln>
+            <a:noFill/>
+          </a:ln>
+        </p:spPr>
+        <p:style>
+          <a:lnRef idx="1">
+            <a:schemeClr val="accent1"/>
+          </a:lnRef>
+          <a:fillRef idx="3">
+            <a:schemeClr val="accent1"/>
+          </a:fillRef>
+          <a:effectRef idx="2">
+            <a:schemeClr val="accent1"/>
+          </a:effectRef>
+          <a:fontRef idx="minor">
+            <a:schemeClr val="lt1"/>
+          </a:fontRef>
+        </p:style>
+        <p:txBody>
+          <a:bodyPr rtlCol="0" anchor="ctr"/>
+          <a:lstStyle/>
+          <a:p>
+            <a:pPr algn="ctr"/>
+          </a:p>
+        </p:txBody>
+      </p:sp>
+      <p:sp>
+        <p:nvSpPr>
+          <p:cNvPr id="63" name="TextBox 62"/>
+          <p:cNvSpPr txBox="1"/>
+          <p:nvPr/>
+        </p:nvSpPr>
+        <p:spPr>
+          <a:xfrm>
+            <a:off x="502920" y="6144768"/>
+            <a:ext cx="8229600" cy="310896"/>
+          </a:xfrm>
+          <a:prstGeom prst="rect">
+            <a:avLst/>
+          </a:prstGeom>
+          <a:noFill/>
+        </p:spPr>
+        <p:txBody>
+          <a:bodyPr wrap="square" lIns="36576" rIns="36576" tIns="18288" bIns="18288">
+            <a:spAutoFit/>
+          </a:bodyPr>
+          <a:lstStyle/>
+          <a:p>
+            <a:pPr algn="ctr"/>
+            <a:r>
+              <a:rPr sz="930" b="1" i="0">
+                <a:solidFill>
+                  <a:srgbClr val="00C8F0"/>
                 </a:solidFill>
                 <a:latin typeface="Segoe UI"/>
               </a:rPr>
@@ -23717,13 +24338,56 @@
       </p:sp>
       <p:sp>
         <p:nvSpPr>
-          <p:cNvPr id="49" name="TextBox 48"/>
+          <p:cNvPr id="64" name="Rectangle 63"/>
+          <p:cNvSpPr/>
+          <p:nvPr/>
+        </p:nvSpPr>
+        <p:spPr>
+          <a:xfrm>
+            <a:off x="0" y="6473952"/>
+            <a:ext cx="9144000" cy="384048"/>
+          </a:xfrm>
+          <a:prstGeom prst="rect">
+            <a:avLst/>
+          </a:prstGeom>
+          <a:solidFill>
+            <a:srgbClr val="0E2A4A"/>
+          </a:solidFill>
+          <a:ln>
+            <a:noFill/>
+          </a:ln>
+        </p:spPr>
+        <p:style>
+          <a:lnRef idx="1">
+            <a:schemeClr val="accent1"/>
+          </a:lnRef>
+          <a:fillRef idx="3">
+            <a:schemeClr val="accent1"/>
+          </a:fillRef>
+          <a:effectRef idx="2">
+            <a:schemeClr val="accent1"/>
+          </a:effectRef>
+          <a:fontRef idx="minor">
+            <a:schemeClr val="lt1"/>
+          </a:fontRef>
+        </p:style>
+        <p:txBody>
+          <a:bodyPr rtlCol="0" anchor="ctr"/>
+          <a:lstStyle/>
+          <a:p>
+            <a:pPr algn="ctr"/>
+          </a:p>
+        </p:txBody>
+      </p:sp>
+      <p:sp>
+        <p:nvSpPr>
+          <p:cNvPr id="65" name="TextBox 64"/>
           <p:cNvSpPr txBox="1"/>
           <p:nvPr/>
         </p:nvSpPr>
         <p:spPr>
           <a:xfrm>
-            <a:off x="8275320" y="6556248"/>
+            <a:off x="8275320" y="6565392"/>
             <a:ext cx="411480" cy="146304"/>
           </a:xfrm>
           <a:prstGeom prst="rect">
@@ -23752,13 +24416,13 @@
       </p:sp>
       <p:sp>
         <p:nvSpPr>
-          <p:cNvPr id="50" name="TextBox 49"/>
+          <p:cNvPr id="66" name="TextBox 65"/>
           <p:cNvSpPr txBox="1"/>
           <p:nvPr/>
         </p:nvSpPr>
         <p:spPr>
           <a:xfrm>
-            <a:off x="7406640" y="6556248"/>
+            <a:off x="7406640" y="6565392"/>
             <a:ext cx="777240" cy="146304"/>
           </a:xfrm>
           <a:prstGeom prst="rect">

</xml_diff>

<commit_message>
V10 slide and speaker note updated
</commit_message>
<xml_diff>
--- a/AI-Driven Embedded Product Lifecycle OrchestratorV10.pptx
+++ b/AI-Driven Embedded Product Lifecycle OrchestratorV10.pptx
@@ -5,17 +5,17 @@
     <p:sldMasterId id="2147483648" r:id="rId4"/>
   </p:sldMasterIdLst>
   <p:notesMasterIdLst>
-    <p:notesMasterId r:id="rId14"/>
+    <p:notesMasterId r:id="rId10"/>
   </p:notesMasterIdLst>
   <p:handoutMasterIdLst>
-    <p:handoutMasterId r:id="rId15"/>
+    <p:handoutMasterId r:id="rId11"/>
   </p:handoutMasterIdLst>
   <p:sldIdLst>
     <p:sldId id="268" r:id="rId5"/>
     <p:sldId id="257" r:id="rId6"/>
-    <p:sldId id="270" r:id="rId10"/>
-    <p:sldId id="263" r:id="rId12"/>
-    <p:sldId id="269" r:id="rId13"/>
+    <p:sldId id="270" r:id="rId7"/>
+    <p:sldId id="263" r:id="rId8"/>
+    <p:sldId id="269" r:id="rId9"/>
   </p:sldIdLst>
   <p:sldSz cx="9144000" cy="6858000" type="screen4x3"/>
   <p:notesSz cx="6858000" cy="9144000"/>
@@ -744,7 +744,7 @@
                 <a:ea typeface="+mn-ea"/>
                 <a:cs typeface="+mn-cs"/>
               </a:rPr>
-              <a:t>Today we are presenting the AEPLO JTAG Accelerator for</a:t>
+              <a:t>"Today we are showing AEPLO, the AI-driven embedded product lifecycle</a:t>
             </a:r>
           </a:p>
           <a:p>
@@ -758,7 +758,7 @@
                 <a:ea typeface="+mn-ea"/>
                 <a:cs typeface="+mn-cs"/>
               </a:rPr>
-              <a:t>Embedded PDLC AI Optimization. The story is simple: connect</a:t>
+              <a:t>orchestrator. The 3-minute story is PRD to firmware, firmware to JTAG</a:t>
             </a:r>
           </a:p>
           <a:p>
@@ -772,12 +772,12 @@
                 <a:ea typeface="+mn-ea"/>
                 <a:cs typeface="+mn-cs"/>
               </a:rPr>
-              <a:t>planning data, code, AI assistance, and JTAG evidence so we</a:t>
+              <a:t>evidence, evidence to QA release readiness, and finally STQC submission</a:t>
             </a:r>
           </a:p>
           <a:p>
             <a:r>
-              <a:rPr lang="en-US" sz="1200" b="0" i="0" kern="1200" dirty="0">
+              <a:rPr lang="en-US" sz="1200" b="0" i="0" kern="1200">
                 <a:solidFill>
                   <a:schemeClr val="tx1"/>
                 </a:solidFill>
@@ -786,7 +786,7 @@
                 <a:ea typeface="+mn-ea"/>
                 <a:cs typeface="+mn-cs"/>
               </a:rPr>
-              <a:t>can move faster from discovery to validated launch readiness.</a:t>
+              <a:t>readiness for regulated IoT security and surveillance products."</a:t>
             </a:r>
             <a:endParaRPr lang="en-US" dirty="0"/>
           </a:p>
@@ -961,33 +961,62 @@
           <a:lstStyle/>
           <a:p>
             <a:r>
-              <a:rPr lang="en-US"/>
-              <a:t>Problem :</a:t>
+              <a:rPr lang="en-US" dirty="0"/>
+              <a:t>embedded PDLC data is</a:t>
             </a:r>
-            <a:br>
-              <a:rPr lang="en-US"/>
-            </a:br>
+          </a:p>
+          <a:p>
             <a:r>
-              <a:rPr lang="en-US"/>
-              <a:t>Embedded PDLC data is fragmented. Jira, Confluence, GitHub,</a:t>
+              <a:rPr lang="en-US" dirty="0"/>
+              <a:t>fragmented across Confluence, Jira, GitHub, QA and hardware evidence, and</a:t>
             </a:r>
           </a:p>
           <a:p>
             <a:r>
-              <a:rPr lang="en-US"/>
-              <a:t>QA results, and JTAG/SWD hardware evidence often sit in</a:t>
+              <a:rPr lang="en-US" dirty="0"/>
+              <a:t>AEPLO brings it into one orchestration layer. Then the  Confluence PRD,</a:t>
             </a:r>
           </a:p>
           <a:p>
             <a:r>
-              <a:rPr lang="en-US"/>
-              <a:t>separate places. That slows decisions across PG1, PG3, and PG5</a:t>
+              <a:rPr lang="en-US" dirty="0"/>
+              <a:t>guided by SDE Elements and PSJIRA, creates epics and stories. </a:t>
             </a:r>
           </a:p>
           <a:p>
             <a:r>
-              <a:rPr lang="en-US"/>
-              <a:t>and makes launch readiness harder to prove.</a:t>
+              <a:rPr lang="en-US" dirty="0"/>
+              <a:t>Next, the  user picks a story and creates a feature branch with PRD and QA context.</a:t>
+            </a:r>
+          </a:p>
+          <a:p>
+            <a:r>
+              <a:rPr lang="en-US" dirty="0"/>
+              <a:t>Next , at PG3, AEPLO generates firmware from the datasheet and PRD,</a:t>
+            </a:r>
+          </a:p>
+          <a:p>
+            <a:r>
+              <a:rPr lang="en-US" dirty="0"/>
+              <a:t>injecting SDK, BSP and OS or RTOS context, then validates it against the</a:t>
+            </a:r>
+          </a:p>
+          <a:p>
+            <a:r>
+              <a:rPr lang="en-US" dirty="0"/>
+              <a:t>datasheet and acceptance criteria. Finally, QA inputs, PRD criteria and</a:t>
+            </a:r>
+          </a:p>
+          <a:p>
+            <a:r>
+              <a:rPr lang="en-US" dirty="0"/>
+              <a:t>JTAG evidence produce READY or NOT_READY; NOT_READY becomes the priority</a:t>
+            </a:r>
+          </a:p>
+          <a:p>
+            <a:r>
+              <a:rPr lang="en-US" dirty="0"/>
+              <a:t>list for the next release loop.</a:t>
             </a:r>
           </a:p>
         </p:txBody>
@@ -1050,7 +1079,7 @@
 </p:notes>
 </file>
 
-<file path=ppt/notesSlides/notesSlide6.xml><?xml version="1.0" encoding="utf-8"?>
+<file path=ppt/notesSlides/notesSlide3.xml><?xml version="1.0" encoding="utf-8"?>
 <p:notes xmlns:a="http://schemas.openxmlformats.org/drawingml/2006/main" xmlns:r="http://schemas.openxmlformats.org/officeDocument/2006/relationships" xmlns:p="http://schemas.openxmlformats.org/presentationml/2006/main">
   <p:cSld>
     <p:spTree>
@@ -1096,126 +1125,51 @@
           <a:p>
             <a:r>
               <a:rPr lang="en-US" dirty="0"/>
-              <a:t>"This slide shows three real-time use cases for the JTAG agent.</a:t>
+              <a:t>" The JTAG  agent starts from a bug or</a:t>
             </a:r>
           </a:p>
           <a:p>
             <a:r>
               <a:rPr lang="en-US" dirty="0"/>
-              <a:t>First, a bootloader-to-application handoff caused a </a:t>
+              <a:t>story ticket, routes context to the JTAG orchestrator, connects to the</a:t>
+            </a:r>
+          </a:p>
+          <a:p>
+            <a:r>
+              <a:rPr lang="en-US" dirty="0"/>
+              <a:t>target MCU, and returns Git PR and Jira evidence. </a:t>
+            </a:r>
+          </a:p>
+          <a:p>
+            <a:r>
+              <a:rPr lang="en-US" dirty="0"/>
+              <a:t>In the demo we will  diagnose a</a:t>
+            </a:r>
+          </a:p>
+          <a:p>
+            <a:r>
+              <a:rPr lang="en-US" dirty="0"/>
+              <a:t>bootloader-to-application </a:t>
             </a:r>
             <a:r>
               <a:rPr lang="en-US" dirty="0" err="1"/>
               <a:t>HardFault</a:t>
             </a:r>
-            <a:endParaRPr lang="en-US" dirty="0"/>
-          </a:p>
-          <a:p>
             <a:r>
               <a:rPr lang="en-US" dirty="0"/>
-              <a:t>because </a:t>
+              <a:t> in 45 minutes, simulate sub-zero ADC</a:t>
             </a:r>
-            <a:r>
-              <a:rPr lang="en-US" dirty="0" err="1"/>
-              <a:t>SysTick</a:t>
-            </a:r>
+          </a:p>
+          <a:p>
             <a:r>
               <a:rPr lang="en-US" dirty="0"/>
-              <a:t> was enabled but the application vector table had</a:t>
+              <a:t>behavior at room temperature, and trace a boot failure to execution</a:t>
             </a:r>
           </a:p>
           <a:p>
             <a:r>
               <a:rPr lang="en-US" dirty="0"/>
-              <a:t>no </a:t>
-            </a:r>
-            <a:r>
-              <a:rPr lang="en-US" dirty="0" err="1"/>
-              <a:t>SysTick</a:t>
-            </a:r>
-            <a:r>
-              <a:rPr lang="en-US" dirty="0"/>
-              <a:t> handler. The agent correlated the PC, vector table,</a:t>
-            </a:r>
-          </a:p>
-          <a:p>
-            <a:r>
-              <a:rPr lang="en-US" dirty="0"/>
-              <a:t>and peripheral state and reduced diagnosis from days to about</a:t>
-            </a:r>
-          </a:p>
-          <a:p>
-            <a:r>
-              <a:rPr lang="en-US" dirty="0"/>
-              <a:t>45 minutes.</a:t>
-            </a:r>
-          </a:p>
-          <a:p>
-            <a:endParaRPr lang="en-US" dirty="0"/>
-          </a:p>
-          <a:p>
-            <a:r>
-              <a:rPr lang="en-US" dirty="0"/>
-              <a:t>Second, the agent emulated a sub-zero ADC condition at room</a:t>
-            </a:r>
-          </a:p>
-          <a:p>
-            <a:r>
-              <a:rPr lang="en-US" dirty="0"/>
-              <a:t>temperature. That allowed driver </a:t>
-            </a:r>
-            <a:r>
-              <a:rPr lang="en-US" dirty="0" err="1"/>
-              <a:t>reinitialisation</a:t>
-            </a:r>
-            <a:r>
-              <a:rPr lang="en-US" dirty="0"/>
-              <a:t> and gain</a:t>
-            </a:r>
-          </a:p>
-          <a:p>
-            <a:r>
-              <a:rPr lang="en-US" dirty="0"/>
-              <a:t>adjustment to be validated without waiting for thermal chamber</a:t>
-            </a:r>
-          </a:p>
-          <a:p>
-            <a:r>
-              <a:rPr lang="en-US" dirty="0"/>
-              <a:t>cycling.</a:t>
-            </a:r>
-          </a:p>
-          <a:p>
-            <a:endParaRPr lang="en-US" dirty="0"/>
-          </a:p>
-          <a:p>
-            <a:r>
-              <a:rPr lang="en-US" dirty="0"/>
-              <a:t>Third, for a boot failure after flashing a new build, the agent</a:t>
-            </a:r>
-          </a:p>
-          <a:p>
-            <a:r>
-              <a:rPr lang="en-US" dirty="0"/>
-              <a:t>traced the Program Counter and identified execution going to</a:t>
-            </a:r>
-          </a:p>
-          <a:p>
-            <a:r>
-              <a:rPr lang="en-US" dirty="0"/>
-              <a:t>system ROM instead of internal flash. The key message is that</a:t>
-            </a:r>
-          </a:p>
-          <a:p>
-            <a:r>
-              <a:rPr lang="en-US" dirty="0"/>
-              <a:t>JTAG evidence becomes actionable AI context, not just a debug</a:t>
-            </a:r>
-          </a:p>
-          <a:p>
-            <a:r>
-              <a:rPr lang="en-US" dirty="0"/>
-              <a:t>artifact."</a:t>
+              <a:t>redirecting to system ROM instead of internal flash."</a:t>
             </a:r>
           </a:p>
         </p:txBody>
@@ -1237,7 +1191,7 @@
           <a:p>
             <a:fld id="{4FA84156-8AE9-4423-952A-88BA8F9A5A49}" type="slidenum">
               <a:rPr lang="en-US" smtClean="0"/>
-              <a:t>6</a:t>
+              <a:t>3</a:t>
             </a:fld>
             <a:endParaRPr lang="en-US"/>
           </a:p>
@@ -1284,7 +1238,7 @@
 </p:notes>
 </file>
 
-<file path=ppt/notesSlides/notesSlide8.xml><?xml version="1.0" encoding="utf-8"?>
+<file path=ppt/notesSlides/notesSlide4.xml><?xml version="1.0" encoding="utf-8"?>
 <p:notes xmlns:a="http://schemas.openxmlformats.org/drawingml/2006/main" xmlns:r="http://schemas.openxmlformats.org/officeDocument/2006/relationships" xmlns:p="http://schemas.openxmlformats.org/presentationml/2006/main">
   <p:cSld>
     <p:spTree>
@@ -1329,60 +1283,51 @@
           <a:lstStyle/>
           <a:p>
             <a:r>
-              <a:rPr lang="en-US"/>
-              <a:t>"At PG5, AEPLO evaluates code, QA results, traceability, and</a:t>
+              <a:rPr lang="en-US" dirty="0"/>
+              <a:t>"The star of the show is the PG5 STQC agent. IoT security and surveillance</a:t>
             </a:r>
           </a:p>
           <a:p>
             <a:r>
-              <a:rPr lang="en-US"/>
-              <a:t>JTAG/SWD evidence together. The gatekeeper produces a clear</a:t>
+              <a:rPr lang="en-US" dirty="0"/>
+              <a:t>devices need BIS certification governed by STQC guidelines, for both</a:t>
             </a:r>
           </a:p>
           <a:p>
             <a:r>
-              <a:rPr lang="en-US"/>
-              <a:t>READY or NOT_READY verdict, plus a prioritized remediation list</a:t>
+              <a:rPr lang="en-US" dirty="0"/>
+              <a:t>in-house designs and BTS sales. Earlier, developers spent months creating</a:t>
             </a:r>
           </a:p>
           <a:p>
             <a:r>
-              <a:rPr lang="en-US"/>
-              <a:t>for validation and launch preparation.“</a:t>
+              <a:rPr lang="en-US" dirty="0"/>
+              <a:t>evidence, validating code and preparing auditor submissions. The STQC</a:t>
             </a:r>
           </a:p>
           <a:p>
             <a:r>
-              <a:rPr lang="en-US"/>
-              <a:t>We also Plan to demo a STQC Agent as part of PG5 , All IOT based Surveillance devices (Cameras and NVRs) need to be BIS certified and in order to do so , need to go through a very strict STQC audit.</a:t>
+              <a:rPr lang="en-US" dirty="0"/>
+              <a:t>agent crawls the code, creates evidence, enforces hard rules like no</a:t>
             </a:r>
           </a:p>
           <a:p>
             <a:r>
-              <a:rPr lang="en-US"/>
-              <a:t>The STQC team updates the Guidelines from time to time, tightening the security norms a little further at each revision.</a:t>
+              <a:rPr lang="en-US" dirty="0"/>
+              <a:t>foreign characters, checks STQC ER guidelines, and decides whether the</a:t>
             </a:r>
           </a:p>
           <a:p>
-            <a:endParaRPr lang="en-US"/>
-          </a:p>
-          <a:p>
             <a:r>
-              <a:rPr lang="en-US"/>
-              <a:t>Developers take  months to traverse through the code, and Create evidences, Validate them and do a thorough Code/Hardware Review.</a:t>
+              <a:rPr lang="en-US" dirty="0"/>
+              <a:t>submission pack is ready. If not, it highlights the section and creates</a:t>
             </a:r>
           </a:p>
           <a:p>
             <a:r>
-              <a:rPr lang="en-US"/>
-              <a:t>AEPLO’s STQC feature reduces this time frame to Days.</a:t>
+              <a:rPr lang="en-US" dirty="0"/>
+              <a:t>Jira tickets or stories for remediation."</a:t>
             </a:r>
-          </a:p>
-          <a:p>
-            <a:endParaRPr lang="en-US"/>
-          </a:p>
-          <a:p>
-            <a:endParaRPr lang="en-US"/>
           </a:p>
         </p:txBody>
       </p:sp>
@@ -1425,7 +1370,7 @@
           <a:p>
             <a:fld id="{BB99C4E8-DCB7-4C66-B47F-361D1DFDA228}" type="slidenum">
               <a:rPr lang="en-US" smtClean="0"/>
-              <a:t>8</a:t>
+              <a:t>4</a:t>
             </a:fld>
             <a:endParaRPr lang="en-US"/>
           </a:p>
@@ -1444,7 +1389,7 @@
 </p:notes>
 </file>
 
-<file path=ppt/notesSlides/notesSlide9.xml><?xml version="1.0" encoding="utf-8"?>
+<file path=ppt/notesSlides/notesSlide5.xml><?xml version="1.0" encoding="utf-8"?>
 <p:notes xmlns:a="http://schemas.openxmlformats.org/drawingml/2006/main" xmlns:r="http://schemas.openxmlformats.org/officeDocument/2006/relationships" xmlns:p="http://schemas.openxmlformats.org/presentationml/2006/main">
   <p:cSld>
     <p:spTree>
@@ -1490,39 +1435,31 @@
           <a:p>
             <a:r>
               <a:rPr lang="en-US" dirty="0"/>
-              <a:t>"The matrix connects the demo to measurable judging criteria.</a:t>
+              <a:t>"The realistic impact is material: STQC evidence preparation drops from</a:t>
             </a:r>
           </a:p>
           <a:p>
             <a:r>
               <a:rPr lang="en-US" dirty="0"/>
-              <a:t>We show a 41 percent lead-time drop, 60 percent fewer projected</a:t>
+              <a:t>8 to 12 weeks into 1 to 3 days, PG3 firmware loops are 45 to 60 percent faster, JTAG root</a:t>
             </a:r>
           </a:p>
           <a:p>
             <a:r>
               <a:rPr lang="en-US" dirty="0"/>
-              <a:t>defect escapes, 85 percent BA hosting readiness, and measurable</a:t>
+              <a:t>cause is reduced to under two hours, and routed context plus prompt caching</a:t>
             </a:r>
           </a:p>
           <a:p>
             <a:r>
               <a:rPr lang="en-US" dirty="0"/>
-              <a:t>agentic AI execution metrics including handoff success, tool</a:t>
+              <a:t>cuts token use by about 35 to 45 percent. AEPLO keeps looping until QA says</a:t>
             </a:r>
           </a:p>
           <a:p>
             <a:r>
               <a:rPr lang="en-US" dirty="0"/>
-              <a:t>calling accuracy, and prompt caching </a:t>
-            </a:r>
-            <a:r>
-              <a:rPr lang="en-US" dirty="0" err="1"/>
-              <a:t>utilisation</a:t>
-            </a:r>
-            <a:r>
-              <a:rPr lang="en-US" dirty="0"/>
-              <a:t>."</a:t>
+              <a:t>READY."</a:t>
             </a:r>
           </a:p>
         </p:txBody>
@@ -1566,7 +1503,7 @@
           <a:p>
             <a:fld id="{BB99C4E8-DCB7-4C66-B47F-361D1DFDA228}" type="slidenum">
               <a:rPr lang="en-US" smtClean="0"/>
-              <a:t>9</a:t>
+              <a:t>5</a:t>
             </a:fld>
             <a:endParaRPr lang="en-US"/>
           </a:p>
@@ -4665,36 +4602,12 @@
           <a:bodyPr rtlCol="0" anchor="ctr"/>
           <a:lstStyle/>
           <a:p>
-            <a:pPr marL="0" marR="0" lvl="0" indent="0" algn="ctr" defTabSz="457200" rtl="0" eaLnBrk="1" fontAlgn="auto" latinLnBrk="0" hangingPunct="1">
-              <a:lnSpc>
-                <a:spcPct val="100000"/>
-              </a:lnSpc>
-              <a:spcBef>
-                <a:spcPts val="0"/>
-              </a:spcBef>
-              <a:spcAft>
-                <a:spcPts val="0"/>
-              </a:spcAft>
-              <a:buClrTx/>
-              <a:buSzTx/>
-              <a:buFontTx/>
-              <a:buNone/>
-              <a:tabLst/>
-              <a:defRPr/>
-            </a:pPr>
-            <a:endParaRPr kumimoji="0" sz="1800" b="0" i="0" u="none" strike="noStrike" kern="1200" cap="none" spc="0" normalizeH="0" baseline="0" noProof="0">
-              <a:ln>
-                <a:noFill/>
-              </a:ln>
+            <a:pPr algn="ctr"/>
+            <a:endParaRPr dirty="0">
               <a:solidFill>
                 <a:prstClr val="white"/>
               </a:solidFill>
-              <a:effectLst/>
-              <a:uLnTx/>
-              <a:uFillTx/>
               <a:latin typeface="Calibri"/>
-              <a:ea typeface="+mn-ea"/>
-              <a:cs typeface="+mn-cs"/>
             </a:endParaRPr>
           </a:p>
         </p:txBody>
@@ -21862,6 +21775,7 @@
           <a:lstStyle/>
           <a:p>
             <a:pPr algn="ctr"/>
+            <a:endParaRPr/>
           </a:p>
         </p:txBody>
       </p:sp>
@@ -21880,7 +21794,7 @@
             <a:avLst/>
           </a:prstGeom>
           <a:solidFill>
-            <a:srgbClr val="00C8F0"/>
+            <a:srgbClr val="FF0000"/>
           </a:solidFill>
           <a:ln>
             <a:noFill/>
@@ -21905,6 +21819,7 @@
           <a:lstStyle/>
           <a:p>
             <a:pPr algn="ctr"/>
+            <a:endParaRPr/>
           </a:p>
         </p:txBody>
       </p:sp>
@@ -21923,7 +21838,7 @@
             <a:avLst/>
           </a:prstGeom>
           <a:solidFill>
-            <a:srgbClr val="0072C6"/>
+            <a:srgbClr val="FF0000"/>
           </a:solidFill>
           <a:ln>
             <a:noFill/>
@@ -21948,6 +21863,7 @@
           <a:lstStyle/>
           <a:p>
             <a:pPr algn="ctr"/>
+            <a:endParaRPr/>
           </a:p>
         </p:txBody>
       </p:sp>
@@ -21968,7 +21884,7 @@
           <a:noFill/>
         </p:spPr>
         <p:txBody>
-          <a:bodyPr wrap="square" lIns="36576" rIns="36576" tIns="18288" bIns="18288">
+          <a:bodyPr wrap="square" lIns="36576" tIns="18288" rIns="36576" bIns="18288">
             <a:spAutoFit/>
           </a:bodyPr>
           <a:lstStyle/>
@@ -21995,7 +21911,7 @@
         <p:spPr>
           <a:xfrm>
             <a:off x="347472" y="749808"/>
-            <a:ext cx="8229600" cy="530352"/>
+            <a:ext cx="8229600" cy="390876"/>
           </a:xfrm>
           <a:prstGeom prst="rect">
             <a:avLst/>
@@ -22003,20 +21919,20 @@
           <a:noFill/>
         </p:spPr>
         <p:txBody>
-          <a:bodyPr wrap="square" lIns="36576" rIns="36576" tIns="18288" bIns="18288">
+          <a:bodyPr wrap="square" lIns="36576" tIns="18288" rIns="36576" bIns="18288">
             <a:spAutoFit/>
           </a:bodyPr>
           <a:lstStyle/>
           <a:p>
             <a:pPr algn="l"/>
             <a:r>
-              <a:rPr sz="2300" b="1" i="0">
+              <a:rPr lang="en-US" sz="2300" b="1" i="0" dirty="0">
                 <a:solidFill>
                   <a:srgbClr val="FFFFFF"/>
                 </a:solidFill>
                 <a:latin typeface="Segoe UI"/>
               </a:rPr>
-              <a:t>One Slide Summary: Problem -&gt; Architecture -&gt; PRD -&gt; PG3 -&gt; QA Gate</a:t>
+              <a:t>From Fragmentation to Release Readiness</a:t>
             </a:r>
           </a:p>
         </p:txBody>
@@ -22036,7 +21952,7 @@
             <a:avLst/>
           </a:prstGeom>
           <a:solidFill>
-            <a:srgbClr val="00C8F0"/>
+            <a:srgbClr val="FF0000"/>
           </a:solidFill>
           <a:ln>
             <a:noFill/>
@@ -22061,41 +21977,7 @@
           <a:lstStyle/>
           <a:p>
             <a:pPr algn="ctr"/>
-          </a:p>
-        </p:txBody>
-      </p:sp>
-      <p:sp>
-        <p:nvSpPr>
-          <p:cNvPr id="8" name="TextBox 7"/>
-          <p:cNvSpPr txBox="1"/>
-          <p:nvPr/>
-        </p:nvSpPr>
-        <p:spPr>
-          <a:xfrm>
-            <a:off x="347472" y="1417320"/>
-            <a:ext cx="8503920" cy="411480"/>
-          </a:xfrm>
-          <a:prstGeom prst="rect">
-            <a:avLst/>
-          </a:prstGeom>
-          <a:noFill/>
-        </p:spPr>
-        <p:txBody>
-          <a:bodyPr wrap="square" lIns="36576" rIns="36576" tIns="18288" bIns="18288">
-            <a:spAutoFit/>
-          </a:bodyPr>
-          <a:lstStyle/>
-          <a:p>
-            <a:pPr algn="l"/>
-            <a:r>
-              <a:rPr sz="1200" b="0" i="1">
-                <a:solidFill>
-                  <a:srgbClr val="B8D0EC"/>
-                </a:solidFill>
-                <a:latin typeface="Segoe UI"/>
-              </a:rPr>
-              <a:t>Combines original pages 2, 3, 4, 5 and 7 while preserving the requested V10 pages 1, 6, 8 and 9 unchanged.</a:t>
-            </a:r>
+            <a:endParaRPr/>
           </a:p>
         </p:txBody>
       </p:sp>
@@ -22139,6 +22021,7 @@
           <a:lstStyle/>
           <a:p>
             <a:pPr algn="ctr"/>
+            <a:endParaRPr/>
           </a:p>
         </p:txBody>
       </p:sp>
@@ -22157,7 +22040,10 @@
             <a:avLst/>
           </a:prstGeom>
           <a:solidFill>
-            <a:srgbClr val="0F2845"/>
+            <a:schemeClr val="tx1">
+              <a:lumMod val="75000"/>
+              <a:lumOff val="25000"/>
+            </a:schemeClr>
           </a:solidFill>
           <a:ln>
             <a:noFill/>
@@ -22182,6 +22068,7 @@
           <a:lstStyle/>
           <a:p>
             <a:pPr algn="ctr"/>
+            <a:endParaRPr/>
           </a:p>
         </p:txBody>
       </p:sp>
@@ -22225,6 +22112,7 @@
           <a:lstStyle/>
           <a:p>
             <a:pPr algn="ctr"/>
+            <a:endParaRPr/>
           </a:p>
         </p:txBody>
       </p:sp>
@@ -22268,6 +22156,7 @@
           <a:lstStyle/>
           <a:p>
             <a:pPr algn="ctr"/>
+            <a:endParaRPr/>
           </a:p>
         </p:txBody>
       </p:sp>
@@ -22288,7 +22177,7 @@
           <a:noFill/>
         </p:spPr>
         <p:txBody>
-          <a:bodyPr wrap="square" lIns="36576" rIns="36576" tIns="18288" bIns="18288">
+          <a:bodyPr wrap="square" lIns="36576" tIns="18288" rIns="36576" bIns="18288">
             <a:spAutoFit/>
           </a:bodyPr>
           <a:lstStyle/>
@@ -22323,7 +22212,7 @@
           <a:noFill/>
         </p:spPr>
         <p:txBody>
-          <a:bodyPr wrap="square" lIns="36576" rIns="36576" tIns="18288" bIns="18288">
+          <a:bodyPr wrap="square" lIns="36576" tIns="18288" rIns="36576" bIns="18288">
             <a:spAutoFit/>
           </a:bodyPr>
           <a:lstStyle/>
@@ -22381,6 +22270,7 @@
           <a:lstStyle/>
           <a:p>
             <a:pPr algn="ctr"/>
+            <a:endParaRPr/>
           </a:p>
         </p:txBody>
       </p:sp>
@@ -22401,7 +22291,7 @@
           <a:noFill/>
         </p:spPr>
         <p:txBody>
-          <a:bodyPr wrap="square" lIns="36576" rIns="36576" tIns="18288" bIns="18288">
+          <a:bodyPr wrap="square" lIns="36576" tIns="18288" rIns="36576" bIns="18288">
             <a:spAutoFit/>
           </a:bodyPr>
           <a:lstStyle/>
@@ -22459,6 +22349,7 @@
           <a:lstStyle/>
           <a:p>
             <a:pPr algn="ctr"/>
+            <a:endParaRPr/>
           </a:p>
         </p:txBody>
       </p:sp>
@@ -22502,6 +22393,7 @@
           <a:lstStyle/>
           <a:p>
             <a:pPr algn="ctr"/>
+            <a:endParaRPr/>
           </a:p>
         </p:txBody>
       </p:sp>
@@ -22545,6 +22437,7 @@
           <a:lstStyle/>
           <a:p>
             <a:pPr algn="ctr"/>
+            <a:endParaRPr/>
           </a:p>
         </p:txBody>
       </p:sp>
@@ -22588,6 +22481,7 @@
           <a:lstStyle/>
           <a:p>
             <a:pPr algn="ctr"/>
+            <a:endParaRPr/>
           </a:p>
         </p:txBody>
       </p:sp>
@@ -22606,7 +22500,10 @@
             <a:avLst/>
           </a:prstGeom>
           <a:solidFill>
-            <a:srgbClr val="0F2845"/>
+            <a:schemeClr val="tx1">
+              <a:lumMod val="75000"/>
+              <a:lumOff val="25000"/>
+            </a:schemeClr>
           </a:solidFill>
           <a:ln>
             <a:noFill/>
@@ -22631,6 +22528,7 @@
           <a:lstStyle/>
           <a:p>
             <a:pPr algn="ctr"/>
+            <a:endParaRPr/>
           </a:p>
         </p:txBody>
       </p:sp>
@@ -22674,6 +22572,7 @@
           <a:lstStyle/>
           <a:p>
             <a:pPr algn="ctr"/>
+            <a:endParaRPr/>
           </a:p>
         </p:txBody>
       </p:sp>
@@ -22717,6 +22616,7 @@
           <a:lstStyle/>
           <a:p>
             <a:pPr algn="ctr"/>
+            <a:endParaRPr/>
           </a:p>
         </p:txBody>
       </p:sp>
@@ -22737,7 +22637,7 @@
           <a:noFill/>
         </p:spPr>
         <p:txBody>
-          <a:bodyPr wrap="square" lIns="36576" rIns="36576" tIns="18288" bIns="18288">
+          <a:bodyPr wrap="square" lIns="36576" tIns="18288" rIns="36576" bIns="18288">
             <a:spAutoFit/>
           </a:bodyPr>
           <a:lstStyle/>
@@ -22772,7 +22672,7 @@
           <a:noFill/>
         </p:spPr>
         <p:txBody>
-          <a:bodyPr wrap="square" lIns="36576" rIns="36576" tIns="18288" bIns="18288">
+          <a:bodyPr wrap="square" lIns="36576" tIns="18288" rIns="36576" bIns="18288">
             <a:spAutoFit/>
           </a:bodyPr>
           <a:lstStyle/>
@@ -22830,6 +22730,7 @@
           <a:lstStyle/>
           <a:p>
             <a:pPr algn="ctr"/>
+            <a:endParaRPr/>
           </a:p>
         </p:txBody>
       </p:sp>
@@ -22850,7 +22751,7 @@
           <a:noFill/>
         </p:spPr>
         <p:txBody>
-          <a:bodyPr wrap="square" lIns="36576" rIns="36576" tIns="18288" bIns="18288">
+          <a:bodyPr wrap="square" lIns="36576" tIns="18288" rIns="36576" bIns="18288">
             <a:spAutoFit/>
           </a:bodyPr>
           <a:lstStyle/>
@@ -22908,6 +22809,7 @@
           <a:lstStyle/>
           <a:p>
             <a:pPr algn="ctr"/>
+            <a:endParaRPr/>
           </a:p>
         </p:txBody>
       </p:sp>
@@ -22951,6 +22853,7 @@
           <a:lstStyle/>
           <a:p>
             <a:pPr algn="ctr"/>
+            <a:endParaRPr/>
           </a:p>
         </p:txBody>
       </p:sp>
@@ -22994,6 +22897,7 @@
           <a:lstStyle/>
           <a:p>
             <a:pPr algn="ctr"/>
+            <a:endParaRPr/>
           </a:p>
         </p:txBody>
       </p:sp>
@@ -23037,6 +22941,7 @@
           <a:lstStyle/>
           <a:p>
             <a:pPr algn="ctr"/>
+            <a:endParaRPr/>
           </a:p>
         </p:txBody>
       </p:sp>
@@ -23055,7 +22960,10 @@
             <a:avLst/>
           </a:prstGeom>
           <a:solidFill>
-            <a:srgbClr val="0F2845"/>
+            <a:schemeClr val="tx1">
+              <a:lumMod val="75000"/>
+              <a:lumOff val="25000"/>
+            </a:schemeClr>
           </a:solidFill>
           <a:ln>
             <a:noFill/>
@@ -23080,6 +22988,7 @@
           <a:lstStyle/>
           <a:p>
             <a:pPr algn="ctr"/>
+            <a:endParaRPr/>
           </a:p>
         </p:txBody>
       </p:sp>
@@ -23123,6 +23032,7 @@
           <a:lstStyle/>
           <a:p>
             <a:pPr algn="ctr"/>
+            <a:endParaRPr/>
           </a:p>
         </p:txBody>
       </p:sp>
@@ -23166,6 +23076,7 @@
           <a:lstStyle/>
           <a:p>
             <a:pPr algn="ctr"/>
+            <a:endParaRPr/>
           </a:p>
         </p:txBody>
       </p:sp>
@@ -23186,7 +23097,7 @@
           <a:noFill/>
         </p:spPr>
         <p:txBody>
-          <a:bodyPr wrap="square" lIns="36576" rIns="36576" tIns="18288" bIns="18288">
+          <a:bodyPr wrap="square" lIns="36576" tIns="18288" rIns="36576" bIns="18288">
             <a:spAutoFit/>
           </a:bodyPr>
           <a:lstStyle/>
@@ -23221,7 +23132,7 @@
           <a:noFill/>
         </p:spPr>
         <p:txBody>
-          <a:bodyPr wrap="square" lIns="36576" rIns="36576" tIns="18288" bIns="18288">
+          <a:bodyPr wrap="square" lIns="36576" tIns="18288" rIns="36576" bIns="18288">
             <a:spAutoFit/>
           </a:bodyPr>
           <a:lstStyle/>
@@ -23279,6 +23190,7 @@
           <a:lstStyle/>
           <a:p>
             <a:pPr algn="ctr"/>
+            <a:endParaRPr/>
           </a:p>
         </p:txBody>
       </p:sp>
@@ -23299,7 +23211,7 @@
           <a:noFill/>
         </p:spPr>
         <p:txBody>
-          <a:bodyPr wrap="square" lIns="36576" rIns="36576" tIns="18288" bIns="18288">
+          <a:bodyPr wrap="square" lIns="36576" tIns="18288" rIns="36576" bIns="18288">
             <a:spAutoFit/>
           </a:bodyPr>
           <a:lstStyle/>
@@ -23357,6 +23269,7 @@
           <a:lstStyle/>
           <a:p>
             <a:pPr algn="ctr"/>
+            <a:endParaRPr/>
           </a:p>
         </p:txBody>
       </p:sp>
@@ -23400,6 +23313,7 @@
           <a:lstStyle/>
           <a:p>
             <a:pPr algn="ctr"/>
+            <a:endParaRPr/>
           </a:p>
         </p:txBody>
       </p:sp>
@@ -23443,6 +23357,7 @@
           <a:lstStyle/>
           <a:p>
             <a:pPr algn="ctr"/>
+            <a:endParaRPr/>
           </a:p>
         </p:txBody>
       </p:sp>
@@ -23486,6 +23401,7 @@
           <a:lstStyle/>
           <a:p>
             <a:pPr algn="ctr"/>
+            <a:endParaRPr/>
           </a:p>
         </p:txBody>
       </p:sp>
@@ -23504,7 +23420,10 @@
             <a:avLst/>
           </a:prstGeom>
           <a:solidFill>
-            <a:srgbClr val="0F2845"/>
+            <a:schemeClr val="tx1">
+              <a:lumMod val="75000"/>
+              <a:lumOff val="25000"/>
+            </a:schemeClr>
           </a:solidFill>
           <a:ln>
             <a:noFill/>
@@ -23529,6 +23448,7 @@
           <a:lstStyle/>
           <a:p>
             <a:pPr algn="ctr"/>
+            <a:endParaRPr/>
           </a:p>
         </p:txBody>
       </p:sp>
@@ -23572,6 +23492,7 @@
           <a:lstStyle/>
           <a:p>
             <a:pPr algn="ctr"/>
+            <a:endParaRPr/>
           </a:p>
         </p:txBody>
       </p:sp>
@@ -23615,6 +23536,7 @@
           <a:lstStyle/>
           <a:p>
             <a:pPr algn="ctr"/>
+            <a:endParaRPr/>
           </a:p>
         </p:txBody>
       </p:sp>
@@ -23635,7 +23557,7 @@
           <a:noFill/>
         </p:spPr>
         <p:txBody>
-          <a:bodyPr wrap="square" lIns="36576" rIns="36576" tIns="18288" bIns="18288">
+          <a:bodyPr wrap="square" lIns="36576" tIns="18288" rIns="36576" bIns="18288">
             <a:spAutoFit/>
           </a:bodyPr>
           <a:lstStyle/>
@@ -23670,7 +23592,7 @@
           <a:noFill/>
         </p:spPr>
         <p:txBody>
-          <a:bodyPr wrap="square" lIns="36576" rIns="36576" tIns="18288" bIns="18288">
+          <a:bodyPr wrap="square" lIns="36576" tIns="18288" rIns="36576" bIns="18288">
             <a:spAutoFit/>
           </a:bodyPr>
           <a:lstStyle/>
@@ -23728,6 +23650,7 @@
           <a:lstStyle/>
           <a:p>
             <a:pPr algn="ctr"/>
+            <a:endParaRPr/>
           </a:p>
         </p:txBody>
       </p:sp>
@@ -23748,7 +23671,7 @@
           <a:noFill/>
         </p:spPr>
         <p:txBody>
-          <a:bodyPr wrap="square" lIns="36576" rIns="36576" tIns="18288" bIns="18288">
+          <a:bodyPr wrap="square" lIns="36576" tIns="18288" rIns="36576" bIns="18288">
             <a:spAutoFit/>
           </a:bodyPr>
           <a:lstStyle/>
@@ -23806,6 +23729,7 @@
           <a:lstStyle/>
           <a:p>
             <a:pPr algn="ctr"/>
+            <a:endParaRPr/>
           </a:p>
         </p:txBody>
       </p:sp>
@@ -23849,6 +23773,7 @@
           <a:lstStyle/>
           <a:p>
             <a:pPr algn="ctr"/>
+            <a:endParaRPr/>
           </a:p>
         </p:txBody>
       </p:sp>
@@ -23892,6 +23817,7 @@
           <a:lstStyle/>
           <a:p>
             <a:pPr algn="ctr"/>
+            <a:endParaRPr/>
           </a:p>
         </p:txBody>
       </p:sp>
@@ -23935,6 +23861,7 @@
           <a:lstStyle/>
           <a:p>
             <a:pPr algn="ctr"/>
+            <a:endParaRPr/>
           </a:p>
         </p:txBody>
       </p:sp>
@@ -23953,7 +23880,10 @@
             <a:avLst/>
           </a:prstGeom>
           <a:solidFill>
-            <a:srgbClr val="0F2845"/>
+            <a:schemeClr val="tx1">
+              <a:lumMod val="75000"/>
+              <a:lumOff val="25000"/>
+            </a:schemeClr>
           </a:solidFill>
           <a:ln>
             <a:noFill/>
@@ -23978,6 +23908,7 @@
           <a:lstStyle/>
           <a:p>
             <a:pPr algn="ctr"/>
+            <a:endParaRPr/>
           </a:p>
         </p:txBody>
       </p:sp>
@@ -24021,6 +23952,7 @@
           <a:lstStyle/>
           <a:p>
             <a:pPr algn="ctr"/>
+            <a:endParaRPr/>
           </a:p>
         </p:txBody>
       </p:sp>
@@ -24064,6 +23996,7 @@
           <a:lstStyle/>
           <a:p>
             <a:pPr algn="ctr"/>
+            <a:endParaRPr/>
           </a:p>
         </p:txBody>
       </p:sp>
@@ -24084,7 +24017,7 @@
           <a:noFill/>
         </p:spPr>
         <p:txBody>
-          <a:bodyPr wrap="square" lIns="36576" rIns="36576" tIns="18288" bIns="18288">
+          <a:bodyPr wrap="square" lIns="36576" tIns="18288" rIns="36576" bIns="18288">
             <a:spAutoFit/>
           </a:bodyPr>
           <a:lstStyle/>
@@ -24119,7 +24052,7 @@
           <a:noFill/>
         </p:spPr>
         <p:txBody>
-          <a:bodyPr wrap="square" lIns="36576" rIns="36576" tIns="18288" bIns="18288">
+          <a:bodyPr wrap="square" lIns="36576" tIns="18288" rIns="36576" bIns="18288">
             <a:spAutoFit/>
           </a:bodyPr>
           <a:lstStyle/>
@@ -24177,6 +24110,7 @@
           <a:lstStyle/>
           <a:p>
             <a:pPr algn="ctr"/>
+            <a:endParaRPr/>
           </a:p>
         </p:txBody>
       </p:sp>
@@ -24197,7 +24131,7 @@
           <a:noFill/>
         </p:spPr>
         <p:txBody>
-          <a:bodyPr wrap="square" lIns="36576" rIns="36576" tIns="18288" bIns="18288">
+          <a:bodyPr wrap="square" lIns="36576" tIns="18288" rIns="36576" bIns="18288">
             <a:spAutoFit/>
           </a:bodyPr>
           <a:lstStyle/>
@@ -24230,7 +24164,10 @@
             <a:avLst/>
           </a:prstGeom>
           <a:solidFill>
-            <a:srgbClr val="0E2A4A"/>
+            <a:schemeClr val="tx1">
+              <a:lumMod val="75000"/>
+              <a:lumOff val="25000"/>
+            </a:schemeClr>
           </a:solidFill>
           <a:ln>
             <a:noFill/>
@@ -24255,6 +24192,7 @@
           <a:lstStyle/>
           <a:p>
             <a:pPr algn="ctr"/>
+            <a:endParaRPr/>
           </a:p>
         </p:txBody>
       </p:sp>
@@ -24273,7 +24211,7 @@
             <a:avLst/>
           </a:prstGeom>
           <a:solidFill>
-            <a:srgbClr val="0072C6"/>
+            <a:srgbClr val="FF0000"/>
           </a:solidFill>
           <a:ln>
             <a:noFill/>
@@ -24298,6 +24236,7 @@
           <a:lstStyle/>
           <a:p>
             <a:pPr algn="ctr"/>
+            <a:endParaRPr/>
           </a:p>
         </p:txBody>
       </p:sp>
@@ -24310,7 +24249,7 @@
         <p:spPr>
           <a:xfrm>
             <a:off x="502920" y="6144768"/>
-            <a:ext cx="8229600" cy="310896"/>
+            <a:ext cx="8229600" cy="180049"/>
           </a:xfrm>
           <a:prstGeom prst="rect">
             <a:avLst/>
@@ -24318,16 +24257,16 @@
           <a:noFill/>
         </p:spPr>
         <p:txBody>
-          <a:bodyPr wrap="square" lIns="36576" rIns="36576" tIns="18288" bIns="18288">
+          <a:bodyPr wrap="square" lIns="36576" tIns="18288" rIns="36576" bIns="18288">
             <a:spAutoFit/>
           </a:bodyPr>
           <a:lstStyle/>
           <a:p>
             <a:pPr algn="ctr"/>
             <a:r>
-              <a:rPr sz="930" b="1" i="0">
+              <a:rPr sz="930" b="1" i="0" dirty="0">
                 <a:solidFill>
-                  <a:srgbClr val="00C8F0"/>
+                  <a:srgbClr val="FF0000"/>
                 </a:solidFill>
                 <a:latin typeface="Segoe UI"/>
               </a:rPr>
@@ -24351,7 +24290,7 @@
             <a:avLst/>
           </a:prstGeom>
           <a:solidFill>
-            <a:srgbClr val="0E2A4A"/>
+            <a:srgbClr val="333333"/>
           </a:solidFill>
           <a:ln>
             <a:noFill/>
@@ -24376,6 +24315,7 @@
           <a:lstStyle/>
           <a:p>
             <a:pPr algn="ctr"/>
+            <a:endParaRPr/>
           </a:p>
         </p:txBody>
       </p:sp>
@@ -24396,7 +24336,7 @@
           <a:noFill/>
         </p:spPr>
         <p:txBody>
-          <a:bodyPr wrap="square" lIns="36576" rIns="36576" tIns="18288" bIns="18288">
+          <a:bodyPr wrap="square" lIns="36576" tIns="18288" rIns="36576" bIns="18288">
             <a:spAutoFit/>
           </a:bodyPr>
           <a:lstStyle/>
@@ -24431,7 +24371,7 @@
           <a:noFill/>
         </p:spPr>
         <p:txBody>
-          <a:bodyPr wrap="square" lIns="36576" rIns="36576" tIns="18288" bIns="18288">
+          <a:bodyPr wrap="square" lIns="36576" tIns="18288" rIns="36576" bIns="18288">
             <a:spAutoFit/>
           </a:bodyPr>
           <a:lstStyle/>
@@ -26503,7 +26443,7 @@
           <a:p>
             <a:pPr algn="l"/>
             <a:r>
-              <a:rPr lang="en-US" sz="1200" b="1" i="0">
+              <a:rPr lang="en-US" sz="1200" b="1" i="0" dirty="0">
                 <a:solidFill>
                   <a:srgbClr val="FF0000"/>
                 </a:solidFill>
@@ -26514,7 +26454,7 @@
           </a:p>
           <a:p>
             <a:pPr algn="l"/>
-            <a:endParaRPr lang="en-US" sz="1100" b="1">
+            <a:endParaRPr lang="en-US" sz="1100" b="1" dirty="0">
               <a:solidFill>
                 <a:srgbClr val="FF8C00"/>
               </a:solidFill>
@@ -26522,7 +26462,7 @@
             </a:endParaRPr>
           </a:p>
           <a:p>
-            <a:endParaRPr lang="en-US" sz="1100" b="1">
+            <a:endParaRPr lang="en-US" sz="1100" b="1" dirty="0">
               <a:solidFill>
                 <a:srgbClr val="00D48A"/>
               </a:solidFill>
@@ -26531,7 +26471,7 @@
           </a:p>
           <a:p>
             <a:r>
-              <a:rPr lang="en-US" sz="1100" b="1">
+              <a:rPr lang="en-US" sz="1100" b="1" dirty="0">
                 <a:solidFill>
                   <a:srgbClr val="2E7D32"/>
                 </a:solidFill>
@@ -26541,7 +26481,7 @@
             </a:r>
           </a:p>
           <a:p>
-            <a:endParaRPr lang="en-US" sz="1100" b="1">
+            <a:endParaRPr lang="en-US" sz="1100" b="1" dirty="0">
               <a:solidFill>
                 <a:srgbClr val="00D48A"/>
               </a:solidFill>
@@ -26550,7 +26490,7 @@
           </a:p>
           <a:p>
             <a:r>
-              <a:rPr lang="en-US" sz="1000" b="1">
+              <a:rPr lang="en-US" sz="1000" b="1" dirty="0">
                 <a:solidFill>
                   <a:srgbClr val="E8E8E8"/>
                 </a:solidFill>
@@ -26559,7 +26499,7 @@
               <a:t>Problem</a:t>
             </a:r>
             <a:r>
-              <a:rPr lang="en-US" sz="930">
+              <a:rPr lang="en-US" sz="930" dirty="0">
                 <a:solidFill>
                   <a:srgbClr val="E8E8E8"/>
                 </a:solidFill>
@@ -26568,7 +26508,7 @@
               <a:t>: Bootloader enabled </a:t>
             </a:r>
             <a:r>
-              <a:rPr lang="en-US" sz="930" err="1">
+              <a:rPr lang="en-US" sz="930" dirty="0" err="1">
                 <a:solidFill>
                   <a:srgbClr val="E8E8E8"/>
                 </a:solidFill>
@@ -26577,7 +26517,7 @@
               <a:t>SysTick</a:t>
             </a:r>
             <a:r>
-              <a:rPr lang="en-US" sz="930">
+              <a:rPr lang="en-US" sz="930" dirty="0">
                 <a:solidFill>
                   <a:srgbClr val="E8E8E8"/>
                 </a:solidFill>
@@ -26586,7 +26526,7 @@
               <a:t> timer; application's vector table had no </a:t>
             </a:r>
             <a:r>
-              <a:rPr lang="en-US" sz="930" err="1">
+              <a:rPr lang="en-US" sz="930" dirty="0" err="1">
                 <a:solidFill>
                   <a:srgbClr val="E8E8E8"/>
                 </a:solidFill>
@@ -26595,7 +26535,7 @@
               <a:t>SysTick</a:t>
             </a:r>
             <a:r>
-              <a:rPr lang="en-US" sz="930">
+              <a:rPr lang="en-US" sz="930" dirty="0">
                 <a:solidFill>
                   <a:srgbClr val="E8E8E8"/>
                 </a:solidFill>
@@ -26604,7 +26544,7 @@
               <a:t> handler → </a:t>
             </a:r>
             <a:r>
-              <a:rPr lang="en-US" sz="930" err="1">
+              <a:rPr lang="en-US" sz="930" dirty="0" err="1">
                 <a:solidFill>
                   <a:srgbClr val="E8E8E8"/>
                 </a:solidFill>
@@ -26613,7 +26553,7 @@
               <a:t>HardFault</a:t>
             </a:r>
             <a:r>
-              <a:rPr lang="en-US" sz="930">
+              <a:rPr lang="en-US" sz="930" dirty="0">
                 <a:solidFill>
                   <a:srgbClr val="E8E8E8"/>
                 </a:solidFill>
@@ -26623,7 +26563,7 @@
             </a:r>
           </a:p>
           <a:p>
-            <a:endParaRPr lang="en-US" sz="930">
+            <a:endParaRPr lang="en-US" sz="930" dirty="0">
               <a:solidFill>
                 <a:srgbClr val="B8D0EC"/>
               </a:solidFill>
@@ -26632,7 +26572,7 @@
           </a:p>
           <a:p>
             <a:r>
-              <a:rPr lang="en-US" sz="1000" b="1">
+              <a:rPr lang="en-US" sz="1000" b="1" dirty="0">
                 <a:solidFill>
                   <a:srgbClr val="E8E8E8"/>
                 </a:solidFill>
@@ -26641,7 +26581,7 @@
               <a:t>Solution: </a:t>
             </a:r>
             <a:r>
-              <a:rPr lang="en-US" sz="1000">
+              <a:rPr lang="en-US" sz="1000" dirty="0">
                 <a:solidFill>
                   <a:srgbClr val="E8E8E8"/>
                 </a:solidFill>
@@ -26651,7 +26591,7 @@
             </a:r>
           </a:p>
           <a:p>
-            <a:endParaRPr lang="en-US" sz="1000">
+            <a:endParaRPr lang="en-US" sz="1000" dirty="0">
               <a:solidFill>
                 <a:srgbClr val="B8D0EC"/>
               </a:solidFill>
@@ -26659,7 +26599,7 @@
             </a:endParaRPr>
           </a:p>
           <a:p>
-            <a:endParaRPr lang="en-US" sz="1000">
+            <a:endParaRPr lang="en-US" sz="1000" dirty="0">
               <a:solidFill>
                 <a:srgbClr val="B8D0EC"/>
               </a:solidFill>
@@ -26668,7 +26608,7 @@
           </a:p>
           <a:p>
             <a:r>
-              <a:rPr lang="en-US" sz="1000" b="1">
+              <a:rPr lang="en-US" sz="1000" b="1" dirty="0">
                 <a:solidFill>
                   <a:srgbClr val="2E7D32"/>
                 </a:solidFill>
@@ -26678,7 +26618,7 @@
             </a:r>
           </a:p>
           <a:p>
-            <a:endParaRPr lang="en-US" sz="1000" b="1">
+            <a:endParaRPr lang="en-US" sz="1000" b="1" dirty="0">
               <a:solidFill>
                 <a:srgbClr val="00D48A"/>
               </a:solidFill>
@@ -26687,7 +26627,7 @@
           </a:p>
           <a:p>
             <a:r>
-              <a:rPr lang="en-US" sz="1000" b="1">
+              <a:rPr lang="en-US" sz="1000" b="1" dirty="0">
                 <a:solidFill>
                   <a:srgbClr val="E8E8E8"/>
                 </a:solidFill>
@@ -26696,7 +26636,7 @@
               <a:t>Problem: </a:t>
             </a:r>
             <a:r>
-              <a:rPr lang="en-US" sz="1000">
+              <a:rPr lang="en-US" sz="1000" dirty="0">
                 <a:solidFill>
                   <a:srgbClr val="E8E8E8"/>
                 </a:solidFill>
@@ -26705,7 +26645,7 @@
               <a:t>ADC stalled at negative temperature; fix required driver </a:t>
             </a:r>
             <a:r>
-              <a:rPr lang="en-US" sz="1000" err="1">
+              <a:rPr lang="en-US" sz="1000" dirty="0" err="1">
                 <a:solidFill>
                   <a:srgbClr val="E8E8E8"/>
                 </a:solidFill>
@@ -26714,7 +26654,7 @@
               <a:t>reinit</a:t>
             </a:r>
             <a:r>
-              <a:rPr lang="en-US" sz="1000">
+              <a:rPr lang="en-US" sz="1000" dirty="0">
                 <a:solidFill>
                   <a:srgbClr val="E8E8E8"/>
                 </a:solidFill>
@@ -26724,7 +26664,7 @@
             </a:r>
           </a:p>
           <a:p>
-            <a:endParaRPr lang="en-US" sz="1000">
+            <a:endParaRPr lang="en-US" sz="1000" dirty="0">
               <a:solidFill>
                 <a:srgbClr val="B8D0EC"/>
               </a:solidFill>
@@ -26733,7 +26673,7 @@
           </a:p>
           <a:p>
             <a:r>
-              <a:rPr lang="en-US" sz="1000" b="1">
+              <a:rPr lang="en-US" sz="1000" b="1" dirty="0">
                 <a:solidFill>
                   <a:srgbClr val="E8E8E8"/>
                 </a:solidFill>
@@ -26742,7 +26682,7 @@
               <a:t>Solution: </a:t>
             </a:r>
             <a:r>
-              <a:rPr lang="en-US" sz="1000">
+              <a:rPr lang="en-US" sz="1000" dirty="0">
                 <a:solidFill>
                   <a:srgbClr val="E8E8E8"/>
                 </a:solidFill>
@@ -26752,7 +26692,7 @@
             </a:r>
           </a:p>
           <a:p>
-            <a:endParaRPr lang="en-US" sz="1000">
+            <a:endParaRPr lang="en-US" sz="1000" dirty="0">
               <a:solidFill>
                 <a:srgbClr val="B8D0EC"/>
               </a:solidFill>
@@ -26761,7 +26701,7 @@
           </a:p>
           <a:p>
             <a:r>
-              <a:rPr lang="en-US" sz="1000" b="1">
+              <a:rPr lang="en-US" sz="1000" b="1" dirty="0">
                 <a:solidFill>
                   <a:srgbClr val="2E7D32"/>
                 </a:solidFill>
@@ -26772,7 +26712,7 @@
           </a:p>
           <a:p>
             <a:r>
-              <a:rPr lang="en-US" sz="1000" b="1">
+              <a:rPr lang="en-US" sz="1000" b="1" dirty="0">
                 <a:solidFill>
                   <a:srgbClr val="E8E8E8"/>
                 </a:solidFill>
@@ -26781,7 +26721,7 @@
               <a:t>Problem: </a:t>
             </a:r>
             <a:r>
-              <a:rPr lang="en-US" sz="1000">
+              <a:rPr lang="en-US" sz="1000" dirty="0">
                 <a:solidFill>
                   <a:srgbClr val="E8E8E8"/>
                 </a:solidFill>
@@ -26791,7 +26731,7 @@
             </a:r>
           </a:p>
           <a:p>
-            <a:endParaRPr lang="en-US" sz="1000">
+            <a:endParaRPr lang="en-US" sz="1000" dirty="0">
               <a:solidFill>
                 <a:srgbClr val="B8D0EC"/>
               </a:solidFill>
@@ -26800,7 +26740,7 @@
           </a:p>
           <a:p>
             <a:r>
-              <a:rPr lang="en-US" sz="1000" b="1">
+              <a:rPr lang="en-US" sz="1000" b="1" dirty="0">
                 <a:solidFill>
                   <a:srgbClr val="E8E8E8"/>
                 </a:solidFill>
@@ -26809,7 +26749,7 @@
               <a:t>Solution: </a:t>
             </a:r>
             <a:r>
-              <a:rPr lang="en-US" sz="1000">
+              <a:rPr lang="en-US" sz="1000" dirty="0">
                 <a:solidFill>
                   <a:srgbClr val="E8E8E8"/>
                 </a:solidFill>
@@ -26819,7 +26759,7 @@
             </a:r>
           </a:p>
           <a:p>
-            <a:endParaRPr lang="en-US" sz="1000" b="1">
+            <a:endParaRPr lang="en-US" sz="1000" b="1" dirty="0">
               <a:solidFill>
                 <a:srgbClr val="00D48A"/>
               </a:solidFill>
@@ -26827,7 +26767,7 @@
             </a:endParaRPr>
           </a:p>
           <a:p>
-            <a:endParaRPr lang="en-US" sz="1000" b="1">
+            <a:endParaRPr lang="en-US" sz="1000" b="1" dirty="0">
               <a:solidFill>
                 <a:srgbClr val="00D48A"/>
               </a:solidFill>
@@ -26835,7 +26775,7 @@
             </a:endParaRPr>
           </a:p>
           <a:p>
-            <a:endParaRPr lang="en-US" sz="1000">
+            <a:endParaRPr lang="en-US" sz="1000" dirty="0">
               <a:solidFill>
                 <a:srgbClr val="B8D0EC"/>
               </a:solidFill>
@@ -26843,7 +26783,7 @@
             </a:endParaRPr>
           </a:p>
           <a:p>
-            <a:endParaRPr lang="en-US" sz="1000">
+            <a:endParaRPr lang="en-US" sz="1000" dirty="0">
               <a:solidFill>
                 <a:srgbClr val="B8D0EC"/>
               </a:solidFill>
@@ -26851,7 +26791,7 @@
             </a:endParaRPr>
           </a:p>
           <a:p>
-            <a:endParaRPr lang="en-US" sz="1000">
+            <a:endParaRPr lang="en-US" sz="1000" dirty="0">
               <a:solidFill>
                 <a:srgbClr val="B8D0EC"/>
               </a:solidFill>
@@ -26859,7 +26799,7 @@
             </a:endParaRPr>
           </a:p>
           <a:p>
-            <a:endParaRPr lang="en-US" sz="930">
+            <a:endParaRPr lang="en-US" sz="930" dirty="0">
               <a:solidFill>
                 <a:srgbClr val="B8D0EC"/>
               </a:solidFill>
@@ -26867,7 +26807,7 @@
             </a:endParaRPr>
           </a:p>
           <a:p>
-            <a:endParaRPr lang="en-US" sz="930">
+            <a:endParaRPr lang="en-US" sz="930" dirty="0">
               <a:solidFill>
                 <a:srgbClr val="B8D0EC"/>
               </a:solidFill>
@@ -26875,7 +26815,7 @@
             </a:endParaRPr>
           </a:p>
           <a:p>
-            <a:endParaRPr lang="en-US" sz="930">
+            <a:endParaRPr lang="en-US" sz="930" dirty="0">
               <a:solidFill>
                 <a:srgbClr val="B8D0EC"/>
               </a:solidFill>
@@ -26883,7 +26823,7 @@
             </a:endParaRPr>
           </a:p>
           <a:p>
-            <a:endParaRPr lang="en-US" sz="930">
+            <a:endParaRPr lang="en-US" sz="930" dirty="0">
               <a:solidFill>
                 <a:srgbClr val="B8D0EC"/>
               </a:solidFill>
@@ -26892,7 +26832,7 @@
           </a:p>
           <a:p>
             <a:pPr algn="l"/>
-            <a:endParaRPr sz="1100" b="1" i="0">
+            <a:endParaRPr sz="1100" b="1" i="0" dirty="0">
               <a:solidFill>
                 <a:srgbClr val="FF8C00"/>
               </a:solidFill>
@@ -27377,7 +27317,7 @@
         <p:spPr>
           <a:xfrm>
             <a:off x="347472" y="1417320"/>
-            <a:ext cx="8503920" cy="411480"/>
+            <a:ext cx="8503920" cy="461665"/>
           </a:xfrm>
           <a:prstGeom prst="rect">
             <a:avLst/>
@@ -27393,13 +27333,13 @@
           <a:p>
             <a:pPr algn="l"/>
             <a:r>
-              <a:rPr sz="1200" b="0" i="1">
+              <a:rPr sz="1200" b="0" i="1" dirty="0">
                 <a:solidFill>
                   <a:srgbClr val="E8E8E8"/>
                 </a:solidFill>
                 <a:latin typeface="Arial"/>
               </a:rPr>
-              <a:t>The star of PG5: IoT security and surveillance devices need BIS certification governed by STQC guidelines for in-house designs and BTS sales.</a:t>
+              <a:t>IoT security and surveillance devices need BIS certification governed by STQC guidelines for in-house designs and BTS sales.</a:t>
             </a:r>
           </a:p>
         </p:txBody>
@@ -30069,8 +30009,8 @@
         </p:nvSpPr>
         <p:spPr>
           <a:xfrm>
-            <a:off x="3584448" y="3054096"/>
-            <a:ext cx="5056632" cy="350865"/>
+            <a:off x="3584448" y="2992446"/>
+            <a:ext cx="5056632" cy="609398"/>
           </a:xfrm>
           <a:prstGeom prst="rect">
             <a:avLst/>
@@ -30092,7 +30032,79 @@
                 </a:solidFill>
                 <a:latin typeface="Arial"/>
               </a:rPr>
-              <a:t>- Firmware first draft and validation: 3-5 days -&gt; 1-2 days
+              <a:t>- Firmware first draft and validation: </a:t>
+            </a:r>
+            <a:r>
+              <a:rPr lang="en-US" sz="840" b="0" i="0" dirty="0">
+                <a:solidFill>
+                  <a:srgbClr val="E8E8E8"/>
+                </a:solidFill>
+                <a:latin typeface="Arial"/>
+              </a:rPr>
+              <a:t>12</a:t>
+            </a:r>
+            <a:r>
+              <a:rPr sz="840" b="0" i="0" dirty="0">
+                <a:solidFill>
+                  <a:srgbClr val="E8E8E8"/>
+                </a:solidFill>
+                <a:latin typeface="Arial"/>
+              </a:rPr>
+              <a:t>-</a:t>
+            </a:r>
+            <a:r>
+              <a:rPr lang="en-US" sz="840" b="0" i="0" dirty="0">
+                <a:solidFill>
+                  <a:srgbClr val="E8E8E8"/>
+                </a:solidFill>
+                <a:latin typeface="Arial"/>
+              </a:rPr>
+              <a:t>1</a:t>
+            </a:r>
+            <a:r>
+              <a:rPr sz="840" b="0" i="0" dirty="0">
+                <a:solidFill>
+                  <a:srgbClr val="E8E8E8"/>
+                </a:solidFill>
+                <a:latin typeface="Arial"/>
+              </a:rPr>
+              <a:t>5 </a:t>
+            </a:r>
+            <a:r>
+              <a:rPr lang="en-US" sz="840" b="0" i="0" dirty="0">
+                <a:solidFill>
+                  <a:srgbClr val="E8E8E8"/>
+                </a:solidFill>
+                <a:latin typeface="Arial"/>
+              </a:rPr>
+              <a:t>months</a:t>
+            </a:r>
+            <a:r>
+              <a:rPr sz="840" b="0" i="0" dirty="0">
+                <a:solidFill>
+                  <a:srgbClr val="E8E8E8"/>
+                </a:solidFill>
+                <a:latin typeface="Arial"/>
+              </a:rPr>
+              <a:t> -&gt; </a:t>
+            </a:r>
+            <a:r>
+              <a:rPr lang="en-US" sz="840" b="0" i="0" dirty="0">
+                <a:solidFill>
+                  <a:srgbClr val="E8E8E8"/>
+                </a:solidFill>
+                <a:latin typeface="Arial"/>
+              </a:rPr>
+              <a:t>8-10 months</a:t>
+            </a:r>
+            <a:r>
+              <a:rPr sz="840" b="0" i="0" dirty="0">
+                <a:solidFill>
+                  <a:srgbClr val="E8E8E8"/>
+                </a:solidFill>
+                <a:latin typeface="Arial"/>
+              </a:rPr>
+              <a:t>
 - Faster first loop: 45-60%
 - Context injected: datasheet, PRD, SDK, BSP, OS/RTOS</a:t>
             </a:r>
@@ -31090,42 +31102,6 @@
       </p:sp>
       <p:sp>
         <p:nvSpPr>
-          <p:cNvPr id="51" name="TextBox 50"/>
-          <p:cNvSpPr txBox="1"/>
-          <p:nvPr/>
-        </p:nvSpPr>
-        <p:spPr>
-          <a:xfrm>
-            <a:off x="502920" y="6318504"/>
-            <a:ext cx="8138160" cy="73152"/>
-          </a:xfrm>
-          <a:prstGeom prst="rect">
-            <a:avLst/>
-          </a:prstGeom>
-          <a:noFill/>
-          <a:ln/>
-        </p:spPr>
-        <p:txBody>
-          <a:bodyPr wrap="square">
-            <a:spAutoFit/>
-          </a:bodyPr>
-          <a:lstStyle/>
-          <a:p>
-            <a:pPr algn="ctr"/>
-            <a:r>
-              <a:rPr sz="740" b="1" i="0">
-                <a:solidFill>
-                  <a:srgbClr val="2E7D32"/>
-                </a:solidFill>
-                <a:latin typeface="Arial"/>
-              </a:rPr>
-              <a:t>FOCUS: AEPLO loops across PRD, PG3 firmware, JTAG, QA and STQC until READY.</a:t>
-            </a:r>
-          </a:p>
-        </p:txBody>
-      </p:sp>
-      <p:sp>
-        <p:nvSpPr>
           <p:cNvPr id="52" name="Rectangle 51"/>
           <p:cNvSpPr/>
           <p:nvPr/>
@@ -31279,6 +31255,42 @@
                 <a:latin typeface="Arial"/>
               </a:rPr>
               <a:t>HONEYWELL</a:t>
+            </a:r>
+          </a:p>
+        </p:txBody>
+      </p:sp>
+      <p:sp>
+        <p:nvSpPr>
+          <p:cNvPr id="51" name="TextBox 50"/>
+          <p:cNvSpPr txBox="1"/>
+          <p:nvPr/>
+        </p:nvSpPr>
+        <p:spPr>
+          <a:xfrm>
+            <a:off x="484632" y="6234869"/>
+            <a:ext cx="8138160" cy="276999"/>
+          </a:xfrm>
+          <a:prstGeom prst="rect">
+            <a:avLst/>
+          </a:prstGeom>
+          <a:noFill/>
+          <a:ln/>
+        </p:spPr>
+        <p:txBody>
+          <a:bodyPr wrap="square">
+            <a:spAutoFit/>
+          </a:bodyPr>
+          <a:lstStyle/>
+          <a:p>
+            <a:pPr algn="ctr"/>
+            <a:r>
+              <a:rPr sz="1200" b="1" i="0" dirty="0">
+                <a:solidFill>
+                  <a:srgbClr val="FF0000"/>
+                </a:solidFill>
+                <a:latin typeface="Arial"/>
+              </a:rPr>
+              <a:t>FOCUS: AEPLO loops across PRD, PG3 firmware, JTAG, QA and STQC until READY.</a:t>
             </a:r>
           </a:p>
         </p:txBody>
@@ -32242,9 +32254,12 @@
 </file>
 
 <file path=customXml/item1.xml><?xml version="1.0" encoding="utf-8"?>
-<p:properties xmlns:p="http://schemas.microsoft.com/office/2006/metadata/properties" xmlns:xsi="http://www.w3.org/2001/XMLSchema-instance" xmlns:pc="http://schemas.microsoft.com/office/infopath/2007/PartnerControls">
-  <documentManagement/>
-</p:properties>
+<?mso-contentType ?>
+<FormTemplates xmlns="http://schemas.microsoft.com/sharepoint/v3/contenttype/forms">
+  <Display>DocumentLibraryForm</Display>
+  <Edit>DocumentLibraryForm</Edit>
+  <New>DocumentLibraryForm</New>
+</FormTemplates>
 </file>
 
 <file path=customXml/item2.xml><?xml version="1.0" encoding="utf-8"?>
@@ -32386,26 +32401,15 @@
 </file>
 
 <file path=customXml/item3.xml><?xml version="1.0" encoding="utf-8"?>
-<?mso-contentType ?>
-<FormTemplates xmlns="http://schemas.microsoft.com/sharepoint/v3/contenttype/forms">
-  <Display>DocumentLibraryForm</Display>
-  <Edit>DocumentLibraryForm</Edit>
-  <New>DocumentLibraryForm</New>
-</FormTemplates>
+<p:properties xmlns:p="http://schemas.microsoft.com/office/2006/metadata/properties" xmlns:xsi="http://www.w3.org/2001/XMLSchema-instance" xmlns:pc="http://schemas.microsoft.com/office/infopath/2007/PartnerControls">
+  <documentManagement/>
+</p:properties>
 </file>
 
 <file path=customXml/itemProps1.xml><?xml version="1.0" encoding="utf-8"?>
-<ds:datastoreItem xmlns:ds="http://schemas.openxmlformats.org/officeDocument/2006/customXml" ds:itemID="{A70049F5-D881-4A27-9198-FB7AEB41FA35}">
+<ds:datastoreItem xmlns:ds="http://schemas.openxmlformats.org/officeDocument/2006/customXml" ds:itemID="{6F64E7DF-7969-461F-8D79-4E2223D5DA13}">
   <ds:schemaRefs>
-    <ds:schemaRef ds:uri="e94ddfc3-4734-4b9a-ae26-16534f892664"/>
-    <ds:schemaRef ds:uri="http://purl.org/dc/elements/1.1/"/>
-    <ds:schemaRef ds:uri="http://schemas.microsoft.com/office/infopath/2007/PartnerControls"/>
-    <ds:schemaRef ds:uri="http://schemas.microsoft.com/office/2006/documentManagement/types"/>
-    <ds:schemaRef ds:uri="http://purl.org/dc/dcmitype/"/>
-    <ds:schemaRef ds:uri="http://schemas.microsoft.com/office/2006/metadata/properties"/>
-    <ds:schemaRef ds:uri="http://schemas.openxmlformats.org/package/2006/metadata/core-properties"/>
-    <ds:schemaRef ds:uri="http://www.w3.org/XML/1998/namespace"/>
-    <ds:schemaRef ds:uri="http://purl.org/dc/terms/"/>
+    <ds:schemaRef ds:uri="http://schemas.microsoft.com/sharepoint/v3/contenttype/forms"/>
   </ds:schemaRefs>
 </ds:datastoreItem>
 </file>
@@ -32429,9 +32433,17 @@
 </file>
 
 <file path=customXml/itemProps3.xml><?xml version="1.0" encoding="utf-8"?>
-<ds:datastoreItem xmlns:ds="http://schemas.openxmlformats.org/officeDocument/2006/customXml" ds:itemID="{6F64E7DF-7969-461F-8D79-4E2223D5DA13}">
+<ds:datastoreItem xmlns:ds="http://schemas.openxmlformats.org/officeDocument/2006/customXml" ds:itemID="{A70049F5-D881-4A27-9198-FB7AEB41FA35}">
   <ds:schemaRefs>
-    <ds:schemaRef ds:uri="http://schemas.microsoft.com/sharepoint/v3/contenttype/forms"/>
+    <ds:schemaRef ds:uri="e94ddfc3-4734-4b9a-ae26-16534f892664"/>
+    <ds:schemaRef ds:uri="http://purl.org/dc/elements/1.1/"/>
+    <ds:schemaRef ds:uri="http://schemas.microsoft.com/office/infopath/2007/PartnerControls"/>
+    <ds:schemaRef ds:uri="http://schemas.microsoft.com/office/2006/documentManagement/types"/>
+    <ds:schemaRef ds:uri="http://purl.org/dc/dcmitype/"/>
+    <ds:schemaRef ds:uri="http://schemas.microsoft.com/office/2006/metadata/properties"/>
+    <ds:schemaRef ds:uri="http://schemas.openxmlformats.org/package/2006/metadata/core-properties"/>
+    <ds:schemaRef ds:uri="http://www.w3.org/XML/1998/namespace"/>
+    <ds:schemaRef ds:uri="http://purl.org/dc/terms/"/>
   </ds:schemaRefs>
 </ds:datastoreItem>
 </file>

</xml_diff>